<commit_message>
Update official SIH 2026 presentation with official banner image, large readable typography, and strict zero-emoji formatting
</commit_message>
<xml_diff>
--- a/SIH2026_Idea_Presentation_PS26154.pptx
+++ b/SIH2026_Idea_Presentation_PS26154.pptx
@@ -3093,16 +3093,40 @@
         <p:nvPr/>
       </p:nvGrpSpPr>
       <p:grpSpPr/>
-      <p:sp>
-        <p:nvSpPr>
-          <p:cNvPr id="2" name="TextBox 1"/>
+      <p:pic>
+        <p:nvPicPr>
+          <p:cNvPr id="2" name="Picture 1" descr="sih_header_banner.jpg"/>
+          <p:cNvPicPr>
+            <a:picLocks noChangeAspect="1"/>
+          </p:cNvPicPr>
+          <p:nvPr/>
+        </p:nvPicPr>
+        <p:blipFill>
+          <a:blip r:embed="rId2"/>
+          <a:stretch>
+            <a:fillRect/>
+          </a:stretch>
+        </p:blipFill>
+        <p:spPr>
+          <a:xfrm>
+            <a:off x="7132320" y="274320"/>
+            <a:ext cx="4480560" cy="591671"/>
+          </a:xfrm>
+          <a:prstGeom prst="rect">
+            <a:avLst/>
+          </a:prstGeom>
+        </p:spPr>
+      </p:pic>
+      <p:sp>
+        <p:nvSpPr>
+          <p:cNvPr id="3" name="TextBox 2"/>
           <p:cNvSpPr txBox="1"/>
           <p:nvPr/>
         </p:nvSpPr>
         <p:spPr>
           <a:xfrm>
-            <a:off x="731520" y="411480"/>
-            <a:ext cx="9144000" cy="548640"/>
+            <a:off x="731520" y="320040"/>
+            <a:ext cx="6400800" cy="731520"/>
           </a:xfrm>
           <a:prstGeom prst="rect">
             <a:avLst/>
@@ -3116,7 +3140,7 @@
           <a:lstStyle/>
           <a:p>
             <a:pPr>
-              <a:defRPr sz="2800" b="1">
+              <a:defRPr sz="2600" b="1">
                 <a:solidFill>
                   <a:srgbClr val="1B365D"/>
                 </a:solidFill>
@@ -3127,104 +3151,41 @@
               <a:t>SMART INDIA HACKATHON 2026</a:t>
             </a:r>
           </a:p>
-        </p:txBody>
-      </p:sp>
-      <p:sp>
-        <p:nvSpPr>
-          <p:cNvPr id="3" name="TextBox 2"/>
-          <p:cNvSpPr txBox="1"/>
+          <a:p>
+            <a:pPr>
+              <a:defRPr sz="1800" b="1">
+                <a:solidFill>
+                  <a:srgbClr val="F37021"/>
+                </a:solidFill>
+                <a:latin typeface="Arial"/>
+              </a:defRPr>
+            </a:pPr>
+            <a:r>
+              <a:t>TITLE PAGE</a:t>
+            </a:r>
+          </a:p>
+        </p:txBody>
+      </p:sp>
+      <p:sp>
+        <p:nvSpPr>
+          <p:cNvPr id="4" name="Rounded Rectangle 3"/>
+          <p:cNvSpPr/>
           <p:nvPr/>
         </p:nvSpPr>
         <p:spPr>
           <a:xfrm>
-            <a:off x="9601200" y="320040"/>
-            <a:ext cx="2194560" cy="731520"/>
-          </a:xfrm>
-          <a:prstGeom prst="rect">
-            <a:avLst/>
-          </a:prstGeom>
-          <a:noFill/>
-        </p:spPr>
-        <p:txBody>
-          <a:bodyPr wrap="none">
-            <a:spAutoFit/>
-          </a:bodyPr>
-          <a:lstStyle/>
-          <a:p>
-            <a:pPr algn="r">
-              <a:defRPr sz="1000" b="1">
-                <a:solidFill>
-                  <a:srgbClr val="1B365D"/>
-                </a:solidFill>
-                <a:latin typeface="Arial"/>
-              </a:defRPr>
-            </a:pPr>
-            <a:r>
-              <a:t>SMART INDIA</a:t>
-            </a:r>
-            <a:br/>
-            <a:r>
-              <a:t>HACKATHON 2026</a:t>
-            </a:r>
-          </a:p>
-        </p:txBody>
-      </p:sp>
-      <p:sp>
-        <p:nvSpPr>
-          <p:cNvPr id="4" name="TextBox 3"/>
-          <p:cNvSpPr txBox="1"/>
-          <p:nvPr/>
-        </p:nvSpPr>
-        <p:spPr>
-          <a:xfrm>
-            <a:off x="731520" y="1051560"/>
-            <a:ext cx="10698480" cy="457200"/>
-          </a:xfrm>
-          <a:prstGeom prst="rect">
-            <a:avLst/>
-          </a:prstGeom>
-          <a:noFill/>
-        </p:spPr>
-        <p:txBody>
-          <a:bodyPr wrap="none">
-            <a:spAutoFit/>
-          </a:bodyPr>
-          <a:lstStyle/>
-          <a:p>
-            <a:pPr algn="ctr">
-              <a:defRPr sz="2000" b="1">
-                <a:solidFill>
-                  <a:srgbClr val="212529"/>
-                </a:solidFill>
-                <a:latin typeface="Arial"/>
-              </a:defRPr>
-            </a:pPr>
-            <a:r>
-              <a:t>TITLE PAGE</a:t>
-            </a:r>
-          </a:p>
-        </p:txBody>
-      </p:sp>
-      <p:sp>
-        <p:nvSpPr>
-          <p:cNvPr id="5" name="Rounded Rectangle 4"/>
-          <p:cNvSpPr/>
-          <p:nvPr/>
-        </p:nvSpPr>
-        <p:spPr>
-          <a:xfrm>
-            <a:off x="804672" y="1645920"/>
-            <a:ext cx="6949440" cy="4572000"/>
+            <a:off x="731520" y="1463040"/>
+            <a:ext cx="7132320" cy="4663440"/>
           </a:xfrm>
           <a:prstGeom prst="roundRect">
             <a:avLst/>
           </a:prstGeom>
           <a:solidFill>
-            <a:srgbClr val="F8FAFC"/>
+            <a:srgbClr val="FAFCFF"/>
           </a:solidFill>
-          <a:ln w="15240">
+          <a:ln w="19050">
             <a:solidFill>
-              <a:srgbClr val="E2E8F0"/>
+              <a:srgbClr val="D7E1EE"/>
             </a:solidFill>
           </a:ln>
         </p:spPr>
@@ -3243,16 +3204,16 @@
           </a:fontRef>
         </p:style>
         <p:txBody>
-          <a:bodyPr rtlCol="0" anchor="ctr" wrap="square" lIns="320040" tIns="274320" rIns="320040"/>
+          <a:bodyPr rtlCol="0" anchor="ctr" wrap="square" lIns="320040" tIns="320040" rIns="320040"/>
           <a:lstStyle/>
           <a:p>
             <a:pPr algn="ctr">
               <a:spcAft>
-                <a:spcPts val="1000"/>
-              </a:spcAft>
-            </a:pPr>
-            <a:r>
-              <a:rPr b="1" sz="1200">
+                <a:spcPts val="1200"/>
+              </a:spcAft>
+            </a:pPr>
+            <a:r>
+              <a:rPr b="1" sz="1300">
                 <a:solidFill>
                   <a:srgbClr val="1B365D"/>
                 </a:solidFill>
@@ -3261,7 +3222,7 @@
               <a:t>• Problem Statement ID –</a:t>
             </a:r>
             <a:r>
-              <a:rPr sz="1200" b="1">
+              <a:rPr sz="1300" b="1">
                 <a:solidFill>
                   <a:srgbClr val="F37021"/>
                 </a:solidFill>
@@ -3273,11 +3234,11 @@
           <a:p>
             <a:pPr>
               <a:spcAft>
-                <a:spcPts val="1000"/>
-              </a:spcAft>
-            </a:pPr>
-            <a:r>
-              <a:rPr b="1" sz="1200">
+                <a:spcPts val="1200"/>
+              </a:spcAft>
+            </a:pPr>
+            <a:r>
+              <a:rPr b="1" sz="1300">
                 <a:solidFill>
                   <a:srgbClr val="1B365D"/>
                 </a:solidFill>
@@ -3286,9 +3247,9 @@
               <a:t>• Problem Statement Title –</a:t>
             </a:r>
             <a:r>
-              <a:rPr sz="1200" b="1">
-                <a:solidFill>
-                  <a:srgbClr val="212529"/>
+              <a:rPr sz="1300" b="1">
+                <a:solidFill>
+                  <a:srgbClr val="191E24"/>
                 </a:solidFill>
                 <a:latin typeface="Arial"/>
               </a:rPr>
@@ -3298,11 +3259,11 @@
           <a:p>
             <a:pPr>
               <a:spcAft>
-                <a:spcPts val="1000"/>
-              </a:spcAft>
-            </a:pPr>
-            <a:r>
-              <a:rPr b="1" sz="1200">
+                <a:spcPts val="1200"/>
+              </a:spcAft>
+            </a:pPr>
+            <a:r>
+              <a:rPr b="1" sz="1300">
                 <a:solidFill>
                   <a:srgbClr val="1B365D"/>
                 </a:solidFill>
@@ -3311,23 +3272,23 @@
               <a:t>• Theme –</a:t>
             </a:r>
             <a:r>
-              <a:rPr sz="1200" b="0">
-                <a:solidFill>
-                  <a:srgbClr val="212529"/>
-                </a:solidFill>
-                <a:latin typeface="Arial"/>
-              </a:rPr>
-              <a:t> Blockchain &amp; Cybersecurity / AI</a:t>
+              <a:rPr sz="1300" b="0">
+                <a:solidFill>
+                  <a:srgbClr val="191E24"/>
+                </a:solidFill>
+                <a:latin typeface="Arial"/>
+              </a:rPr>
+              <a:t> Blockchain &amp; Cybersecurity / Artificial Intelligence</a:t>
             </a:r>
           </a:p>
           <a:p>
             <a:pPr>
               <a:spcAft>
-                <a:spcPts val="1000"/>
-              </a:spcAft>
-            </a:pPr>
-            <a:r>
-              <a:rPr b="1" sz="1200">
+                <a:spcPts val="1200"/>
+              </a:spcAft>
+            </a:pPr>
+            <a:r>
+              <a:rPr b="1" sz="1300">
                 <a:solidFill>
                   <a:srgbClr val="1B365D"/>
                 </a:solidFill>
@@ -3336,9 +3297,9 @@
               <a:t>• PS Category –</a:t>
             </a:r>
             <a:r>
-              <a:rPr sz="1200" b="0">
-                <a:solidFill>
-                  <a:srgbClr val="212529"/>
+              <a:rPr sz="1300" b="0">
+                <a:solidFill>
+                  <a:srgbClr val="191E24"/>
                 </a:solidFill>
                 <a:latin typeface="Arial"/>
               </a:rPr>
@@ -3348,11 +3309,11 @@
           <a:p>
             <a:pPr>
               <a:spcAft>
-                <a:spcPts val="1000"/>
-              </a:spcAft>
-            </a:pPr>
-            <a:r>
-              <a:rPr b="1" sz="1200">
+                <a:spcPts val="1200"/>
+              </a:spcAft>
+            </a:pPr>
+            <a:r>
+              <a:rPr b="1" sz="1300">
                 <a:solidFill>
                   <a:srgbClr val="1B365D"/>
                 </a:solidFill>
@@ -3361,9 +3322,9 @@
               <a:t>• Organization –</a:t>
             </a:r>
             <a:r>
-              <a:rPr sz="1200" b="0">
-                <a:solidFill>
-                  <a:srgbClr val="212529"/>
+              <a:rPr sz="1300" b="0">
+                <a:solidFill>
+                  <a:srgbClr val="191E24"/>
                 </a:solidFill>
                 <a:latin typeface="Arial"/>
               </a:rPr>
@@ -3373,11 +3334,11 @@
           <a:p>
             <a:pPr>
               <a:spcAft>
-                <a:spcPts val="1000"/>
-              </a:spcAft>
-            </a:pPr>
-            <a:r>
-              <a:rPr b="1" sz="1200">
+                <a:spcPts val="1200"/>
+              </a:spcAft>
+            </a:pPr>
+            <a:r>
+              <a:rPr b="1" sz="1300">
                 <a:solidFill>
                   <a:srgbClr val="1B365D"/>
                 </a:solidFill>
@@ -3386,23 +3347,23 @@
               <a:t>• Team ID –</a:t>
             </a:r>
             <a:r>
-              <a:rPr sz="1200" b="0">
-                <a:solidFill>
-                  <a:srgbClr val="212529"/>
-                </a:solidFill>
-                <a:latin typeface="Arial"/>
-              </a:rPr>
-              <a:t> [Registered Team ID]</a:t>
+              <a:rPr sz="1300" b="0">
+                <a:solidFill>
+                  <a:srgbClr val="191E24"/>
+                </a:solidFill>
+                <a:latin typeface="Arial"/>
+              </a:rPr>
+              <a:t> [Registered Team ID on SIH Portal]</a:t>
             </a:r>
           </a:p>
           <a:p>
             <a:pPr>
               <a:spcAft>
-                <a:spcPts val="1000"/>
-              </a:spcAft>
-            </a:pPr>
-            <a:r>
-              <a:rPr b="1" sz="1200">
+                <a:spcPts val="1200"/>
+              </a:spcAft>
+            </a:pPr>
+            <a:r>
+              <a:rPr b="1" sz="1300">
                 <a:solidFill>
                   <a:srgbClr val="1B365D"/>
                 </a:solidFill>
@@ -3411,9 +3372,9 @@
               <a:t>• Team Name (Registered on portal) –</a:t>
             </a:r>
             <a:r>
-              <a:rPr sz="1200" b="1">
-                <a:solidFill>
-                  <a:srgbClr val="212529"/>
+              <a:rPr sz="1300" b="1">
+                <a:solidFill>
+                  <a:srgbClr val="191E24"/>
                 </a:solidFill>
                 <a:latin typeface="Arial"/>
               </a:rPr>
@@ -3424,14 +3385,14 @@
       </p:sp>
       <p:sp>
         <p:nvSpPr>
-          <p:cNvPr id="6" name="Rounded Rectangle 5"/>
+          <p:cNvPr id="5" name="Rounded Rectangle 4"/>
           <p:cNvSpPr/>
           <p:nvPr/>
         </p:nvSpPr>
         <p:spPr>
           <a:xfrm>
-            <a:off x="8001000" y="1645920"/>
-            <a:ext cx="3383280" cy="4572000"/>
+            <a:off x="8046720" y="1463040"/>
+            <a:ext cx="3383280" cy="4663440"/>
           </a:xfrm>
           <a:prstGeom prst="roundRect">
             <a:avLst/>
@@ -3458,14 +3419,14 @@
           </a:fontRef>
         </p:style>
         <p:txBody>
-          <a:bodyPr rtlCol="0" anchor="ctr" wrap="square" lIns="228600" tIns="365760" rIns="228600"/>
+          <a:bodyPr rtlCol="0" anchor="ctr" wrap="square" lIns="274320" tIns="365760" rIns="274320"/>
           <a:lstStyle/>
           <a:p>
             <a:pPr algn="ctr">
               <a:spcAft>
-                <a:spcPts val="600"/>
-              </a:spcAft>
-              <a:defRPr sz="1100" b="1">
+                <a:spcPts val="800"/>
+              </a:spcAft>
+              <a:defRPr sz="1200" b="1">
                 <a:solidFill>
                   <a:srgbClr val="F37021"/>
                 </a:solidFill>
@@ -3473,87 +3434,87 @@
               </a:defRPr>
             </a:pPr>
             <a:r>
-              <a:t>PROPOSED SYSTEM</a:t>
+              <a:t>PROPOSED SOLUTION</a:t>
             </a:r>
           </a:p>
           <a:p>
             <a:pPr algn="ctr">
               <a:spcAft>
+                <a:spcPts val="1600"/>
+              </a:spcAft>
+              <a:defRPr sz="2100" b="1">
+                <a:solidFill>
+                  <a:srgbClr val="FFFFFF"/>
+                </a:solidFill>
+                <a:latin typeface="Arial"/>
+              </a:defRPr>
+            </a:pPr>
+            <a:r>
+              <a:t>OmniTransform AI</a:t>
+            </a:r>
+          </a:p>
+          <a:p>
+            <a:pPr>
+              <a:spcAft>
                 <a:spcPts val="1400"/>
               </a:spcAft>
-              <a:defRPr sz="1900" b="1">
-                <a:solidFill>
-                  <a:srgbClr val="FFFFFF"/>
-                </a:solidFill>
-                <a:latin typeface="Arial"/>
-              </a:defRPr>
-            </a:pPr>
-            <a:r>
-              <a:t>OmniTransform AI</a:t>
+              <a:defRPr sz="1150">
+                <a:solidFill>
+                  <a:srgbClr val="E6F0FF"/>
+                </a:solidFill>
+                <a:latin typeface="Arial"/>
+              </a:defRPr>
+            </a:pPr>
+            <a:r>
+              <a:t>[+] Single-Pass 1-to-5 Synchronized Output</a:t>
             </a:r>
           </a:p>
           <a:p>
             <a:pPr>
               <a:spcAft>
-                <a:spcPts val="1200"/>
-              </a:spcAft>
-              <a:defRPr sz="1050">
-                <a:solidFill>
-                  <a:srgbClr val="E1EEFF"/>
-                </a:solidFill>
-                <a:latin typeface="Arial"/>
-              </a:defRPr>
-            </a:pPr>
-            <a:r>
-              <a:t>✔ 1-to-5 Synchronized Ingestion Engine</a:t>
+                <a:spcPts val="1400"/>
+              </a:spcAft>
+              <a:defRPr sz="1150">
+                <a:solidFill>
+                  <a:srgbClr val="E6F0FF"/>
+                </a:solidFill>
+                <a:latin typeface="Arial"/>
+              </a:defRPr>
+            </a:pPr>
+            <a:r>
+              <a:t>[+] 100% Grounded Source Citations</a:t>
             </a:r>
           </a:p>
           <a:p>
             <a:pPr>
               <a:spcAft>
-                <a:spcPts val="1200"/>
-              </a:spcAft>
-              <a:defRPr sz="1050">
-                <a:solidFill>
-                  <a:srgbClr val="E1EEFF"/>
-                </a:solidFill>
-                <a:latin typeface="Arial"/>
-              </a:defRPr>
-            </a:pPr>
-            <a:r>
-              <a:t>✔ 100% Grounded Source Citations</a:t>
+                <a:spcPts val="1400"/>
+              </a:spcAft>
+              <a:defRPr sz="1150">
+                <a:solidFill>
+                  <a:srgbClr val="E6F0FF"/>
+                </a:solidFill>
+                <a:latin typeface="Arial"/>
+              </a:defRPr>
+            </a:pPr>
+            <a:r>
+              <a:t>[+] Sovereign Air-Gapped Compliance</a:t>
             </a:r>
           </a:p>
           <a:p>
             <a:pPr>
               <a:spcAft>
-                <a:spcPts val="1200"/>
-              </a:spcAft>
-              <a:defRPr sz="1050">
-                <a:solidFill>
-                  <a:srgbClr val="E1EEFF"/>
-                </a:solidFill>
-                <a:latin typeface="Arial"/>
-              </a:defRPr>
-            </a:pPr>
-            <a:r>
-              <a:t>✔ Air-Gapped Sovereign On-Premise</a:t>
-            </a:r>
-          </a:p>
-          <a:p>
-            <a:pPr>
-              <a:spcAft>
-                <a:spcPts val="1200"/>
-              </a:spcAft>
-              <a:defRPr sz="1050">
-                <a:solidFill>
-                  <a:srgbClr val="E1EEFF"/>
-                </a:solidFill>
-                <a:latin typeface="Arial"/>
-              </a:defRPr>
-            </a:pPr>
-            <a:r>
-              <a:t>✔ Live Proof: hrl-brand-seo.vercel.app</a:t>
+                <a:spcPts val="1400"/>
+              </a:spcAft>
+              <a:defRPr sz="1150">
+                <a:solidFill>
+                  <a:srgbClr val="E6F0FF"/>
+                </a:solidFill>
+                <a:latin typeface="Arial"/>
+              </a:defRPr>
+            </a:pPr>
+            <a:r>
+              <a:t>[+] Production Ecosystem: hrl-brand-seo.vercel.app</a:t>
             </a:r>
           </a:p>
         </p:txBody>
@@ -3584,8 +3545,8 @@
         </p:nvSpPr>
         <p:spPr>
           <a:xfrm>
-            <a:off x="411480" y="320040"/>
-            <a:ext cx="1600200" cy="960120"/>
+            <a:off x="502920" y="228600"/>
+            <a:ext cx="1691640" cy="960120"/>
           </a:xfrm>
           <a:prstGeom prst="ellipse">
             <a:avLst/>
@@ -3620,18 +3581,18 @@
             <a:pPr algn="ctr">
               <a:defRPr sz="1000">
                 <a:solidFill>
-                  <a:srgbClr val="212529"/>
-                </a:solidFill>
-                <a:latin typeface="Arial"/>
-              </a:defRPr>
-            </a:pPr>
-            <a:r>
-              <a:t>Team</a:t>
+                  <a:srgbClr val="191E24"/>
+                </a:solidFill>
+                <a:latin typeface="Arial"/>
+              </a:defRPr>
+            </a:pPr>
+            <a:r>
+              <a:t>Team Name</a:t>
             </a:r>
           </a:p>
           <a:p>
             <a:pPr algn="ctr">
-              <a:defRPr sz="1100" b="1">
+              <a:defRPr sz="1150" b="1">
                 <a:solidFill>
                   <a:srgbClr val="1B365D"/>
                 </a:solidFill>
@@ -3652,8 +3613,8 @@
         </p:nvSpPr>
         <p:spPr>
           <a:xfrm>
-            <a:off x="2286000" y="411480"/>
-            <a:ext cx="7132320" cy="731520"/>
+            <a:off x="2377440" y="320040"/>
+            <a:ext cx="5303520" cy="777240"/>
           </a:xfrm>
           <a:prstGeom prst="rect">
             <a:avLst/>
@@ -3675,73 +3636,35 @@
               </a:defRPr>
             </a:pPr>
             <a:r>
-              <a:t>IDEA TITLE</a:t>
-            </a:r>
-          </a:p>
-        </p:txBody>
-      </p:sp>
-      <p:sp>
-        <p:nvSpPr>
-          <p:cNvPr id="4" name="TextBox 3"/>
-          <p:cNvSpPr txBox="1"/>
+              <a:t>IDEA TITLE: OmniTransform AI</a:t>
+            </a:r>
+          </a:p>
+        </p:txBody>
+      </p:sp>
+      <p:pic>
+        <p:nvPicPr>
+          <p:cNvPr id="4" name="Picture 3" descr="sih_header_banner.jpg"/>
+          <p:cNvPicPr>
+            <a:picLocks noChangeAspect="1"/>
+          </p:cNvPicPr>
           <p:nvPr/>
-        </p:nvSpPr>
+        </p:nvPicPr>
+        <p:blipFill>
+          <a:blip r:embed="rId2"/>
+          <a:stretch>
+            <a:fillRect/>
+          </a:stretch>
+        </p:blipFill>
         <p:spPr>
           <a:xfrm>
-            <a:off x="9601200" y="274320"/>
-            <a:ext cx="2194560" cy="822960"/>
+            <a:off x="7818120" y="228600"/>
+            <a:ext cx="3886200" cy="513184"/>
           </a:xfrm>
           <a:prstGeom prst="rect">
             <a:avLst/>
           </a:prstGeom>
-          <a:noFill/>
         </p:spPr>
-        <p:txBody>
-          <a:bodyPr wrap="square">
-            <a:spAutoFit/>
-          </a:bodyPr>
-          <a:lstStyle/>
-          <a:p>
-            <a:pPr algn="r">
-              <a:defRPr sz="1000" b="1">
-                <a:solidFill>
-                  <a:srgbClr val="1B365D"/>
-                </a:solidFill>
-                <a:latin typeface="Arial"/>
-              </a:defRPr>
-            </a:pPr>
-            <a:r>
-              <a:t>SMART INDIA</a:t>
-            </a:r>
-          </a:p>
-          <a:p>
-            <a:pPr algn="r">
-              <a:defRPr sz="1000" b="1">
-                <a:solidFill>
-                  <a:srgbClr val="1B365D"/>
-                </a:solidFill>
-                <a:latin typeface="Arial"/>
-              </a:defRPr>
-            </a:pPr>
-            <a:r>
-              <a:t>HACKATHON</a:t>
-            </a:r>
-          </a:p>
-          <a:p>
-            <a:pPr algn="r">
-              <a:defRPr sz="1200" b="1">
-                <a:solidFill>
-                  <a:srgbClr val="F37021"/>
-                </a:solidFill>
-                <a:latin typeface="Arial"/>
-              </a:defRPr>
-            </a:pPr>
-            <a:r>
-              <a:t>2026</a:t>
-            </a:r>
-          </a:p>
-        </p:txBody>
-      </p:sp>
+      </p:pic>
       <p:sp>
         <p:nvSpPr>
           <p:cNvPr id="5" name="Rectangle 4"/>
@@ -3808,7 +3731,7 @@
           <a:lstStyle/>
           <a:p>
             <a:pPr>
-              <a:defRPr sz="950">
+              <a:defRPr sz="1000">
                 <a:solidFill>
                   <a:srgbClr val="FFFFFF"/>
                 </a:solidFill>
@@ -3844,7 +3767,7 @@
           <a:lstStyle/>
           <a:p>
             <a:pPr algn="r">
-              <a:defRPr sz="1050" b="1">
+              <a:defRPr sz="1100" b="1">
                 <a:solidFill>
                   <a:srgbClr val="FFFFFF"/>
                 </a:solidFill>
@@ -3865,8 +3788,8 @@
         </p:nvSpPr>
         <p:spPr>
           <a:xfrm>
-            <a:off x="804672" y="1188720"/>
-            <a:ext cx="10579608" cy="411480"/>
+            <a:off x="731520" y="1234440"/>
+            <a:ext cx="10698480" cy="411480"/>
           </a:xfrm>
           <a:prstGeom prst="rect">
             <a:avLst/>
@@ -3880,7 +3803,7 @@
           <a:lstStyle/>
           <a:p>
             <a:pPr>
-              <a:defRPr sz="1550" b="1" u="sng">
+              <a:defRPr sz="1600" b="1" u="sng">
                 <a:solidFill>
                   <a:srgbClr val="1B365D"/>
                 </a:solidFill>
@@ -3901,18 +3824,18 @@
         </p:nvSpPr>
         <p:spPr>
           <a:xfrm>
-            <a:off x="804672" y="1691640"/>
-            <a:ext cx="3337560" cy="4526280"/>
+            <a:off x="731520" y="1737360"/>
+            <a:ext cx="3337560" cy="4480560"/>
           </a:xfrm>
           <a:prstGeom prst="roundRect">
             <a:avLst/>
           </a:prstGeom>
           <a:solidFill>
-            <a:srgbClr val="F8FAFC"/>
+            <a:srgbClr val="FAFCFF"/>
           </a:solidFill>
           <a:ln>
             <a:solidFill>
-              <a:srgbClr val="E2E8F0"/>
+              <a:srgbClr val="D7E1EE"/>
             </a:solidFill>
           </a:ln>
         </p:spPr>
@@ -3931,47 +3854,70 @@
           </a:fontRef>
         </p:style>
         <p:txBody>
-          <a:bodyPr rtlCol="0" anchor="ctr" wrap="square" lIns="182880" tIns="182880" rIns="182880"/>
+          <a:bodyPr rtlCol="0" anchor="ctr" wrap="square" lIns="201168" tIns="201168" rIns="201168"/>
           <a:lstStyle/>
           <a:p>
             <a:pPr algn="ctr">
               <a:spcAft>
+                <a:spcPts val="1000"/>
+              </a:spcAft>
+              <a:defRPr sz="1400" b="1">
+                <a:solidFill>
+                  <a:srgbClr val="1B365D"/>
+                </a:solidFill>
+                <a:latin typeface="Arial"/>
+              </a:defRPr>
+            </a:pPr>
+            <a:r>
+              <a:t>Detailed Explanation</a:t>
+            </a:r>
+          </a:p>
+          <a:p>
+            <a:pPr>
+              <a:spcAft>
                 <a:spcPts val="800"/>
               </a:spcAft>
-              <a:defRPr sz="1300" b="1">
-                <a:solidFill>
-                  <a:srgbClr val="1B365D"/>
-                </a:solidFill>
-                <a:latin typeface="Arial"/>
-              </a:defRPr>
-            </a:pPr>
-            <a:r>
-              <a:t>Detailed Explanation</a:t>
+              <a:defRPr sz="1200">
+                <a:solidFill>
+                  <a:srgbClr val="191E24"/>
+                </a:solidFill>
+                <a:latin typeface="Arial"/>
+              </a:defRPr>
+            </a:pPr>
+            <a:r>
+              <a:t>• Ingests 50+ page PDFs, threat advisories, and policy whitepapers in a single pass.</a:t>
             </a:r>
           </a:p>
           <a:p>
             <a:pPr>
               <a:spcAft>
+                <a:spcPts val="600"/>
+              </a:spcAft>
+              <a:defRPr sz="1200" b="1">
+                <a:solidFill>
+                  <a:srgbClr val="1B365D"/>
+                </a:solidFill>
+                <a:latin typeface="Arial"/>
+              </a:defRPr>
+            </a:pPr>
+            <a:r>
+              <a:t>• Automatically generates 5 synchronized communication assets in &lt;10s:</a:t>
+            </a:r>
+          </a:p>
+          <a:p>
+            <a:pPr>
+              <a:spcAft>
                 <a:spcPts val="400"/>
               </a:spcAft>
-            </a:pPr>
-            <a:r>
-              <a:rPr b="1" sz="1000">
-                <a:solidFill>
-                  <a:srgbClr val="1B365D"/>
-                </a:solidFill>
-                <a:latin typeface="Arial"/>
-              </a:rPr>
-              <a:t>Core Function: </a:t>
-            </a:r>
-            <a:r>
-              <a:rPr sz="1000">
-                <a:solidFill>
-                  <a:srgbClr val="212529"/>
-                </a:solidFill>
-                <a:latin typeface="Arial"/>
-              </a:rPr>
-              <a:t> Ingests raw 50+ page PDFs, threat advisories, and policy documents in a single pass.</a:t>
+              <a:defRPr sz="1150">
+                <a:solidFill>
+                  <a:srgbClr val="191E24"/>
+                </a:solidFill>
+                <a:latin typeface="Arial"/>
+              </a:defRPr>
+            </a:pPr>
+            <a:r>
+              <a:t>   - 1. Executive 1-Page Summary Brief</a:t>
             </a:r>
           </a:p>
           <a:p>
@@ -3979,24 +3925,15 @@
               <a:spcAft>
                 <a:spcPts val="400"/>
               </a:spcAft>
-            </a:pPr>
-            <a:r>
-              <a:rPr b="1" sz="1000">
-                <a:solidFill>
-                  <a:srgbClr val="1B365D"/>
-                </a:solidFill>
-                <a:latin typeface="Arial"/>
-              </a:rPr>
-              <a:t>1-to-5 Transformation: </a:t>
-            </a:r>
-            <a:r>
-              <a:rPr sz="1000">
-                <a:solidFill>
-                  <a:srgbClr val="212529"/>
-                </a:solidFill>
-                <a:latin typeface="Arial"/>
-              </a:rPr>
-              <a:t> Automatically produces 5 tailored communication assets in &lt;10s:</a:t>
+              <a:defRPr sz="1150">
+                <a:solidFill>
+                  <a:srgbClr val="191E24"/>
+                </a:solidFill>
+                <a:latin typeface="Arial"/>
+              </a:defRPr>
+            </a:pPr>
+            <a:r>
+              <a:t>   - 2. Presentation Slide Deck</a:t>
             </a:r>
           </a:p>
           <a:p>
@@ -4004,24 +3941,15 @@
               <a:spcAft>
                 <a:spcPts val="400"/>
               </a:spcAft>
-            </a:pPr>
-            <a:r>
-              <a:rPr b="1" sz="1000">
-                <a:solidFill>
-                  <a:srgbClr val="F37021"/>
-                </a:solidFill>
-                <a:latin typeface="Arial"/>
-              </a:rPr>
-              <a:t>1. </a:t>
-            </a:r>
-            <a:r>
-              <a:rPr sz="1000">
-                <a:solidFill>
-                  <a:srgbClr val="212529"/>
-                </a:solidFill>
-                <a:latin typeface="Arial"/>
-              </a:rPr>
-              <a:t> 📊 Executive 1-Page Summary Memo</a:t>
+              <a:defRPr sz="1150">
+                <a:solidFill>
+                  <a:srgbClr val="191E24"/>
+                </a:solidFill>
+                <a:latin typeface="Arial"/>
+              </a:defRPr>
+            </a:pPr>
+            <a:r>
+              <a:t>   - 3. Visual Infographic Cards</a:t>
             </a:r>
           </a:p>
           <a:p>
@@ -4029,24 +3957,15 @@
               <a:spcAft>
                 <a:spcPts val="400"/>
               </a:spcAft>
-            </a:pPr>
-            <a:r>
-              <a:rPr b="1" sz="1000">
-                <a:solidFill>
-                  <a:srgbClr val="F37021"/>
-                </a:solidFill>
-                <a:latin typeface="Arial"/>
-              </a:rPr>
-              <a:t>2. </a:t>
-            </a:r>
-            <a:r>
-              <a:rPr sz="1000">
-                <a:solidFill>
-                  <a:srgbClr val="212529"/>
-                </a:solidFill>
-                <a:latin typeface="Arial"/>
-              </a:rPr>
-              <a:t> 🖥️ Meeting-Ready Slide Deck</a:t>
+              <a:defRPr sz="1150">
+                <a:solidFill>
+                  <a:srgbClr val="191E24"/>
+                </a:solidFill>
+                <a:latin typeface="Arial"/>
+              </a:defRPr>
+            </a:pPr>
+            <a:r>
+              <a:t>   - 4. Multilingual Press Release</a:t>
             </a:r>
           </a:p>
           <a:p>
@@ -4054,74 +3973,15 @@
               <a:spcAft>
                 <a:spcPts val="400"/>
               </a:spcAft>
-            </a:pPr>
-            <a:r>
-              <a:rPr b="1" sz="1000">
-                <a:solidFill>
-                  <a:srgbClr val="F37021"/>
-                </a:solidFill>
-                <a:latin typeface="Arial"/>
-              </a:rPr>
-              <a:t>3. </a:t>
-            </a:r>
-            <a:r>
-              <a:rPr sz="1000">
-                <a:solidFill>
-                  <a:srgbClr val="212529"/>
-                </a:solidFill>
-                <a:latin typeface="Arial"/>
-              </a:rPr>
-              <a:t> 🎨 Public Visual Infographic Cards</a:t>
-            </a:r>
-          </a:p>
-          <a:p>
-            <a:pPr>
-              <a:spcAft>
-                <a:spcPts val="400"/>
-              </a:spcAft>
-            </a:pPr>
-            <a:r>
-              <a:rPr b="1" sz="1000">
-                <a:solidFill>
-                  <a:srgbClr val="F37021"/>
-                </a:solidFill>
-                <a:latin typeface="Arial"/>
-              </a:rPr>
-              <a:t>4. </a:t>
-            </a:r>
-            <a:r>
-              <a:rPr sz="1000">
-                <a:solidFill>
-                  <a:srgbClr val="212529"/>
-                </a:solidFill>
-                <a:latin typeface="Arial"/>
-              </a:rPr>
-              <a:t> 📰 Regional Multilingual Press Release</a:t>
-            </a:r>
-          </a:p>
-          <a:p>
-            <a:pPr>
-              <a:spcAft>
-                <a:spcPts val="400"/>
-              </a:spcAft>
-            </a:pPr>
-            <a:r>
-              <a:rPr b="1" sz="1000">
-                <a:solidFill>
-                  <a:srgbClr val="F37021"/>
-                </a:solidFill>
-                <a:latin typeface="Arial"/>
-              </a:rPr>
-              <a:t>5. </a:t>
-            </a:r>
-            <a:r>
-              <a:rPr sz="1000">
-                <a:solidFill>
-                  <a:srgbClr val="212529"/>
-                </a:solidFill>
-                <a:latin typeface="Arial"/>
-              </a:rPr>
-              <a:t> 🎙️ 60s Voice AI Audio Briefing</a:t>
+              <a:defRPr sz="1150">
+                <a:solidFill>
+                  <a:srgbClr val="191E24"/>
+                </a:solidFill>
+                <a:latin typeface="Arial"/>
+              </a:defRPr>
+            </a:pPr>
+            <a:r>
+              <a:t>   - 5. 60s Voice Audio Podcast</a:t>
             </a:r>
           </a:p>
         </p:txBody>
@@ -4134,18 +3994,18 @@
         </p:nvSpPr>
         <p:spPr>
           <a:xfrm>
-            <a:off x="4425696" y="1691640"/>
-            <a:ext cx="3337560" cy="4526280"/>
+            <a:off x="4416552" y="1737360"/>
+            <a:ext cx="3337560" cy="4480560"/>
           </a:xfrm>
           <a:prstGeom prst="roundRect">
             <a:avLst/>
           </a:prstGeom>
           <a:solidFill>
-            <a:srgbClr val="F8FAFC"/>
+            <a:srgbClr val="FAFCFF"/>
           </a:solidFill>
           <a:ln>
             <a:solidFill>
-              <a:srgbClr val="E2E8F0"/>
+              <a:srgbClr val="D7E1EE"/>
             </a:solidFill>
           </a:ln>
         </p:spPr>
@@ -4164,122 +4024,122 @@
           </a:fontRef>
         </p:style>
         <p:txBody>
-          <a:bodyPr rtlCol="0" anchor="ctr" wrap="square" lIns="182880" tIns="182880" rIns="182880"/>
+          <a:bodyPr rtlCol="0" anchor="ctr" wrap="square" lIns="201168" tIns="201168" rIns="201168"/>
           <a:lstStyle/>
           <a:p>
             <a:pPr algn="ctr">
               <a:spcAft>
+                <a:spcPts val="1000"/>
+              </a:spcAft>
+              <a:defRPr sz="1400" b="1">
+                <a:solidFill>
+                  <a:srgbClr val="1B365D"/>
+                </a:solidFill>
+                <a:latin typeface="Arial"/>
+              </a:defRPr>
+            </a:pPr>
+            <a:r>
+              <a:t>How it Addresses the Problem</a:t>
+            </a:r>
+          </a:p>
+          <a:p>
+            <a:pPr>
+              <a:spcAft>
                 <a:spcPts val="800"/>
               </a:spcAft>
-              <a:defRPr sz="1300" b="1">
-                <a:solidFill>
-                  <a:srgbClr val="1B365D"/>
-                </a:solidFill>
-                <a:latin typeface="Arial"/>
-              </a:defRPr>
-            </a:pPr>
-            <a:r>
-              <a:t>How It Addresses Problem</a:t>
+            </a:pPr>
+            <a:r>
+              <a:rPr b="1" sz="1150">
+                <a:solidFill>
+                  <a:srgbClr val="1B365D"/>
+                </a:solidFill>
+                <a:latin typeface="Arial"/>
+              </a:rPr>
+              <a:t>• Eliminates Manual Bottlenecks: </a:t>
+            </a:r>
+            <a:r>
+              <a:rPr sz="1150">
+                <a:solidFill>
+                  <a:srgbClr val="191E24"/>
+                </a:solidFill>
+                <a:latin typeface="Arial"/>
+              </a:rPr>
+              <a:t> Saves 4-6 hours daily spent by officers manually restructuring dense technical documents.</a:t>
             </a:r>
           </a:p>
           <a:p>
             <a:pPr>
               <a:spcAft>
-                <a:spcPts val="600"/>
-              </a:spcAft>
-            </a:pPr>
-            <a:r>
-              <a:rPr b="1" sz="1000">
-                <a:solidFill>
-                  <a:srgbClr val="1B365D"/>
-                </a:solidFill>
-                <a:latin typeface="Arial"/>
-              </a:rPr>
-              <a:t>• Eliminates Manual Bottleneck: </a:t>
-            </a:r>
-            <a:r>
-              <a:rPr sz="1000">
-                <a:solidFill>
-                  <a:srgbClr val="212529"/>
-                </a:solidFill>
-                <a:latin typeface="Arial"/>
-              </a:rPr>
-              <a:t> Saves 4-6 hours daily spent by officers rewriting dense reports for leadership and public channels.</a:t>
+                <a:spcPts val="800"/>
+              </a:spcAft>
+            </a:pPr>
+            <a:r>
+              <a:rPr b="1" sz="1150">
+                <a:solidFill>
+                  <a:srgbClr val="1B365D"/>
+                </a:solidFill>
+                <a:latin typeface="Arial"/>
+              </a:rPr>
+              <a:t>• Unified Sovereign Platform: </a:t>
+            </a:r>
+            <a:r>
+              <a:rPr sz="1150">
+                <a:solidFill>
+                  <a:srgbClr val="191E24"/>
+                </a:solidFill>
+                <a:latin typeface="Arial"/>
+              </a:rPr>
+              <a:t> Replaces disconnected tools into one integrated local dashboard.</a:t>
             </a:r>
           </a:p>
           <a:p>
             <a:pPr>
               <a:spcAft>
-                <a:spcPts val="600"/>
-              </a:spcAft>
-            </a:pPr>
-            <a:r>
-              <a:rPr b="1" sz="1000">
-                <a:solidFill>
-                  <a:srgbClr val="1B365D"/>
-                </a:solidFill>
-                <a:latin typeface="Arial"/>
-              </a:rPr>
-              <a:t>• Unified Sovereign Dashboard: </a:t>
-            </a:r>
-            <a:r>
-              <a:rPr sz="1000">
-                <a:solidFill>
-                  <a:srgbClr val="212529"/>
-                </a:solidFill>
-                <a:latin typeface="Arial"/>
-              </a:rPr>
-              <a:t> Replaces disconnected tools (Canva, Word, PPT, Chatbots) into one unified system.</a:t>
+                <a:spcPts val="800"/>
+              </a:spcAft>
+            </a:pPr>
+            <a:r>
+              <a:rPr b="1" sz="1150">
+                <a:solidFill>
+                  <a:srgbClr val="1B365D"/>
+                </a:solidFill>
+                <a:latin typeface="Arial"/>
+              </a:rPr>
+              <a:t>• Preserves Tactical Velocity: </a:t>
+            </a:r>
+            <a:r>
+              <a:rPr sz="1150">
+                <a:solidFill>
+                  <a:srgbClr val="191E24"/>
+                </a:solidFill>
+                <a:latin typeface="Arial"/>
+              </a:rPr>
+              <a:t> Delivers immediate dissemination during critical national security events.</a:t>
             </a:r>
           </a:p>
           <a:p>
             <a:pPr>
               <a:spcAft>
-                <a:spcPts val="600"/>
-              </a:spcAft>
-            </a:pPr>
-            <a:r>
-              <a:rPr b="1" sz="1000">
-                <a:solidFill>
-                  <a:srgbClr val="1B365D"/>
-                </a:solidFill>
-                <a:latin typeface="Arial"/>
-              </a:rPr>
-              <a:t>• Prevents Tactical Delay: </a:t>
-            </a:r>
-            <a:r>
-              <a:rPr sz="1000">
-                <a:solidFill>
-                  <a:srgbClr val="212529"/>
-                </a:solidFill>
-                <a:latin typeface="Arial"/>
-              </a:rPr>
-              <a:t> Delivers instant threat intelligence dissemination for time-critical defense scenarios.</a:t>
-            </a:r>
-          </a:p>
-          <a:p>
-            <a:pPr>
-              <a:spcAft>
-                <a:spcPts val="600"/>
-              </a:spcAft>
-            </a:pPr>
-            <a:r>
-              <a:rPr b="1" sz="1000">
-                <a:solidFill>
-                  <a:srgbClr val="1B365D"/>
-                </a:solidFill>
-                <a:latin typeface="Arial"/>
-              </a:rPr>
-              <a:t>• Eliminates Hallucinations: </a:t>
-            </a:r>
-            <a:r>
-              <a:rPr sz="1000">
-                <a:solidFill>
-                  <a:srgbClr val="212529"/>
-                </a:solidFill>
-                <a:latin typeface="Arial"/>
-              </a:rPr>
-              <a:t> Strict RAG boundaries guarantee outputs are 100% faithful to the source document.</a:t>
+                <a:spcPts val="800"/>
+              </a:spcAft>
+            </a:pPr>
+            <a:r>
+              <a:rPr b="1" sz="1150">
+                <a:solidFill>
+                  <a:srgbClr val="1B365D"/>
+                </a:solidFill>
+                <a:latin typeface="Arial"/>
+              </a:rPr>
+              <a:t>• Eliminates Hallucination Risk: </a:t>
+            </a:r>
+            <a:r>
+              <a:rPr sz="1150">
+                <a:solidFill>
+                  <a:srgbClr val="191E24"/>
+                </a:solidFill>
+                <a:latin typeface="Arial"/>
+              </a:rPr>
+              <a:t> Enforces strict RAG boundaries to ensure complete factual precision.</a:t>
             </a:r>
           </a:p>
         </p:txBody>
@@ -4292,18 +4152,18 @@
         </p:nvSpPr>
         <p:spPr>
           <a:xfrm>
-            <a:off x="8046720" y="1691640"/>
-            <a:ext cx="3337560" cy="4526280"/>
+            <a:off x="8101584" y="1737360"/>
+            <a:ext cx="3337560" cy="4480560"/>
           </a:xfrm>
           <a:prstGeom prst="roundRect">
             <a:avLst/>
           </a:prstGeom>
           <a:solidFill>
-            <a:srgbClr val="F8FAFC"/>
+            <a:srgbClr val="FAFCFF"/>
           </a:solidFill>
           <a:ln>
             <a:solidFill>
-              <a:srgbClr val="E2E8F0"/>
+              <a:srgbClr val="D7E1EE"/>
             </a:solidFill>
           </a:ln>
         </p:spPr>
@@ -4322,122 +4182,122 @@
           </a:fontRef>
         </p:style>
         <p:txBody>
-          <a:bodyPr rtlCol="0" anchor="ctr" wrap="square" lIns="182880" tIns="182880" rIns="182880"/>
+          <a:bodyPr rtlCol="0" anchor="ctr" wrap="square" lIns="201168" tIns="201168" rIns="201168"/>
           <a:lstStyle/>
           <a:p>
             <a:pPr algn="ctr">
               <a:spcAft>
+                <a:spcPts val="1000"/>
+              </a:spcAft>
+              <a:defRPr sz="1400" b="1">
+                <a:solidFill>
+                  <a:srgbClr val="1B365D"/>
+                </a:solidFill>
+                <a:latin typeface="Arial"/>
+              </a:defRPr>
+            </a:pPr>
+            <a:r>
+              <a:t>Innovation and Uniqueness</a:t>
+            </a:r>
+          </a:p>
+          <a:p>
+            <a:pPr>
+              <a:spcAft>
                 <a:spcPts val="800"/>
               </a:spcAft>
-              <a:defRPr sz="1300" b="1">
-                <a:solidFill>
-                  <a:srgbClr val="1B365D"/>
-                </a:solidFill>
-                <a:latin typeface="Arial"/>
-              </a:defRPr>
-            </a:pPr>
-            <a:r>
-              <a:t>Innovation &amp; Uniqueness</a:t>
+            </a:pPr>
+            <a:r>
+              <a:rPr b="1" sz="1150">
+                <a:solidFill>
+                  <a:srgbClr val="1B365D"/>
+                </a:solidFill>
+                <a:latin typeface="Arial"/>
+              </a:rPr>
+              <a:t>• Interactive Source Highlighting: </a:t>
+            </a:r>
+            <a:r>
+              <a:rPr sz="1150">
+                <a:solidFill>
+                  <a:srgbClr val="191E24"/>
+                </a:solidFill>
+                <a:latin typeface="Arial"/>
+              </a:rPr>
+              <a:t> Click any bullet point to open the raw PDF with the exact sentence highlighted.</a:t>
             </a:r>
           </a:p>
           <a:p>
             <a:pPr>
               <a:spcAft>
-                <a:spcPts val="600"/>
-              </a:spcAft>
-            </a:pPr>
-            <a:r>
-              <a:rPr b="1" sz="1000">
-                <a:solidFill>
-                  <a:srgbClr val="1B365D"/>
-                </a:solidFill>
-                <a:latin typeface="Arial"/>
-              </a:rPr>
-              <a:t>• Interactive Source Highlighting: </a:t>
-            </a:r>
-            <a:r>
-              <a:rPr sz="1000">
-                <a:solidFill>
-                  <a:srgbClr val="212529"/>
-                </a:solidFill>
-                <a:latin typeface="Arial"/>
-              </a:rPr>
-              <a:t> Click any bullet point to open the PDF with exact sentence coordinates highlighted.</a:t>
+                <a:spcPts val="800"/>
+              </a:spcAft>
+            </a:pPr>
+            <a:r>
+              <a:rPr b="1" sz="1150">
+                <a:solidFill>
+                  <a:srgbClr val="1B365D"/>
+                </a:solidFill>
+                <a:latin typeface="Arial"/>
+              </a:rPr>
+              <a:t>• Multi-Persona Tone Switching: </a:t>
+            </a:r>
+            <a:r>
+              <a:rPr sz="1150">
+                <a:solidFill>
+                  <a:srgbClr val="191E24"/>
+                </a:solidFill>
+                <a:latin typeface="Arial"/>
+              </a:rPr>
+              <a:t> 1-click toggle between C-Suite Brief, Citizen Explainer, and Threat Alert.</a:t>
             </a:r>
           </a:p>
           <a:p>
             <a:pPr>
               <a:spcAft>
-                <a:spcPts val="600"/>
-              </a:spcAft>
-            </a:pPr>
-            <a:r>
-              <a:rPr b="1" sz="1000">
-                <a:solidFill>
-                  <a:srgbClr val="1B365D"/>
-                </a:solidFill>
-                <a:latin typeface="Arial"/>
-              </a:rPr>
-              <a:t>• Dynamic Multi-Persona Switching: </a:t>
-            </a:r>
-            <a:r>
-              <a:rPr sz="1000">
-                <a:solidFill>
-                  <a:srgbClr val="212529"/>
-                </a:solidFill>
-                <a:latin typeface="Arial"/>
-              </a:rPr>
-              <a:t> 1-click toggle between C-Suite Brief, Citizen Explainer, and Threat Alert.</a:t>
+                <a:spcPts val="800"/>
+              </a:spcAft>
+            </a:pPr>
+            <a:r>
+              <a:rPr b="1" sz="1150">
+                <a:solidFill>
+                  <a:srgbClr val="1B365D"/>
+                </a:solidFill>
+                <a:latin typeface="Arial"/>
+              </a:rPr>
+              <a:t>• Air-Gapped Sovereign Security: </a:t>
+            </a:r>
+            <a:r>
+              <a:rPr sz="1150">
+                <a:solidFill>
+                  <a:srgbClr val="191E24"/>
+                </a:solidFill>
+                <a:latin typeface="Arial"/>
+              </a:rPr>
+              <a:t> Runs locally on open-weights (Llama 3/Mistral) without public cloud data leaks.</a:t>
             </a:r>
           </a:p>
           <a:p>
             <a:pPr>
               <a:spcAft>
-                <a:spcPts val="600"/>
-              </a:spcAft>
-            </a:pPr>
-            <a:r>
-              <a:rPr b="1" sz="1000">
-                <a:solidFill>
-                  <a:srgbClr val="1B365D"/>
-                </a:solidFill>
-                <a:latin typeface="Arial"/>
-              </a:rPr>
-              <a:t>• Air-Gapped Sovereign Security: </a:t>
-            </a:r>
-            <a:r>
-              <a:rPr sz="1000">
-                <a:solidFill>
-                  <a:srgbClr val="212529"/>
-                </a:solidFill>
-                <a:latin typeface="Arial"/>
-              </a:rPr>
-              <a:t> Operates entirely offline on open-weights (Llama 3/Mistral) with zero cloud telemetry.</a:t>
-            </a:r>
-          </a:p>
-          <a:p>
-            <a:pPr>
-              <a:spcAft>
-                <a:spcPts val="600"/>
-              </a:spcAft>
-            </a:pPr>
-            <a:r>
-              <a:rPr b="1" sz="1000">
-                <a:solidFill>
-                  <a:srgbClr val="1B365D"/>
-                </a:solidFill>
-                <a:latin typeface="Arial"/>
-              </a:rPr>
-              <a:t>• Apple Design Standard: </a:t>
-            </a:r>
-            <a:r>
-              <a:rPr sz="1000">
-                <a:solidFill>
-                  <a:srgbClr val="212529"/>
-                </a:solidFill>
-                <a:latin typeface="Arial"/>
-              </a:rPr>
-              <a:t> High-contrast glassmorphism UI engineered for high readability and fast decision-making.</a:t>
+                <a:spcPts val="800"/>
+              </a:spcAft>
+            </a:pPr>
+            <a:r>
+              <a:rPr b="1" sz="1150">
+                <a:solidFill>
+                  <a:srgbClr val="1B365D"/>
+                </a:solidFill>
+                <a:latin typeface="Arial"/>
+              </a:rPr>
+              <a:t>• Deterministic Speed (&lt;10s): </a:t>
+            </a:r>
+            <a:r>
+              <a:rPr sz="1150">
+                <a:solidFill>
+                  <a:srgbClr val="191E24"/>
+                </a:solidFill>
+                <a:latin typeface="Arial"/>
+              </a:rPr>
+              <a:t> High-throughput asynchronous pipeline with zero runtime failures.</a:t>
             </a:r>
           </a:p>
         </p:txBody>
@@ -4468,8 +4328,8 @@
         </p:nvSpPr>
         <p:spPr>
           <a:xfrm>
-            <a:off x="411480" y="320040"/>
-            <a:ext cx="1600200" cy="960120"/>
+            <a:off x="502920" y="228600"/>
+            <a:ext cx="1691640" cy="960120"/>
           </a:xfrm>
           <a:prstGeom prst="ellipse">
             <a:avLst/>
@@ -4504,18 +4364,18 @@
             <a:pPr algn="ctr">
               <a:defRPr sz="1000">
                 <a:solidFill>
-                  <a:srgbClr val="212529"/>
-                </a:solidFill>
-                <a:latin typeface="Arial"/>
-              </a:defRPr>
-            </a:pPr>
-            <a:r>
-              <a:t>Team</a:t>
+                  <a:srgbClr val="191E24"/>
+                </a:solidFill>
+                <a:latin typeface="Arial"/>
+              </a:defRPr>
+            </a:pPr>
+            <a:r>
+              <a:t>Team Name</a:t>
             </a:r>
           </a:p>
           <a:p>
             <a:pPr algn="ctr">
-              <a:defRPr sz="1100" b="1">
+              <a:defRPr sz="1150" b="1">
                 <a:solidFill>
                   <a:srgbClr val="1B365D"/>
                 </a:solidFill>
@@ -4536,8 +4396,8 @@
         </p:nvSpPr>
         <p:spPr>
           <a:xfrm>
-            <a:off x="2286000" y="411480"/>
-            <a:ext cx="7132320" cy="731520"/>
+            <a:off x="2377440" y="320040"/>
+            <a:ext cx="5303520" cy="777240"/>
           </a:xfrm>
           <a:prstGeom prst="rect">
             <a:avLst/>
@@ -4564,68 +4424,30 @@
           </a:p>
         </p:txBody>
       </p:sp>
-      <p:sp>
-        <p:nvSpPr>
-          <p:cNvPr id="4" name="TextBox 3"/>
-          <p:cNvSpPr txBox="1"/>
+      <p:pic>
+        <p:nvPicPr>
+          <p:cNvPr id="4" name="Picture 3" descr="sih_header_banner.jpg"/>
+          <p:cNvPicPr>
+            <a:picLocks noChangeAspect="1"/>
+          </p:cNvPicPr>
           <p:nvPr/>
-        </p:nvSpPr>
+        </p:nvPicPr>
+        <p:blipFill>
+          <a:blip r:embed="rId2"/>
+          <a:stretch>
+            <a:fillRect/>
+          </a:stretch>
+        </p:blipFill>
         <p:spPr>
           <a:xfrm>
-            <a:off x="9601200" y="274320"/>
-            <a:ext cx="2194560" cy="822960"/>
+            <a:off x="7818120" y="228600"/>
+            <a:ext cx="3886200" cy="513184"/>
           </a:xfrm>
           <a:prstGeom prst="rect">
             <a:avLst/>
           </a:prstGeom>
-          <a:noFill/>
         </p:spPr>
-        <p:txBody>
-          <a:bodyPr wrap="square">
-            <a:spAutoFit/>
-          </a:bodyPr>
-          <a:lstStyle/>
-          <a:p>
-            <a:pPr algn="r">
-              <a:defRPr sz="1000" b="1">
-                <a:solidFill>
-                  <a:srgbClr val="1B365D"/>
-                </a:solidFill>
-                <a:latin typeface="Arial"/>
-              </a:defRPr>
-            </a:pPr>
-            <a:r>
-              <a:t>SMART INDIA</a:t>
-            </a:r>
-          </a:p>
-          <a:p>
-            <a:pPr algn="r">
-              <a:defRPr sz="1000" b="1">
-                <a:solidFill>
-                  <a:srgbClr val="1B365D"/>
-                </a:solidFill>
-                <a:latin typeface="Arial"/>
-              </a:defRPr>
-            </a:pPr>
-            <a:r>
-              <a:t>HACKATHON</a:t>
-            </a:r>
-          </a:p>
-          <a:p>
-            <a:pPr algn="r">
-              <a:defRPr sz="1200" b="1">
-                <a:solidFill>
-                  <a:srgbClr val="F37021"/>
-                </a:solidFill>
-                <a:latin typeface="Arial"/>
-              </a:defRPr>
-            </a:pPr>
-            <a:r>
-              <a:t>2026</a:t>
-            </a:r>
-          </a:p>
-        </p:txBody>
-      </p:sp>
+      </p:pic>
       <p:sp>
         <p:nvSpPr>
           <p:cNvPr id="5" name="Rectangle 4"/>
@@ -4692,7 +4514,7 @@
           <a:lstStyle/>
           <a:p>
             <a:pPr>
-              <a:defRPr sz="950">
+              <a:defRPr sz="1000">
                 <a:solidFill>
                   <a:srgbClr val="FFFFFF"/>
                 </a:solidFill>
@@ -4728,7 +4550,7 @@
           <a:lstStyle/>
           <a:p>
             <a:pPr algn="r">
-              <a:defRPr sz="1050" b="1">
+              <a:defRPr sz="1100" b="1">
                 <a:solidFill>
                   <a:srgbClr val="FFFFFF"/>
                 </a:solidFill>
@@ -4749,18 +4571,18 @@
         </p:nvSpPr>
         <p:spPr>
           <a:xfrm>
-            <a:off x="804672" y="1325880"/>
-            <a:ext cx="4297680" cy="4892040"/>
+            <a:off x="731520" y="1325880"/>
+            <a:ext cx="4389120" cy="4892040"/>
           </a:xfrm>
           <a:prstGeom prst="roundRect">
             <a:avLst/>
           </a:prstGeom>
           <a:solidFill>
-            <a:srgbClr val="F8FAFC"/>
+            <a:srgbClr val="FAFCFF"/>
           </a:solidFill>
           <a:ln>
             <a:solidFill>
-              <a:srgbClr val="E2E8F0"/>
+              <a:srgbClr val="D7E1EE"/>
             </a:solidFill>
           </a:ln>
         </p:spPr>
@@ -4779,14 +4601,14 @@
           </a:fontRef>
         </p:style>
         <p:txBody>
-          <a:bodyPr rtlCol="0" anchor="ctr" wrap="square" lIns="228600" tIns="182880" rIns="228600"/>
+          <a:bodyPr rtlCol="0" anchor="ctr" wrap="square" lIns="256032" tIns="228600" rIns="256032"/>
           <a:lstStyle/>
           <a:p>
             <a:pPr algn="ctr">
               <a:spcAft>
-                <a:spcPts val="1000"/>
-              </a:spcAft>
-              <a:defRPr sz="1550" b="1" u="sng">
+                <a:spcPts val="1200"/>
+              </a:spcAft>
+              <a:defRPr sz="1500" b="1" u="sng">
                 <a:solidFill>
                   <a:srgbClr val="1B365D"/>
                 </a:solidFill>
@@ -4800,11 +4622,11 @@
           <a:p>
             <a:pPr>
               <a:spcAft>
-                <a:spcPts val="500"/>
-              </a:spcAft>
-            </a:pPr>
-            <a:r>
-              <a:rPr b="1" sz="1000">
+                <a:spcPts val="600"/>
+              </a:spcAft>
+            </a:pPr>
+            <a:r>
+              <a:rPr b="1" sz="1150">
                 <a:solidFill>
                   <a:srgbClr val="1B365D"/>
                 </a:solidFill>
@@ -4813,9 +4635,9 @@
               <a:t>Frontend: </a:t>
             </a:r>
             <a:r>
-              <a:rPr sz="950">
-                <a:solidFill>
-                  <a:srgbClr val="212529"/>
+              <a:rPr sz="1100">
+                <a:solidFill>
+                  <a:srgbClr val="191E24"/>
                 </a:solidFill>
                 <a:latin typeface="Arial"/>
               </a:rPr>
@@ -4825,97 +4647,97 @@
           <a:p>
             <a:pPr>
               <a:spcAft>
-                <a:spcPts val="500"/>
-              </a:spcAft>
-            </a:pPr>
-            <a:r>
-              <a:rPr b="1" sz="1000">
-                <a:solidFill>
-                  <a:srgbClr val="1B365D"/>
-                </a:solidFill>
-                <a:latin typeface="Arial"/>
-              </a:rPr>
-              <a:t>Backend &amp; Parser: </a:t>
-            </a:r>
-            <a:r>
-              <a:rPr sz="950">
-                <a:solidFill>
-                  <a:srgbClr val="212529"/>
-                </a:solidFill>
-                <a:latin typeface="Arial"/>
-              </a:rPr>
-              <a:t>Python FastAPI, PyMuPDF spatial coordinate extractor, LangChain / LlamaIndex.</a:t>
+                <a:spcPts val="600"/>
+              </a:spcAft>
+            </a:pPr>
+            <a:r>
+              <a:rPr b="1" sz="1150">
+                <a:solidFill>
+                  <a:srgbClr val="1B365D"/>
+                </a:solidFill>
+                <a:latin typeface="Arial"/>
+              </a:rPr>
+              <a:t>Backend &amp; Ingestion: </a:t>
+            </a:r>
+            <a:r>
+              <a:rPr sz="1100">
+                <a:solidFill>
+                  <a:srgbClr val="191E24"/>
+                </a:solidFill>
+                <a:latin typeface="Arial"/>
+              </a:rPr>
+              <a:t>Python FastAPI, PyMuPDF spatial coordinate extractor, LangChain.</a:t>
             </a:r>
           </a:p>
           <a:p>
             <a:pPr>
               <a:spcAft>
-                <a:spcPts val="500"/>
-              </a:spcAft>
-            </a:pPr>
-            <a:r>
-              <a:rPr b="1" sz="1000">
-                <a:solidFill>
-                  <a:srgbClr val="1B365D"/>
-                </a:solidFill>
-                <a:latin typeface="Arial"/>
-              </a:rPr>
-              <a:t>AI / Foundation LLMs: </a:t>
-            </a:r>
-            <a:r>
-              <a:rPr sz="950">
-                <a:solidFill>
-                  <a:srgbClr val="212529"/>
-                </a:solidFill>
-                <a:latin typeface="Arial"/>
-              </a:rPr>
-              <a:t>Llama 3.3 (70B), Mistral Large, IndicBERT for regional translation.</a:t>
+                <a:spcPts val="600"/>
+              </a:spcAft>
+            </a:pPr>
+            <a:r>
+              <a:rPr b="1" sz="1150">
+                <a:solidFill>
+                  <a:srgbClr val="1B365D"/>
+                </a:solidFill>
+                <a:latin typeface="Arial"/>
+              </a:rPr>
+              <a:t>Foundation AI Models: </a:t>
+            </a:r>
+            <a:r>
+              <a:rPr sz="1100">
+                <a:solidFill>
+                  <a:srgbClr val="191E24"/>
+                </a:solidFill>
+                <a:latin typeface="Arial"/>
+              </a:rPr>
+              <a:t>Llama 3.3 (70B), Mistral Large, IndicBERT (regional translation).</a:t>
             </a:r>
           </a:p>
           <a:p>
             <a:pPr>
               <a:spcAft>
-                <a:spcPts val="500"/>
-              </a:spcAft>
-            </a:pPr>
-            <a:r>
-              <a:rPr b="1" sz="1000">
-                <a:solidFill>
-                  <a:srgbClr val="1B365D"/>
-                </a:solidFill>
-                <a:latin typeface="Arial"/>
-              </a:rPr>
-              <a:t>Slide &amp; Canvas Renderers: </a:t>
-            </a:r>
-            <a:r>
-              <a:rPr sz="950">
-                <a:solidFill>
-                  <a:srgbClr val="212529"/>
-                </a:solidFill>
-                <a:latin typeface="Arial"/>
-              </a:rPr>
-              <a:t>Satori HTML-to-Image Canvas API, Marp slide compiler, FFmpeg.</a:t>
+                <a:spcPts val="600"/>
+              </a:spcAft>
+            </a:pPr>
+            <a:r>
+              <a:rPr b="1" sz="1150">
+                <a:solidFill>
+                  <a:srgbClr val="1B365D"/>
+                </a:solidFill>
+                <a:latin typeface="Arial"/>
+              </a:rPr>
+              <a:t>Rendering Compilers: </a:t>
+            </a:r>
+            <a:r>
+              <a:rPr sz="1100">
+                <a:solidFill>
+                  <a:srgbClr val="191E24"/>
+                </a:solidFill>
+                <a:latin typeface="Arial"/>
+              </a:rPr>
+              <a:t>Satori HTML-to-Image Canvas API, Marp slide engine, FFmpeg.</a:t>
             </a:r>
           </a:p>
           <a:p>
             <a:pPr>
               <a:spcAft>
-                <a:spcPts val="500"/>
-              </a:spcAft>
-            </a:pPr>
-            <a:r>
-              <a:rPr b="1" sz="1000">
-                <a:solidFill>
-                  <a:srgbClr val="1B365D"/>
-                </a:solidFill>
-                <a:latin typeface="Arial"/>
-              </a:rPr>
-              <a:t>Voice AI Engine: </a:t>
-            </a:r>
-            <a:r>
-              <a:rPr sz="950">
-                <a:solidFill>
-                  <a:srgbClr val="212529"/>
+                <a:spcPts val="600"/>
+              </a:spcAft>
+            </a:pPr>
+            <a:r>
+              <a:rPr b="1" sz="1150">
+                <a:solidFill>
+                  <a:srgbClr val="1B365D"/>
+                </a:solidFill>
+                <a:latin typeface="Arial"/>
+              </a:rPr>
+              <a:t>Voice AI Synthesis: </a:t>
+            </a:r>
+            <a:r>
+              <a:rPr sz="1100">
+                <a:solidFill>
+                  <a:srgbClr val="191E24"/>
                 </a:solidFill>
                 <a:latin typeface="Arial"/>
               </a:rPr>
@@ -4925,26 +4747,26 @@
           <a:p>
             <a:pPr>
               <a:spcAft>
-                <a:spcPts val="500"/>
-              </a:spcAft>
-            </a:pPr>
-            <a:r>
-              <a:rPr b="1" sz="1000">
-                <a:solidFill>
-                  <a:srgbClr val="1B365D"/>
-                </a:solidFill>
-                <a:latin typeface="Arial"/>
-              </a:rPr>
-              <a:t>Infrastructure: </a:t>
-            </a:r>
-            <a:r>
-              <a:rPr sz="950">
-                <a:solidFill>
-                  <a:srgbClr val="212529"/>
-                </a:solidFill>
-                <a:latin typeface="Arial"/>
-              </a:rPr>
-              <a:t>Docker containerized, air-gapped on-premise Linux host, zero telemetry.</a:t>
+                <a:spcPts val="600"/>
+              </a:spcAft>
+            </a:pPr>
+            <a:r>
+              <a:rPr b="1" sz="1150">
+                <a:solidFill>
+                  <a:srgbClr val="1B365D"/>
+                </a:solidFill>
+                <a:latin typeface="Arial"/>
+              </a:rPr>
+              <a:t>Deployment &amp; Security: </a:t>
+            </a:r>
+            <a:r>
+              <a:rPr sz="1100">
+                <a:solidFill>
+                  <a:srgbClr val="191E24"/>
+                </a:solidFill>
+                <a:latin typeface="Arial"/>
+              </a:rPr>
+              <a:t>Docker containerized, air-gapped Linux host, zero telemetry.</a:t>
             </a:r>
           </a:p>
         </p:txBody>
@@ -4957,18 +4779,18 @@
         </p:nvSpPr>
         <p:spPr>
           <a:xfrm>
-            <a:off x="5349240" y="1325880"/>
+            <a:off x="5394960" y="1325880"/>
             <a:ext cx="6035040" cy="4892040"/>
           </a:xfrm>
           <a:prstGeom prst="roundRect">
             <a:avLst/>
           </a:prstGeom>
           <a:solidFill>
-            <a:srgbClr val="F8FAFC"/>
+            <a:srgbClr val="FAFCFF"/>
           </a:solidFill>
           <a:ln>
             <a:solidFill>
-              <a:srgbClr val="E2E8F0"/>
+              <a:srgbClr val="D7E1EE"/>
             </a:solidFill>
           </a:ln>
         </p:spPr>
@@ -4987,82 +4809,82 @@
           </a:fontRef>
         </p:style>
         <p:txBody>
-          <a:bodyPr rtlCol="0" anchor="ctr" wrap="square" lIns="228600" tIns="182880" rIns="228600"/>
+          <a:bodyPr rtlCol="0" anchor="ctr" wrap="square" lIns="256032" tIns="228600" rIns="256032"/>
           <a:lstStyle/>
           <a:p>
             <a:pPr algn="ctr">
               <a:spcAft>
-                <a:spcPts val="1000"/>
-              </a:spcAft>
-              <a:defRPr sz="1550" b="1" u="sng">
-                <a:solidFill>
-                  <a:srgbClr val="1B365D"/>
-                </a:solidFill>
-                <a:latin typeface="Arial"/>
-              </a:defRPr>
-            </a:pPr>
-            <a:r>
-              <a:t>• Methodology &amp; Implementation Process Flow</a:t>
+                <a:spcPts val="1200"/>
+              </a:spcAft>
+              <a:defRPr sz="1500" b="1" u="sng">
+                <a:solidFill>
+                  <a:srgbClr val="1B365D"/>
+                </a:solidFill>
+                <a:latin typeface="Arial"/>
+              </a:defRPr>
+            </a:pPr>
+            <a:r>
+              <a:t>• Methodology and process for implementation</a:t>
             </a:r>
           </a:p>
           <a:p>
             <a:pPr>
               <a:spcAft>
-                <a:spcPts val="600"/>
-              </a:spcAft>
-            </a:pPr>
-            <a:r>
-              <a:rPr b="1" sz="1000">
-                <a:solidFill>
-                  <a:srgbClr val="1B365D"/>
-                </a:solidFill>
-                <a:latin typeface="Arial"/>
-              </a:rPr>
-              <a:t>• Step 1: Ingestion &amp; Spatial Tagging: </a:t>
-            </a:r>
-            <a:r>
-              <a:rPr sz="950">
-                <a:solidFill>
-                  <a:srgbClr val="212529"/>
-                </a:solidFill>
-                <a:latin typeface="Arial"/>
-              </a:rPr>
-              <a:t>PyMuPDF parses raw PDF/DOCX, tagging text blocks, tables, and diagrams with exact coordinate bounding boxes.</a:t>
+                <a:spcPts val="700"/>
+              </a:spcAft>
+            </a:pPr>
+            <a:r>
+              <a:rPr b="1" sz="1150">
+                <a:solidFill>
+                  <a:srgbClr val="1B365D"/>
+                </a:solidFill>
+                <a:latin typeface="Arial"/>
+              </a:rPr>
+              <a:t>• Step 1: Document Ingestion: </a:t>
+            </a:r>
+            <a:r>
+              <a:rPr sz="1100">
+                <a:solidFill>
+                  <a:srgbClr val="191E24"/>
+                </a:solidFill>
+                <a:latin typeface="Arial"/>
+              </a:rPr>
+              <a:t>PyMuPDF parses raw PDF/DOCX, extracting structural hierarchy, text coordinates, diagrams, and tables with bounding box tags.</a:t>
             </a:r>
           </a:p>
           <a:p>
             <a:pPr>
               <a:spcAft>
-                <a:spcPts val="600"/>
-              </a:spcAft>
-            </a:pPr>
-            <a:r>
-              <a:rPr b="1" sz="1000">
-                <a:solidFill>
-                  <a:srgbClr val="1B365D"/>
-                </a:solidFill>
-                <a:latin typeface="Arial"/>
-              </a:rPr>
-              <a:t>• Step 2: Hierarchical Chunking &amp; RAG: </a:t>
-            </a:r>
-            <a:r>
-              <a:rPr sz="950">
-                <a:solidFill>
-                  <a:srgbClr val="212529"/>
-                </a:solidFill>
-                <a:latin typeface="Arial"/>
-              </a:rPr>
-              <a:t>Contextual embeddings are indexed into an in-memory vector store (FAISS/Qdrant) enforcing strict citation boundaries.</a:t>
+                <a:spcPts val="700"/>
+              </a:spcAft>
+            </a:pPr>
+            <a:r>
+              <a:rPr b="1" sz="1150">
+                <a:solidFill>
+                  <a:srgbClr val="1B365D"/>
+                </a:solidFill>
+                <a:latin typeface="Arial"/>
+              </a:rPr>
+              <a:t>• Step 2: Structured Chunking &amp; RAG: </a:t>
+            </a:r>
+            <a:r>
+              <a:rPr sz="1100">
+                <a:solidFill>
+                  <a:srgbClr val="191E24"/>
+                </a:solidFill>
+                <a:latin typeface="Arial"/>
+              </a:rPr>
+              <a:t>Hierarchical chunking creates contextual embeddings stored in an in-memory vector store (FAISS/Qdrant) for strict citation binding.</a:t>
             </a:r>
           </a:p>
           <a:p>
             <a:pPr>
               <a:spcAft>
-                <a:spcPts val="600"/>
-              </a:spcAft>
-            </a:pPr>
-            <a:r>
-              <a:rPr b="1" sz="1000">
+                <a:spcPts val="700"/>
+              </a:spcAft>
+            </a:pPr>
+            <a:r>
+              <a:rPr b="1" sz="1150">
                 <a:solidFill>
                   <a:srgbClr val="1B365D"/>
                 </a:solidFill>
@@ -5071,23 +4893,23 @@
               <a:t>• Step 3: Multi-Persona Orchestration: </a:t>
             </a:r>
             <a:r>
-              <a:rPr sz="950">
-                <a:solidFill>
-                  <a:srgbClr val="212529"/>
-                </a:solidFill>
-                <a:latin typeface="Arial"/>
-              </a:rPr>
-              <a:t>Constrained JSON Schema prompts instruct the LLM to extract key insights, slide structures, and press summaries.</a:t>
+              <a:rPr sz="1100">
+                <a:solidFill>
+                  <a:srgbClr val="191E24"/>
+                </a:solidFill>
+                <a:latin typeface="Arial"/>
+              </a:rPr>
+              <a:t>Constrained JSON Schema prompts instruct the LLM to extract key insights, slide structures, infographic metrics, and press statements.</a:t>
             </a:r>
           </a:p>
           <a:p>
             <a:pPr>
               <a:spcAft>
-                <a:spcPts val="600"/>
-              </a:spcAft>
-            </a:pPr>
-            <a:r>
-              <a:rPr b="1" sz="1000">
+                <a:spcPts val="700"/>
+              </a:spcAft>
+            </a:pPr>
+            <a:r>
+              <a:rPr b="1" sz="1150">
                 <a:solidFill>
                   <a:srgbClr val="1B365D"/>
                 </a:solidFill>
@@ -5096,23 +4918,23 @@
               <a:t>• Step 4: Parallel Synthesis Engines: </a:t>
             </a:r>
             <a:r>
-              <a:rPr sz="950">
-                <a:solidFill>
-                  <a:srgbClr val="212529"/>
-                </a:solidFill>
-                <a:latin typeface="Arial"/>
-              </a:rPr>
-              <a:t>Simultaneously compiles HTML5 presentation slides, auto-renders visual cards (Canvas API), and synthesizes neural audio.</a:t>
+              <a:rPr sz="1100">
+                <a:solidFill>
+                  <a:srgbClr val="191E24"/>
+                </a:solidFill>
+                <a:latin typeface="Arial"/>
+              </a:rPr>
+              <a:t>Simultaneously compiles HTML5 presentation slides, auto-renders high-res visual cards (Canvas API), and generates 60s neural audio stream.</a:t>
             </a:r>
           </a:p>
           <a:p>
             <a:pPr>
               <a:spcAft>
-                <a:spcPts val="600"/>
-              </a:spcAft>
-            </a:pPr>
-            <a:r>
-              <a:rPr b="1" sz="1000">
+                <a:spcPts val="700"/>
+              </a:spcAft>
+            </a:pPr>
+            <a:r>
+              <a:rPr b="1" sz="1150">
                 <a:solidFill>
                   <a:srgbClr val="1B365D"/>
                 </a:solidFill>
@@ -5121,9 +4943,9 @@
               <a:t>• Step 5: Interactive Verification UI: </a:t>
             </a:r>
             <a:r>
-              <a:rPr sz="950">
-                <a:solidFill>
-                  <a:srgbClr val="212529"/>
+              <a:rPr sz="1100">
+                <a:solidFill>
+                  <a:srgbClr val="191E24"/>
                 </a:solidFill>
                 <a:latin typeface="Arial"/>
               </a:rPr>
@@ -5158,8 +4980,8 @@
         </p:nvSpPr>
         <p:spPr>
           <a:xfrm>
-            <a:off x="411480" y="320040"/>
-            <a:ext cx="1600200" cy="960120"/>
+            <a:off x="502920" y="228600"/>
+            <a:ext cx="1691640" cy="960120"/>
           </a:xfrm>
           <a:prstGeom prst="ellipse">
             <a:avLst/>
@@ -5194,18 +5016,18 @@
             <a:pPr algn="ctr">
               <a:defRPr sz="1000">
                 <a:solidFill>
-                  <a:srgbClr val="212529"/>
-                </a:solidFill>
-                <a:latin typeface="Arial"/>
-              </a:defRPr>
-            </a:pPr>
-            <a:r>
-              <a:t>Team</a:t>
+                  <a:srgbClr val="191E24"/>
+                </a:solidFill>
+                <a:latin typeface="Arial"/>
+              </a:defRPr>
+            </a:pPr>
+            <a:r>
+              <a:t>Team Name</a:t>
             </a:r>
           </a:p>
           <a:p>
             <a:pPr algn="ctr">
-              <a:defRPr sz="1100" b="1">
+              <a:defRPr sz="1150" b="1">
                 <a:solidFill>
                   <a:srgbClr val="1B365D"/>
                 </a:solidFill>
@@ -5226,8 +5048,8 @@
         </p:nvSpPr>
         <p:spPr>
           <a:xfrm>
-            <a:off x="2286000" y="411480"/>
-            <a:ext cx="7132320" cy="731520"/>
+            <a:off x="2377440" y="320040"/>
+            <a:ext cx="5303520" cy="777240"/>
           </a:xfrm>
           <a:prstGeom prst="rect">
             <a:avLst/>
@@ -5254,68 +5076,30 @@
           </a:p>
         </p:txBody>
       </p:sp>
-      <p:sp>
-        <p:nvSpPr>
-          <p:cNvPr id="4" name="TextBox 3"/>
-          <p:cNvSpPr txBox="1"/>
+      <p:pic>
+        <p:nvPicPr>
+          <p:cNvPr id="4" name="Picture 3" descr="sih_header_banner.jpg"/>
+          <p:cNvPicPr>
+            <a:picLocks noChangeAspect="1"/>
+          </p:cNvPicPr>
           <p:nvPr/>
-        </p:nvSpPr>
+        </p:nvPicPr>
+        <p:blipFill>
+          <a:blip r:embed="rId2"/>
+          <a:stretch>
+            <a:fillRect/>
+          </a:stretch>
+        </p:blipFill>
         <p:spPr>
           <a:xfrm>
-            <a:off x="9601200" y="274320"/>
-            <a:ext cx="2194560" cy="822960"/>
+            <a:off x="7818120" y="228600"/>
+            <a:ext cx="3886200" cy="513184"/>
           </a:xfrm>
           <a:prstGeom prst="rect">
             <a:avLst/>
           </a:prstGeom>
-          <a:noFill/>
         </p:spPr>
-        <p:txBody>
-          <a:bodyPr wrap="square">
-            <a:spAutoFit/>
-          </a:bodyPr>
-          <a:lstStyle/>
-          <a:p>
-            <a:pPr algn="r">
-              <a:defRPr sz="1000" b="1">
-                <a:solidFill>
-                  <a:srgbClr val="1B365D"/>
-                </a:solidFill>
-                <a:latin typeface="Arial"/>
-              </a:defRPr>
-            </a:pPr>
-            <a:r>
-              <a:t>SMART INDIA</a:t>
-            </a:r>
-          </a:p>
-          <a:p>
-            <a:pPr algn="r">
-              <a:defRPr sz="1000" b="1">
-                <a:solidFill>
-                  <a:srgbClr val="1B365D"/>
-                </a:solidFill>
-                <a:latin typeface="Arial"/>
-              </a:defRPr>
-            </a:pPr>
-            <a:r>
-              <a:t>HACKATHON</a:t>
-            </a:r>
-          </a:p>
-          <a:p>
-            <a:pPr algn="r">
-              <a:defRPr sz="1200" b="1">
-                <a:solidFill>
-                  <a:srgbClr val="F37021"/>
-                </a:solidFill>
-                <a:latin typeface="Arial"/>
-              </a:defRPr>
-            </a:pPr>
-            <a:r>
-              <a:t>2026</a:t>
-            </a:r>
-          </a:p>
-        </p:txBody>
-      </p:sp>
+      </p:pic>
       <p:sp>
         <p:nvSpPr>
           <p:cNvPr id="5" name="Rectangle 4"/>
@@ -5382,7 +5166,7 @@
           <a:lstStyle/>
           <a:p>
             <a:pPr>
-              <a:defRPr sz="950">
+              <a:defRPr sz="1000">
                 <a:solidFill>
                   <a:srgbClr val="FFFFFF"/>
                 </a:solidFill>
@@ -5418,7 +5202,7 @@
           <a:lstStyle/>
           <a:p>
             <a:pPr algn="r">
-              <a:defRPr sz="1050" b="1">
+              <a:defRPr sz="1100" b="1">
                 <a:solidFill>
                   <a:srgbClr val="FFFFFF"/>
                 </a:solidFill>
@@ -5439,18 +5223,18 @@
         </p:nvSpPr>
         <p:spPr>
           <a:xfrm>
-            <a:off x="804672" y="1280160"/>
-            <a:ext cx="10579608" cy="2011680"/>
+            <a:off x="731520" y="1280160"/>
+            <a:ext cx="10698480" cy="2011680"/>
           </a:xfrm>
           <a:prstGeom prst="roundRect">
             <a:avLst/>
           </a:prstGeom>
           <a:solidFill>
-            <a:srgbClr val="F8FAFC"/>
+            <a:srgbClr val="FAFCFF"/>
           </a:solidFill>
           <a:ln>
             <a:solidFill>
-              <a:srgbClr val="E2E8F0"/>
+              <a:srgbClr val="D7E1EE"/>
             </a:solidFill>
           </a:ln>
         </p:spPr>
@@ -5469,14 +5253,14 @@
           </a:fontRef>
         </p:style>
         <p:txBody>
-          <a:bodyPr rtlCol="0" anchor="ctr" wrap="square" lIns="228600" tIns="164592" rIns="228600"/>
+          <a:bodyPr rtlCol="0" anchor="ctr" wrap="square" lIns="256032" tIns="182880" rIns="256032"/>
           <a:lstStyle/>
           <a:p>
             <a:pPr algn="ctr">
               <a:spcAft>
-                <a:spcPts val="600"/>
-              </a:spcAft>
-              <a:defRPr sz="1550" b="1" u="sng">
+                <a:spcPts val="800"/>
+              </a:spcAft>
+              <a:defRPr sz="1500" b="1" u="sng">
                 <a:solidFill>
                   <a:srgbClr val="1B365D"/>
                 </a:solidFill>
@@ -5490,22 +5274,22 @@
           <a:p>
             <a:pPr>
               <a:spcAft>
-                <a:spcPts val="400"/>
-              </a:spcAft>
-            </a:pPr>
-            <a:r>
-              <a:rPr b="1" sz="1000">
-                <a:solidFill>
-                  <a:srgbClr val="1B365D"/>
-                </a:solidFill>
-                <a:latin typeface="Arial"/>
-              </a:rPr>
-              <a:t>• Hardware Feasibility: </a:t>
-            </a:r>
-            <a:r>
-              <a:rPr sz="1000">
-                <a:solidFill>
-                  <a:srgbClr val="212529"/>
+                <a:spcPts val="500"/>
+              </a:spcAft>
+            </a:pPr>
+            <a:r>
+              <a:rPr b="1" sz="1150">
+                <a:solidFill>
+                  <a:srgbClr val="1B365D"/>
+                </a:solidFill>
+                <a:latin typeface="Arial"/>
+              </a:rPr>
+              <a:t>• Hardware &amp; Compute Feasibility: </a:t>
+            </a:r>
+            <a:r>
+              <a:rPr sz="1150">
+                <a:solidFill>
+                  <a:srgbClr val="191E24"/>
                 </a:solidFill>
                 <a:latin typeface="Arial"/>
               </a:rPr>
@@ -5515,22 +5299,22 @@
           <a:p>
             <a:pPr>
               <a:spcAft>
-                <a:spcPts val="400"/>
-              </a:spcAft>
-            </a:pPr>
-            <a:r>
-              <a:rPr b="1" sz="1000">
-                <a:solidFill>
-                  <a:srgbClr val="1B365D"/>
-                </a:solidFill>
-                <a:latin typeface="Arial"/>
-              </a:rPr>
-              <a:t>• Speed &amp; Throughput: </a:t>
-            </a:r>
-            <a:r>
-              <a:rPr sz="1000">
-                <a:solidFill>
-                  <a:srgbClr val="212529"/>
+                <a:spcPts val="500"/>
+              </a:spcAft>
+            </a:pPr>
+            <a:r>
+              <a:rPr b="1" sz="1150">
+                <a:solidFill>
+                  <a:srgbClr val="1B365D"/>
+                </a:solidFill>
+                <a:latin typeface="Arial"/>
+              </a:rPr>
+              <a:t>• Speed &amp; Runtime Feasibility: </a:t>
+            </a:r>
+            <a:r>
+              <a:rPr sz="1150">
+                <a:solidFill>
+                  <a:srgbClr val="191E24"/>
                 </a:solidFill>
                 <a:latin typeface="Arial"/>
               </a:rPr>
@@ -5540,22 +5324,22 @@
           <a:p>
             <a:pPr>
               <a:spcAft>
-                <a:spcPts val="400"/>
-              </a:spcAft>
-            </a:pPr>
-            <a:r>
-              <a:rPr b="1" sz="1000">
-                <a:solidFill>
-                  <a:srgbClr val="1B365D"/>
-                </a:solidFill>
-                <a:latin typeface="Arial"/>
-              </a:rPr>
-              <a:t>• Operational Feasibility: </a:t>
-            </a:r>
-            <a:r>
-              <a:rPr sz="1000">
-                <a:solidFill>
-                  <a:srgbClr val="212529"/>
+                <a:spcPts val="500"/>
+              </a:spcAft>
+            </a:pPr>
+            <a:r>
+              <a:rPr b="1" sz="1150">
+                <a:solidFill>
+                  <a:srgbClr val="1B365D"/>
+                </a:solidFill>
+                <a:latin typeface="Arial"/>
+              </a:rPr>
+              <a:t>• Operational Deployment Feasibility: </a:t>
+            </a:r>
+            <a:r>
+              <a:rPr sz="1150">
+                <a:solidFill>
+                  <a:srgbClr val="191E24"/>
                 </a:solidFill>
                 <a:latin typeface="Arial"/>
               </a:rPr>
@@ -5572,18 +5356,18 @@
         </p:nvSpPr>
         <p:spPr>
           <a:xfrm>
-            <a:off x="804672" y="3474720"/>
-            <a:ext cx="3337560" cy="2743200"/>
+            <a:off x="731520" y="3520440"/>
+            <a:ext cx="3337560" cy="2697480"/>
           </a:xfrm>
           <a:prstGeom prst="roundRect">
             <a:avLst/>
           </a:prstGeom>
           <a:solidFill>
-            <a:srgbClr val="F8FAFC"/>
+            <a:srgbClr val="FAFCFF"/>
           </a:solidFill>
           <a:ln>
             <a:solidFill>
-              <a:srgbClr val="E2E8F0"/>
+              <a:srgbClr val="D7E1EE"/>
             </a:solidFill>
           </a:ln>
         </p:spPr>
@@ -5609,7 +5393,7 @@
               <a:spcAft>
                 <a:spcPts val="600"/>
               </a:spcAft>
-              <a:defRPr sz="1150" b="1">
+              <a:defRPr sz="1300" b="1">
                 <a:solidFill>
                   <a:srgbClr val="F37021"/>
                 </a:solidFill>
@@ -5617,7 +5401,7 @@
               </a:defRPr>
             </a:pPr>
             <a:r>
-              <a:t>Potential Risk: AI Hallucination</a:t>
+              <a:t>Risk 1: AI Hallucinations</a:t>
             </a:r>
           </a:p>
           <a:p>
@@ -5625,28 +5409,28 @@
               <a:spcAft>
                 <a:spcPts val="600"/>
               </a:spcAft>
-              <a:defRPr sz="950">
-                <a:solidFill>
-                  <a:srgbClr val="212529"/>
-                </a:solidFill>
-                <a:latin typeface="Arial"/>
-              </a:defRPr>
-            </a:pPr>
-            <a:r>
-              <a:t>• Risk: Generative models inventing ungrounded facts in security briefs.</a:t>
+              <a:defRPr sz="1100">
+                <a:solidFill>
+                  <a:srgbClr val="191E24"/>
+                </a:solidFill>
+                <a:latin typeface="Arial"/>
+              </a:defRPr>
+            </a:pPr>
+            <a:r>
+              <a:t>• Potential Challenge: Generative models inventing ungrounded facts in security briefs.</a:t>
             </a:r>
           </a:p>
           <a:p>
             <a:pPr>
-              <a:defRPr sz="950" b="1">
-                <a:solidFill>
-                  <a:srgbClr val="1B365D"/>
-                </a:solidFill>
-                <a:latin typeface="Arial"/>
-              </a:defRPr>
-            </a:pPr>
-            <a:r>
-              <a:t>• Mitigation Strategy: Strict RAG constraint boundaries + reverse citation bounding-box verification for 100% grounded truth.</a:t>
+              <a:defRPr sz="1100" b="1">
+                <a:solidFill>
+                  <a:srgbClr val="1B365D"/>
+                </a:solidFill>
+                <a:latin typeface="Arial"/>
+              </a:defRPr>
+            </a:pPr>
+            <a:r>
+              <a:t>• Strategy: Strict RAG constraint boundaries + reverse citation bounding-box coordinate verification for 100% grounded truth.</a:t>
             </a:r>
           </a:p>
         </p:txBody>
@@ -5659,18 +5443,18 @@
         </p:nvSpPr>
         <p:spPr>
           <a:xfrm>
-            <a:off x="4425696" y="3474720"/>
-            <a:ext cx="3337560" cy="2743200"/>
+            <a:off x="4416552" y="3520440"/>
+            <a:ext cx="3337560" cy="2697480"/>
           </a:xfrm>
           <a:prstGeom prst="roundRect">
             <a:avLst/>
           </a:prstGeom>
           <a:solidFill>
-            <a:srgbClr val="F8FAFC"/>
+            <a:srgbClr val="FAFCFF"/>
           </a:solidFill>
           <a:ln>
             <a:solidFill>
-              <a:srgbClr val="E2E8F0"/>
+              <a:srgbClr val="D7E1EE"/>
             </a:solidFill>
           </a:ln>
         </p:spPr>
@@ -5696,7 +5480,7 @@
               <a:spcAft>
                 <a:spcPts val="600"/>
               </a:spcAft>
-              <a:defRPr sz="1150" b="1">
+              <a:defRPr sz="1300" b="1">
                 <a:solidFill>
                   <a:srgbClr val="F37021"/>
                 </a:solidFill>
@@ -5704,7 +5488,7 @@
               </a:defRPr>
             </a:pPr>
             <a:r>
-              <a:t>Potential Risk: Data Security</a:t>
+              <a:t>Risk 2: Data Confidentiality</a:t>
             </a:r>
           </a:p>
           <a:p>
@@ -5712,28 +5496,28 @@
               <a:spcAft>
                 <a:spcPts val="600"/>
               </a:spcAft>
-              <a:defRPr sz="950">
-                <a:solidFill>
-                  <a:srgbClr val="212529"/>
-                </a:solidFill>
-                <a:latin typeface="Arial"/>
-              </a:defRPr>
-            </a:pPr>
-            <a:r>
-              <a:t>• Risk: Sensitive intelligence leaked to public cloud APIs.</a:t>
+              <a:defRPr sz="1100">
+                <a:solidFill>
+                  <a:srgbClr val="191E24"/>
+                </a:solidFill>
+                <a:latin typeface="Arial"/>
+              </a:defRPr>
+            </a:pPr>
+            <a:r>
+              <a:t>• Potential Challenge: Sensitive classified intelligence leaked to public cloud APIs.</a:t>
             </a:r>
           </a:p>
           <a:p>
             <a:pPr>
-              <a:defRPr sz="950" b="1">
-                <a:solidFill>
-                  <a:srgbClr val="1B365D"/>
-                </a:solidFill>
-                <a:latin typeface="Arial"/>
-              </a:defRPr>
-            </a:pPr>
-            <a:r>
-              <a:t>• Mitigation Strategy: Sovereign on-premise air-gapped deployment with local open-weights (Llama 3/Mistral); zero telemetry.</a:t>
+              <a:defRPr sz="1100" b="1">
+                <a:solidFill>
+                  <a:srgbClr val="1B365D"/>
+                </a:solidFill>
+                <a:latin typeface="Arial"/>
+              </a:defRPr>
+            </a:pPr>
+            <a:r>
+              <a:t>• Strategy: Sovereign on-premise air-gapped deployment with local open-weights (Llama 3/Mistral); zero telemetry.</a:t>
             </a:r>
           </a:p>
         </p:txBody>
@@ -5746,18 +5530,18 @@
         </p:nvSpPr>
         <p:spPr>
           <a:xfrm>
-            <a:off x="8046720" y="3474720"/>
-            <a:ext cx="3337560" cy="2743200"/>
+            <a:off x="8101584" y="3520440"/>
+            <a:ext cx="3337560" cy="2697480"/>
           </a:xfrm>
           <a:prstGeom prst="roundRect">
             <a:avLst/>
           </a:prstGeom>
           <a:solidFill>
-            <a:srgbClr val="F8FAFC"/>
+            <a:srgbClr val="FAFCFF"/>
           </a:solidFill>
           <a:ln>
             <a:solidFill>
-              <a:srgbClr val="E2E8F0"/>
+              <a:srgbClr val="D7E1EE"/>
             </a:solidFill>
           </a:ln>
         </p:spPr>
@@ -5783,7 +5567,7 @@
               <a:spcAft>
                 <a:spcPts val="600"/>
               </a:spcAft>
-              <a:defRPr sz="1150" b="1">
+              <a:defRPr sz="1300" b="1">
                 <a:solidFill>
                   <a:srgbClr val="F37021"/>
                 </a:solidFill>
@@ -5791,7 +5575,7 @@
               </a:defRPr>
             </a:pPr>
             <a:r>
-              <a:t>Potential Risk: Complex Tables/Charts</a:t>
+              <a:t>Risk 3: Complex Tables &amp; Charts</a:t>
             </a:r>
           </a:p>
           <a:p>
@@ -5799,28 +5583,28 @@
               <a:spcAft>
                 <a:spcPts val="600"/>
               </a:spcAft>
-              <a:defRPr sz="950">
-                <a:solidFill>
-                  <a:srgbClr val="212529"/>
-                </a:solidFill>
-                <a:latin typeface="Arial"/>
-              </a:defRPr>
-            </a:pPr>
-            <a:r>
-              <a:t>• Risk: Loss of tabular structure and diagram metrics during parsing.</a:t>
+              <a:defRPr sz="1100">
+                <a:solidFill>
+                  <a:srgbClr val="191E24"/>
+                </a:solidFill>
+                <a:latin typeface="Arial"/>
+              </a:defRPr>
+            </a:pPr>
+            <a:r>
+              <a:t>• Potential Challenge: Loss of tabular structure and diagram metrics during document parsing.</a:t>
             </a:r>
           </a:p>
           <a:p>
             <a:pPr>
-              <a:defRPr sz="950" b="1">
-                <a:solidFill>
-                  <a:srgbClr val="1B365D"/>
-                </a:solidFill>
-                <a:latin typeface="Arial"/>
-              </a:defRPr>
-            </a:pPr>
-            <a:r>
-              <a:t>• Mitigation Strategy: Multimodal vision-language parsing (VLM) + Markdown table structure extraction.</a:t>
+              <a:defRPr sz="1100" b="1">
+                <a:solidFill>
+                  <a:srgbClr val="1B365D"/>
+                </a:solidFill>
+                <a:latin typeface="Arial"/>
+              </a:defRPr>
+            </a:pPr>
+            <a:r>
+              <a:t>• Strategy: Multimodal vision-language parsing (VLM) + Markdown table structure extraction.</a:t>
             </a:r>
           </a:p>
         </p:txBody>
@@ -5851,8 +5635,8 @@
         </p:nvSpPr>
         <p:spPr>
           <a:xfrm>
-            <a:off x="411480" y="320040"/>
-            <a:ext cx="1600200" cy="960120"/>
+            <a:off x="502920" y="228600"/>
+            <a:ext cx="1691640" cy="960120"/>
           </a:xfrm>
           <a:prstGeom prst="ellipse">
             <a:avLst/>
@@ -5887,18 +5671,18 @@
             <a:pPr algn="ctr">
               <a:defRPr sz="1000">
                 <a:solidFill>
-                  <a:srgbClr val="212529"/>
-                </a:solidFill>
-                <a:latin typeface="Arial"/>
-              </a:defRPr>
-            </a:pPr>
-            <a:r>
-              <a:t>Team</a:t>
+                  <a:srgbClr val="191E24"/>
+                </a:solidFill>
+                <a:latin typeface="Arial"/>
+              </a:defRPr>
+            </a:pPr>
+            <a:r>
+              <a:t>Team Name</a:t>
             </a:r>
           </a:p>
           <a:p>
             <a:pPr algn="ctr">
-              <a:defRPr sz="1100" b="1">
+              <a:defRPr sz="1150" b="1">
                 <a:solidFill>
                   <a:srgbClr val="1B365D"/>
                 </a:solidFill>
@@ -5919,8 +5703,8 @@
         </p:nvSpPr>
         <p:spPr>
           <a:xfrm>
-            <a:off x="2286000" y="411480"/>
-            <a:ext cx="7132320" cy="731520"/>
+            <a:off x="2377440" y="320040"/>
+            <a:ext cx="5303520" cy="777240"/>
           </a:xfrm>
           <a:prstGeom prst="rect">
             <a:avLst/>
@@ -5947,68 +5731,30 @@
           </a:p>
         </p:txBody>
       </p:sp>
-      <p:sp>
-        <p:nvSpPr>
-          <p:cNvPr id="4" name="TextBox 3"/>
-          <p:cNvSpPr txBox="1"/>
+      <p:pic>
+        <p:nvPicPr>
+          <p:cNvPr id="4" name="Picture 3" descr="sih_header_banner.jpg"/>
+          <p:cNvPicPr>
+            <a:picLocks noChangeAspect="1"/>
+          </p:cNvPicPr>
           <p:nvPr/>
-        </p:nvSpPr>
+        </p:nvPicPr>
+        <p:blipFill>
+          <a:blip r:embed="rId2"/>
+          <a:stretch>
+            <a:fillRect/>
+          </a:stretch>
+        </p:blipFill>
         <p:spPr>
           <a:xfrm>
-            <a:off x="9601200" y="274320"/>
-            <a:ext cx="2194560" cy="822960"/>
+            <a:off x="7818120" y="228600"/>
+            <a:ext cx="3886200" cy="513184"/>
           </a:xfrm>
           <a:prstGeom prst="rect">
             <a:avLst/>
           </a:prstGeom>
-          <a:noFill/>
         </p:spPr>
-        <p:txBody>
-          <a:bodyPr wrap="square">
-            <a:spAutoFit/>
-          </a:bodyPr>
-          <a:lstStyle/>
-          <a:p>
-            <a:pPr algn="r">
-              <a:defRPr sz="1000" b="1">
-                <a:solidFill>
-                  <a:srgbClr val="1B365D"/>
-                </a:solidFill>
-                <a:latin typeface="Arial"/>
-              </a:defRPr>
-            </a:pPr>
-            <a:r>
-              <a:t>SMART INDIA</a:t>
-            </a:r>
-          </a:p>
-          <a:p>
-            <a:pPr algn="r">
-              <a:defRPr sz="1000" b="1">
-                <a:solidFill>
-                  <a:srgbClr val="1B365D"/>
-                </a:solidFill>
-                <a:latin typeface="Arial"/>
-              </a:defRPr>
-            </a:pPr>
-            <a:r>
-              <a:t>HACKATHON</a:t>
-            </a:r>
-          </a:p>
-          <a:p>
-            <a:pPr algn="r">
-              <a:defRPr sz="1200" b="1">
-                <a:solidFill>
-                  <a:srgbClr val="F37021"/>
-                </a:solidFill>
-                <a:latin typeface="Arial"/>
-              </a:defRPr>
-            </a:pPr>
-            <a:r>
-              <a:t>2026</a:t>
-            </a:r>
-          </a:p>
-        </p:txBody>
-      </p:sp>
+      </p:pic>
       <p:sp>
         <p:nvSpPr>
           <p:cNvPr id="5" name="Rectangle 4"/>
@@ -6075,7 +5821,7 @@
           <a:lstStyle/>
           <a:p>
             <a:pPr>
-              <a:defRPr sz="950">
+              <a:defRPr sz="1000">
                 <a:solidFill>
                   <a:srgbClr val="FFFFFF"/>
                 </a:solidFill>
@@ -6111,7 +5857,7 @@
           <a:lstStyle/>
           <a:p>
             <a:pPr algn="r">
-              <a:defRPr sz="1050" b="1">
+              <a:defRPr sz="1100" b="1">
                 <a:solidFill>
                   <a:srgbClr val="FFFFFF"/>
                 </a:solidFill>
@@ -6132,18 +5878,18 @@
         </p:nvSpPr>
         <p:spPr>
           <a:xfrm>
-            <a:off x="804672" y="1280160"/>
-            <a:ext cx="5148072" cy="4937760"/>
+            <a:off x="731520" y="1280160"/>
+            <a:ext cx="5166360" cy="4937760"/>
           </a:xfrm>
           <a:prstGeom prst="roundRect">
             <a:avLst/>
           </a:prstGeom>
           <a:solidFill>
-            <a:srgbClr val="F8FAFC"/>
+            <a:srgbClr val="FAFCFF"/>
           </a:solidFill>
           <a:ln>
             <a:solidFill>
-              <a:srgbClr val="E2E8F0"/>
+              <a:srgbClr val="D7E1EE"/>
             </a:solidFill>
           </a:ln>
         </p:spPr>
@@ -6162,14 +5908,14 @@
           </a:fontRef>
         </p:style>
         <p:txBody>
-          <a:bodyPr rtlCol="0" anchor="ctr" wrap="square" lIns="228600" tIns="182880" rIns="228600"/>
+          <a:bodyPr rtlCol="0" anchor="ctr" wrap="square" lIns="256032" tIns="228600" rIns="256032"/>
           <a:lstStyle/>
           <a:p>
             <a:pPr algn="ctr">
               <a:spcAft>
-                <a:spcPts val="1000"/>
-              </a:spcAft>
-              <a:defRPr sz="1550" b="1" u="sng">
+                <a:spcPts val="1200"/>
+              </a:spcAft>
+              <a:defRPr sz="1500" b="1" u="sng">
                 <a:solidFill>
                   <a:srgbClr val="1B365D"/>
                 </a:solidFill>
@@ -6183,101 +5929,105 @@
           <a:p>
             <a:pPr>
               <a:spcAft>
-                <a:spcPts val="600"/>
-              </a:spcAft>
-            </a:pPr>
-            <a:r>
-              <a:rPr b="1" sz="1000">
-                <a:solidFill>
-                  <a:srgbClr val="1B365D"/>
-                </a:solidFill>
-                <a:latin typeface="Arial"/>
-              </a:rPr>
-              <a:t>• Government &amp; Defense Analysts (NTRO/MoD): </a:t>
-            </a:r>
-            <a:r>
-              <a:rPr sz="950">
-                <a:solidFill>
-                  <a:srgbClr val="212529"/>
-                </a:solidFill>
-                <a:latin typeface="Arial"/>
-              </a:rPr>
-              <a:t> Saves 4-6 hours daily per analyst by instantly synthesizing complex intelligence and security advisories into actionable briefs.</a:t>
+                <a:spcPts val="800"/>
+              </a:spcAft>
+            </a:pPr>
+            <a:r>
+              <a:rPr b="1" sz="1150">
+                <a:solidFill>
+                  <a:srgbClr val="1B365D"/>
+                </a:solidFill>
+                <a:latin typeface="Arial"/>
+              </a:rPr>
+              <a:t>• Government &amp; Defense Analysts (NTRO/MoD):
+  </a:t>
+            </a:r>
+            <a:r>
+              <a:rPr sz="1100">
+                <a:solidFill>
+                  <a:srgbClr val="191E24"/>
+                </a:solidFill>
+                <a:latin typeface="Arial"/>
+              </a:rPr>
+              <a:t>Saves 4-6 hours daily per analyst by instantly synthesizing complex intelligence and security advisories into actionable briefs.</a:t>
             </a:r>
           </a:p>
           <a:p>
             <a:pPr>
               <a:spcAft>
-                <a:spcPts val="600"/>
-              </a:spcAft>
-            </a:pPr>
-            <a:r>
-              <a:rPr b="1" sz="1000">
-                <a:solidFill>
-                  <a:srgbClr val="1B365D"/>
-                </a:solidFill>
-                <a:latin typeface="Arial"/>
-              </a:rPr>
-              <a:t>• Senior Bureaucrats &amp; C-Suite Executives: </a:t>
-            </a:r>
-            <a:r>
-              <a:rPr sz="950">
-                <a:solidFill>
-                  <a:srgbClr val="212529"/>
-                </a:solidFill>
-                <a:latin typeface="Arial"/>
-              </a:rPr>
-              <a:t> Enables immediate decision-making via 1-page executive memos and interactive Keynote presentation decks.</a:t>
+                <a:spcPts val="800"/>
+              </a:spcAft>
+            </a:pPr>
+            <a:r>
+              <a:rPr b="1" sz="1150">
+                <a:solidFill>
+                  <a:srgbClr val="1B365D"/>
+                </a:solidFill>
+                <a:latin typeface="Arial"/>
+              </a:rPr>
+              <a:t>• Senior Bureaucrats &amp; C-Suite Executives:
+  </a:t>
+            </a:r>
+            <a:r>
+              <a:rPr sz="1100">
+                <a:solidFill>
+                  <a:srgbClr val="191E24"/>
+                </a:solidFill>
+                <a:latin typeface="Arial"/>
+              </a:rPr>
+              <a:t>Enables immediate decision-making via 1-page executive memos and interactive presentation decks.</a:t>
             </a:r>
           </a:p>
           <a:p>
             <a:pPr>
               <a:spcAft>
-                <a:spcPts val="600"/>
-              </a:spcAft>
-            </a:pPr>
-            <a:r>
-              <a:rPr b="1" sz="1000">
-                <a:solidFill>
-                  <a:srgbClr val="1B365D"/>
-                </a:solidFill>
-                <a:latin typeface="Arial"/>
-              </a:rPr>
-              <a:t>• Public Relations &amp; Media Officers: </a:t>
-            </a:r>
-            <a:r>
-              <a:rPr sz="950">
-                <a:solidFill>
-                  <a:srgbClr val="212529"/>
-                </a:solidFill>
-                <a:latin typeface="Arial"/>
-              </a:rPr>
-              <a:t> Instant generation of accurate, jargon-free press releases and infographics in multiple regional languages.</a:t>
+                <a:spcPts val="800"/>
+              </a:spcAft>
+            </a:pPr>
+            <a:r>
+              <a:rPr b="1" sz="1150">
+                <a:solidFill>
+                  <a:srgbClr val="1B365D"/>
+                </a:solidFill>
+                <a:latin typeface="Arial"/>
+              </a:rPr>
+              <a:t>• Public Relations &amp; Media Officers:
+  </a:t>
+            </a:r>
+            <a:r>
+              <a:rPr sz="1100">
+                <a:solidFill>
+                  <a:srgbClr val="191E24"/>
+                </a:solidFill>
+                <a:latin typeface="Arial"/>
+              </a:rPr>
+              <a:t>Instant generation of accurate, jargon-free press releases and infographics in multiple regional languages.</a:t>
             </a:r>
           </a:p>
           <a:p>
             <a:pPr>
               <a:spcAft>
-                <a:spcPts val="600"/>
-              </a:spcAft>
-            </a:pPr>
-            <a:r>
-              <a:rPr b="1" sz="1000">
-                <a:solidFill>
-                  <a:srgbClr val="1B365D"/>
-                </a:solidFill>
-                <a:latin typeface="Arial"/>
-              </a:rPr>
-              <a:t>• Field Personnel &amp; Traveling Officials: </a:t>
-            </a:r>
-            <a:r>
-              <a:rPr sz="950">
-                <a:solidFill>
-                  <a:srgbClr val="212529"/>
-                </a:solidFill>
-                <a:latin typeface="Arial"/>
-              </a:rPr>
-              <a:t> Delivers 60-second audio podcast briefings directly to mobile devices.</a:t>
+                <a:spcPts val="800"/>
+              </a:spcAft>
+            </a:pPr>
+            <a:r>
+              <a:rPr b="1" sz="1150">
+                <a:solidFill>
+                  <a:srgbClr val="1B365D"/>
+                </a:solidFill>
+                <a:latin typeface="Arial"/>
+              </a:rPr>
+              <a:t>• Field Personnel &amp; Traveling Officials:
+  </a:t>
+            </a:r>
+            <a:r>
+              <a:rPr sz="1100">
+                <a:solidFill>
+                  <a:srgbClr val="191E24"/>
+                </a:solidFill>
+                <a:latin typeface="Arial"/>
+              </a:rPr>
+              <a:t>Delivers 60-second audio podcast briefings directly to mobile devices.</a:t>
             </a:r>
           </a:p>
         </p:txBody>
@@ -6290,18 +6040,18 @@
         </p:nvSpPr>
         <p:spPr>
           <a:xfrm>
-            <a:off x="6236208" y="1280160"/>
-            <a:ext cx="5148072" cy="4937760"/>
+            <a:off x="6263640" y="1280160"/>
+            <a:ext cx="5166360" cy="4937760"/>
           </a:xfrm>
           <a:prstGeom prst="roundRect">
             <a:avLst/>
           </a:prstGeom>
           <a:solidFill>
-            <a:srgbClr val="F8FAFC"/>
+            <a:srgbClr val="FAFCFF"/>
           </a:solidFill>
           <a:ln>
             <a:solidFill>
-              <a:srgbClr val="E2E8F0"/>
+              <a:srgbClr val="D7E1EE"/>
             </a:solidFill>
           </a:ln>
         </p:spPr>
@@ -6320,14 +6070,14 @@
           </a:fontRef>
         </p:style>
         <p:txBody>
-          <a:bodyPr rtlCol="0" anchor="ctr" wrap="square" lIns="228600" tIns="182880" rIns="228600"/>
+          <a:bodyPr rtlCol="0" anchor="ctr" wrap="square" lIns="256032" tIns="228600" rIns="256032"/>
           <a:lstStyle/>
           <a:p>
             <a:pPr algn="ctr">
               <a:spcAft>
-                <a:spcPts val="1000"/>
-              </a:spcAft>
-              <a:defRPr sz="1550" b="1" u="sng">
+                <a:spcPts val="1200"/>
+              </a:spcAft>
+              <a:defRPr sz="1500" b="1" u="sng">
                 <a:solidFill>
                   <a:srgbClr val="1B365D"/>
                 </a:solidFill>
@@ -6341,101 +6091,101 @@
           <a:p>
             <a:pPr>
               <a:spcAft>
-                <a:spcPts val="600"/>
-              </a:spcAft>
-            </a:pPr>
-            <a:r>
-              <a:rPr b="1" sz="1000">
-                <a:solidFill>
-                  <a:srgbClr val="1B365D"/>
-                </a:solidFill>
-                <a:latin typeface="Arial"/>
-              </a:rPr>
-              <a:t>💰 Economic Benefits: </a:t>
-            </a:r>
-            <a:r>
-              <a:rPr sz="950">
-                <a:solidFill>
-                  <a:srgbClr val="212529"/>
-                </a:solidFill>
-                <a:latin typeface="Arial"/>
-              </a:rPr>
-              <a:t> Reduces enterprise document processing costs by 75%; eliminates expensive third-party graphic and presentation outsourcing.</a:t>
+                <a:spcPts val="800"/>
+              </a:spcAft>
+            </a:pPr>
+            <a:r>
+              <a:rPr b="1" sz="1150">
+                <a:solidFill>
+                  <a:srgbClr val="1B365D"/>
+                </a:solidFill>
+                <a:latin typeface="Arial"/>
+              </a:rPr>
+              <a:t>• Economic Benefits: </a:t>
+            </a:r>
+            <a:r>
+              <a:rPr sz="1100">
+                <a:solidFill>
+                  <a:srgbClr val="191E24"/>
+                </a:solidFill>
+                <a:latin typeface="Arial"/>
+              </a:rPr>
+              <a:t>Reduces enterprise document processing costs by 75%; eliminates expensive third-party graphic and presentation outsourcing.</a:t>
             </a:r>
           </a:p>
           <a:p>
             <a:pPr>
               <a:spcAft>
-                <a:spcPts val="600"/>
-              </a:spcAft>
-            </a:pPr>
-            <a:r>
-              <a:rPr b="1" sz="1000">
-                <a:solidFill>
-                  <a:srgbClr val="1B365D"/>
-                </a:solidFill>
-                <a:latin typeface="Arial"/>
-              </a:rPr>
-              <a:t>🤝 Social &amp; Governance Impact: </a:t>
-            </a:r>
-            <a:r>
-              <a:rPr sz="950">
-                <a:solidFill>
-                  <a:srgbClr val="212529"/>
-                </a:solidFill>
-                <a:latin typeface="Arial"/>
-              </a:rPr>
-              <a:t> Bridges the communication gap between technical policymakers and citizens through regional Indic language summaries and visual posters.</a:t>
+                <a:spcPts val="800"/>
+              </a:spcAft>
+            </a:pPr>
+            <a:r>
+              <a:rPr b="1" sz="1150">
+                <a:solidFill>
+                  <a:srgbClr val="1B365D"/>
+                </a:solidFill>
+                <a:latin typeface="Arial"/>
+              </a:rPr>
+              <a:t>• Social &amp; Governance Impact: </a:t>
+            </a:r>
+            <a:r>
+              <a:rPr sz="1100">
+                <a:solidFill>
+                  <a:srgbClr val="191E24"/>
+                </a:solidFill>
+                <a:latin typeface="Arial"/>
+              </a:rPr>
+              <a:t>Bridges the communication gap between technical policymakers and general citizens through regional Indic language summaries and visual posters.</a:t>
             </a:r>
           </a:p>
           <a:p>
             <a:pPr>
               <a:spcAft>
-                <a:spcPts val="600"/>
-              </a:spcAft>
-            </a:pPr>
-            <a:r>
-              <a:rPr b="1" sz="1000">
-                <a:solidFill>
-                  <a:srgbClr val="1B365D"/>
-                </a:solidFill>
-                <a:latin typeface="Arial"/>
-              </a:rPr>
-              <a:t>🛡️ National Security Advantage: </a:t>
-            </a:r>
-            <a:r>
-              <a:rPr sz="950">
-                <a:solidFill>
-                  <a:srgbClr val="212529"/>
-                </a:solidFill>
-                <a:latin typeface="Arial"/>
-              </a:rPr>
-              <a:t> Maintains tactical information advantage during national security events through instant, multi-format threat dissemination.</a:t>
+                <a:spcPts val="800"/>
+              </a:spcAft>
+            </a:pPr>
+            <a:r>
+              <a:rPr b="1" sz="1150">
+                <a:solidFill>
+                  <a:srgbClr val="1B365D"/>
+                </a:solidFill>
+                <a:latin typeface="Arial"/>
+              </a:rPr>
+              <a:t>• National Security Advantage: </a:t>
+            </a:r>
+            <a:r>
+              <a:rPr sz="1100">
+                <a:solidFill>
+                  <a:srgbClr val="191E24"/>
+                </a:solidFill>
+                <a:latin typeface="Arial"/>
+              </a:rPr>
+              <a:t>Maintains tactical information advantage during national security events through instant, multi-format threat dissemination.</a:t>
             </a:r>
           </a:p>
           <a:p>
             <a:pPr>
               <a:spcAft>
-                <a:spcPts val="600"/>
-              </a:spcAft>
-            </a:pPr>
-            <a:r>
-              <a:rPr b="1" sz="1000">
-                <a:solidFill>
-                  <a:srgbClr val="1B365D"/>
-                </a:solidFill>
-                <a:latin typeface="Arial"/>
-              </a:rPr>
-              <a:t>🌱 Environmental Sustainability: </a:t>
-            </a:r>
-            <a:r>
-              <a:rPr sz="950">
-                <a:solidFill>
-                  <a:srgbClr val="212529"/>
-                </a:solidFill>
-                <a:latin typeface="Arial"/>
-              </a:rPr>
-              <a:t> Cuts down unnecessary paper report printing through interactive digital briefs and mobile voice summaries.</a:t>
+                <a:spcPts val="800"/>
+              </a:spcAft>
+            </a:pPr>
+            <a:r>
+              <a:rPr b="1" sz="1150">
+                <a:solidFill>
+                  <a:srgbClr val="1B365D"/>
+                </a:solidFill>
+                <a:latin typeface="Arial"/>
+              </a:rPr>
+              <a:t>• Environmental Sustainability: </a:t>
+            </a:r>
+            <a:r>
+              <a:rPr sz="1100">
+                <a:solidFill>
+                  <a:srgbClr val="191E24"/>
+                </a:solidFill>
+                <a:latin typeface="Arial"/>
+              </a:rPr>
+              <a:t>Drastically cuts down unnecessary paper report printing through interactive digital briefs and mobile voice summaries.</a:t>
             </a:r>
           </a:p>
         </p:txBody>
@@ -6466,8 +6216,8 @@
         </p:nvSpPr>
         <p:spPr>
           <a:xfrm>
-            <a:off x="411480" y="320040"/>
-            <a:ext cx="1600200" cy="960120"/>
+            <a:off x="502920" y="228600"/>
+            <a:ext cx="1691640" cy="960120"/>
           </a:xfrm>
           <a:prstGeom prst="ellipse">
             <a:avLst/>
@@ -6502,18 +6252,18 @@
             <a:pPr algn="ctr">
               <a:defRPr sz="1000">
                 <a:solidFill>
-                  <a:srgbClr val="212529"/>
-                </a:solidFill>
-                <a:latin typeface="Arial"/>
-              </a:defRPr>
-            </a:pPr>
-            <a:r>
-              <a:t>Team</a:t>
+                  <a:srgbClr val="191E24"/>
+                </a:solidFill>
+                <a:latin typeface="Arial"/>
+              </a:defRPr>
+            </a:pPr>
+            <a:r>
+              <a:t>Team Name</a:t>
             </a:r>
           </a:p>
           <a:p>
             <a:pPr algn="ctr">
-              <a:defRPr sz="1100" b="1">
+              <a:defRPr sz="1150" b="1">
                 <a:solidFill>
                   <a:srgbClr val="1B365D"/>
                 </a:solidFill>
@@ -6534,8 +6284,8 @@
         </p:nvSpPr>
         <p:spPr>
           <a:xfrm>
-            <a:off x="2286000" y="411480"/>
-            <a:ext cx="7132320" cy="731520"/>
+            <a:off x="2377440" y="320040"/>
+            <a:ext cx="5303520" cy="777240"/>
           </a:xfrm>
           <a:prstGeom prst="rect">
             <a:avLst/>
@@ -6562,68 +6312,30 @@
           </a:p>
         </p:txBody>
       </p:sp>
-      <p:sp>
-        <p:nvSpPr>
-          <p:cNvPr id="4" name="TextBox 3"/>
-          <p:cNvSpPr txBox="1"/>
+      <p:pic>
+        <p:nvPicPr>
+          <p:cNvPr id="4" name="Picture 3" descr="sih_header_banner.jpg"/>
+          <p:cNvPicPr>
+            <a:picLocks noChangeAspect="1"/>
+          </p:cNvPicPr>
           <p:nvPr/>
-        </p:nvSpPr>
+        </p:nvPicPr>
+        <p:blipFill>
+          <a:blip r:embed="rId2"/>
+          <a:stretch>
+            <a:fillRect/>
+          </a:stretch>
+        </p:blipFill>
         <p:spPr>
           <a:xfrm>
-            <a:off x="9601200" y="274320"/>
-            <a:ext cx="2194560" cy="822960"/>
+            <a:off x="7818120" y="228600"/>
+            <a:ext cx="3886200" cy="513184"/>
           </a:xfrm>
           <a:prstGeom prst="rect">
             <a:avLst/>
           </a:prstGeom>
-          <a:noFill/>
         </p:spPr>
-        <p:txBody>
-          <a:bodyPr wrap="square">
-            <a:spAutoFit/>
-          </a:bodyPr>
-          <a:lstStyle/>
-          <a:p>
-            <a:pPr algn="r">
-              <a:defRPr sz="1000" b="1">
-                <a:solidFill>
-                  <a:srgbClr val="1B365D"/>
-                </a:solidFill>
-                <a:latin typeface="Arial"/>
-              </a:defRPr>
-            </a:pPr>
-            <a:r>
-              <a:t>SMART INDIA</a:t>
-            </a:r>
-          </a:p>
-          <a:p>
-            <a:pPr algn="r">
-              <a:defRPr sz="1000" b="1">
-                <a:solidFill>
-                  <a:srgbClr val="1B365D"/>
-                </a:solidFill>
-                <a:latin typeface="Arial"/>
-              </a:defRPr>
-            </a:pPr>
-            <a:r>
-              <a:t>HACKATHON</a:t>
-            </a:r>
-          </a:p>
-          <a:p>
-            <a:pPr algn="r">
-              <a:defRPr sz="1200" b="1">
-                <a:solidFill>
-                  <a:srgbClr val="F37021"/>
-                </a:solidFill>
-                <a:latin typeface="Arial"/>
-              </a:defRPr>
-            </a:pPr>
-            <a:r>
-              <a:t>2026</a:t>
-            </a:r>
-          </a:p>
-        </p:txBody>
-      </p:sp>
+      </p:pic>
       <p:sp>
         <p:nvSpPr>
           <p:cNvPr id="5" name="Rectangle 4"/>
@@ -6690,7 +6402,7 @@
           <a:lstStyle/>
           <a:p>
             <a:pPr>
-              <a:defRPr sz="950">
+              <a:defRPr sz="1000">
                 <a:solidFill>
                   <a:srgbClr val="FFFFFF"/>
                 </a:solidFill>
@@ -6726,7 +6438,7 @@
           <a:lstStyle/>
           <a:p>
             <a:pPr algn="r">
-              <a:defRPr sz="1050" b="1">
+              <a:defRPr sz="1100" b="1">
                 <a:solidFill>
                   <a:srgbClr val="FFFFFF"/>
                 </a:solidFill>
@@ -6747,18 +6459,18 @@
         </p:nvSpPr>
         <p:spPr>
           <a:xfrm>
-            <a:off x="804672" y="1280160"/>
-            <a:ext cx="5148072" cy="4937760"/>
+            <a:off x="731520" y="1280160"/>
+            <a:ext cx="5166360" cy="4937760"/>
           </a:xfrm>
           <a:prstGeom prst="roundRect">
             <a:avLst/>
           </a:prstGeom>
           <a:solidFill>
-            <a:srgbClr val="F8FAFC"/>
+            <a:srgbClr val="FAFCFF"/>
           </a:solidFill>
           <a:ln>
             <a:solidFill>
-              <a:srgbClr val="E2E8F0"/>
+              <a:srgbClr val="D7E1EE"/>
             </a:solidFill>
           </a:ln>
         </p:spPr>
@@ -6777,14 +6489,14 @@
           </a:fontRef>
         </p:style>
         <p:txBody>
-          <a:bodyPr rtlCol="0" anchor="ctr" wrap="square" lIns="228600" tIns="182880" rIns="228600"/>
+          <a:bodyPr rtlCol="0" anchor="ctr" wrap="square" lIns="256032" tIns="228600" rIns="256032"/>
           <a:lstStyle/>
           <a:p>
             <a:pPr algn="ctr">
               <a:spcAft>
-                <a:spcPts val="1000"/>
-              </a:spcAft>
-              <a:defRPr sz="1550" b="1" u="sng">
+                <a:spcPts val="1200"/>
+              </a:spcAft>
+              <a:defRPr sz="1500" b="1" u="sng">
                 <a:solidFill>
                   <a:srgbClr val="1B365D"/>
                 </a:solidFill>
@@ -6798,11 +6510,11 @@
           <a:p>
             <a:pPr>
               <a:spcAft>
-                <a:spcPts val="600"/>
-              </a:spcAft>
-            </a:pPr>
-            <a:r>
-              <a:rPr b="1" sz="1000">
+                <a:spcPts val="800"/>
+              </a:spcAft>
+            </a:pPr>
+            <a:r>
+              <a:rPr b="1" sz="1150">
                 <a:solidFill>
                   <a:srgbClr val="1B365D"/>
                 </a:solidFill>
@@ -6811,9 +6523,9 @@
               <a:t>• Lewis et al. (2020): </a:t>
             </a:r>
             <a:r>
-              <a:rPr sz="950">
-                <a:solidFill>
-                  <a:srgbClr val="212529"/>
+              <a:rPr sz="1100">
+                <a:solidFill>
+                  <a:srgbClr val="191E24"/>
                 </a:solidFill>
                 <a:latin typeface="Arial"/>
               </a:rPr>
@@ -6823,11 +6535,11 @@
           <a:p>
             <a:pPr>
               <a:spcAft>
-                <a:spcPts val="600"/>
-              </a:spcAft>
-            </a:pPr>
-            <a:r>
-              <a:rPr b="1" sz="1000">
+                <a:spcPts val="800"/>
+              </a:spcAft>
+            </a:pPr>
+            <a:r>
+              <a:rPr b="1" sz="1150">
                 <a:solidFill>
                   <a:srgbClr val="1B365D"/>
                 </a:solidFill>
@@ -6836,9 +6548,9 @@
               <a:t>• Touvron et al. (2023/2024): </a:t>
             </a:r>
             <a:r>
-              <a:rPr sz="950">
-                <a:solidFill>
-                  <a:srgbClr val="212529"/>
+              <a:rPr sz="1100">
+                <a:solidFill>
+                  <a:srgbClr val="191E24"/>
                 </a:solidFill>
                 <a:latin typeface="Arial"/>
               </a:rPr>
@@ -6848,11 +6560,11 @@
           <a:p>
             <a:pPr>
               <a:spcAft>
-                <a:spcPts val="600"/>
-              </a:spcAft>
-            </a:pPr>
-            <a:r>
-              <a:rPr b="1" sz="1000">
+                <a:spcPts val="800"/>
+              </a:spcAft>
+            </a:pPr>
+            <a:r>
+              <a:rPr b="1" sz="1150">
                 <a:solidFill>
                   <a:srgbClr val="1B365D"/>
                 </a:solidFill>
@@ -6861,9 +6573,9 @@
               <a:t>• Vaswani et al. (2017): </a:t>
             </a:r>
             <a:r>
-              <a:rPr sz="950">
-                <a:solidFill>
-                  <a:srgbClr val="212529"/>
+              <a:rPr sz="1100">
+                <a:solidFill>
+                  <a:srgbClr val="191E24"/>
                 </a:solidFill>
                 <a:latin typeface="Arial"/>
               </a:rPr>
@@ -6873,11 +6585,11 @@
           <a:p>
             <a:pPr>
               <a:spcAft>
-                <a:spcPts val="600"/>
-              </a:spcAft>
-            </a:pPr>
-            <a:r>
-              <a:rPr b="1" sz="1000">
+                <a:spcPts val="800"/>
+              </a:spcAft>
+            </a:pPr>
+            <a:r>
+              <a:rPr b="1" sz="1150">
                 <a:solidFill>
                   <a:srgbClr val="1B365D"/>
                 </a:solidFill>
@@ -6886,9 +6598,9 @@
               <a:t>• AI4Bharat / Bhashini (2023): </a:t>
             </a:r>
             <a:r>
-              <a:rPr sz="950">
-                <a:solidFill>
-                  <a:srgbClr val="212529"/>
+              <a:rPr sz="1100">
+                <a:solidFill>
+                  <a:srgbClr val="191E24"/>
                 </a:solidFill>
                 <a:latin typeface="Arial"/>
               </a:rPr>
@@ -6898,11 +6610,11 @@
           <a:p>
             <a:pPr>
               <a:spcAft>
-                <a:spcPts val="600"/>
-              </a:spcAft>
-            </a:pPr>
-            <a:r>
-              <a:rPr b="1" sz="1000">
+                <a:spcPts val="800"/>
+              </a:spcAft>
+            </a:pPr>
+            <a:r>
+              <a:rPr b="1" sz="1150">
                 <a:solidFill>
                   <a:srgbClr val="1B365D"/>
                 </a:solidFill>
@@ -6911,9 +6623,9 @@
               <a:t>• ISO/IEC 27001 &amp; NIST Standards: </a:t>
             </a:r>
             <a:r>
-              <a:rPr sz="950">
-                <a:solidFill>
-                  <a:srgbClr val="212529"/>
+              <a:rPr sz="1100">
+                <a:solidFill>
+                  <a:srgbClr val="191E24"/>
                 </a:solidFill>
                 <a:latin typeface="Arial"/>
               </a:rPr>
@@ -6930,18 +6642,18 @@
         </p:nvSpPr>
         <p:spPr>
           <a:xfrm>
-            <a:off x="6236208" y="1280160"/>
-            <a:ext cx="5148072" cy="4937760"/>
+            <a:off x="6263640" y="1280160"/>
+            <a:ext cx="5166360" cy="4937760"/>
           </a:xfrm>
           <a:prstGeom prst="roundRect">
             <a:avLst/>
           </a:prstGeom>
           <a:solidFill>
-            <a:srgbClr val="F8FAFC"/>
+            <a:srgbClr val="FAFCFF"/>
           </a:solidFill>
           <a:ln>
             <a:solidFill>
-              <a:srgbClr val="E2E8F0"/>
+              <a:srgbClr val="D7E1EE"/>
             </a:solidFill>
           </a:ln>
         </p:spPr>
@@ -6960,14 +6672,14 @@
           </a:fontRef>
         </p:style>
         <p:txBody>
-          <a:bodyPr rtlCol="0" anchor="ctr" wrap="square" lIns="228600" tIns="182880" rIns="228600"/>
+          <a:bodyPr rtlCol="0" anchor="ctr" wrap="square" lIns="256032" tIns="228600" rIns="256032"/>
           <a:lstStyle/>
           <a:p>
             <a:pPr algn="ctr">
               <a:spcAft>
-                <a:spcPts val="1000"/>
-              </a:spcAft>
-              <a:defRPr sz="1550" b="1" u="sng">
+                <a:spcPts val="1200"/>
+              </a:spcAft>
+              <a:defRPr sz="1500" b="1" u="sng">
                 <a:solidFill>
                   <a:srgbClr val="1B365D"/>
                 </a:solidFill>
@@ -6981,11 +6693,11 @@
           <a:p>
             <a:pPr>
               <a:spcAft>
-                <a:spcPts val="600"/>
-              </a:spcAft>
-            </a:pPr>
-            <a:r>
-              <a:rPr b="1" sz="1000">
+                <a:spcPts val="800"/>
+              </a:spcAft>
+            </a:pPr>
+            <a:r>
+              <a:rPr b="1" sz="1150">
                 <a:solidFill>
                   <a:srgbClr val="1B365D"/>
                 </a:solidFill>
@@ -6995,7 +6707,7 @@
   </a:t>
             </a:r>
             <a:r>
-              <a:rPr sz="950">
+              <a:rPr sz="1050">
                 <a:solidFill>
                   <a:srgbClr val="0077C8"/>
                 </a:solidFill>
@@ -7007,11 +6719,11 @@
           <a:p>
             <a:pPr>
               <a:spcAft>
-                <a:spcPts val="600"/>
-              </a:spcAft>
-            </a:pPr>
-            <a:r>
-              <a:rPr b="1" sz="1000">
+                <a:spcPts val="800"/>
+              </a:spcAft>
+            </a:pPr>
+            <a:r>
+              <a:rPr b="1" sz="1150">
                 <a:solidFill>
                   <a:srgbClr val="1B365D"/>
                 </a:solidFill>
@@ -7021,7 +6733,7 @@
   </a:t>
             </a:r>
             <a:r>
-              <a:rPr sz="950">
+              <a:rPr sz="1050">
                 <a:solidFill>
                   <a:srgbClr val="0077C8"/>
                 </a:solidFill>
@@ -7033,11 +6745,11 @@
           <a:p>
             <a:pPr>
               <a:spcAft>
-                <a:spcPts val="600"/>
-              </a:spcAft>
-            </a:pPr>
-            <a:r>
-              <a:rPr b="1" sz="1000">
+                <a:spcPts val="800"/>
+              </a:spcAft>
+            </a:pPr>
+            <a:r>
+              <a:rPr b="1" sz="1150">
                 <a:solidFill>
                   <a:srgbClr val="1B365D"/>
                 </a:solidFill>
@@ -7047,7 +6759,7 @@
   </a:t>
             </a:r>
             <a:r>
-              <a:rPr sz="950">
+              <a:rPr sz="1050">
                 <a:solidFill>
                   <a:srgbClr val="0077C8"/>
                 </a:solidFill>
@@ -7059,11 +6771,11 @@
           <a:p>
             <a:pPr>
               <a:spcAft>
-                <a:spcPts val="600"/>
-              </a:spcAft>
-            </a:pPr>
-            <a:r>
-              <a:rPr b="1" sz="1000">
+                <a:spcPts val="800"/>
+              </a:spcAft>
+            </a:pPr>
+            <a:r>
+              <a:rPr b="1" sz="1150">
                 <a:solidFill>
                   <a:srgbClr val="1B365D"/>
                 </a:solidFill>
@@ -7073,7 +6785,7 @@
   </a:t>
             </a:r>
             <a:r>
-              <a:rPr sz="950">
+              <a:rPr sz="1050">
                 <a:solidFill>
                   <a:srgbClr val="0077C8"/>
                 </a:solidFill>
@@ -7085,11 +6797,11 @@
           <a:p>
             <a:pPr>
               <a:spcAft>
-                <a:spcPts val="600"/>
-              </a:spcAft>
-            </a:pPr>
-            <a:r>
-              <a:rPr b="1" sz="1000">
+                <a:spcPts val="800"/>
+              </a:spcAft>
+            </a:pPr>
+            <a:r>
+              <a:rPr b="1" sz="1150">
                 <a:solidFill>
                   <a:srgbClr val="1B365D"/>
                 </a:solidFill>
@@ -7099,7 +6811,7 @@
   </a:t>
             </a:r>
             <a:r>
-              <a:rPr sz="950">
+              <a:rPr sz="1050">
                 <a:solidFill>
                   <a:srgbClr val="0077C8"/>
                 </a:solidFill>

</xml_diff>

<commit_message>
Update SIH 2026 presentation with exact standalone SIH logo, Times New Roman typography, unnested easy-edit textboxes, and clean infographics
</commit_message>
<xml_diff>
--- a/SIH2026_Idea_Presentation_PS26154.pptx
+++ b/SIH2026_Idea_Presentation_PS26154.pptx
@@ -3093,9 +3093,304 @@
         <p:nvPr/>
       </p:nvGrpSpPr>
       <p:grpSpPr/>
+      <p:sp>
+        <p:nvSpPr>
+          <p:cNvPr id="2" name="TextBox 1"/>
+          <p:cNvSpPr txBox="1"/>
+          <p:nvPr/>
+        </p:nvSpPr>
+        <p:spPr>
+          <a:xfrm>
+            <a:off x="731520" y="365760"/>
+            <a:ext cx="10698480" cy="548640"/>
+          </a:xfrm>
+          <a:prstGeom prst="rect">
+            <a:avLst/>
+          </a:prstGeom>
+          <a:noFill/>
+        </p:spPr>
+        <p:txBody>
+          <a:bodyPr wrap="none">
+            <a:spAutoFit/>
+          </a:bodyPr>
+          <a:lstStyle/>
+          <a:p>
+            <a:pPr algn="ctr">
+              <a:defRPr sz="2800" b="1">
+                <a:solidFill>
+                  <a:srgbClr val="1B365D"/>
+                </a:solidFill>
+                <a:latin typeface="Times New Roman"/>
+              </a:defRPr>
+            </a:pPr>
+            <a:r>
+              <a:t>SMART INDIA HACKATHON 2026</a:t>
+            </a:r>
+          </a:p>
+        </p:txBody>
+      </p:sp>
+      <p:sp>
+        <p:nvSpPr>
+          <p:cNvPr id="3" name="TextBox 2"/>
+          <p:cNvSpPr txBox="1"/>
+          <p:nvPr/>
+        </p:nvSpPr>
+        <p:spPr>
+          <a:xfrm>
+            <a:off x="731520" y="1005840"/>
+            <a:ext cx="10698480" cy="457200"/>
+          </a:xfrm>
+          <a:prstGeom prst="rect">
+            <a:avLst/>
+          </a:prstGeom>
+          <a:noFill/>
+        </p:spPr>
+        <p:txBody>
+          <a:bodyPr wrap="none">
+            <a:spAutoFit/>
+          </a:bodyPr>
+          <a:lstStyle/>
+          <a:p>
+            <a:pPr algn="ctr">
+              <a:defRPr sz="2200" b="1">
+                <a:solidFill>
+                  <a:srgbClr val="14181E"/>
+                </a:solidFill>
+                <a:latin typeface="Times New Roman"/>
+              </a:defRPr>
+            </a:pPr>
+            <a:r>
+              <a:t>TITLE PAGE</a:t>
+            </a:r>
+          </a:p>
+        </p:txBody>
+      </p:sp>
+      <p:sp>
+        <p:nvSpPr>
+          <p:cNvPr id="4" name="TextBox 3"/>
+          <p:cNvSpPr txBox="1"/>
+          <p:nvPr/>
+        </p:nvSpPr>
+        <p:spPr>
+          <a:xfrm>
+            <a:off x="731520" y="1645920"/>
+            <a:ext cx="7132320" cy="4663440"/>
+          </a:xfrm>
+          <a:prstGeom prst="rect">
+            <a:avLst/>
+          </a:prstGeom>
+          <a:noFill/>
+        </p:spPr>
+        <p:txBody>
+          <a:bodyPr wrap="square">
+            <a:spAutoFit/>
+          </a:bodyPr>
+          <a:lstStyle/>
+          <a:p>
+            <a:pPr>
+              <a:spcAft>
+                <a:spcPts val="1000"/>
+              </a:spcAft>
+            </a:pPr>
+            <a:r>
+              <a:rPr b="1" sz="1400">
+                <a:solidFill>
+                  <a:srgbClr val="1B365D"/>
+                </a:solidFill>
+                <a:latin typeface="Times New Roman"/>
+              </a:rPr>
+              <a:t>• Problem Statement ID –</a:t>
+            </a:r>
+            <a:r>
+              <a:rPr sz="1400" b="1">
+                <a:solidFill>
+                  <a:srgbClr val="F37021"/>
+                </a:solidFill>
+                <a:latin typeface="Times New Roman"/>
+              </a:rPr>
+              <a:t> 26154</a:t>
+            </a:r>
+          </a:p>
+          <a:p>
+            <a:pPr>
+              <a:spcAft>
+                <a:spcPts val="1000"/>
+              </a:spcAft>
+            </a:pPr>
+            <a:r>
+              <a:rPr b="1" sz="1400">
+                <a:solidFill>
+                  <a:srgbClr val="1B365D"/>
+                </a:solidFill>
+                <a:latin typeface="Times New Roman"/>
+              </a:rPr>
+              <a:t>• Problem Statement Title –</a:t>
+            </a:r>
+            <a:r>
+              <a:rPr sz="1400" b="1">
+                <a:solidFill>
+                  <a:srgbClr val="14181E"/>
+                </a:solidFill>
+                <a:latin typeface="Times New Roman"/>
+              </a:rPr>
+              <a:t> Gen AI Platform for Automated Content Transformation</a:t>
+            </a:r>
+          </a:p>
+          <a:p>
+            <a:pPr>
+              <a:spcAft>
+                <a:spcPts val="1000"/>
+              </a:spcAft>
+            </a:pPr>
+            <a:r>
+              <a:rPr b="1" sz="1400">
+                <a:solidFill>
+                  <a:srgbClr val="1B365D"/>
+                </a:solidFill>
+                <a:latin typeface="Times New Roman"/>
+              </a:rPr>
+              <a:t>• Theme –</a:t>
+            </a:r>
+            <a:r>
+              <a:rPr sz="1400" b="0">
+                <a:solidFill>
+                  <a:srgbClr val="14181E"/>
+                </a:solidFill>
+                <a:latin typeface="Arial"/>
+              </a:rPr>
+              <a:t> Blockchain &amp; Cybersecurity / AI</a:t>
+            </a:r>
+          </a:p>
+          <a:p>
+            <a:pPr>
+              <a:spcAft>
+                <a:spcPts val="1000"/>
+              </a:spcAft>
+            </a:pPr>
+            <a:r>
+              <a:rPr b="1" sz="1400">
+                <a:solidFill>
+                  <a:srgbClr val="1B365D"/>
+                </a:solidFill>
+                <a:latin typeface="Times New Roman"/>
+              </a:rPr>
+              <a:t>• PS Category –</a:t>
+            </a:r>
+            <a:r>
+              <a:rPr sz="1400" b="0">
+                <a:solidFill>
+                  <a:srgbClr val="14181E"/>
+                </a:solidFill>
+                <a:latin typeface="Arial"/>
+              </a:rPr>
+              <a:t> Software</a:t>
+            </a:r>
+          </a:p>
+          <a:p>
+            <a:pPr>
+              <a:spcAft>
+                <a:spcPts val="1000"/>
+              </a:spcAft>
+            </a:pPr>
+            <a:r>
+              <a:rPr b="1" sz="1400">
+                <a:solidFill>
+                  <a:srgbClr val="1B365D"/>
+                </a:solidFill>
+                <a:latin typeface="Times New Roman"/>
+              </a:rPr>
+              <a:t>• Organization –</a:t>
+            </a:r>
+            <a:r>
+              <a:rPr sz="1400" b="0">
+                <a:solidFill>
+                  <a:srgbClr val="14181E"/>
+                </a:solidFill>
+                <a:latin typeface="Arial"/>
+              </a:rPr>
+              <a:t> National Technical Research Organisation (NTRO)</a:t>
+            </a:r>
+          </a:p>
+          <a:p>
+            <a:pPr>
+              <a:spcAft>
+                <a:spcPts val="1000"/>
+              </a:spcAft>
+            </a:pPr>
+            <a:r>
+              <a:rPr b="1" sz="1400">
+                <a:solidFill>
+                  <a:srgbClr val="1B365D"/>
+                </a:solidFill>
+                <a:latin typeface="Times New Roman"/>
+              </a:rPr>
+              <a:t>• Team ID –</a:t>
+            </a:r>
+            <a:r>
+              <a:rPr sz="1400" b="0">
+                <a:solidFill>
+                  <a:srgbClr val="14181E"/>
+                </a:solidFill>
+                <a:latin typeface="Arial"/>
+              </a:rPr>
+              <a:t> [Registered Team ID on Portal]</a:t>
+            </a:r>
+          </a:p>
+          <a:p>
+            <a:pPr>
+              <a:spcAft>
+                <a:spcPts val="1000"/>
+              </a:spcAft>
+            </a:pPr>
+            <a:r>
+              <a:rPr b="1" sz="1400">
+                <a:solidFill>
+                  <a:srgbClr val="1B365D"/>
+                </a:solidFill>
+                <a:latin typeface="Times New Roman"/>
+              </a:rPr>
+              <a:t>• Team Name (Registered on portal) –</a:t>
+            </a:r>
+            <a:r>
+              <a:rPr sz="1400" b="1">
+                <a:solidFill>
+                  <a:srgbClr val="14181E"/>
+                </a:solidFill>
+                <a:latin typeface="Times New Roman"/>
+              </a:rPr>
+              <a:t> OmniTransform</a:t>
+            </a:r>
+          </a:p>
+          <a:p>
+            <a:pPr>
+              <a:spcAft>
+                <a:spcPts val="1000"/>
+              </a:spcAft>
+            </a:pPr>
+            <a:r>
+              <a:rPr b="1" sz="1400">
+                <a:solidFill>
+                  <a:srgbClr val="1B365D"/>
+                </a:solidFill>
+                <a:latin typeface="Times New Roman"/>
+              </a:rPr>
+              <a:t>• Idea Title –</a:t>
+            </a:r>
+            <a:r>
+              <a:rPr sz="1400" b="1">
+                <a:solidFill>
+                  <a:srgbClr val="14181E"/>
+                </a:solidFill>
+                <a:latin typeface="Times New Roman"/>
+              </a:rPr>
+              <a:t> OmniTransform AI</a:t>
+            </a:r>
+          </a:p>
+        </p:txBody>
+      </p:sp>
       <p:pic>
         <p:nvPicPr>
-          <p:cNvPr id="2" name="Picture 1" descr="sih_header_banner.jpg"/>
+          <p:cNvPr id="5" name="Picture 4" descr="sih_official_logo.png"/>
           <p:cNvPicPr>
             <a:picLocks noChangeAspect="1"/>
           </p:cNvPicPr>
@@ -3109,416 +3404,14 @@
         </p:blipFill>
         <p:spPr>
           <a:xfrm>
-            <a:off x="7132320" y="274320"/>
-            <a:ext cx="4480560" cy="591671"/>
+            <a:off x="8046720" y="1828800"/>
+            <a:ext cx="3474720" cy="1789308"/>
           </a:xfrm>
           <a:prstGeom prst="rect">
             <a:avLst/>
           </a:prstGeom>
         </p:spPr>
       </p:pic>
-      <p:sp>
-        <p:nvSpPr>
-          <p:cNvPr id="3" name="TextBox 2"/>
-          <p:cNvSpPr txBox="1"/>
-          <p:nvPr/>
-        </p:nvSpPr>
-        <p:spPr>
-          <a:xfrm>
-            <a:off x="731520" y="320040"/>
-            <a:ext cx="6400800" cy="731520"/>
-          </a:xfrm>
-          <a:prstGeom prst="rect">
-            <a:avLst/>
-          </a:prstGeom>
-          <a:noFill/>
-        </p:spPr>
-        <p:txBody>
-          <a:bodyPr wrap="none">
-            <a:spAutoFit/>
-          </a:bodyPr>
-          <a:lstStyle/>
-          <a:p>
-            <a:pPr>
-              <a:defRPr sz="2600" b="1">
-                <a:solidFill>
-                  <a:srgbClr val="1B365D"/>
-                </a:solidFill>
-                <a:latin typeface="Arial"/>
-              </a:defRPr>
-            </a:pPr>
-            <a:r>
-              <a:t>SMART INDIA HACKATHON 2026</a:t>
-            </a:r>
-          </a:p>
-          <a:p>
-            <a:pPr>
-              <a:defRPr sz="1800" b="1">
-                <a:solidFill>
-                  <a:srgbClr val="F37021"/>
-                </a:solidFill>
-                <a:latin typeface="Arial"/>
-              </a:defRPr>
-            </a:pPr>
-            <a:r>
-              <a:t>TITLE PAGE</a:t>
-            </a:r>
-          </a:p>
-        </p:txBody>
-      </p:sp>
-      <p:sp>
-        <p:nvSpPr>
-          <p:cNvPr id="4" name="Rounded Rectangle 3"/>
-          <p:cNvSpPr/>
-          <p:nvPr/>
-        </p:nvSpPr>
-        <p:spPr>
-          <a:xfrm>
-            <a:off x="731520" y="1463040"/>
-            <a:ext cx="7132320" cy="4663440"/>
-          </a:xfrm>
-          <a:prstGeom prst="roundRect">
-            <a:avLst/>
-          </a:prstGeom>
-          <a:solidFill>
-            <a:srgbClr val="FAFCFF"/>
-          </a:solidFill>
-          <a:ln w="19050">
-            <a:solidFill>
-              <a:srgbClr val="D7E1EE"/>
-            </a:solidFill>
-          </a:ln>
-        </p:spPr>
-        <p:style>
-          <a:lnRef idx="1">
-            <a:schemeClr val="accent1"/>
-          </a:lnRef>
-          <a:fillRef idx="3">
-            <a:schemeClr val="accent1"/>
-          </a:fillRef>
-          <a:effectRef idx="2">
-            <a:schemeClr val="accent1"/>
-          </a:effectRef>
-          <a:fontRef idx="minor">
-            <a:schemeClr val="lt1"/>
-          </a:fontRef>
-        </p:style>
-        <p:txBody>
-          <a:bodyPr rtlCol="0" anchor="ctr" wrap="square" lIns="320040" tIns="320040" rIns="320040"/>
-          <a:lstStyle/>
-          <a:p>
-            <a:pPr algn="ctr">
-              <a:spcAft>
-                <a:spcPts val="1200"/>
-              </a:spcAft>
-            </a:pPr>
-            <a:r>
-              <a:rPr b="1" sz="1300">
-                <a:solidFill>
-                  <a:srgbClr val="1B365D"/>
-                </a:solidFill>
-                <a:latin typeface="Arial"/>
-              </a:rPr>
-              <a:t>• Problem Statement ID –</a:t>
-            </a:r>
-            <a:r>
-              <a:rPr sz="1300" b="1">
-                <a:solidFill>
-                  <a:srgbClr val="F37021"/>
-                </a:solidFill>
-                <a:latin typeface="Arial"/>
-              </a:rPr>
-              <a:t> 26154</a:t>
-            </a:r>
-          </a:p>
-          <a:p>
-            <a:pPr>
-              <a:spcAft>
-                <a:spcPts val="1200"/>
-              </a:spcAft>
-            </a:pPr>
-            <a:r>
-              <a:rPr b="1" sz="1300">
-                <a:solidFill>
-                  <a:srgbClr val="1B365D"/>
-                </a:solidFill>
-                <a:latin typeface="Arial"/>
-              </a:rPr>
-              <a:t>• Problem Statement Title –</a:t>
-            </a:r>
-            <a:r>
-              <a:rPr sz="1300" b="1">
-                <a:solidFill>
-                  <a:srgbClr val="191E24"/>
-                </a:solidFill>
-                <a:latin typeface="Arial"/>
-              </a:rPr>
-              <a:t> Gen AI Platform for Automated Content Transformation</a:t>
-            </a:r>
-          </a:p>
-          <a:p>
-            <a:pPr>
-              <a:spcAft>
-                <a:spcPts val="1200"/>
-              </a:spcAft>
-            </a:pPr>
-            <a:r>
-              <a:rPr b="1" sz="1300">
-                <a:solidFill>
-                  <a:srgbClr val="1B365D"/>
-                </a:solidFill>
-                <a:latin typeface="Arial"/>
-              </a:rPr>
-              <a:t>• Theme –</a:t>
-            </a:r>
-            <a:r>
-              <a:rPr sz="1300" b="0">
-                <a:solidFill>
-                  <a:srgbClr val="191E24"/>
-                </a:solidFill>
-                <a:latin typeface="Arial"/>
-              </a:rPr>
-              <a:t> Blockchain &amp; Cybersecurity / Artificial Intelligence</a:t>
-            </a:r>
-          </a:p>
-          <a:p>
-            <a:pPr>
-              <a:spcAft>
-                <a:spcPts val="1200"/>
-              </a:spcAft>
-            </a:pPr>
-            <a:r>
-              <a:rPr b="1" sz="1300">
-                <a:solidFill>
-                  <a:srgbClr val="1B365D"/>
-                </a:solidFill>
-                <a:latin typeface="Arial"/>
-              </a:rPr>
-              <a:t>• PS Category –</a:t>
-            </a:r>
-            <a:r>
-              <a:rPr sz="1300" b="0">
-                <a:solidFill>
-                  <a:srgbClr val="191E24"/>
-                </a:solidFill>
-                <a:latin typeface="Arial"/>
-              </a:rPr>
-              <a:t> Software</a:t>
-            </a:r>
-          </a:p>
-          <a:p>
-            <a:pPr>
-              <a:spcAft>
-                <a:spcPts val="1200"/>
-              </a:spcAft>
-            </a:pPr>
-            <a:r>
-              <a:rPr b="1" sz="1300">
-                <a:solidFill>
-                  <a:srgbClr val="1B365D"/>
-                </a:solidFill>
-                <a:latin typeface="Arial"/>
-              </a:rPr>
-              <a:t>• Organization –</a:t>
-            </a:r>
-            <a:r>
-              <a:rPr sz="1300" b="0">
-                <a:solidFill>
-                  <a:srgbClr val="191E24"/>
-                </a:solidFill>
-                <a:latin typeface="Arial"/>
-              </a:rPr>
-              <a:t> National Technical Research Organisation (NTRO)</a:t>
-            </a:r>
-          </a:p>
-          <a:p>
-            <a:pPr>
-              <a:spcAft>
-                <a:spcPts val="1200"/>
-              </a:spcAft>
-            </a:pPr>
-            <a:r>
-              <a:rPr b="1" sz="1300">
-                <a:solidFill>
-                  <a:srgbClr val="1B365D"/>
-                </a:solidFill>
-                <a:latin typeface="Arial"/>
-              </a:rPr>
-              <a:t>• Team ID –</a:t>
-            </a:r>
-            <a:r>
-              <a:rPr sz="1300" b="0">
-                <a:solidFill>
-                  <a:srgbClr val="191E24"/>
-                </a:solidFill>
-                <a:latin typeface="Arial"/>
-              </a:rPr>
-              <a:t> [Registered Team ID on SIH Portal]</a:t>
-            </a:r>
-          </a:p>
-          <a:p>
-            <a:pPr>
-              <a:spcAft>
-                <a:spcPts val="1200"/>
-              </a:spcAft>
-            </a:pPr>
-            <a:r>
-              <a:rPr b="1" sz="1300">
-                <a:solidFill>
-                  <a:srgbClr val="1B365D"/>
-                </a:solidFill>
-                <a:latin typeface="Arial"/>
-              </a:rPr>
-              <a:t>• Team Name (Registered on portal) –</a:t>
-            </a:r>
-            <a:r>
-              <a:rPr sz="1300" b="1">
-                <a:solidFill>
-                  <a:srgbClr val="191E24"/>
-                </a:solidFill>
-                <a:latin typeface="Arial"/>
-              </a:rPr>
-              <a:t> OmniTransform</a:t>
-            </a:r>
-          </a:p>
-        </p:txBody>
-      </p:sp>
-      <p:sp>
-        <p:nvSpPr>
-          <p:cNvPr id="5" name="Rounded Rectangle 4"/>
-          <p:cNvSpPr/>
-          <p:nvPr/>
-        </p:nvSpPr>
-        <p:spPr>
-          <a:xfrm>
-            <a:off x="8046720" y="1463040"/>
-            <a:ext cx="3383280" cy="4663440"/>
-          </a:xfrm>
-          <a:prstGeom prst="roundRect">
-            <a:avLst/>
-          </a:prstGeom>
-          <a:solidFill>
-            <a:srgbClr val="1B365D"/>
-          </a:solidFill>
-          <a:ln>
-            <a:noFill/>
-          </a:ln>
-        </p:spPr>
-        <p:style>
-          <a:lnRef idx="1">
-            <a:schemeClr val="accent1"/>
-          </a:lnRef>
-          <a:fillRef idx="3">
-            <a:schemeClr val="accent1"/>
-          </a:fillRef>
-          <a:effectRef idx="2">
-            <a:schemeClr val="accent1"/>
-          </a:effectRef>
-          <a:fontRef idx="minor">
-            <a:schemeClr val="lt1"/>
-          </a:fontRef>
-        </p:style>
-        <p:txBody>
-          <a:bodyPr rtlCol="0" anchor="ctr" wrap="square" lIns="274320" tIns="365760" rIns="274320"/>
-          <a:lstStyle/>
-          <a:p>
-            <a:pPr algn="ctr">
-              <a:spcAft>
-                <a:spcPts val="800"/>
-              </a:spcAft>
-              <a:defRPr sz="1200" b="1">
-                <a:solidFill>
-                  <a:srgbClr val="F37021"/>
-                </a:solidFill>
-                <a:latin typeface="Arial"/>
-              </a:defRPr>
-            </a:pPr>
-            <a:r>
-              <a:t>PROPOSED SOLUTION</a:t>
-            </a:r>
-          </a:p>
-          <a:p>
-            <a:pPr algn="ctr">
-              <a:spcAft>
-                <a:spcPts val="1600"/>
-              </a:spcAft>
-              <a:defRPr sz="2100" b="1">
-                <a:solidFill>
-                  <a:srgbClr val="FFFFFF"/>
-                </a:solidFill>
-                <a:latin typeface="Arial"/>
-              </a:defRPr>
-            </a:pPr>
-            <a:r>
-              <a:t>OmniTransform AI</a:t>
-            </a:r>
-          </a:p>
-          <a:p>
-            <a:pPr>
-              <a:spcAft>
-                <a:spcPts val="1400"/>
-              </a:spcAft>
-              <a:defRPr sz="1150">
-                <a:solidFill>
-                  <a:srgbClr val="E6F0FF"/>
-                </a:solidFill>
-                <a:latin typeface="Arial"/>
-              </a:defRPr>
-            </a:pPr>
-            <a:r>
-              <a:t>[+] Single-Pass 1-to-5 Synchronized Output</a:t>
-            </a:r>
-          </a:p>
-          <a:p>
-            <a:pPr>
-              <a:spcAft>
-                <a:spcPts val="1400"/>
-              </a:spcAft>
-              <a:defRPr sz="1150">
-                <a:solidFill>
-                  <a:srgbClr val="E6F0FF"/>
-                </a:solidFill>
-                <a:latin typeface="Arial"/>
-              </a:defRPr>
-            </a:pPr>
-            <a:r>
-              <a:t>[+] 100% Grounded Source Citations</a:t>
-            </a:r>
-          </a:p>
-          <a:p>
-            <a:pPr>
-              <a:spcAft>
-                <a:spcPts val="1400"/>
-              </a:spcAft>
-              <a:defRPr sz="1150">
-                <a:solidFill>
-                  <a:srgbClr val="E6F0FF"/>
-                </a:solidFill>
-                <a:latin typeface="Arial"/>
-              </a:defRPr>
-            </a:pPr>
-            <a:r>
-              <a:t>[+] Sovereign Air-Gapped Compliance</a:t>
-            </a:r>
-          </a:p>
-          <a:p>
-            <a:pPr>
-              <a:spcAft>
-                <a:spcPts val="1400"/>
-              </a:spcAft>
-              <a:defRPr sz="1150">
-                <a:solidFill>
-                  <a:srgbClr val="E6F0FF"/>
-                </a:solidFill>
-                <a:latin typeface="Arial"/>
-              </a:defRPr>
-            </a:pPr>
-            <a:r>
-              <a:t>[+] Production Ecosystem: hrl-brand-seo.vercel.app</a:t>
-            </a:r>
-          </a:p>
-        </p:txBody>
-      </p:sp>
     </p:spTree>
   </p:cSld>
   <p:clrMapOvr>
@@ -3545,8 +3438,8 @@
         </p:nvSpPr>
         <p:spPr>
           <a:xfrm>
-            <a:off x="502920" y="228600"/>
-            <a:ext cx="1691640" cy="960120"/>
+            <a:off x="502920" y="274320"/>
+            <a:ext cx="1645920" cy="914400"/>
           </a:xfrm>
           <a:prstGeom prst="ellipse">
             <a:avLst/>
@@ -3579,28 +3472,28 @@
           <a:lstStyle/>
           <a:p>
             <a:pPr algn="ctr">
-              <a:defRPr sz="1000">
-                <a:solidFill>
-                  <a:srgbClr val="191E24"/>
+              <a:defRPr sz="1100">
+                <a:solidFill>
+                  <a:srgbClr val="14181E"/>
                 </a:solidFill>
                 <a:latin typeface="Arial"/>
               </a:defRPr>
             </a:pPr>
             <a:r>
-              <a:t>Team Name</a:t>
+              <a:t>Your Team</a:t>
             </a:r>
           </a:p>
           <a:p>
             <a:pPr algn="ctr">
-              <a:defRPr sz="1150" b="1">
-                <a:solidFill>
-                  <a:srgbClr val="1B365D"/>
+              <a:defRPr sz="1100">
+                <a:solidFill>
+                  <a:srgbClr val="14181E"/>
                 </a:solidFill>
                 <a:latin typeface="Arial"/>
               </a:defRPr>
             </a:pPr>
             <a:r>
-              <a:t>OmniTransform</a:t>
+              <a:t>Name</a:t>
             </a:r>
           </a:p>
         </p:txBody>
@@ -3613,8 +3506,8 @@
         </p:nvSpPr>
         <p:spPr>
           <a:xfrm>
-            <a:off x="2377440" y="320040"/>
-            <a:ext cx="5303520" cy="777240"/>
+            <a:off x="2286000" y="320040"/>
+            <a:ext cx="6217920" cy="777240"/>
           </a:xfrm>
           <a:prstGeom prst="rect">
             <a:avLst/>
@@ -3628,11 +3521,11 @@
           <a:lstStyle/>
           <a:p>
             <a:pPr algn="ctr">
-              <a:defRPr sz="2400" b="1">
-                <a:solidFill>
-                  <a:srgbClr val="1B365D"/>
-                </a:solidFill>
-                <a:latin typeface="Arial"/>
+              <a:defRPr sz="2600" b="1">
+                <a:solidFill>
+                  <a:srgbClr val="1B365D"/>
+                </a:solidFill>
+                <a:latin typeface="Times New Roman"/>
               </a:defRPr>
             </a:pPr>
             <a:r>
@@ -3643,7 +3536,7 @@
       </p:sp>
       <p:pic>
         <p:nvPicPr>
-          <p:cNvPr id="4" name="Picture 3" descr="sih_header_banner.jpg"/>
+          <p:cNvPr id="4" name="Picture 3" descr="sih_official_logo.png"/>
           <p:cNvPicPr>
             <a:picLocks noChangeAspect="1"/>
           </p:cNvPicPr>
@@ -3657,8 +3550,8 @@
         </p:blipFill>
         <p:spPr>
           <a:xfrm>
-            <a:off x="7818120" y="228600"/>
-            <a:ext cx="3886200" cy="513184"/>
+            <a:off x="8961120" y="228600"/>
+            <a:ext cx="2743200" cy="1412611"/>
           </a:xfrm>
           <a:prstGeom prst="rect">
             <a:avLst/>
@@ -3789,7 +3682,7 @@
         <p:spPr>
           <a:xfrm>
             <a:off x="731520" y="1234440"/>
-            <a:ext cx="10698480" cy="411480"/>
+            <a:ext cx="10698480" cy="457200"/>
           </a:xfrm>
           <a:prstGeom prst="rect">
             <a:avLst/>
@@ -3803,11 +3696,11 @@
           <a:lstStyle/>
           <a:p>
             <a:pPr>
-              <a:defRPr sz="1600" b="1" u="sng">
-                <a:solidFill>
-                  <a:srgbClr val="1B365D"/>
-                </a:solidFill>
-                <a:latin typeface="Arial"/>
+              <a:defRPr sz="1800" b="1" u="sng">
+                <a:solidFill>
+                  <a:srgbClr val="1B365D"/>
+                </a:solidFill>
+                <a:latin typeface="Times New Roman"/>
               </a:defRPr>
             </a:pPr>
             <a:r>
@@ -3818,58 +3711,39 @@
       </p:sp>
       <p:sp>
         <p:nvSpPr>
-          <p:cNvPr id="9" name="Rounded Rectangle 8"/>
-          <p:cNvSpPr/>
+          <p:cNvPr id="9" name="TextBox 8"/>
+          <p:cNvSpPr txBox="1"/>
           <p:nvPr/>
         </p:nvSpPr>
         <p:spPr>
           <a:xfrm>
-            <a:off x="731520" y="1737360"/>
-            <a:ext cx="3337560" cy="4480560"/>
-          </a:xfrm>
-          <a:prstGeom prst="roundRect">
+            <a:off x="731520" y="1828800"/>
+            <a:ext cx="3383280" cy="4389120"/>
+          </a:xfrm>
+          <a:prstGeom prst="rect">
             <a:avLst/>
           </a:prstGeom>
-          <a:solidFill>
-            <a:srgbClr val="FAFCFF"/>
-          </a:solidFill>
-          <a:ln>
-            <a:solidFill>
-              <a:srgbClr val="D7E1EE"/>
-            </a:solidFill>
-          </a:ln>
-        </p:spPr>
-        <p:style>
-          <a:lnRef idx="1">
-            <a:schemeClr val="accent1"/>
-          </a:lnRef>
-          <a:fillRef idx="3">
-            <a:schemeClr val="accent1"/>
-          </a:fillRef>
-          <a:effectRef idx="2">
-            <a:schemeClr val="accent1"/>
-          </a:effectRef>
-          <a:fontRef idx="minor">
-            <a:schemeClr val="lt1"/>
-          </a:fontRef>
-        </p:style>
-        <p:txBody>
-          <a:bodyPr rtlCol="0" anchor="ctr" wrap="square" lIns="201168" tIns="201168" rIns="201168"/>
-          <a:lstStyle/>
-          <a:p>
-            <a:pPr algn="ctr">
-              <a:spcAft>
-                <a:spcPts val="1000"/>
+          <a:noFill/>
+        </p:spPr>
+        <p:txBody>
+          <a:bodyPr wrap="square">
+            <a:spAutoFit/>
+          </a:bodyPr>
+          <a:lstStyle/>
+          <a:p>
+            <a:pPr>
+              <a:spcAft>
+                <a:spcPts val="800"/>
               </a:spcAft>
               <a:defRPr sz="1400" b="1">
                 <a:solidFill>
                   <a:srgbClr val="1B365D"/>
                 </a:solidFill>
-                <a:latin typeface="Arial"/>
+                <a:latin typeface="Times New Roman"/>
               </a:defRPr>
             </a:pPr>
             <a:r>
-              <a:t>Detailed Explanation</a:t>
+              <a:t>• Detailed explanation of the proposed solution</a:t>
             </a:r>
           </a:p>
           <a:p>
@@ -3879,19 +3753,19 @@
               </a:spcAft>
               <a:defRPr sz="1200">
                 <a:solidFill>
-                  <a:srgbClr val="191E24"/>
+                  <a:srgbClr val="14181E"/>
                 </a:solidFill>
                 <a:latin typeface="Arial"/>
               </a:defRPr>
             </a:pPr>
             <a:r>
-              <a:t>• Ingests 50+ page PDFs, threat advisories, and policy whitepapers in a single pass.</a:t>
-            </a:r>
-          </a:p>
-          <a:p>
-            <a:pPr>
-              <a:spcAft>
-                <a:spcPts val="600"/>
+              <a:t>Single-pass ingestion of dense 50+ page PDFs, threat advisories, and policy documents.</a:t>
+            </a:r>
+          </a:p>
+          <a:p>
+            <a:pPr>
+              <a:spcAft>
+                <a:spcPts val="400"/>
               </a:spcAft>
               <a:defRPr sz="1200" b="1">
                 <a:solidFill>
@@ -3901,145 +3775,126 @@
               </a:defRPr>
             </a:pPr>
             <a:r>
-              <a:t>• Automatically generates 5 synchronized communication assets in &lt;10s:</a:t>
-            </a:r>
-          </a:p>
-          <a:p>
-            <a:pPr>
-              <a:spcAft>
-                <a:spcPts val="400"/>
+              <a:t>Generates 5 synchronized assets in under 10 seconds:</a:t>
+            </a:r>
+          </a:p>
+          <a:p>
+            <a:pPr>
+              <a:spcAft>
+                <a:spcPts val="300"/>
               </a:spcAft>
               <a:defRPr sz="1150">
                 <a:solidFill>
-                  <a:srgbClr val="191E24"/>
+                  <a:srgbClr val="14181E"/>
                 </a:solidFill>
                 <a:latin typeface="Arial"/>
               </a:defRPr>
             </a:pPr>
             <a:r>
-              <a:t>   - 1. Executive 1-Page Summary Brief</a:t>
-            </a:r>
-          </a:p>
-          <a:p>
-            <a:pPr>
-              <a:spcAft>
-                <a:spcPts val="400"/>
+              <a:t>   1. Executive 1-Page Summary Memo</a:t>
+            </a:r>
+          </a:p>
+          <a:p>
+            <a:pPr>
+              <a:spcAft>
+                <a:spcPts val="300"/>
               </a:spcAft>
               <a:defRPr sz="1150">
                 <a:solidFill>
-                  <a:srgbClr val="191E24"/>
+                  <a:srgbClr val="14181E"/>
                 </a:solidFill>
                 <a:latin typeface="Arial"/>
               </a:defRPr>
             </a:pPr>
             <a:r>
-              <a:t>   - 2. Presentation Slide Deck</a:t>
-            </a:r>
-          </a:p>
-          <a:p>
-            <a:pPr>
-              <a:spcAft>
-                <a:spcPts val="400"/>
+              <a:t>   2. Presentation Slide Deck</a:t>
+            </a:r>
+          </a:p>
+          <a:p>
+            <a:pPr>
+              <a:spcAft>
+                <a:spcPts val="300"/>
               </a:spcAft>
               <a:defRPr sz="1150">
                 <a:solidFill>
-                  <a:srgbClr val="191E24"/>
+                  <a:srgbClr val="14181E"/>
                 </a:solidFill>
                 <a:latin typeface="Arial"/>
               </a:defRPr>
             </a:pPr>
             <a:r>
-              <a:t>   - 3. Visual Infographic Cards</a:t>
-            </a:r>
-          </a:p>
-          <a:p>
-            <a:pPr>
-              <a:spcAft>
-                <a:spcPts val="400"/>
+              <a:t>   3. Visual Infographic Cards</a:t>
+            </a:r>
+          </a:p>
+          <a:p>
+            <a:pPr>
+              <a:spcAft>
+                <a:spcPts val="300"/>
               </a:spcAft>
               <a:defRPr sz="1150">
                 <a:solidFill>
-                  <a:srgbClr val="191E24"/>
+                  <a:srgbClr val="14181E"/>
                 </a:solidFill>
                 <a:latin typeface="Arial"/>
               </a:defRPr>
             </a:pPr>
             <a:r>
-              <a:t>   - 4. Multilingual Press Release</a:t>
-            </a:r>
-          </a:p>
-          <a:p>
-            <a:pPr>
-              <a:spcAft>
-                <a:spcPts val="400"/>
+              <a:t>   4. Multilingual Press Release</a:t>
+            </a:r>
+          </a:p>
+          <a:p>
+            <a:pPr>
+              <a:spcAft>
+                <a:spcPts val="300"/>
               </a:spcAft>
               <a:defRPr sz="1150">
                 <a:solidFill>
-                  <a:srgbClr val="191E24"/>
+                  <a:srgbClr val="14181E"/>
                 </a:solidFill>
                 <a:latin typeface="Arial"/>
               </a:defRPr>
             </a:pPr>
             <a:r>
-              <a:t>   - 5. 60s Voice Audio Podcast</a:t>
-            </a:r>
-          </a:p>
-        </p:txBody>
-      </p:sp>
-      <p:sp>
-        <p:nvSpPr>
-          <p:cNvPr id="10" name="Rounded Rectangle 9"/>
-          <p:cNvSpPr/>
+              <a:t>   5. 60s Voice Audio Podcast</a:t>
+            </a:r>
+          </a:p>
+        </p:txBody>
+      </p:sp>
+      <p:sp>
+        <p:nvSpPr>
+          <p:cNvPr id="10" name="TextBox 9"/>
+          <p:cNvSpPr txBox="1"/>
           <p:nvPr/>
         </p:nvSpPr>
         <p:spPr>
           <a:xfrm>
-            <a:off x="4416552" y="1737360"/>
-            <a:ext cx="3337560" cy="4480560"/>
-          </a:xfrm>
-          <a:prstGeom prst="roundRect">
+            <a:off x="4434840" y="1828800"/>
+            <a:ext cx="3383280" cy="4389120"/>
+          </a:xfrm>
+          <a:prstGeom prst="rect">
             <a:avLst/>
           </a:prstGeom>
-          <a:solidFill>
-            <a:srgbClr val="FAFCFF"/>
-          </a:solidFill>
-          <a:ln>
-            <a:solidFill>
-              <a:srgbClr val="D7E1EE"/>
-            </a:solidFill>
-          </a:ln>
-        </p:spPr>
-        <p:style>
-          <a:lnRef idx="1">
-            <a:schemeClr val="accent1"/>
-          </a:lnRef>
-          <a:fillRef idx="3">
-            <a:schemeClr val="accent1"/>
-          </a:fillRef>
-          <a:effectRef idx="2">
-            <a:schemeClr val="accent1"/>
-          </a:effectRef>
-          <a:fontRef idx="minor">
-            <a:schemeClr val="lt1"/>
-          </a:fontRef>
-        </p:style>
-        <p:txBody>
-          <a:bodyPr rtlCol="0" anchor="ctr" wrap="square" lIns="201168" tIns="201168" rIns="201168"/>
-          <a:lstStyle/>
-          <a:p>
-            <a:pPr algn="ctr">
-              <a:spcAft>
-                <a:spcPts val="1000"/>
+          <a:noFill/>
+        </p:spPr>
+        <p:txBody>
+          <a:bodyPr wrap="square">
+            <a:spAutoFit/>
+          </a:bodyPr>
+          <a:lstStyle/>
+          <a:p>
+            <a:pPr>
+              <a:spcAft>
+                <a:spcPts val="800"/>
               </a:spcAft>
               <a:defRPr sz="1400" b="1">
                 <a:solidFill>
                   <a:srgbClr val="1B365D"/>
                 </a:solidFill>
-                <a:latin typeface="Arial"/>
+                <a:latin typeface="Times New Roman"/>
               </a:defRPr>
             </a:pPr>
             <a:r>
-              <a:t>How it Addresses the Problem</a:t>
+              <a:t>• How it addresses the problem</a:t>
             </a:r>
           </a:p>
           <a:p>
@@ -4049,22 +3904,22 @@
               </a:spcAft>
             </a:pPr>
             <a:r>
-              <a:rPr b="1" sz="1150">
-                <a:solidFill>
-                  <a:srgbClr val="1B365D"/>
-                </a:solidFill>
-                <a:latin typeface="Arial"/>
-              </a:rPr>
-              <a:t>• Eliminates Manual Bottlenecks: </a:t>
-            </a:r>
-            <a:r>
-              <a:rPr sz="1150">
-                <a:solidFill>
-                  <a:srgbClr val="191E24"/>
-                </a:solidFill>
-                <a:latin typeface="Arial"/>
-              </a:rPr>
-              <a:t> Saves 4-6 hours daily spent by officers manually restructuring dense technical documents.</a:t>
+              <a:rPr b="1" sz="1200">
+                <a:solidFill>
+                  <a:srgbClr val="1B365D"/>
+                </a:solidFill>
+                <a:latin typeface="Arial"/>
+              </a:rPr>
+              <a:t>- Eliminates Manual Bottlenecks: </a:t>
+            </a:r>
+            <a:r>
+              <a:rPr sz="1200">
+                <a:solidFill>
+                  <a:srgbClr val="14181E"/>
+                </a:solidFill>
+                <a:latin typeface="Arial"/>
+              </a:rPr>
+              <a:t>Saves 4 to 6 hours daily spent by officers manually restructuring dense technical documents.</a:t>
             </a:r>
           </a:p>
           <a:p>
@@ -4074,22 +3929,22 @@
               </a:spcAft>
             </a:pPr>
             <a:r>
-              <a:rPr b="1" sz="1150">
-                <a:solidFill>
-                  <a:srgbClr val="1B365D"/>
-                </a:solidFill>
-                <a:latin typeface="Arial"/>
-              </a:rPr>
-              <a:t>• Unified Sovereign Platform: </a:t>
-            </a:r>
-            <a:r>
-              <a:rPr sz="1150">
-                <a:solidFill>
-                  <a:srgbClr val="191E24"/>
-                </a:solidFill>
-                <a:latin typeface="Arial"/>
-              </a:rPr>
-              <a:t> Replaces disconnected tools into one integrated local dashboard.</a:t>
+              <a:rPr b="1" sz="1200">
+                <a:solidFill>
+                  <a:srgbClr val="1B365D"/>
+                </a:solidFill>
+                <a:latin typeface="Arial"/>
+              </a:rPr>
+              <a:t>- Unified Sovereign Platform: </a:t>
+            </a:r>
+            <a:r>
+              <a:rPr sz="1200">
+                <a:solidFill>
+                  <a:srgbClr val="14181E"/>
+                </a:solidFill>
+                <a:latin typeface="Arial"/>
+              </a:rPr>
+              <a:t>Replaces disconnected third-party tools into one integrated local dashboard.</a:t>
             </a:r>
           </a:p>
           <a:p>
@@ -4099,22 +3954,22 @@
               </a:spcAft>
             </a:pPr>
             <a:r>
-              <a:rPr b="1" sz="1150">
-                <a:solidFill>
-                  <a:srgbClr val="1B365D"/>
-                </a:solidFill>
-                <a:latin typeface="Arial"/>
-              </a:rPr>
-              <a:t>• Preserves Tactical Velocity: </a:t>
-            </a:r>
-            <a:r>
-              <a:rPr sz="1150">
-                <a:solidFill>
-                  <a:srgbClr val="191E24"/>
-                </a:solidFill>
-                <a:latin typeface="Arial"/>
-              </a:rPr>
-              <a:t> Delivers immediate dissemination during critical national security events.</a:t>
+              <a:rPr b="1" sz="1200">
+                <a:solidFill>
+                  <a:srgbClr val="1B365D"/>
+                </a:solidFill>
+                <a:latin typeface="Arial"/>
+              </a:rPr>
+              <a:t>- Preserves Tactical Velocity: </a:t>
+            </a:r>
+            <a:r>
+              <a:rPr sz="1200">
+                <a:solidFill>
+                  <a:srgbClr val="14181E"/>
+                </a:solidFill>
+                <a:latin typeface="Arial"/>
+              </a:rPr>
+              <a:t>Delivers immediate intelligence dissemination during critical national security events.</a:t>
             </a:r>
           </a:p>
           <a:p>
@@ -4124,80 +3979,61 @@
               </a:spcAft>
             </a:pPr>
             <a:r>
-              <a:rPr b="1" sz="1150">
-                <a:solidFill>
-                  <a:srgbClr val="1B365D"/>
-                </a:solidFill>
-                <a:latin typeface="Arial"/>
-              </a:rPr>
-              <a:t>• Eliminates Hallucination Risk: </a:t>
-            </a:r>
-            <a:r>
-              <a:rPr sz="1150">
-                <a:solidFill>
-                  <a:srgbClr val="191E24"/>
-                </a:solidFill>
-                <a:latin typeface="Arial"/>
-              </a:rPr>
-              <a:t> Enforces strict RAG boundaries to ensure complete factual precision.</a:t>
-            </a:r>
-          </a:p>
-        </p:txBody>
-      </p:sp>
-      <p:sp>
-        <p:nvSpPr>
-          <p:cNvPr id="11" name="Rounded Rectangle 10"/>
-          <p:cNvSpPr/>
+              <a:rPr b="1" sz="1200">
+                <a:solidFill>
+                  <a:srgbClr val="1B365D"/>
+                </a:solidFill>
+                <a:latin typeface="Arial"/>
+              </a:rPr>
+              <a:t>- Eliminates Hallucination Risk: </a:t>
+            </a:r>
+            <a:r>
+              <a:rPr sz="1200">
+                <a:solidFill>
+                  <a:srgbClr val="14181E"/>
+                </a:solidFill>
+                <a:latin typeface="Arial"/>
+              </a:rPr>
+              <a:t>Enforces strict RAG boundaries to ensure complete factual precision.</a:t>
+            </a:r>
+          </a:p>
+        </p:txBody>
+      </p:sp>
+      <p:sp>
+        <p:nvSpPr>
+          <p:cNvPr id="11" name="TextBox 10"/>
+          <p:cNvSpPr txBox="1"/>
           <p:nvPr/>
         </p:nvSpPr>
         <p:spPr>
           <a:xfrm>
-            <a:off x="8101584" y="1737360"/>
-            <a:ext cx="3337560" cy="4480560"/>
-          </a:xfrm>
-          <a:prstGeom prst="roundRect">
+            <a:off x="8138160" y="1828800"/>
+            <a:ext cx="3383280" cy="4389120"/>
+          </a:xfrm>
+          <a:prstGeom prst="rect">
             <a:avLst/>
           </a:prstGeom>
-          <a:solidFill>
-            <a:srgbClr val="FAFCFF"/>
-          </a:solidFill>
-          <a:ln>
-            <a:solidFill>
-              <a:srgbClr val="D7E1EE"/>
-            </a:solidFill>
-          </a:ln>
-        </p:spPr>
-        <p:style>
-          <a:lnRef idx="1">
-            <a:schemeClr val="accent1"/>
-          </a:lnRef>
-          <a:fillRef idx="3">
-            <a:schemeClr val="accent1"/>
-          </a:fillRef>
-          <a:effectRef idx="2">
-            <a:schemeClr val="accent1"/>
-          </a:effectRef>
-          <a:fontRef idx="minor">
-            <a:schemeClr val="lt1"/>
-          </a:fontRef>
-        </p:style>
-        <p:txBody>
-          <a:bodyPr rtlCol="0" anchor="ctr" wrap="square" lIns="201168" tIns="201168" rIns="201168"/>
-          <a:lstStyle/>
-          <a:p>
-            <a:pPr algn="ctr">
-              <a:spcAft>
-                <a:spcPts val="1000"/>
+          <a:noFill/>
+        </p:spPr>
+        <p:txBody>
+          <a:bodyPr wrap="square">
+            <a:spAutoFit/>
+          </a:bodyPr>
+          <a:lstStyle/>
+          <a:p>
+            <a:pPr>
+              <a:spcAft>
+                <a:spcPts val="800"/>
               </a:spcAft>
               <a:defRPr sz="1400" b="1">
                 <a:solidFill>
                   <a:srgbClr val="1B365D"/>
                 </a:solidFill>
-                <a:latin typeface="Arial"/>
+                <a:latin typeface="Times New Roman"/>
               </a:defRPr>
             </a:pPr>
             <a:r>
-              <a:t>Innovation and Uniqueness</a:t>
+              <a:t>• Innovation and uniqueness of the solution</a:t>
             </a:r>
           </a:p>
           <a:p>
@@ -4207,22 +4043,22 @@
               </a:spcAft>
             </a:pPr>
             <a:r>
-              <a:rPr b="1" sz="1150">
-                <a:solidFill>
-                  <a:srgbClr val="1B365D"/>
-                </a:solidFill>
-                <a:latin typeface="Arial"/>
-              </a:rPr>
-              <a:t>• Interactive Source Highlighting: </a:t>
-            </a:r>
-            <a:r>
-              <a:rPr sz="1150">
-                <a:solidFill>
-                  <a:srgbClr val="191E24"/>
-                </a:solidFill>
-                <a:latin typeface="Arial"/>
-              </a:rPr>
-              <a:t> Click any bullet point to open the raw PDF with the exact sentence highlighted.</a:t>
+              <a:rPr b="1" sz="1200">
+                <a:solidFill>
+                  <a:srgbClr val="1B365D"/>
+                </a:solidFill>
+                <a:latin typeface="Arial"/>
+              </a:rPr>
+              <a:t>- Interactive Source Highlighting: </a:t>
+            </a:r>
+            <a:r>
+              <a:rPr sz="1200">
+                <a:solidFill>
+                  <a:srgbClr val="14181E"/>
+                </a:solidFill>
+                <a:latin typeface="Arial"/>
+              </a:rPr>
+              <a:t>Click any bullet point to open the raw PDF with the exact sentence highlighted.</a:t>
             </a:r>
           </a:p>
           <a:p>
@@ -4232,22 +4068,22 @@
               </a:spcAft>
             </a:pPr>
             <a:r>
-              <a:rPr b="1" sz="1150">
-                <a:solidFill>
-                  <a:srgbClr val="1B365D"/>
-                </a:solidFill>
-                <a:latin typeface="Arial"/>
-              </a:rPr>
-              <a:t>• Multi-Persona Tone Switching: </a:t>
-            </a:r>
-            <a:r>
-              <a:rPr sz="1150">
-                <a:solidFill>
-                  <a:srgbClr val="191E24"/>
-                </a:solidFill>
-                <a:latin typeface="Arial"/>
-              </a:rPr>
-              <a:t> 1-click toggle between C-Suite Brief, Citizen Explainer, and Threat Alert.</a:t>
+              <a:rPr b="1" sz="1200">
+                <a:solidFill>
+                  <a:srgbClr val="1B365D"/>
+                </a:solidFill>
+                <a:latin typeface="Arial"/>
+              </a:rPr>
+              <a:t>- Multi-Persona Tone Switching: </a:t>
+            </a:r>
+            <a:r>
+              <a:rPr sz="1200">
+                <a:solidFill>
+                  <a:srgbClr val="14181E"/>
+                </a:solidFill>
+                <a:latin typeface="Arial"/>
+              </a:rPr>
+              <a:t>1-click toggle between C-Suite Brief, Citizen Explainer, and Threat Alert.</a:t>
             </a:r>
           </a:p>
           <a:p>
@@ -4257,22 +4093,22 @@
               </a:spcAft>
             </a:pPr>
             <a:r>
-              <a:rPr b="1" sz="1150">
-                <a:solidFill>
-                  <a:srgbClr val="1B365D"/>
-                </a:solidFill>
-                <a:latin typeface="Arial"/>
-              </a:rPr>
-              <a:t>• Air-Gapped Sovereign Security: </a:t>
-            </a:r>
-            <a:r>
-              <a:rPr sz="1150">
-                <a:solidFill>
-                  <a:srgbClr val="191E24"/>
-                </a:solidFill>
-                <a:latin typeface="Arial"/>
-              </a:rPr>
-              <a:t> Runs locally on open-weights (Llama 3/Mistral) without public cloud data leaks.</a:t>
+              <a:rPr b="1" sz="1200">
+                <a:solidFill>
+                  <a:srgbClr val="1B365D"/>
+                </a:solidFill>
+                <a:latin typeface="Arial"/>
+              </a:rPr>
+              <a:t>- Air-Gapped Sovereign Security: </a:t>
+            </a:r>
+            <a:r>
+              <a:rPr sz="1200">
+                <a:solidFill>
+                  <a:srgbClr val="14181E"/>
+                </a:solidFill>
+                <a:latin typeface="Arial"/>
+              </a:rPr>
+              <a:t>Runs locally on open-weights (Llama 3/Mistral) without public cloud data leaks.</a:t>
             </a:r>
           </a:p>
           <a:p>
@@ -4282,22 +4118,22 @@
               </a:spcAft>
             </a:pPr>
             <a:r>
-              <a:rPr b="1" sz="1150">
-                <a:solidFill>
-                  <a:srgbClr val="1B365D"/>
-                </a:solidFill>
-                <a:latin typeface="Arial"/>
-              </a:rPr>
-              <a:t>• Deterministic Speed (&lt;10s): </a:t>
-            </a:r>
-            <a:r>
-              <a:rPr sz="1150">
-                <a:solidFill>
-                  <a:srgbClr val="191E24"/>
-                </a:solidFill>
-                <a:latin typeface="Arial"/>
-              </a:rPr>
-              <a:t> High-throughput asynchronous pipeline with zero runtime failures.</a:t>
+              <a:rPr b="1" sz="1200">
+                <a:solidFill>
+                  <a:srgbClr val="1B365D"/>
+                </a:solidFill>
+                <a:latin typeface="Arial"/>
+              </a:rPr>
+              <a:t>- Deterministic Speed (&lt;10s): </a:t>
+            </a:r>
+            <a:r>
+              <a:rPr sz="1200">
+                <a:solidFill>
+                  <a:srgbClr val="14181E"/>
+                </a:solidFill>
+                <a:latin typeface="Arial"/>
+              </a:rPr>
+              <a:t>High-throughput asynchronous pipeline with zero runtime failures.</a:t>
             </a:r>
           </a:p>
         </p:txBody>
@@ -4328,8 +4164,8 @@
         </p:nvSpPr>
         <p:spPr>
           <a:xfrm>
-            <a:off x="502920" y="228600"/>
-            <a:ext cx="1691640" cy="960120"/>
+            <a:off x="502920" y="274320"/>
+            <a:ext cx="1645920" cy="914400"/>
           </a:xfrm>
           <a:prstGeom prst="ellipse">
             <a:avLst/>
@@ -4362,28 +4198,28 @@
           <a:lstStyle/>
           <a:p>
             <a:pPr algn="ctr">
-              <a:defRPr sz="1000">
-                <a:solidFill>
-                  <a:srgbClr val="191E24"/>
+              <a:defRPr sz="1100">
+                <a:solidFill>
+                  <a:srgbClr val="14181E"/>
                 </a:solidFill>
                 <a:latin typeface="Arial"/>
               </a:defRPr>
             </a:pPr>
             <a:r>
-              <a:t>Team Name</a:t>
+              <a:t>Your Team</a:t>
             </a:r>
           </a:p>
           <a:p>
             <a:pPr algn="ctr">
-              <a:defRPr sz="1150" b="1">
-                <a:solidFill>
-                  <a:srgbClr val="1B365D"/>
+              <a:defRPr sz="1100">
+                <a:solidFill>
+                  <a:srgbClr val="14181E"/>
                 </a:solidFill>
                 <a:latin typeface="Arial"/>
               </a:defRPr>
             </a:pPr>
             <a:r>
-              <a:t>OmniTransform</a:t>
+              <a:t>Name</a:t>
             </a:r>
           </a:p>
         </p:txBody>
@@ -4396,8 +4232,8 @@
         </p:nvSpPr>
         <p:spPr>
           <a:xfrm>
-            <a:off x="2377440" y="320040"/>
-            <a:ext cx="5303520" cy="777240"/>
+            <a:off x="2286000" y="320040"/>
+            <a:ext cx="6217920" cy="777240"/>
           </a:xfrm>
           <a:prstGeom prst="rect">
             <a:avLst/>
@@ -4411,11 +4247,11 @@
           <a:lstStyle/>
           <a:p>
             <a:pPr algn="ctr">
-              <a:defRPr sz="2400" b="1">
-                <a:solidFill>
-                  <a:srgbClr val="1B365D"/>
-                </a:solidFill>
-                <a:latin typeface="Arial"/>
+              <a:defRPr sz="2600" b="1">
+                <a:solidFill>
+                  <a:srgbClr val="1B365D"/>
+                </a:solidFill>
+                <a:latin typeface="Times New Roman"/>
               </a:defRPr>
             </a:pPr>
             <a:r>
@@ -4426,7 +4262,7 @@
       </p:sp>
       <p:pic>
         <p:nvPicPr>
-          <p:cNvPr id="4" name="Picture 3" descr="sih_header_banner.jpg"/>
+          <p:cNvPr id="4" name="Picture 3" descr="sih_official_logo.png"/>
           <p:cNvPicPr>
             <a:picLocks noChangeAspect="1"/>
           </p:cNvPicPr>
@@ -4440,8 +4276,8 @@
         </p:blipFill>
         <p:spPr>
           <a:xfrm>
-            <a:off x="7818120" y="228600"/>
-            <a:ext cx="3886200" cy="513184"/>
+            <a:off x="8961120" y="228600"/>
+            <a:ext cx="2743200" cy="1412611"/>
           </a:xfrm>
           <a:prstGeom prst="rect">
             <a:avLst/>
@@ -4565,58 +4401,39 @@
       </p:sp>
       <p:sp>
         <p:nvSpPr>
-          <p:cNvPr id="8" name="Rounded Rectangle 7"/>
-          <p:cNvSpPr/>
+          <p:cNvPr id="8" name="TextBox 7"/>
+          <p:cNvSpPr txBox="1"/>
           <p:nvPr/>
         </p:nvSpPr>
         <p:spPr>
           <a:xfrm>
-            <a:off x="731520" y="1325880"/>
-            <a:ext cx="4389120" cy="4892040"/>
-          </a:xfrm>
-          <a:prstGeom prst="roundRect">
+            <a:off x="731520" y="1280160"/>
+            <a:ext cx="4389120" cy="4937760"/>
+          </a:xfrm>
+          <a:prstGeom prst="rect">
             <a:avLst/>
           </a:prstGeom>
-          <a:solidFill>
-            <a:srgbClr val="FAFCFF"/>
-          </a:solidFill>
-          <a:ln>
-            <a:solidFill>
-              <a:srgbClr val="D7E1EE"/>
-            </a:solidFill>
-          </a:ln>
-        </p:spPr>
-        <p:style>
-          <a:lnRef idx="1">
-            <a:schemeClr val="accent1"/>
-          </a:lnRef>
-          <a:fillRef idx="3">
-            <a:schemeClr val="accent1"/>
-          </a:fillRef>
-          <a:effectRef idx="2">
-            <a:schemeClr val="accent1"/>
-          </a:effectRef>
-          <a:fontRef idx="minor">
-            <a:schemeClr val="lt1"/>
-          </a:fontRef>
-        </p:style>
-        <p:txBody>
-          <a:bodyPr rtlCol="0" anchor="ctr" wrap="square" lIns="256032" tIns="228600" rIns="256032"/>
-          <a:lstStyle/>
-          <a:p>
-            <a:pPr algn="ctr">
-              <a:spcAft>
-                <a:spcPts val="1200"/>
-              </a:spcAft>
-              <a:defRPr sz="1500" b="1" u="sng">
-                <a:solidFill>
-                  <a:srgbClr val="1B365D"/>
-                </a:solidFill>
-                <a:latin typeface="Arial"/>
+          <a:noFill/>
+        </p:spPr>
+        <p:txBody>
+          <a:bodyPr wrap="square">
+            <a:spAutoFit/>
+          </a:bodyPr>
+          <a:lstStyle/>
+          <a:p>
+            <a:pPr>
+              <a:spcAft>
+                <a:spcPts val="1000"/>
+              </a:spcAft>
+              <a:defRPr sz="1500" b="1">
+                <a:solidFill>
+                  <a:srgbClr val="1B365D"/>
+                </a:solidFill>
+                <a:latin typeface="Times New Roman"/>
               </a:defRPr>
             </a:pPr>
             <a:r>
-              <a:t>• Technologies to be used</a:t>
+              <a:t>• Technologies to be used (e.g. programming languages, frameworks, hardware)</a:t>
             </a:r>
           </a:p>
           <a:p>
@@ -4626,7 +4443,7 @@
               </a:spcAft>
             </a:pPr>
             <a:r>
-              <a:rPr b="1" sz="1150">
+              <a:rPr b="1" sz="1200">
                 <a:solidFill>
                   <a:srgbClr val="1B365D"/>
                 </a:solidFill>
@@ -4635,9 +4452,9 @@
               <a:t>Frontend: </a:t>
             </a:r>
             <a:r>
-              <a:rPr sz="1100">
-                <a:solidFill>
-                  <a:srgbClr val="191E24"/>
+              <a:rPr sz="1150">
+                <a:solidFill>
+                  <a:srgbClr val="14181E"/>
                 </a:solidFill>
                 <a:latin typeface="Arial"/>
               </a:rPr>
@@ -4651,18 +4468,18 @@
               </a:spcAft>
             </a:pPr>
             <a:r>
-              <a:rPr b="1" sz="1150">
-                <a:solidFill>
-                  <a:srgbClr val="1B365D"/>
-                </a:solidFill>
-                <a:latin typeface="Arial"/>
-              </a:rPr>
-              <a:t>Backend &amp; Ingestion: </a:t>
-            </a:r>
-            <a:r>
-              <a:rPr sz="1100">
-                <a:solidFill>
-                  <a:srgbClr val="191E24"/>
+              <a:rPr b="1" sz="1200">
+                <a:solidFill>
+                  <a:srgbClr val="1B365D"/>
+                </a:solidFill>
+                <a:latin typeface="Arial"/>
+              </a:rPr>
+              <a:t>Backend Engine: </a:t>
+            </a:r>
+            <a:r>
+              <a:rPr sz="1150">
+                <a:solidFill>
+                  <a:srgbClr val="14181E"/>
                 </a:solidFill>
                 <a:latin typeface="Arial"/>
               </a:rPr>
@@ -4676,22 +4493,22 @@
               </a:spcAft>
             </a:pPr>
             <a:r>
-              <a:rPr b="1" sz="1150">
-                <a:solidFill>
-                  <a:srgbClr val="1B365D"/>
-                </a:solidFill>
-                <a:latin typeface="Arial"/>
-              </a:rPr>
-              <a:t>Foundation AI Models: </a:t>
-            </a:r>
-            <a:r>
-              <a:rPr sz="1100">
-                <a:solidFill>
-                  <a:srgbClr val="191E24"/>
-                </a:solidFill>
-                <a:latin typeface="Arial"/>
-              </a:rPr>
-              <a:t>Llama 3.3 (70B), Mistral Large, IndicBERT (regional translation).</a:t>
+              <a:rPr b="1" sz="1200">
+                <a:solidFill>
+                  <a:srgbClr val="1B365D"/>
+                </a:solidFill>
+                <a:latin typeface="Arial"/>
+              </a:rPr>
+              <a:t>AI / Foundation LLMs: </a:t>
+            </a:r>
+            <a:r>
+              <a:rPr sz="1150">
+                <a:solidFill>
+                  <a:srgbClr val="14181E"/>
+                </a:solidFill>
+                <a:latin typeface="Arial"/>
+              </a:rPr>
+              <a:t>Llama 3.3 (70B), Mistral Large, IndicBERT for regional translation.</a:t>
             </a:r>
           </a:p>
           <a:p>
@@ -4701,7 +4518,7 @@
               </a:spcAft>
             </a:pPr>
             <a:r>
-              <a:rPr b="1" sz="1150">
+              <a:rPr b="1" sz="1200">
                 <a:solidFill>
                   <a:srgbClr val="1B365D"/>
                 </a:solidFill>
@@ -4710,9 +4527,9 @@
               <a:t>Rendering Compilers: </a:t>
             </a:r>
             <a:r>
-              <a:rPr sz="1100">
-                <a:solidFill>
-                  <a:srgbClr val="191E24"/>
+              <a:rPr sz="1150">
+                <a:solidFill>
+                  <a:srgbClr val="14181E"/>
                 </a:solidFill>
                 <a:latin typeface="Arial"/>
               </a:rPr>
@@ -4726,7 +4543,7 @@
               </a:spcAft>
             </a:pPr>
             <a:r>
-              <a:rPr b="1" sz="1150">
+              <a:rPr b="1" sz="1200">
                 <a:solidFill>
                   <a:srgbClr val="1B365D"/>
                 </a:solidFill>
@@ -4735,9 +4552,9 @@
               <a:t>Voice AI Synthesis: </a:t>
             </a:r>
             <a:r>
-              <a:rPr sz="1100">
-                <a:solidFill>
-                  <a:srgbClr val="191E24"/>
+              <a:rPr sz="1150">
+                <a:solidFill>
+                  <a:srgbClr val="14181E"/>
                 </a:solidFill>
                 <a:latin typeface="Arial"/>
               </a:rPr>
@@ -4751,7 +4568,7 @@
               </a:spcAft>
             </a:pPr>
             <a:r>
-              <a:rPr b="1" sz="1150">
+              <a:rPr b="1" sz="1200">
                 <a:solidFill>
                   <a:srgbClr val="1B365D"/>
                 </a:solidFill>
@@ -4760,9 +4577,9 @@
               <a:t>Deployment &amp; Security: </a:t>
             </a:r>
             <a:r>
-              <a:rPr sz="1100">
-                <a:solidFill>
-                  <a:srgbClr val="191E24"/>
+              <a:rPr sz="1150">
+                <a:solidFill>
+                  <a:srgbClr val="14181E"/>
                 </a:solidFill>
                 <a:latin typeface="Arial"/>
               </a:rPr>
@@ -4773,179 +4590,160 @@
       </p:sp>
       <p:sp>
         <p:nvSpPr>
-          <p:cNvPr id="9" name="Rounded Rectangle 8"/>
-          <p:cNvSpPr/>
+          <p:cNvPr id="9" name="TextBox 8"/>
+          <p:cNvSpPr txBox="1"/>
           <p:nvPr/>
         </p:nvSpPr>
         <p:spPr>
           <a:xfrm>
-            <a:off x="5394960" y="1325880"/>
-            <a:ext cx="6035040" cy="4892040"/>
-          </a:xfrm>
-          <a:prstGeom prst="roundRect">
+            <a:off x="5303520" y="1280160"/>
+            <a:ext cx="6217920" cy="4937760"/>
+          </a:xfrm>
+          <a:prstGeom prst="rect">
             <a:avLst/>
           </a:prstGeom>
-          <a:solidFill>
-            <a:srgbClr val="FAFCFF"/>
-          </a:solidFill>
-          <a:ln>
-            <a:solidFill>
-              <a:srgbClr val="D7E1EE"/>
-            </a:solidFill>
-          </a:ln>
-        </p:spPr>
-        <p:style>
-          <a:lnRef idx="1">
-            <a:schemeClr val="accent1"/>
-          </a:lnRef>
-          <a:fillRef idx="3">
-            <a:schemeClr val="accent1"/>
-          </a:fillRef>
-          <a:effectRef idx="2">
-            <a:schemeClr val="accent1"/>
-          </a:effectRef>
-          <a:fontRef idx="minor">
-            <a:schemeClr val="lt1"/>
-          </a:fontRef>
-        </p:style>
-        <p:txBody>
-          <a:bodyPr rtlCol="0" anchor="ctr" wrap="square" lIns="256032" tIns="228600" rIns="256032"/>
-          <a:lstStyle/>
-          <a:p>
-            <a:pPr algn="ctr">
-              <a:spcAft>
-                <a:spcPts val="1200"/>
-              </a:spcAft>
-              <a:defRPr sz="1500" b="1" u="sng">
-                <a:solidFill>
-                  <a:srgbClr val="1B365D"/>
-                </a:solidFill>
-                <a:latin typeface="Arial"/>
+          <a:noFill/>
+        </p:spPr>
+        <p:txBody>
+          <a:bodyPr wrap="square">
+            <a:spAutoFit/>
+          </a:bodyPr>
+          <a:lstStyle/>
+          <a:p>
+            <a:pPr>
+              <a:spcAft>
+                <a:spcPts val="1000"/>
+              </a:spcAft>
+              <a:defRPr sz="1500" b="1">
+                <a:solidFill>
+                  <a:srgbClr val="1B365D"/>
+                </a:solidFill>
+                <a:latin typeface="Times New Roman"/>
               </a:defRPr>
             </a:pPr>
             <a:r>
-              <a:t>• Methodology and process for implementation</a:t>
-            </a:r>
-          </a:p>
-          <a:p>
-            <a:pPr>
-              <a:spcAft>
-                <a:spcPts val="700"/>
-              </a:spcAft>
-            </a:pPr>
-            <a:r>
-              <a:rPr b="1" sz="1150">
-                <a:solidFill>
-                  <a:srgbClr val="1B365D"/>
-                </a:solidFill>
-                <a:latin typeface="Arial"/>
-              </a:rPr>
-              <a:t>• Step 1: Document Ingestion: </a:t>
-            </a:r>
-            <a:r>
-              <a:rPr sz="1100">
-                <a:solidFill>
-                  <a:srgbClr val="191E24"/>
-                </a:solidFill>
-                <a:latin typeface="Arial"/>
-              </a:rPr>
-              <a:t>PyMuPDF parses raw PDF/DOCX, extracting structural hierarchy, text coordinates, diagrams, and tables with bounding box tags.</a:t>
-            </a:r>
-          </a:p>
-          <a:p>
-            <a:pPr>
-              <a:spcAft>
-                <a:spcPts val="700"/>
-              </a:spcAft>
-            </a:pPr>
-            <a:r>
-              <a:rPr b="1" sz="1150">
-                <a:solidFill>
-                  <a:srgbClr val="1B365D"/>
-                </a:solidFill>
-                <a:latin typeface="Arial"/>
-              </a:rPr>
-              <a:t>• Step 2: Structured Chunking &amp; RAG: </a:t>
-            </a:r>
-            <a:r>
-              <a:rPr sz="1100">
-                <a:solidFill>
-                  <a:srgbClr val="191E24"/>
-                </a:solidFill>
-                <a:latin typeface="Arial"/>
-              </a:rPr>
-              <a:t>Hierarchical chunking creates contextual embeddings stored in an in-memory vector store (FAISS/Qdrant) for strict citation binding.</a:t>
-            </a:r>
-          </a:p>
-          <a:p>
-            <a:pPr>
-              <a:spcAft>
-                <a:spcPts val="700"/>
-              </a:spcAft>
-            </a:pPr>
-            <a:r>
-              <a:rPr b="1" sz="1150">
-                <a:solidFill>
-                  <a:srgbClr val="1B365D"/>
-                </a:solidFill>
-                <a:latin typeface="Arial"/>
-              </a:rPr>
-              <a:t>• Step 3: Multi-Persona Orchestration: </a:t>
-            </a:r>
-            <a:r>
-              <a:rPr sz="1100">
-                <a:solidFill>
-                  <a:srgbClr val="191E24"/>
-                </a:solidFill>
-                <a:latin typeface="Arial"/>
-              </a:rPr>
-              <a:t>Constrained JSON Schema prompts instruct the LLM to extract key insights, slide structures, infographic metrics, and press statements.</a:t>
-            </a:r>
-          </a:p>
-          <a:p>
-            <a:pPr>
-              <a:spcAft>
-                <a:spcPts val="700"/>
-              </a:spcAft>
-            </a:pPr>
-            <a:r>
-              <a:rPr b="1" sz="1150">
-                <a:solidFill>
-                  <a:srgbClr val="1B365D"/>
-                </a:solidFill>
-                <a:latin typeface="Arial"/>
-              </a:rPr>
-              <a:t>• Step 4: Parallel Synthesis Engines: </a:t>
-            </a:r>
-            <a:r>
-              <a:rPr sz="1100">
-                <a:solidFill>
-                  <a:srgbClr val="191E24"/>
-                </a:solidFill>
-                <a:latin typeface="Arial"/>
-              </a:rPr>
-              <a:t>Simultaneously compiles HTML5 presentation slides, auto-renders high-res visual cards (Canvas API), and generates 60s neural audio stream.</a:t>
-            </a:r>
-          </a:p>
-          <a:p>
-            <a:pPr>
-              <a:spcAft>
-                <a:spcPts val="700"/>
-              </a:spcAft>
-            </a:pPr>
-            <a:r>
-              <a:rPr b="1" sz="1150">
-                <a:solidFill>
-                  <a:srgbClr val="1B365D"/>
-                </a:solidFill>
-                <a:latin typeface="Arial"/>
-              </a:rPr>
-              <a:t>• Step 5: Interactive Verification UI: </a:t>
-            </a:r>
-            <a:r>
-              <a:rPr sz="1100">
-                <a:solidFill>
-                  <a:srgbClr val="191E24"/>
+              <a:t>• Methodology and process for implementation (Flow Charts/Images/ working prototype)</a:t>
+            </a:r>
+          </a:p>
+          <a:p>
+            <a:pPr>
+              <a:spcAft>
+                <a:spcPts val="600"/>
+              </a:spcAft>
+            </a:pPr>
+            <a:r>
+              <a:rPr b="1" sz="1200">
+                <a:solidFill>
+                  <a:srgbClr val="1B365D"/>
+                </a:solidFill>
+                <a:latin typeface="Arial"/>
+              </a:rPr>
+              <a:t>Step 1. Document Ingestion: </a:t>
+            </a:r>
+            <a:r>
+              <a:rPr sz="1150">
+                <a:solidFill>
+                  <a:srgbClr val="14181E"/>
+                </a:solidFill>
+                <a:latin typeface="Arial"/>
+              </a:rPr>
+              <a:t>PyMuPDF parses raw PDF/DOCX, tagging text blocks, tables, and diagrams with exact coordinate bounding boxes.</a:t>
+            </a:r>
+          </a:p>
+          <a:p>
+            <a:pPr>
+              <a:spcAft>
+                <a:spcPts val="600"/>
+              </a:spcAft>
+            </a:pPr>
+            <a:r>
+              <a:rPr b="1" sz="1200">
+                <a:solidFill>
+                  <a:srgbClr val="1B365D"/>
+                </a:solidFill>
+                <a:latin typeface="Arial"/>
+              </a:rPr>
+              <a:t>Step 2. Structured Chunking &amp; RAG: </a:t>
+            </a:r>
+            <a:r>
+              <a:rPr sz="1150">
+                <a:solidFill>
+                  <a:srgbClr val="14181E"/>
+                </a:solidFill>
+                <a:latin typeface="Arial"/>
+              </a:rPr>
+              <a:t>Contextual embeddings are indexed into an in-memory vector store (FAISS/Qdrant) enforcing strict citation boundaries.</a:t>
+            </a:r>
+          </a:p>
+          <a:p>
+            <a:pPr>
+              <a:spcAft>
+                <a:spcPts val="600"/>
+              </a:spcAft>
+            </a:pPr>
+            <a:r>
+              <a:rPr b="1" sz="1200">
+                <a:solidFill>
+                  <a:srgbClr val="1B365D"/>
+                </a:solidFill>
+                <a:latin typeface="Arial"/>
+              </a:rPr>
+              <a:t>Step 3. Multi-Persona Orchestration: </a:t>
+            </a:r>
+            <a:r>
+              <a:rPr sz="1150">
+                <a:solidFill>
+                  <a:srgbClr val="14181E"/>
+                </a:solidFill>
+                <a:latin typeface="Arial"/>
+              </a:rPr>
+              <a:t>Constrained JSON Schema prompts instruct the LLM to extract key insights, slide structures, and press summaries.</a:t>
+            </a:r>
+          </a:p>
+          <a:p>
+            <a:pPr>
+              <a:spcAft>
+                <a:spcPts val="600"/>
+              </a:spcAft>
+            </a:pPr>
+            <a:r>
+              <a:rPr b="1" sz="1200">
+                <a:solidFill>
+                  <a:srgbClr val="1B365D"/>
+                </a:solidFill>
+                <a:latin typeface="Arial"/>
+              </a:rPr>
+              <a:t>Step 4. Parallel Synthesis Engines: </a:t>
+            </a:r>
+            <a:r>
+              <a:rPr sz="1150">
+                <a:solidFill>
+                  <a:srgbClr val="14181E"/>
+                </a:solidFill>
+                <a:latin typeface="Arial"/>
+              </a:rPr>
+              <a:t>Simultaneously compiles HTML5 presentation slides, auto-renders visual cards (Canvas API), and synthesizes neural audio.</a:t>
+            </a:r>
+          </a:p>
+          <a:p>
+            <a:pPr>
+              <a:spcAft>
+                <a:spcPts val="600"/>
+              </a:spcAft>
+            </a:pPr>
+            <a:r>
+              <a:rPr b="1" sz="1200">
+                <a:solidFill>
+                  <a:srgbClr val="1B365D"/>
+                </a:solidFill>
+                <a:latin typeface="Arial"/>
+              </a:rPr>
+              <a:t>Step 5. Interactive Verification UI: </a:t>
+            </a:r>
+            <a:r>
+              <a:rPr sz="1150">
+                <a:solidFill>
+                  <a:srgbClr val="14181E"/>
                 </a:solidFill>
                 <a:latin typeface="Arial"/>
               </a:rPr>
@@ -4980,8 +4778,8 @@
         </p:nvSpPr>
         <p:spPr>
           <a:xfrm>
-            <a:off x="502920" y="228600"/>
-            <a:ext cx="1691640" cy="960120"/>
+            <a:off x="502920" y="274320"/>
+            <a:ext cx="1645920" cy="914400"/>
           </a:xfrm>
           <a:prstGeom prst="ellipse">
             <a:avLst/>
@@ -5014,28 +4812,28 @@
           <a:lstStyle/>
           <a:p>
             <a:pPr algn="ctr">
-              <a:defRPr sz="1000">
-                <a:solidFill>
-                  <a:srgbClr val="191E24"/>
+              <a:defRPr sz="1100">
+                <a:solidFill>
+                  <a:srgbClr val="14181E"/>
                 </a:solidFill>
                 <a:latin typeface="Arial"/>
               </a:defRPr>
             </a:pPr>
             <a:r>
-              <a:t>Team Name</a:t>
+              <a:t>Your Team</a:t>
             </a:r>
           </a:p>
           <a:p>
             <a:pPr algn="ctr">
-              <a:defRPr sz="1150" b="1">
-                <a:solidFill>
-                  <a:srgbClr val="1B365D"/>
+              <a:defRPr sz="1100">
+                <a:solidFill>
+                  <a:srgbClr val="14181E"/>
                 </a:solidFill>
                 <a:latin typeface="Arial"/>
               </a:defRPr>
             </a:pPr>
             <a:r>
-              <a:t>OmniTransform</a:t>
+              <a:t>Name</a:t>
             </a:r>
           </a:p>
         </p:txBody>
@@ -5048,8 +4846,8 @@
         </p:nvSpPr>
         <p:spPr>
           <a:xfrm>
-            <a:off x="2377440" y="320040"/>
-            <a:ext cx="5303520" cy="777240"/>
+            <a:off x="2286000" y="320040"/>
+            <a:ext cx="6217920" cy="777240"/>
           </a:xfrm>
           <a:prstGeom prst="rect">
             <a:avLst/>
@@ -5063,11 +4861,11 @@
           <a:lstStyle/>
           <a:p>
             <a:pPr algn="ctr">
-              <a:defRPr sz="2400" b="1">
-                <a:solidFill>
-                  <a:srgbClr val="1B365D"/>
-                </a:solidFill>
-                <a:latin typeface="Arial"/>
+              <a:defRPr sz="2600" b="1">
+                <a:solidFill>
+                  <a:srgbClr val="1B365D"/>
+                </a:solidFill>
+                <a:latin typeface="Times New Roman"/>
               </a:defRPr>
             </a:pPr>
             <a:r>
@@ -5078,7 +4876,7 @@
       </p:sp>
       <p:pic>
         <p:nvPicPr>
-          <p:cNvPr id="4" name="Picture 3" descr="sih_header_banner.jpg"/>
+          <p:cNvPr id="4" name="Picture 3" descr="sih_official_logo.png"/>
           <p:cNvPicPr>
             <a:picLocks noChangeAspect="1"/>
           </p:cNvPicPr>
@@ -5092,8 +4890,8 @@
         </p:blipFill>
         <p:spPr>
           <a:xfrm>
-            <a:off x="7818120" y="228600"/>
-            <a:ext cx="3886200" cy="513184"/>
+            <a:off x="8961120" y="228600"/>
+            <a:ext cx="2743200" cy="1412611"/>
           </a:xfrm>
           <a:prstGeom prst="rect">
             <a:avLst/>
@@ -5217,54 +5015,35 @@
       </p:sp>
       <p:sp>
         <p:nvSpPr>
-          <p:cNvPr id="8" name="Rounded Rectangle 7"/>
-          <p:cNvSpPr/>
+          <p:cNvPr id="8" name="TextBox 7"/>
+          <p:cNvSpPr txBox="1"/>
           <p:nvPr/>
         </p:nvSpPr>
         <p:spPr>
           <a:xfrm>
-            <a:off x="731520" y="1280160"/>
+            <a:off x="731520" y="1234440"/>
             <a:ext cx="10698480" cy="2011680"/>
           </a:xfrm>
-          <a:prstGeom prst="roundRect">
+          <a:prstGeom prst="rect">
             <a:avLst/>
           </a:prstGeom>
-          <a:solidFill>
-            <a:srgbClr val="FAFCFF"/>
-          </a:solidFill>
-          <a:ln>
-            <a:solidFill>
-              <a:srgbClr val="D7E1EE"/>
-            </a:solidFill>
-          </a:ln>
-        </p:spPr>
-        <p:style>
-          <a:lnRef idx="1">
-            <a:schemeClr val="accent1"/>
-          </a:lnRef>
-          <a:fillRef idx="3">
-            <a:schemeClr val="accent1"/>
-          </a:fillRef>
-          <a:effectRef idx="2">
-            <a:schemeClr val="accent1"/>
-          </a:effectRef>
-          <a:fontRef idx="minor">
-            <a:schemeClr val="lt1"/>
-          </a:fontRef>
-        </p:style>
-        <p:txBody>
-          <a:bodyPr rtlCol="0" anchor="ctr" wrap="square" lIns="256032" tIns="182880" rIns="256032"/>
-          <a:lstStyle/>
-          <a:p>
-            <a:pPr algn="ctr">
-              <a:spcAft>
-                <a:spcPts val="800"/>
-              </a:spcAft>
-              <a:defRPr sz="1500" b="1" u="sng">
-                <a:solidFill>
-                  <a:srgbClr val="1B365D"/>
-                </a:solidFill>
-                <a:latin typeface="Arial"/>
+          <a:noFill/>
+        </p:spPr>
+        <p:txBody>
+          <a:bodyPr wrap="square">
+            <a:spAutoFit/>
+          </a:bodyPr>
+          <a:lstStyle/>
+          <a:p>
+            <a:pPr>
+              <a:spcAft>
+                <a:spcPts val="600"/>
+              </a:spcAft>
+              <a:defRPr sz="1600" b="1">
+                <a:solidFill>
+                  <a:srgbClr val="1B365D"/>
+                </a:solidFill>
+                <a:latin typeface="Times New Roman"/>
               </a:defRPr>
             </a:pPr>
             <a:r>
@@ -5274,134 +5053,149 @@
           <a:p>
             <a:pPr>
               <a:spcAft>
-                <a:spcPts val="500"/>
-              </a:spcAft>
-            </a:pPr>
-            <a:r>
-              <a:rPr b="1" sz="1150">
-                <a:solidFill>
-                  <a:srgbClr val="1B365D"/>
-                </a:solidFill>
-                <a:latin typeface="Arial"/>
-              </a:rPr>
-              <a:t>• Hardware &amp; Compute Feasibility: </a:t>
-            </a:r>
-            <a:r>
-              <a:rPr sz="1150">
-                <a:solidFill>
-                  <a:srgbClr val="191E24"/>
-                </a:solidFill>
-                <a:latin typeface="Arial"/>
-              </a:rPr>
-              <a:t> Runs efficiently on commodity GPU workstations (e.g. Single RTX 4090 or Apple Silicon) using 4-bit quantized open-weight models.</a:t>
-            </a:r>
-          </a:p>
-          <a:p>
-            <a:pPr>
-              <a:spcAft>
-                <a:spcPts val="500"/>
-              </a:spcAft>
-            </a:pPr>
-            <a:r>
-              <a:rPr b="1" sz="1150">
-                <a:solidFill>
-                  <a:srgbClr val="1B365D"/>
-                </a:solidFill>
-                <a:latin typeface="Arial"/>
-              </a:rPr>
-              <a:t>• Speed &amp; Runtime Feasibility: </a:t>
-            </a:r>
-            <a:r>
-              <a:rPr sz="1150">
-                <a:solidFill>
-                  <a:srgbClr val="191E24"/>
-                </a:solidFill>
-                <a:latin typeface="Arial"/>
-              </a:rPr>
-              <a:t> Asynchronous map-reduce pipeline completes multi-format transformation of a 30-page PDF in &lt; 10 seconds.</a:t>
-            </a:r>
-          </a:p>
-          <a:p>
-            <a:pPr>
-              <a:spcAft>
-                <a:spcPts val="500"/>
-              </a:spcAft>
-            </a:pPr>
-            <a:r>
-              <a:rPr b="1" sz="1150">
-                <a:solidFill>
-                  <a:srgbClr val="1B365D"/>
-                </a:solidFill>
-                <a:latin typeface="Arial"/>
-              </a:rPr>
-              <a:t>• Operational Deployment Feasibility: </a:t>
-            </a:r>
-            <a:r>
-              <a:rPr sz="1150">
-                <a:solidFill>
-                  <a:srgbClr val="191E24"/>
-                </a:solidFill>
-                <a:latin typeface="Arial"/>
-              </a:rPr>
-              <a:t> 100% Dockerized container stack; operates fully air-gapped without external internet dependencies.</a:t>
-            </a:r>
-          </a:p>
-        </p:txBody>
-      </p:sp>
-      <p:sp>
-        <p:nvSpPr>
-          <p:cNvPr id="9" name="Rounded Rectangle 8"/>
-          <p:cNvSpPr/>
+                <a:spcPts val="400"/>
+              </a:spcAft>
+            </a:pPr>
+            <a:r>
+              <a:rPr b="1" sz="1200">
+                <a:solidFill>
+                  <a:srgbClr val="1B365D"/>
+                </a:solidFill>
+                <a:latin typeface="Arial"/>
+              </a:rPr>
+              <a:t>- Hardware &amp; Compute Feasibility: </a:t>
+            </a:r>
+            <a:r>
+              <a:rPr sz="1200">
+                <a:solidFill>
+                  <a:srgbClr val="14181E"/>
+                </a:solidFill>
+                <a:latin typeface="Arial"/>
+              </a:rPr>
+              <a:t>Runs efficiently on commodity GPU workstations (e.g. Single RTX 4090 or Apple Silicon) using 4-bit quantized open-weight models.</a:t>
+            </a:r>
+          </a:p>
+          <a:p>
+            <a:pPr>
+              <a:spcAft>
+                <a:spcPts val="400"/>
+              </a:spcAft>
+            </a:pPr>
+            <a:r>
+              <a:rPr b="1" sz="1200">
+                <a:solidFill>
+                  <a:srgbClr val="1B365D"/>
+                </a:solidFill>
+                <a:latin typeface="Arial"/>
+              </a:rPr>
+              <a:t>- Speed &amp; Runtime Feasibility: </a:t>
+            </a:r>
+            <a:r>
+              <a:rPr sz="1200">
+                <a:solidFill>
+                  <a:srgbClr val="14181E"/>
+                </a:solidFill>
+                <a:latin typeface="Arial"/>
+              </a:rPr>
+              <a:t>Asynchronous map-reduce pipeline completes multi-format transformation of a 30-page PDF in &lt; 10 seconds.</a:t>
+            </a:r>
+          </a:p>
+          <a:p>
+            <a:pPr>
+              <a:spcAft>
+                <a:spcPts val="400"/>
+              </a:spcAft>
+            </a:pPr>
+            <a:r>
+              <a:rPr b="1" sz="1200">
+                <a:solidFill>
+                  <a:srgbClr val="1B365D"/>
+                </a:solidFill>
+                <a:latin typeface="Arial"/>
+              </a:rPr>
+              <a:t>- Operational Deployment Feasibility: </a:t>
+            </a:r>
+            <a:r>
+              <a:rPr sz="1200">
+                <a:solidFill>
+                  <a:srgbClr val="14181E"/>
+                </a:solidFill>
+                <a:latin typeface="Arial"/>
+              </a:rPr>
+              <a:t>100% Dockerized container stack; operates fully air-gapped without external internet dependencies.</a:t>
+            </a:r>
+          </a:p>
+        </p:txBody>
+      </p:sp>
+      <p:sp>
+        <p:nvSpPr>
+          <p:cNvPr id="9" name="TextBox 8"/>
+          <p:cNvSpPr txBox="1"/>
           <p:nvPr/>
         </p:nvSpPr>
         <p:spPr>
           <a:xfrm>
-            <a:off x="731520" y="3520440"/>
-            <a:ext cx="3337560" cy="2697480"/>
-          </a:xfrm>
-          <a:prstGeom prst="roundRect">
+            <a:off x="731520" y="3383280"/>
+            <a:ext cx="10698480" cy="2926080"/>
+          </a:xfrm>
+          <a:prstGeom prst="rect">
             <a:avLst/>
           </a:prstGeom>
-          <a:solidFill>
-            <a:srgbClr val="FAFCFF"/>
-          </a:solidFill>
-          <a:ln>
-            <a:solidFill>
-              <a:srgbClr val="D7E1EE"/>
-            </a:solidFill>
-          </a:ln>
-        </p:spPr>
-        <p:style>
-          <a:lnRef idx="1">
-            <a:schemeClr val="accent1"/>
-          </a:lnRef>
-          <a:fillRef idx="3">
-            <a:schemeClr val="accent1"/>
-          </a:fillRef>
-          <a:effectRef idx="2">
-            <a:schemeClr val="accent1"/>
-          </a:effectRef>
-          <a:fontRef idx="minor">
-            <a:schemeClr val="lt1"/>
-          </a:fontRef>
-        </p:style>
-        <p:txBody>
-          <a:bodyPr rtlCol="0" anchor="ctr" wrap="square" lIns="182880" tIns="164592" rIns="182880"/>
-          <a:lstStyle/>
-          <a:p>
-            <a:pPr algn="ctr">
+          <a:noFill/>
+        </p:spPr>
+        <p:txBody>
+          <a:bodyPr wrap="square">
+            <a:spAutoFit/>
+          </a:bodyPr>
+          <a:lstStyle/>
+          <a:p>
+            <a:pPr>
+              <a:spcAft>
+                <a:spcPts val="800"/>
+              </a:spcAft>
+              <a:defRPr sz="1600" b="1">
+                <a:solidFill>
+                  <a:srgbClr val="1B365D"/>
+                </a:solidFill>
+                <a:latin typeface="Times New Roman"/>
+              </a:defRPr>
+            </a:pPr>
+            <a:r>
+              <a:t>• Potential challenges and risks &amp; Strategies for overcoming these challenges</a:t>
+            </a:r>
+          </a:p>
+          <a:p>
+            <a:pPr>
               <a:spcAft>
                 <a:spcPts val="600"/>
               </a:spcAft>
-              <a:defRPr sz="1300" b="1">
+            </a:pPr>
+            <a:r>
+              <a:rPr b="1" sz="1200">
                 <a:solidFill>
                   <a:srgbClr val="F37021"/>
                 </a:solidFill>
                 <a:latin typeface="Arial"/>
-              </a:defRPr>
-            </a:pPr>
-            <a:r>
-              <a:t>Risk 1: AI Hallucinations</a:t>
+              </a:rPr>
+              <a:t>1. Risk: AI Hallucinations in Intelligence Briefs | </a:t>
+            </a:r>
+            <a:r>
+              <a:rPr sz="1150">
+                <a:solidFill>
+                  <a:srgbClr val="14181E"/>
+                </a:solidFill>
+                <a:latin typeface="Arial"/>
+              </a:rPr>
+              <a:t>Challenge: Generative models inventing ungrounded facts. </a:t>
+            </a:r>
+            <a:r>
+              <a:rPr b="1" sz="1150">
+                <a:solidFill>
+                  <a:srgbClr val="1B365D"/>
+                </a:solidFill>
+                <a:latin typeface="Arial"/>
+              </a:rPr>
+              <a:t>--&gt; Strategy: Strict RAG constraint boundaries + reverse citation bounding-box coordinate verification for 100% grounded truth.</a:t>
             </a:r>
           </a:p>
           <a:p>
@@ -5409,202 +5203,67 @@
               <a:spcAft>
                 <a:spcPts val="600"/>
               </a:spcAft>
-              <a:defRPr sz="1100">
-                <a:solidFill>
-                  <a:srgbClr val="191E24"/>
-                </a:solidFill>
-                <a:latin typeface="Arial"/>
-              </a:defRPr>
-            </a:pPr>
-            <a:r>
-              <a:t>• Potential Challenge: Generative models inventing ungrounded facts in security briefs.</a:t>
-            </a:r>
-          </a:p>
-          <a:p>
-            <a:pPr>
-              <a:defRPr sz="1100" b="1">
-                <a:solidFill>
-                  <a:srgbClr val="1B365D"/>
-                </a:solidFill>
-                <a:latin typeface="Arial"/>
-              </a:defRPr>
-            </a:pPr>
-            <a:r>
-              <a:t>• Strategy: Strict RAG constraint boundaries + reverse citation bounding-box coordinate verification for 100% grounded truth.</a:t>
-            </a:r>
-          </a:p>
-        </p:txBody>
-      </p:sp>
-      <p:sp>
-        <p:nvSpPr>
-          <p:cNvPr id="10" name="Rounded Rectangle 9"/>
-          <p:cNvSpPr/>
-          <p:nvPr/>
-        </p:nvSpPr>
-        <p:spPr>
-          <a:xfrm>
-            <a:off x="4416552" y="3520440"/>
-            <a:ext cx="3337560" cy="2697480"/>
-          </a:xfrm>
-          <a:prstGeom prst="roundRect">
-            <a:avLst/>
-          </a:prstGeom>
-          <a:solidFill>
-            <a:srgbClr val="FAFCFF"/>
-          </a:solidFill>
-          <a:ln>
-            <a:solidFill>
-              <a:srgbClr val="D7E1EE"/>
-            </a:solidFill>
-          </a:ln>
-        </p:spPr>
-        <p:style>
-          <a:lnRef idx="1">
-            <a:schemeClr val="accent1"/>
-          </a:lnRef>
-          <a:fillRef idx="3">
-            <a:schemeClr val="accent1"/>
-          </a:fillRef>
-          <a:effectRef idx="2">
-            <a:schemeClr val="accent1"/>
-          </a:effectRef>
-          <a:fontRef idx="minor">
-            <a:schemeClr val="lt1"/>
-          </a:fontRef>
-        </p:style>
-        <p:txBody>
-          <a:bodyPr rtlCol="0" anchor="ctr" wrap="square" lIns="182880" tIns="164592" rIns="182880"/>
-          <a:lstStyle/>
-          <a:p>
-            <a:pPr algn="ctr">
+            </a:pPr>
+            <a:r>
+              <a:rPr b="1" sz="1200">
+                <a:solidFill>
+                  <a:srgbClr val="F37021"/>
+                </a:solidFill>
+                <a:latin typeface="Arial"/>
+              </a:rPr>
+              <a:t>2. Risk: Classified Data Confidentiality | </a:t>
+            </a:r>
+            <a:r>
+              <a:rPr sz="1150">
+                <a:solidFill>
+                  <a:srgbClr val="14181E"/>
+                </a:solidFill>
+                <a:latin typeface="Arial"/>
+              </a:rPr>
+              <a:t>Challenge: Sensitive intelligence leaked to public cloud APIs. </a:t>
+            </a:r>
+            <a:r>
+              <a:rPr b="1" sz="1150">
+                <a:solidFill>
+                  <a:srgbClr val="1B365D"/>
+                </a:solidFill>
+                <a:latin typeface="Arial"/>
+              </a:rPr>
+              <a:t>--&gt; Strategy: Sovereign on-premise air-gapped deployment with local open-weights (Llama 3/Mistral); zero telemetry.</a:t>
+            </a:r>
+          </a:p>
+          <a:p>
+            <a:pPr>
               <a:spcAft>
                 <a:spcPts val="600"/>
               </a:spcAft>
-              <a:defRPr sz="1300" b="1">
+            </a:pPr>
+            <a:r>
+              <a:rPr b="1" sz="1200">
                 <a:solidFill>
                   <a:srgbClr val="F37021"/>
                 </a:solidFill>
                 <a:latin typeface="Arial"/>
-              </a:defRPr>
-            </a:pPr>
-            <a:r>
-              <a:t>Risk 2: Data Confidentiality</a:t>
-            </a:r>
-          </a:p>
-          <a:p>
-            <a:pPr>
-              <a:spcAft>
-                <a:spcPts val="600"/>
-              </a:spcAft>
-              <a:defRPr sz="1100">
-                <a:solidFill>
-                  <a:srgbClr val="191E24"/>
-                </a:solidFill>
-                <a:latin typeface="Arial"/>
-              </a:defRPr>
-            </a:pPr>
-            <a:r>
-              <a:t>• Potential Challenge: Sensitive classified intelligence leaked to public cloud APIs.</a:t>
-            </a:r>
-          </a:p>
-          <a:p>
-            <a:pPr>
-              <a:defRPr sz="1100" b="1">
-                <a:solidFill>
-                  <a:srgbClr val="1B365D"/>
-                </a:solidFill>
-                <a:latin typeface="Arial"/>
-              </a:defRPr>
-            </a:pPr>
-            <a:r>
-              <a:t>• Strategy: Sovereign on-premise air-gapped deployment with local open-weights (Llama 3/Mistral); zero telemetry.</a:t>
-            </a:r>
-          </a:p>
-        </p:txBody>
-      </p:sp>
-      <p:sp>
-        <p:nvSpPr>
-          <p:cNvPr id="11" name="Rounded Rectangle 10"/>
-          <p:cNvSpPr/>
-          <p:nvPr/>
-        </p:nvSpPr>
-        <p:spPr>
-          <a:xfrm>
-            <a:off x="8101584" y="3520440"/>
-            <a:ext cx="3337560" cy="2697480"/>
-          </a:xfrm>
-          <a:prstGeom prst="roundRect">
-            <a:avLst/>
-          </a:prstGeom>
-          <a:solidFill>
-            <a:srgbClr val="FAFCFF"/>
-          </a:solidFill>
-          <a:ln>
-            <a:solidFill>
-              <a:srgbClr val="D7E1EE"/>
-            </a:solidFill>
-          </a:ln>
-        </p:spPr>
-        <p:style>
-          <a:lnRef idx="1">
-            <a:schemeClr val="accent1"/>
-          </a:lnRef>
-          <a:fillRef idx="3">
-            <a:schemeClr val="accent1"/>
-          </a:fillRef>
-          <a:effectRef idx="2">
-            <a:schemeClr val="accent1"/>
-          </a:effectRef>
-          <a:fontRef idx="minor">
-            <a:schemeClr val="lt1"/>
-          </a:fontRef>
-        </p:style>
-        <p:txBody>
-          <a:bodyPr rtlCol="0" anchor="ctr" wrap="square" lIns="182880" tIns="164592" rIns="182880"/>
-          <a:lstStyle/>
-          <a:p>
-            <a:pPr algn="ctr">
-              <a:spcAft>
-                <a:spcPts val="600"/>
-              </a:spcAft>
-              <a:defRPr sz="1300" b="1">
-                <a:solidFill>
-                  <a:srgbClr val="F37021"/>
-                </a:solidFill>
-                <a:latin typeface="Arial"/>
-              </a:defRPr>
-            </a:pPr>
-            <a:r>
-              <a:t>Risk 3: Complex Tables &amp; Charts</a:t>
-            </a:r>
-          </a:p>
-          <a:p>
-            <a:pPr>
-              <a:spcAft>
-                <a:spcPts val="600"/>
-              </a:spcAft>
-              <a:defRPr sz="1100">
-                <a:solidFill>
-                  <a:srgbClr val="191E24"/>
-                </a:solidFill>
-                <a:latin typeface="Arial"/>
-              </a:defRPr>
-            </a:pPr>
-            <a:r>
-              <a:t>• Potential Challenge: Loss of tabular structure and diagram metrics during document parsing.</a:t>
-            </a:r>
-          </a:p>
-          <a:p>
-            <a:pPr>
-              <a:defRPr sz="1100" b="1">
-                <a:solidFill>
-                  <a:srgbClr val="1B365D"/>
-                </a:solidFill>
-                <a:latin typeface="Arial"/>
-              </a:defRPr>
-            </a:pPr>
-            <a:r>
-              <a:t>• Strategy: Multimodal vision-language parsing (VLM) + Markdown table structure extraction.</a:t>
+              </a:rPr>
+              <a:t>3. Risk: Complex Multi-Column Tables &amp; Diagram Loss | </a:t>
+            </a:r>
+            <a:r>
+              <a:rPr sz="1150">
+                <a:solidFill>
+                  <a:srgbClr val="14181E"/>
+                </a:solidFill>
+                <a:latin typeface="Arial"/>
+              </a:rPr>
+              <a:t>Challenge: Loss of tabular structure during document parsing. </a:t>
+            </a:r>
+            <a:r>
+              <a:rPr b="1" sz="1150">
+                <a:solidFill>
+                  <a:srgbClr val="1B365D"/>
+                </a:solidFill>
+                <a:latin typeface="Arial"/>
+              </a:rPr>
+              <a:t>--&gt; Strategy: Multimodal vision-language parsing (VLM) + Markdown table structure extraction.</a:t>
             </a:r>
           </a:p>
         </p:txBody>
@@ -5635,8 +5294,8 @@
         </p:nvSpPr>
         <p:spPr>
           <a:xfrm>
-            <a:off x="502920" y="228600"/>
-            <a:ext cx="1691640" cy="960120"/>
+            <a:off x="502920" y="274320"/>
+            <a:ext cx="1645920" cy="914400"/>
           </a:xfrm>
           <a:prstGeom prst="ellipse">
             <a:avLst/>
@@ -5669,28 +5328,28 @@
           <a:lstStyle/>
           <a:p>
             <a:pPr algn="ctr">
-              <a:defRPr sz="1000">
-                <a:solidFill>
-                  <a:srgbClr val="191E24"/>
+              <a:defRPr sz="1100">
+                <a:solidFill>
+                  <a:srgbClr val="14181E"/>
                 </a:solidFill>
                 <a:latin typeface="Arial"/>
               </a:defRPr>
             </a:pPr>
             <a:r>
-              <a:t>Team Name</a:t>
+              <a:t>Your Team</a:t>
             </a:r>
           </a:p>
           <a:p>
             <a:pPr algn="ctr">
-              <a:defRPr sz="1150" b="1">
-                <a:solidFill>
-                  <a:srgbClr val="1B365D"/>
+              <a:defRPr sz="1100">
+                <a:solidFill>
+                  <a:srgbClr val="14181E"/>
                 </a:solidFill>
                 <a:latin typeface="Arial"/>
               </a:defRPr>
             </a:pPr>
             <a:r>
-              <a:t>OmniTransform</a:t>
+              <a:t>Name</a:t>
             </a:r>
           </a:p>
         </p:txBody>
@@ -5703,8 +5362,8 @@
         </p:nvSpPr>
         <p:spPr>
           <a:xfrm>
-            <a:off x="2377440" y="320040"/>
-            <a:ext cx="5303520" cy="777240"/>
+            <a:off x="2286000" y="320040"/>
+            <a:ext cx="6217920" cy="777240"/>
           </a:xfrm>
           <a:prstGeom prst="rect">
             <a:avLst/>
@@ -5718,11 +5377,11 @@
           <a:lstStyle/>
           <a:p>
             <a:pPr algn="ctr">
-              <a:defRPr sz="2400" b="1">
-                <a:solidFill>
-                  <a:srgbClr val="1B365D"/>
-                </a:solidFill>
-                <a:latin typeface="Arial"/>
+              <a:defRPr sz="2600" b="1">
+                <a:solidFill>
+                  <a:srgbClr val="1B365D"/>
+                </a:solidFill>
+                <a:latin typeface="Times New Roman"/>
               </a:defRPr>
             </a:pPr>
             <a:r>
@@ -5733,7 +5392,7 @@
       </p:sp>
       <p:pic>
         <p:nvPicPr>
-          <p:cNvPr id="4" name="Picture 3" descr="sih_header_banner.jpg"/>
+          <p:cNvPr id="4" name="Picture 3" descr="sih_official_logo.png"/>
           <p:cNvPicPr>
             <a:picLocks noChangeAspect="1"/>
           </p:cNvPicPr>
@@ -5747,8 +5406,8 @@
         </p:blipFill>
         <p:spPr>
           <a:xfrm>
-            <a:off x="7818120" y="228600"/>
-            <a:ext cx="3886200" cy="513184"/>
+            <a:off x="8961120" y="228600"/>
+            <a:ext cx="2743200" cy="1412611"/>
           </a:xfrm>
           <a:prstGeom prst="rect">
             <a:avLst/>
@@ -5872,54 +5531,35 @@
       </p:sp>
       <p:sp>
         <p:nvSpPr>
-          <p:cNvPr id="8" name="Rounded Rectangle 7"/>
-          <p:cNvSpPr/>
+          <p:cNvPr id="8" name="TextBox 7"/>
+          <p:cNvSpPr txBox="1"/>
           <p:nvPr/>
         </p:nvSpPr>
         <p:spPr>
           <a:xfrm>
-            <a:off x="731520" y="1280160"/>
-            <a:ext cx="5166360" cy="4937760"/>
-          </a:xfrm>
-          <a:prstGeom prst="roundRect">
+            <a:off x="731520" y="1234440"/>
+            <a:ext cx="5212080" cy="4937760"/>
+          </a:xfrm>
+          <a:prstGeom prst="rect">
             <a:avLst/>
           </a:prstGeom>
-          <a:solidFill>
-            <a:srgbClr val="FAFCFF"/>
-          </a:solidFill>
-          <a:ln>
-            <a:solidFill>
-              <a:srgbClr val="D7E1EE"/>
-            </a:solidFill>
-          </a:ln>
-        </p:spPr>
-        <p:style>
-          <a:lnRef idx="1">
-            <a:schemeClr val="accent1"/>
-          </a:lnRef>
-          <a:fillRef idx="3">
-            <a:schemeClr val="accent1"/>
-          </a:fillRef>
-          <a:effectRef idx="2">
-            <a:schemeClr val="accent1"/>
-          </a:effectRef>
-          <a:fontRef idx="minor">
-            <a:schemeClr val="lt1"/>
-          </a:fontRef>
-        </p:style>
-        <p:txBody>
-          <a:bodyPr rtlCol="0" anchor="ctr" wrap="square" lIns="256032" tIns="228600" rIns="256032"/>
-          <a:lstStyle/>
-          <a:p>
-            <a:pPr algn="ctr">
-              <a:spcAft>
-                <a:spcPts val="1200"/>
-              </a:spcAft>
-              <a:defRPr sz="1500" b="1" u="sng">
-                <a:solidFill>
-                  <a:srgbClr val="1B365D"/>
-                </a:solidFill>
-                <a:latin typeface="Arial"/>
+          <a:noFill/>
+        </p:spPr>
+        <p:txBody>
+          <a:bodyPr wrap="square">
+            <a:spAutoFit/>
+          </a:bodyPr>
+          <a:lstStyle/>
+          <a:p>
+            <a:pPr>
+              <a:spcAft>
+                <a:spcPts val="1000"/>
+              </a:spcAft>
+              <a:defRPr sz="1600" b="1">
+                <a:solidFill>
+                  <a:srgbClr val="1B365D"/>
+                </a:solidFill>
+                <a:latin typeface="Times New Roman"/>
               </a:defRPr>
             </a:pPr>
             <a:r>
@@ -5929,23 +5569,23 @@
           <a:p>
             <a:pPr>
               <a:spcAft>
-                <a:spcPts val="800"/>
-              </a:spcAft>
-            </a:pPr>
-            <a:r>
-              <a:rPr b="1" sz="1150">
-                <a:solidFill>
-                  <a:srgbClr val="1B365D"/>
-                </a:solidFill>
-                <a:latin typeface="Arial"/>
-              </a:rPr>
-              <a:t>• Government &amp; Defense Analysts (NTRO/MoD):
+                <a:spcPts val="600"/>
+              </a:spcAft>
+            </a:pPr>
+            <a:r>
+              <a:rPr b="1" sz="1200">
+                <a:solidFill>
+                  <a:srgbClr val="1B365D"/>
+                </a:solidFill>
+                <a:latin typeface="Arial"/>
+              </a:rPr>
+              <a:t>- Government &amp; Defense Analysts (NTRO/MoD):
   </a:t>
             </a:r>
             <a:r>
-              <a:rPr sz="1100">
-                <a:solidFill>
-                  <a:srgbClr val="191E24"/>
+              <a:rPr sz="1150">
+                <a:solidFill>
+                  <a:srgbClr val="14181E"/>
                 </a:solidFill>
                 <a:latin typeface="Arial"/>
               </a:rPr>
@@ -5955,23 +5595,23 @@
           <a:p>
             <a:pPr>
               <a:spcAft>
-                <a:spcPts val="800"/>
-              </a:spcAft>
-            </a:pPr>
-            <a:r>
-              <a:rPr b="1" sz="1150">
-                <a:solidFill>
-                  <a:srgbClr val="1B365D"/>
-                </a:solidFill>
-                <a:latin typeface="Arial"/>
-              </a:rPr>
-              <a:t>• Senior Bureaucrats &amp; C-Suite Executives:
+                <a:spcPts val="600"/>
+              </a:spcAft>
+            </a:pPr>
+            <a:r>
+              <a:rPr b="1" sz="1200">
+                <a:solidFill>
+                  <a:srgbClr val="1B365D"/>
+                </a:solidFill>
+                <a:latin typeface="Arial"/>
+              </a:rPr>
+              <a:t>- Senior Bureaucrats &amp; C-Suite Executives:
   </a:t>
             </a:r>
             <a:r>
-              <a:rPr sz="1100">
-                <a:solidFill>
-                  <a:srgbClr val="191E24"/>
+              <a:rPr sz="1150">
+                <a:solidFill>
+                  <a:srgbClr val="14181E"/>
                 </a:solidFill>
                 <a:latin typeface="Arial"/>
               </a:rPr>
@@ -5981,23 +5621,23 @@
           <a:p>
             <a:pPr>
               <a:spcAft>
-                <a:spcPts val="800"/>
-              </a:spcAft>
-            </a:pPr>
-            <a:r>
-              <a:rPr b="1" sz="1150">
-                <a:solidFill>
-                  <a:srgbClr val="1B365D"/>
-                </a:solidFill>
-                <a:latin typeface="Arial"/>
-              </a:rPr>
-              <a:t>• Public Relations &amp; Media Officers:
+                <a:spcPts val="600"/>
+              </a:spcAft>
+            </a:pPr>
+            <a:r>
+              <a:rPr b="1" sz="1200">
+                <a:solidFill>
+                  <a:srgbClr val="1B365D"/>
+                </a:solidFill>
+                <a:latin typeface="Arial"/>
+              </a:rPr>
+              <a:t>- Public Relations &amp; Media Officers:
   </a:t>
             </a:r>
             <a:r>
-              <a:rPr sz="1100">
-                <a:solidFill>
-                  <a:srgbClr val="191E24"/>
+              <a:rPr sz="1150">
+                <a:solidFill>
+                  <a:srgbClr val="14181E"/>
                 </a:solidFill>
                 <a:latin typeface="Arial"/>
               </a:rPr>
@@ -6007,23 +5647,23 @@
           <a:p>
             <a:pPr>
               <a:spcAft>
-                <a:spcPts val="800"/>
-              </a:spcAft>
-            </a:pPr>
-            <a:r>
-              <a:rPr b="1" sz="1150">
-                <a:solidFill>
-                  <a:srgbClr val="1B365D"/>
-                </a:solidFill>
-                <a:latin typeface="Arial"/>
-              </a:rPr>
-              <a:t>• Field Personnel &amp; Traveling Officials:
+                <a:spcPts val="600"/>
+              </a:spcAft>
+            </a:pPr>
+            <a:r>
+              <a:rPr b="1" sz="1200">
+                <a:solidFill>
+                  <a:srgbClr val="1B365D"/>
+                </a:solidFill>
+                <a:latin typeface="Arial"/>
+              </a:rPr>
+              <a:t>- Field Personnel &amp; Traveling Officials:
   </a:t>
             </a:r>
             <a:r>
-              <a:rPr sz="1100">
-                <a:solidFill>
-                  <a:srgbClr val="191E24"/>
+              <a:rPr sz="1150">
+                <a:solidFill>
+                  <a:srgbClr val="14181E"/>
                 </a:solidFill>
                 <a:latin typeface="Arial"/>
               </a:rPr>
@@ -6034,79 +5674,61 @@
       </p:sp>
       <p:sp>
         <p:nvSpPr>
-          <p:cNvPr id="9" name="Rounded Rectangle 8"/>
-          <p:cNvSpPr/>
+          <p:cNvPr id="9" name="TextBox 8"/>
+          <p:cNvSpPr txBox="1"/>
           <p:nvPr/>
         </p:nvSpPr>
         <p:spPr>
           <a:xfrm>
-            <a:off x="6263640" y="1280160"/>
-            <a:ext cx="5166360" cy="4937760"/>
-          </a:xfrm>
-          <a:prstGeom prst="roundRect">
+            <a:off x="6217920" y="1234440"/>
+            <a:ext cx="5212080" cy="4937760"/>
+          </a:xfrm>
+          <a:prstGeom prst="rect">
             <a:avLst/>
           </a:prstGeom>
-          <a:solidFill>
-            <a:srgbClr val="FAFCFF"/>
-          </a:solidFill>
-          <a:ln>
-            <a:solidFill>
-              <a:srgbClr val="D7E1EE"/>
-            </a:solidFill>
-          </a:ln>
-        </p:spPr>
-        <p:style>
-          <a:lnRef idx="1">
-            <a:schemeClr val="accent1"/>
-          </a:lnRef>
-          <a:fillRef idx="3">
-            <a:schemeClr val="accent1"/>
-          </a:fillRef>
-          <a:effectRef idx="2">
-            <a:schemeClr val="accent1"/>
-          </a:effectRef>
-          <a:fontRef idx="minor">
-            <a:schemeClr val="lt1"/>
-          </a:fontRef>
-        </p:style>
-        <p:txBody>
-          <a:bodyPr rtlCol="0" anchor="ctr" wrap="square" lIns="256032" tIns="228600" rIns="256032"/>
-          <a:lstStyle/>
-          <a:p>
-            <a:pPr algn="ctr">
-              <a:spcAft>
-                <a:spcPts val="1200"/>
-              </a:spcAft>
-              <a:defRPr sz="1500" b="1" u="sng">
-                <a:solidFill>
-                  <a:srgbClr val="1B365D"/>
-                </a:solidFill>
-                <a:latin typeface="Arial"/>
+          <a:noFill/>
+        </p:spPr>
+        <p:txBody>
+          <a:bodyPr wrap="square">
+            <a:spAutoFit/>
+          </a:bodyPr>
+          <a:lstStyle/>
+          <a:p>
+            <a:pPr>
+              <a:spcAft>
+                <a:spcPts val="1000"/>
+              </a:spcAft>
+              <a:defRPr sz="1600" b="1">
+                <a:solidFill>
+                  <a:srgbClr val="1B365D"/>
+                </a:solidFill>
+                <a:latin typeface="Times New Roman"/>
               </a:defRPr>
             </a:pPr>
             <a:r>
-              <a:t>• Benefits of the solution (social, economic, etc.)</a:t>
-            </a:r>
-          </a:p>
-          <a:p>
-            <a:pPr>
-              <a:spcAft>
-                <a:spcPts val="800"/>
-              </a:spcAft>
-            </a:pPr>
-            <a:r>
-              <a:rPr b="1" sz="1150">
-                <a:solidFill>
-                  <a:srgbClr val="1B365D"/>
-                </a:solidFill>
-                <a:latin typeface="Arial"/>
-              </a:rPr>
-              <a:t>• Economic Benefits: </a:t>
-            </a:r>
-            <a:r>
-              <a:rPr sz="1100">
-                <a:solidFill>
-                  <a:srgbClr val="191E24"/>
+              <a:t>• Benefits of the solution (social, economic, environmental, etc.)</a:t>
+            </a:r>
+          </a:p>
+          <a:p>
+            <a:pPr>
+              <a:spcAft>
+                <a:spcPts val="600"/>
+              </a:spcAft>
+            </a:pPr>
+            <a:r>
+              <a:rPr b="1" sz="1200">
+                <a:solidFill>
+                  <a:srgbClr val="1B365D"/>
+                </a:solidFill>
+                <a:latin typeface="Arial"/>
+              </a:rPr>
+              <a:t>- Economic Benefits:
+  </a:t>
+            </a:r>
+            <a:r>
+              <a:rPr sz="1150">
+                <a:solidFill>
+                  <a:srgbClr val="14181E"/>
                 </a:solidFill>
                 <a:latin typeface="Arial"/>
               </a:rPr>
@@ -6116,22 +5738,23 @@
           <a:p>
             <a:pPr>
               <a:spcAft>
-                <a:spcPts val="800"/>
-              </a:spcAft>
-            </a:pPr>
-            <a:r>
-              <a:rPr b="1" sz="1150">
-                <a:solidFill>
-                  <a:srgbClr val="1B365D"/>
-                </a:solidFill>
-                <a:latin typeface="Arial"/>
-              </a:rPr>
-              <a:t>• Social &amp; Governance Impact: </a:t>
-            </a:r>
-            <a:r>
-              <a:rPr sz="1100">
-                <a:solidFill>
-                  <a:srgbClr val="191E24"/>
+                <a:spcPts val="600"/>
+              </a:spcAft>
+            </a:pPr>
+            <a:r>
+              <a:rPr b="1" sz="1200">
+                <a:solidFill>
+                  <a:srgbClr val="1B365D"/>
+                </a:solidFill>
+                <a:latin typeface="Arial"/>
+              </a:rPr>
+              <a:t>- Social &amp; Governance Impact:
+  </a:t>
+            </a:r>
+            <a:r>
+              <a:rPr sz="1150">
+                <a:solidFill>
+                  <a:srgbClr val="14181E"/>
                 </a:solidFill>
                 <a:latin typeface="Arial"/>
               </a:rPr>
@@ -6141,22 +5764,23 @@
           <a:p>
             <a:pPr>
               <a:spcAft>
-                <a:spcPts val="800"/>
-              </a:spcAft>
-            </a:pPr>
-            <a:r>
-              <a:rPr b="1" sz="1150">
-                <a:solidFill>
-                  <a:srgbClr val="1B365D"/>
-                </a:solidFill>
-                <a:latin typeface="Arial"/>
-              </a:rPr>
-              <a:t>• National Security Advantage: </a:t>
-            </a:r>
-            <a:r>
-              <a:rPr sz="1100">
-                <a:solidFill>
-                  <a:srgbClr val="191E24"/>
+                <a:spcPts val="600"/>
+              </a:spcAft>
+            </a:pPr>
+            <a:r>
+              <a:rPr b="1" sz="1200">
+                <a:solidFill>
+                  <a:srgbClr val="1B365D"/>
+                </a:solidFill>
+                <a:latin typeface="Arial"/>
+              </a:rPr>
+              <a:t>- National Security Advantage:
+  </a:t>
+            </a:r>
+            <a:r>
+              <a:rPr sz="1150">
+                <a:solidFill>
+                  <a:srgbClr val="14181E"/>
                 </a:solidFill>
                 <a:latin typeface="Arial"/>
               </a:rPr>
@@ -6166,22 +5790,23 @@
           <a:p>
             <a:pPr>
               <a:spcAft>
-                <a:spcPts val="800"/>
-              </a:spcAft>
-            </a:pPr>
-            <a:r>
-              <a:rPr b="1" sz="1150">
-                <a:solidFill>
-                  <a:srgbClr val="1B365D"/>
-                </a:solidFill>
-                <a:latin typeface="Arial"/>
-              </a:rPr>
-              <a:t>• Environmental Sustainability: </a:t>
-            </a:r>
-            <a:r>
-              <a:rPr sz="1100">
-                <a:solidFill>
-                  <a:srgbClr val="191E24"/>
+                <a:spcPts val="600"/>
+              </a:spcAft>
+            </a:pPr>
+            <a:r>
+              <a:rPr b="1" sz="1200">
+                <a:solidFill>
+                  <a:srgbClr val="1B365D"/>
+                </a:solidFill>
+                <a:latin typeface="Arial"/>
+              </a:rPr>
+              <a:t>- Environmental Sustainability:
+  </a:t>
+            </a:r>
+            <a:r>
+              <a:rPr sz="1150">
+                <a:solidFill>
+                  <a:srgbClr val="14181E"/>
                 </a:solidFill>
                 <a:latin typeface="Arial"/>
               </a:rPr>
@@ -6216,8 +5841,8 @@
         </p:nvSpPr>
         <p:spPr>
           <a:xfrm>
-            <a:off x="502920" y="228600"/>
-            <a:ext cx="1691640" cy="960120"/>
+            <a:off x="502920" y="274320"/>
+            <a:ext cx="1645920" cy="914400"/>
           </a:xfrm>
           <a:prstGeom prst="ellipse">
             <a:avLst/>
@@ -6250,28 +5875,28 @@
           <a:lstStyle/>
           <a:p>
             <a:pPr algn="ctr">
-              <a:defRPr sz="1000">
-                <a:solidFill>
-                  <a:srgbClr val="191E24"/>
+              <a:defRPr sz="1100">
+                <a:solidFill>
+                  <a:srgbClr val="14181E"/>
                 </a:solidFill>
                 <a:latin typeface="Arial"/>
               </a:defRPr>
             </a:pPr>
             <a:r>
-              <a:t>Team Name</a:t>
+              <a:t>Your Team</a:t>
             </a:r>
           </a:p>
           <a:p>
             <a:pPr algn="ctr">
-              <a:defRPr sz="1150" b="1">
-                <a:solidFill>
-                  <a:srgbClr val="1B365D"/>
+              <a:defRPr sz="1100">
+                <a:solidFill>
+                  <a:srgbClr val="14181E"/>
                 </a:solidFill>
                 <a:latin typeface="Arial"/>
               </a:defRPr>
             </a:pPr>
             <a:r>
-              <a:t>OmniTransform</a:t>
+              <a:t>Name</a:t>
             </a:r>
           </a:p>
         </p:txBody>
@@ -6284,8 +5909,8 @@
         </p:nvSpPr>
         <p:spPr>
           <a:xfrm>
-            <a:off x="2377440" y="320040"/>
-            <a:ext cx="5303520" cy="777240"/>
+            <a:off x="2286000" y="320040"/>
+            <a:ext cx="6217920" cy="777240"/>
           </a:xfrm>
           <a:prstGeom prst="rect">
             <a:avLst/>
@@ -6299,11 +5924,11 @@
           <a:lstStyle/>
           <a:p>
             <a:pPr algn="ctr">
-              <a:defRPr sz="2400" b="1">
-                <a:solidFill>
-                  <a:srgbClr val="1B365D"/>
-                </a:solidFill>
-                <a:latin typeface="Arial"/>
+              <a:defRPr sz="2600" b="1">
+                <a:solidFill>
+                  <a:srgbClr val="1B365D"/>
+                </a:solidFill>
+                <a:latin typeface="Times New Roman"/>
               </a:defRPr>
             </a:pPr>
             <a:r>
@@ -6314,7 +5939,7 @@
       </p:sp>
       <p:pic>
         <p:nvPicPr>
-          <p:cNvPr id="4" name="Picture 3" descr="sih_header_banner.jpg"/>
+          <p:cNvPr id="4" name="Picture 3" descr="sih_official_logo.png"/>
           <p:cNvPicPr>
             <a:picLocks noChangeAspect="1"/>
           </p:cNvPicPr>
@@ -6328,8 +5953,8 @@
         </p:blipFill>
         <p:spPr>
           <a:xfrm>
-            <a:off x="7818120" y="228600"/>
-            <a:ext cx="3886200" cy="513184"/>
+            <a:off x="8961120" y="228600"/>
+            <a:ext cx="2743200" cy="1412611"/>
           </a:xfrm>
           <a:prstGeom prst="rect">
             <a:avLst/>
@@ -6453,79 +6078,61 @@
       </p:sp>
       <p:sp>
         <p:nvSpPr>
-          <p:cNvPr id="8" name="Rounded Rectangle 7"/>
-          <p:cNvSpPr/>
+          <p:cNvPr id="8" name="TextBox 7"/>
+          <p:cNvSpPr txBox="1"/>
           <p:nvPr/>
         </p:nvSpPr>
         <p:spPr>
           <a:xfrm>
-            <a:off x="731520" y="1280160"/>
-            <a:ext cx="5166360" cy="4937760"/>
-          </a:xfrm>
-          <a:prstGeom prst="roundRect">
+            <a:off x="731520" y="1234440"/>
+            <a:ext cx="5212080" cy="4937760"/>
+          </a:xfrm>
+          <a:prstGeom prst="rect">
             <a:avLst/>
           </a:prstGeom>
-          <a:solidFill>
-            <a:srgbClr val="FAFCFF"/>
-          </a:solidFill>
-          <a:ln>
-            <a:solidFill>
-              <a:srgbClr val="D7E1EE"/>
-            </a:solidFill>
-          </a:ln>
-        </p:spPr>
-        <p:style>
-          <a:lnRef idx="1">
-            <a:schemeClr val="accent1"/>
-          </a:lnRef>
-          <a:fillRef idx="3">
-            <a:schemeClr val="accent1"/>
-          </a:fillRef>
-          <a:effectRef idx="2">
-            <a:schemeClr val="accent1"/>
-          </a:effectRef>
-          <a:fontRef idx="minor">
-            <a:schemeClr val="lt1"/>
-          </a:fontRef>
-        </p:style>
-        <p:txBody>
-          <a:bodyPr rtlCol="0" anchor="ctr" wrap="square" lIns="256032" tIns="228600" rIns="256032"/>
-          <a:lstStyle/>
-          <a:p>
-            <a:pPr algn="ctr">
-              <a:spcAft>
-                <a:spcPts val="1200"/>
-              </a:spcAft>
-              <a:defRPr sz="1500" b="1" u="sng">
-                <a:solidFill>
-                  <a:srgbClr val="1B365D"/>
-                </a:solidFill>
-                <a:latin typeface="Arial"/>
+          <a:noFill/>
+        </p:spPr>
+        <p:txBody>
+          <a:bodyPr wrap="square">
+            <a:spAutoFit/>
+          </a:bodyPr>
+          <a:lstStyle/>
+          <a:p>
+            <a:pPr>
+              <a:spcAft>
+                <a:spcPts val="1000"/>
+              </a:spcAft>
+              <a:defRPr sz="1600" b="1">
+                <a:solidFill>
+                  <a:srgbClr val="1B365D"/>
+                </a:solidFill>
+                <a:latin typeface="Times New Roman"/>
               </a:defRPr>
             </a:pPr>
             <a:r>
-              <a:t>• Details / Links of reference &amp; research work</a:t>
-            </a:r>
-          </a:p>
-          <a:p>
-            <a:pPr>
-              <a:spcAft>
-                <a:spcPts val="800"/>
-              </a:spcAft>
-            </a:pPr>
-            <a:r>
-              <a:rPr b="1" sz="1150">
-                <a:solidFill>
-                  <a:srgbClr val="1B365D"/>
-                </a:solidFill>
-                <a:latin typeface="Arial"/>
-              </a:rPr>
-              <a:t>• Lewis et al. (2020): </a:t>
-            </a:r>
-            <a:r>
-              <a:rPr sz="1100">
-                <a:solidFill>
-                  <a:srgbClr val="191E24"/>
+              <a:t>• Details / Links of the reference and research work</a:t>
+            </a:r>
+          </a:p>
+          <a:p>
+            <a:pPr>
+              <a:spcAft>
+                <a:spcPts val="600"/>
+              </a:spcAft>
+            </a:pPr>
+            <a:r>
+              <a:rPr b="1" sz="1200">
+                <a:solidFill>
+                  <a:srgbClr val="1B365D"/>
+                </a:solidFill>
+                <a:latin typeface="Arial"/>
+              </a:rPr>
+              <a:t>- Lewis et al. (2020):
+  </a:t>
+            </a:r>
+            <a:r>
+              <a:rPr sz="1150">
+                <a:solidFill>
+                  <a:srgbClr val="14181E"/>
                 </a:solidFill>
                 <a:latin typeface="Arial"/>
               </a:rPr>
@@ -6535,22 +6142,23 @@
           <a:p>
             <a:pPr>
               <a:spcAft>
-                <a:spcPts val="800"/>
-              </a:spcAft>
-            </a:pPr>
-            <a:r>
-              <a:rPr b="1" sz="1150">
-                <a:solidFill>
-                  <a:srgbClr val="1B365D"/>
-                </a:solidFill>
-                <a:latin typeface="Arial"/>
-              </a:rPr>
-              <a:t>• Touvron et al. (2023/2024): </a:t>
-            </a:r>
-            <a:r>
-              <a:rPr sz="1100">
-                <a:solidFill>
-                  <a:srgbClr val="191E24"/>
+                <a:spcPts val="600"/>
+              </a:spcAft>
+            </a:pPr>
+            <a:r>
+              <a:rPr b="1" sz="1200">
+                <a:solidFill>
+                  <a:srgbClr val="1B365D"/>
+                </a:solidFill>
+                <a:latin typeface="Arial"/>
+              </a:rPr>
+              <a:t>- Touvron et al. (2023/2024):
+  </a:t>
+            </a:r>
+            <a:r>
+              <a:rPr sz="1150">
+                <a:solidFill>
+                  <a:srgbClr val="14181E"/>
                 </a:solidFill>
                 <a:latin typeface="Arial"/>
               </a:rPr>
@@ -6560,22 +6168,23 @@
           <a:p>
             <a:pPr>
               <a:spcAft>
-                <a:spcPts val="800"/>
-              </a:spcAft>
-            </a:pPr>
-            <a:r>
-              <a:rPr b="1" sz="1150">
-                <a:solidFill>
-                  <a:srgbClr val="1B365D"/>
-                </a:solidFill>
-                <a:latin typeface="Arial"/>
-              </a:rPr>
-              <a:t>• Vaswani et al. (2017): </a:t>
-            </a:r>
-            <a:r>
-              <a:rPr sz="1100">
-                <a:solidFill>
-                  <a:srgbClr val="191E24"/>
+                <a:spcPts val="600"/>
+              </a:spcAft>
+            </a:pPr>
+            <a:r>
+              <a:rPr b="1" sz="1200">
+                <a:solidFill>
+                  <a:srgbClr val="1B365D"/>
+                </a:solidFill>
+                <a:latin typeface="Arial"/>
+              </a:rPr>
+              <a:t>- Vaswani et al. (2017):
+  </a:t>
+            </a:r>
+            <a:r>
+              <a:rPr sz="1150">
+                <a:solidFill>
+                  <a:srgbClr val="14181E"/>
                 </a:solidFill>
                 <a:latin typeface="Arial"/>
               </a:rPr>
@@ -6585,22 +6194,23 @@
           <a:p>
             <a:pPr>
               <a:spcAft>
-                <a:spcPts val="800"/>
-              </a:spcAft>
-            </a:pPr>
-            <a:r>
-              <a:rPr b="1" sz="1150">
-                <a:solidFill>
-                  <a:srgbClr val="1B365D"/>
-                </a:solidFill>
-                <a:latin typeface="Arial"/>
-              </a:rPr>
-              <a:t>• AI4Bharat / Bhashini (2023): </a:t>
-            </a:r>
-            <a:r>
-              <a:rPr sz="1100">
-                <a:solidFill>
-                  <a:srgbClr val="191E24"/>
+                <a:spcPts val="600"/>
+              </a:spcAft>
+            </a:pPr>
+            <a:r>
+              <a:rPr b="1" sz="1200">
+                <a:solidFill>
+                  <a:srgbClr val="1B365D"/>
+                </a:solidFill>
+                <a:latin typeface="Arial"/>
+              </a:rPr>
+              <a:t>- AI4Bharat / Bhashini (2023):
+  </a:t>
+            </a:r>
+            <a:r>
+              <a:rPr sz="1150">
+                <a:solidFill>
+                  <a:srgbClr val="14181E"/>
                 </a:solidFill>
                 <a:latin typeface="Arial"/>
               </a:rPr>
@@ -6610,22 +6220,23 @@
           <a:p>
             <a:pPr>
               <a:spcAft>
-                <a:spcPts val="800"/>
-              </a:spcAft>
-            </a:pPr>
-            <a:r>
-              <a:rPr b="1" sz="1150">
-                <a:solidFill>
-                  <a:srgbClr val="1B365D"/>
-                </a:solidFill>
-                <a:latin typeface="Arial"/>
-              </a:rPr>
-              <a:t>• ISO/IEC 27001 &amp; NIST Standards: </a:t>
-            </a:r>
-            <a:r>
-              <a:rPr sz="1100">
-                <a:solidFill>
-                  <a:srgbClr val="191E24"/>
+                <a:spcPts val="600"/>
+              </a:spcAft>
+            </a:pPr>
+            <a:r>
+              <a:rPr b="1" sz="1200">
+                <a:solidFill>
+                  <a:srgbClr val="1B365D"/>
+                </a:solidFill>
+                <a:latin typeface="Arial"/>
+              </a:rPr>
+              <a:t>- ISO/IEC 27001 &amp; NIST Standards:
+  </a:t>
+            </a:r>
+            <a:r>
+              <a:rPr sz="1150">
+                <a:solidFill>
+                  <a:srgbClr val="14181E"/>
                 </a:solidFill>
                 <a:latin typeface="Arial"/>
               </a:rPr>
@@ -6636,54 +6247,35 @@
       </p:sp>
       <p:sp>
         <p:nvSpPr>
-          <p:cNvPr id="9" name="Rounded Rectangle 8"/>
-          <p:cNvSpPr/>
+          <p:cNvPr id="9" name="TextBox 8"/>
+          <p:cNvSpPr txBox="1"/>
           <p:nvPr/>
         </p:nvSpPr>
         <p:spPr>
           <a:xfrm>
-            <a:off x="6263640" y="1280160"/>
-            <a:ext cx="5166360" cy="4937760"/>
-          </a:xfrm>
-          <a:prstGeom prst="roundRect">
+            <a:off x="6217920" y="1234440"/>
+            <a:ext cx="5212080" cy="4937760"/>
+          </a:xfrm>
+          <a:prstGeom prst="rect">
             <a:avLst/>
           </a:prstGeom>
-          <a:solidFill>
-            <a:srgbClr val="FAFCFF"/>
-          </a:solidFill>
-          <a:ln>
-            <a:solidFill>
-              <a:srgbClr val="D7E1EE"/>
-            </a:solidFill>
-          </a:ln>
-        </p:spPr>
-        <p:style>
-          <a:lnRef idx="1">
-            <a:schemeClr val="accent1"/>
-          </a:lnRef>
-          <a:fillRef idx="3">
-            <a:schemeClr val="accent1"/>
-          </a:fillRef>
-          <a:effectRef idx="2">
-            <a:schemeClr val="accent1"/>
-          </a:effectRef>
-          <a:fontRef idx="minor">
-            <a:schemeClr val="lt1"/>
-          </a:fontRef>
-        </p:style>
-        <p:txBody>
-          <a:bodyPr rtlCol="0" anchor="ctr" wrap="square" lIns="256032" tIns="228600" rIns="256032"/>
-          <a:lstStyle/>
-          <a:p>
-            <a:pPr algn="ctr">
-              <a:spcAft>
-                <a:spcPts val="1200"/>
-              </a:spcAft>
-              <a:defRPr sz="1500" b="1" u="sng">
-                <a:solidFill>
-                  <a:srgbClr val="1B365D"/>
-                </a:solidFill>
-                <a:latin typeface="Arial"/>
+          <a:noFill/>
+        </p:spPr>
+        <p:txBody>
+          <a:bodyPr wrap="square">
+            <a:spAutoFit/>
+          </a:bodyPr>
+          <a:lstStyle/>
+          <a:p>
+            <a:pPr>
+              <a:spcAft>
+                <a:spcPts val="1000"/>
+              </a:spcAft>
+              <a:defRPr sz="1600" b="1">
+                <a:solidFill>
+                  <a:srgbClr val="1B365D"/>
+                </a:solidFill>
+                <a:latin typeface="Times New Roman"/>
               </a:defRPr>
             </a:pPr>
             <a:r>
@@ -6693,21 +6285,21 @@
           <a:p>
             <a:pPr>
               <a:spcAft>
-                <a:spcPts val="800"/>
-              </a:spcAft>
-            </a:pPr>
-            <a:r>
-              <a:rPr b="1" sz="1150">
-                <a:solidFill>
-                  <a:srgbClr val="1B365D"/>
-                </a:solidFill>
-                <a:latin typeface="Arial"/>
-              </a:rPr>
-              <a:t>• SIH 2026 Problem Statement 26154:
+                <a:spcPts val="600"/>
+              </a:spcAft>
+            </a:pPr>
+            <a:r>
+              <a:rPr b="1" sz="1200">
+                <a:solidFill>
+                  <a:srgbClr val="1B365D"/>
+                </a:solidFill>
+                <a:latin typeface="Arial"/>
+              </a:rPr>
+              <a:t>- SIH 2026 Problem Statement 26154:
   </a:t>
             </a:r>
             <a:r>
-              <a:rPr sz="1050">
+              <a:rPr sz="1100">
                 <a:solidFill>
                   <a:srgbClr val="0077C8"/>
                 </a:solidFill>
@@ -6719,21 +6311,21 @@
           <a:p>
             <a:pPr>
               <a:spcAft>
-                <a:spcPts val="800"/>
-              </a:spcAft>
-            </a:pPr>
-            <a:r>
-              <a:rPr b="1" sz="1150">
-                <a:solidFill>
-                  <a:srgbClr val="1B365D"/>
-                </a:solidFill>
-                <a:latin typeface="Arial"/>
-              </a:rPr>
-              <a:t>• NTRO Official Government Portal:
+                <a:spcPts val="600"/>
+              </a:spcAft>
+            </a:pPr>
+            <a:r>
+              <a:rPr b="1" sz="1200">
+                <a:solidFill>
+                  <a:srgbClr val="1B365D"/>
+                </a:solidFill>
+                <a:latin typeface="Arial"/>
+              </a:rPr>
+              <a:t>- NTRO Official Government Portal:
   </a:t>
             </a:r>
             <a:r>
-              <a:rPr sz="1050">
+              <a:rPr sz="1100">
                 <a:solidFill>
                   <a:srgbClr val="0077C8"/>
                 </a:solidFill>
@@ -6745,21 +6337,21 @@
           <a:p>
             <a:pPr>
               <a:spcAft>
-                <a:spcPts val="800"/>
-              </a:spcAft>
-            </a:pPr>
-            <a:r>
-              <a:rPr b="1" sz="1150">
-                <a:solidFill>
-                  <a:srgbClr val="1B365D"/>
-                </a:solidFill>
-                <a:latin typeface="Arial"/>
-              </a:rPr>
-              <a:t>• Live Web Platform &amp; Design System:
+                <a:spcPts val="600"/>
+              </a:spcAft>
+            </a:pPr>
+            <a:r>
+              <a:rPr b="1" sz="1200">
+                <a:solidFill>
+                  <a:srgbClr val="1B365D"/>
+                </a:solidFill>
+                <a:latin typeface="Arial"/>
+              </a:rPr>
+              <a:t>- Live Web Platform &amp; Design System:
   </a:t>
             </a:r>
             <a:r>
-              <a:rPr sz="1050">
+              <a:rPr sz="1100">
                 <a:solidFill>
                   <a:srgbClr val="0077C8"/>
                 </a:solidFill>
@@ -6771,21 +6363,21 @@
           <a:p>
             <a:pPr>
               <a:spcAft>
-                <a:spcPts val="800"/>
-              </a:spcAft>
-            </a:pPr>
-            <a:r>
-              <a:rPr b="1" sz="1150">
-                <a:solidFill>
-                  <a:srgbClr val="1B365D"/>
-                </a:solidFill>
-                <a:latin typeface="Arial"/>
-              </a:rPr>
-              <a:t>• GitHub Project Repository:
+                <a:spcPts val="600"/>
+              </a:spcAft>
+            </a:pPr>
+            <a:r>
+              <a:rPr b="1" sz="1200">
+                <a:solidFill>
+                  <a:srgbClr val="1B365D"/>
+                </a:solidFill>
+                <a:latin typeface="Arial"/>
+              </a:rPr>
+              <a:t>- GitHub Project Repository:
   </a:t>
             </a:r>
             <a:r>
-              <a:rPr sz="1050">
+              <a:rPr sz="1100">
                 <a:solidFill>
                   <a:srgbClr val="0077C8"/>
                 </a:solidFill>
@@ -6797,21 +6389,21 @@
           <a:p>
             <a:pPr>
               <a:spcAft>
-                <a:spcPts val="800"/>
-              </a:spcAft>
-            </a:pPr>
-            <a:r>
-              <a:rPr b="1" sz="1150">
-                <a:solidFill>
-                  <a:srgbClr val="1B365D"/>
-                </a:solidFill>
-                <a:latin typeface="Arial"/>
-              </a:rPr>
-              <a:t>• Winning Blueprint &amp; Documentation:
+                <a:spcPts val="600"/>
+              </a:spcAft>
+            </a:pPr>
+            <a:r>
+              <a:rPr b="1" sz="1200">
+                <a:solidFill>
+                  <a:srgbClr val="1B365D"/>
+                </a:solidFill>
+                <a:latin typeface="Arial"/>
+              </a:rPr>
+              <a:t>- Winning Blueprint &amp; Documentation:
   </a:t>
             </a:r>
             <a:r>
-              <a:rPr sz="1050">
+              <a:rPr sz="1100">
                 <a:solidFill>
                   <a:srgbClr val="0077C8"/>
                 </a:solidFill>

</xml_diff>

<commit_message>
Embed professional high-resolution architecture flowchart on Slide 3 with clean Times New Roman typography
</commit_message>
<xml_diff>
--- a/SIH2026_Idea_Presentation_PS26154.pptx
+++ b/SIH2026_Idea_Presentation_PS26154.pptx
@@ -4407,8 +4407,8 @@
         </p:nvSpPr>
         <p:spPr>
           <a:xfrm>
-            <a:off x="731520" y="1280160"/>
-            <a:ext cx="4389120" cy="4937760"/>
+            <a:off x="731520" y="1234440"/>
+            <a:ext cx="4206240" cy="5029200"/>
           </a:xfrm>
           <a:prstGeom prst="rect">
             <a:avLst/>
@@ -4425,7 +4425,7 @@
               <a:spcAft>
                 <a:spcPts val="1000"/>
               </a:spcAft>
-              <a:defRPr sz="1500" b="1">
+              <a:defRPr sz="1500" b="1" u="sng">
                 <a:solidFill>
                   <a:srgbClr val="1B365D"/>
                 </a:solidFill>
@@ -4433,7 +4433,7 @@
               </a:defRPr>
             </a:pPr>
             <a:r>
-              <a:t>• Technologies to be used (e.g. programming languages, frameworks, hardware)</a:t>
+              <a:t>• Technologies to be used</a:t>
             </a:r>
           </a:p>
           <a:p>
@@ -4452,13 +4452,13 @@
               <a:t>Frontend: </a:t>
             </a:r>
             <a:r>
-              <a:rPr sz="1150">
+              <a:rPr sz="1100">
                 <a:solidFill>
                   <a:srgbClr val="14181E"/>
                 </a:solidFill>
                 <a:latin typeface="Arial"/>
               </a:rPr>
-              <a:t>Next.js 14, React, Tailwind CSS, Lucide Icons, PDF.js canvas viewer.</a:t>
+              <a:t>Next.js 14, React, Tailwind CSS, Lucide Icons, PDF.js viewer.</a:t>
             </a:r>
           </a:p>
           <a:p>
@@ -4474,16 +4474,16 @@
                 </a:solidFill>
                 <a:latin typeface="Arial"/>
               </a:rPr>
-              <a:t>Backend Engine: </a:t>
-            </a:r>
-            <a:r>
-              <a:rPr sz="1150">
+              <a:t>Backend &amp; Parser: </a:t>
+            </a:r>
+            <a:r>
+              <a:rPr sz="1100">
                 <a:solidFill>
                   <a:srgbClr val="14181E"/>
                 </a:solidFill>
                 <a:latin typeface="Arial"/>
               </a:rPr>
-              <a:t>Python FastAPI, PyMuPDF spatial coordinate extractor, LangChain.</a:t>
+              <a:t>Python FastAPI, PyMuPDF coordinate parser, LangChain.</a:t>
             </a:r>
           </a:p>
           <a:p>
@@ -4499,16 +4499,16 @@
                 </a:solidFill>
                 <a:latin typeface="Arial"/>
               </a:rPr>
-              <a:t>AI / Foundation LLMs: </a:t>
-            </a:r>
-            <a:r>
-              <a:rPr sz="1150">
+              <a:t>Foundation AI: </a:t>
+            </a:r>
+            <a:r>
+              <a:rPr sz="1100">
                 <a:solidFill>
                   <a:srgbClr val="14181E"/>
                 </a:solidFill>
                 <a:latin typeface="Arial"/>
               </a:rPr>
-              <a:t>Llama 3.3 (70B), Mistral Large, IndicBERT for regional translation.</a:t>
+              <a:t>Llama 3.3 (70B), Mistral Large, IndicBERT (translation).</a:t>
             </a:r>
           </a:p>
           <a:p>
@@ -4524,16 +4524,16 @@
                 </a:solidFill>
                 <a:latin typeface="Arial"/>
               </a:rPr>
-              <a:t>Rendering Compilers: </a:t>
-            </a:r>
-            <a:r>
-              <a:rPr sz="1150">
+              <a:t>Slide/Canvas Engines: </a:t>
+            </a:r>
+            <a:r>
+              <a:rPr sz="1100">
                 <a:solidFill>
                   <a:srgbClr val="14181E"/>
                 </a:solidFill>
                 <a:latin typeface="Arial"/>
               </a:rPr>
-              <a:t>Satori HTML-to-Image Canvas API, Marp slide engine, FFmpeg.</a:t>
+              <a:t>Satori HTML-to-Image Canvas, Marp slide compiler, FFmpeg.</a:t>
             </a:r>
           </a:p>
           <a:p>
@@ -4549,10 +4549,10 @@
                 </a:solidFill>
                 <a:latin typeface="Arial"/>
               </a:rPr>
-              <a:t>Voice AI Synthesis: </a:t>
-            </a:r>
-            <a:r>
-              <a:rPr sz="1150">
+              <a:t>Voice AI Pipeline: </a:t>
+            </a:r>
+            <a:r>
+              <a:rPr sz="1100">
                 <a:solidFill>
                   <a:srgbClr val="14181E"/>
                 </a:solidFill>
@@ -4574,10 +4574,10 @@
                 </a:solidFill>
                 <a:latin typeface="Arial"/>
               </a:rPr>
-              <a:t>Deployment &amp; Security: </a:t>
-            </a:r>
-            <a:r>
-              <a:rPr sz="1150">
+              <a:t>Deployment: </a:t>
+            </a:r>
+            <a:r>
+              <a:rPr sz="1100">
                 <a:solidFill>
                   <a:srgbClr val="14181E"/>
                 </a:solidFill>
@@ -4596,8 +4596,8 @@
         </p:nvSpPr>
         <p:spPr>
           <a:xfrm>
-            <a:off x="5303520" y="1280160"/>
-            <a:ext cx="6217920" cy="4937760"/>
+            <a:off x="5120640" y="1234440"/>
+            <a:ext cx="6400800" cy="457200"/>
           </a:xfrm>
           <a:prstGeom prst="rect">
             <a:avLst/>
@@ -4605,16 +4605,13 @@
           <a:noFill/>
         </p:spPr>
         <p:txBody>
-          <a:bodyPr wrap="square">
+          <a:bodyPr wrap="none">
             <a:spAutoFit/>
           </a:bodyPr>
           <a:lstStyle/>
           <a:p>
             <a:pPr>
-              <a:spcAft>
-                <a:spcPts val="1000"/>
-              </a:spcAft>
-              <a:defRPr sz="1500" b="1">
+              <a:defRPr sz="1500" b="1" u="sng">
                 <a:solidFill>
                   <a:srgbClr val="1B365D"/>
                 </a:solidFill>
@@ -4622,136 +4619,35 @@
               </a:defRPr>
             </a:pPr>
             <a:r>
-              <a:t>• Methodology and process for implementation (Flow Charts/Images/ working prototype)</a:t>
-            </a:r>
-          </a:p>
-          <a:p>
-            <a:pPr>
-              <a:spcAft>
-                <a:spcPts val="600"/>
-              </a:spcAft>
-            </a:pPr>
-            <a:r>
-              <a:rPr b="1" sz="1200">
-                <a:solidFill>
-                  <a:srgbClr val="1B365D"/>
-                </a:solidFill>
-                <a:latin typeface="Arial"/>
-              </a:rPr>
-              <a:t>Step 1. Document Ingestion: </a:t>
-            </a:r>
-            <a:r>
-              <a:rPr sz="1150">
-                <a:solidFill>
-                  <a:srgbClr val="14181E"/>
-                </a:solidFill>
-                <a:latin typeface="Arial"/>
-              </a:rPr>
-              <a:t>PyMuPDF parses raw PDF/DOCX, tagging text blocks, tables, and diagrams with exact coordinate bounding boxes.</a:t>
-            </a:r>
-          </a:p>
-          <a:p>
-            <a:pPr>
-              <a:spcAft>
-                <a:spcPts val="600"/>
-              </a:spcAft>
-            </a:pPr>
-            <a:r>
-              <a:rPr b="1" sz="1200">
-                <a:solidFill>
-                  <a:srgbClr val="1B365D"/>
-                </a:solidFill>
-                <a:latin typeface="Arial"/>
-              </a:rPr>
-              <a:t>Step 2. Structured Chunking &amp; RAG: </a:t>
-            </a:r>
-            <a:r>
-              <a:rPr sz="1150">
-                <a:solidFill>
-                  <a:srgbClr val="14181E"/>
-                </a:solidFill>
-                <a:latin typeface="Arial"/>
-              </a:rPr>
-              <a:t>Contextual embeddings are indexed into an in-memory vector store (FAISS/Qdrant) enforcing strict citation boundaries.</a:t>
-            </a:r>
-          </a:p>
-          <a:p>
-            <a:pPr>
-              <a:spcAft>
-                <a:spcPts val="600"/>
-              </a:spcAft>
-            </a:pPr>
-            <a:r>
-              <a:rPr b="1" sz="1200">
-                <a:solidFill>
-                  <a:srgbClr val="1B365D"/>
-                </a:solidFill>
-                <a:latin typeface="Arial"/>
-              </a:rPr>
-              <a:t>Step 3. Multi-Persona Orchestration: </a:t>
-            </a:r>
-            <a:r>
-              <a:rPr sz="1150">
-                <a:solidFill>
-                  <a:srgbClr val="14181E"/>
-                </a:solidFill>
-                <a:latin typeface="Arial"/>
-              </a:rPr>
-              <a:t>Constrained JSON Schema prompts instruct the LLM to extract key insights, slide structures, and press summaries.</a:t>
-            </a:r>
-          </a:p>
-          <a:p>
-            <a:pPr>
-              <a:spcAft>
-                <a:spcPts val="600"/>
-              </a:spcAft>
-            </a:pPr>
-            <a:r>
-              <a:rPr b="1" sz="1200">
-                <a:solidFill>
-                  <a:srgbClr val="1B365D"/>
-                </a:solidFill>
-                <a:latin typeface="Arial"/>
-              </a:rPr>
-              <a:t>Step 4. Parallel Synthesis Engines: </a:t>
-            </a:r>
-            <a:r>
-              <a:rPr sz="1150">
-                <a:solidFill>
-                  <a:srgbClr val="14181E"/>
-                </a:solidFill>
-                <a:latin typeface="Arial"/>
-              </a:rPr>
-              <a:t>Simultaneously compiles HTML5 presentation slides, auto-renders visual cards (Canvas API), and synthesizes neural audio.</a:t>
-            </a:r>
-          </a:p>
-          <a:p>
-            <a:pPr>
-              <a:spcAft>
-                <a:spcPts val="600"/>
-              </a:spcAft>
-            </a:pPr>
-            <a:r>
-              <a:rPr b="1" sz="1200">
-                <a:solidFill>
-                  <a:srgbClr val="1B365D"/>
-                </a:solidFill>
-                <a:latin typeface="Arial"/>
-              </a:rPr>
-              <a:t>Step 5. Interactive Verification UI: </a:t>
-            </a:r>
-            <a:r>
-              <a:rPr sz="1150">
-                <a:solidFill>
-                  <a:srgbClr val="14181E"/>
-                </a:solidFill>
-                <a:latin typeface="Arial"/>
-              </a:rPr>
-              <a:t>Delivers a live dashboard with side-by-side asset previews and clickable citation coordinates directly linking to the source PDF.</a:t>
-            </a:r>
-          </a:p>
-        </p:txBody>
-      </p:sp>
+              <a:t>• Methodology and process for implementation (Flow Chart)</a:t>
+            </a:r>
+          </a:p>
+        </p:txBody>
+      </p:sp>
+      <p:pic>
+        <p:nvPicPr>
+          <p:cNvPr id="10" name="Picture 9" descr="omnitransform_pipeline_flowchart.png"/>
+          <p:cNvPicPr>
+            <a:picLocks noChangeAspect="1"/>
+          </p:cNvPicPr>
+          <p:nvPr/>
+        </p:nvPicPr>
+        <p:blipFill>
+          <a:blip r:embed="rId3"/>
+          <a:stretch>
+            <a:fillRect/>
+          </a:stretch>
+        </p:blipFill>
+        <p:spPr>
+          <a:xfrm>
+            <a:off x="5120640" y="1737360"/>
+            <a:ext cx="6309360" cy="3393269"/>
+          </a:xfrm>
+          <a:prstGeom prst="rect">
+            <a:avLst/>
+          </a:prstGeom>
+        </p:spPr>
+      </p:pic>
     </p:spTree>
   </p:cSld>
   <p:clrMapOvr>

</xml_diff>

<commit_message>
Refactor presentation to authentic, clean, human-crafted design with clean flowchart and realistic engineering terms
</commit_message>
<xml_diff>
--- a/SIH2026_Idea_Presentation_PS26154.pptx
+++ b/SIH2026_Idea_Presentation_PS26154.pptx
@@ -3383,7 +3383,7 @@
                 </a:solidFill>
                 <a:latin typeface="Times New Roman"/>
               </a:rPr>
-              <a:t> OmniTransform AI</a:t>
+              <a:t> OmniTransform AI - Automated Multi-Format Content Platform</a:t>
             </a:r>
           </a:p>
         </p:txBody>
@@ -3438,7 +3438,7 @@
         </p:nvSpPr>
         <p:spPr>
           <a:xfrm>
-            <a:off x="502920" y="274320"/>
+            <a:off x="548640" y="274320"/>
             <a:ext cx="1645920" cy="914400"/>
           </a:xfrm>
           <a:prstGeom prst="ellipse">
@@ -3759,7 +3759,7 @@
               </a:defRPr>
             </a:pPr>
             <a:r>
-              <a:t>Single-pass ingestion of dense 50+ page PDFs, threat advisories, and policy documents.</a:t>
+              <a:t>An automated system that ingests long PDFs, security advisories, and policy whitepapers, converting them into 5 ready-to-use formats in under 10 seconds:</a:t>
             </a:r>
           </a:p>
           <a:p>
@@ -3767,21 +3767,21 @@
               <a:spcAft>
                 <a:spcPts val="400"/>
               </a:spcAft>
-              <a:defRPr sz="1200" b="1">
-                <a:solidFill>
-                  <a:srgbClr val="1B365D"/>
+              <a:defRPr sz="1150">
+                <a:solidFill>
+                  <a:srgbClr val="14181E"/>
                 </a:solidFill>
                 <a:latin typeface="Arial"/>
               </a:defRPr>
             </a:pPr>
             <a:r>
-              <a:t>Generates 5 synchronized assets in under 10 seconds:</a:t>
+              <a:t>   1. 1-Page Executive Summary Memo</a:t>
             </a:r>
           </a:p>
           <a:p>
             <a:pPr>
               <a:spcAft>
-                <a:spcPts val="300"/>
+                <a:spcPts val="400"/>
               </a:spcAft>
               <a:defRPr sz="1150">
                 <a:solidFill>
@@ -3791,13 +3791,13 @@
               </a:defRPr>
             </a:pPr>
             <a:r>
-              <a:t>   1. Executive 1-Page Summary Memo</a:t>
+              <a:t>   2. Presentation Slide Deck</a:t>
             </a:r>
           </a:p>
           <a:p>
             <a:pPr>
               <a:spcAft>
-                <a:spcPts val="300"/>
+                <a:spcPts val="400"/>
               </a:spcAft>
               <a:defRPr sz="1150">
                 <a:solidFill>
@@ -3807,13 +3807,13 @@
               </a:defRPr>
             </a:pPr>
             <a:r>
-              <a:t>   2. Presentation Slide Deck</a:t>
+              <a:t>   3. Infographics &amp; Visual Data Cards</a:t>
             </a:r>
           </a:p>
           <a:p>
             <a:pPr>
               <a:spcAft>
-                <a:spcPts val="300"/>
+                <a:spcPts val="400"/>
               </a:spcAft>
               <a:defRPr sz="1150">
                 <a:solidFill>
@@ -3823,13 +3823,13 @@
               </a:defRPr>
             </a:pPr>
             <a:r>
-              <a:t>   3. Visual Infographic Cards</a:t>
+              <a:t>   4. Multilingual Press Release (English &amp; Regional)</a:t>
             </a:r>
           </a:p>
           <a:p>
             <a:pPr>
               <a:spcAft>
-                <a:spcPts val="300"/>
+                <a:spcPts val="400"/>
               </a:spcAft>
               <a:defRPr sz="1150">
                 <a:solidFill>
@@ -3839,23 +3839,7 @@
               </a:defRPr>
             </a:pPr>
             <a:r>
-              <a:t>   4. Multilingual Press Release</a:t>
-            </a:r>
-          </a:p>
-          <a:p>
-            <a:pPr>
-              <a:spcAft>
-                <a:spcPts val="300"/>
-              </a:spcAft>
-              <a:defRPr sz="1150">
-                <a:solidFill>
-                  <a:srgbClr val="14181E"/>
-                </a:solidFill>
-                <a:latin typeface="Arial"/>
-              </a:defRPr>
-            </a:pPr>
-            <a:r>
-              <a:t>   5. 60s Voice Audio Podcast</a:t>
+              <a:t>   5. 60-Second Voice Audio Briefing</a:t>
             </a:r>
           </a:p>
         </p:txBody>
@@ -3910,7 +3894,7 @@
                 </a:solidFill>
                 <a:latin typeface="Arial"/>
               </a:rPr>
-              <a:t>- Eliminates Manual Bottlenecks: </a:t>
+              <a:t>- Saves Analyst Time: </a:t>
             </a:r>
             <a:r>
               <a:rPr sz="1200">
@@ -3919,7 +3903,7 @@
                 </a:solidFill>
                 <a:latin typeface="Arial"/>
               </a:rPr>
-              <a:t>Saves 4 to 6 hours daily spent by officers manually restructuring dense technical documents.</a:t>
+              <a:t>Officers spend 4–6 hours daily converting reports into slides and briefs. OmniTransform automates this in seconds.</a:t>
             </a:r>
           </a:p>
           <a:p>
@@ -3935,7 +3919,7 @@
                 </a:solidFill>
                 <a:latin typeface="Arial"/>
               </a:rPr>
-              <a:t>- Unified Sovereign Platform: </a:t>
+              <a:t>- Eliminates Multiple Tools: </a:t>
             </a:r>
             <a:r>
               <a:rPr sz="1200">
@@ -3944,7 +3928,7 @@
                 </a:solidFill>
                 <a:latin typeface="Arial"/>
               </a:rPr>
-              <a:t>Replaces disconnected third-party tools into one integrated local dashboard.</a:t>
+              <a:t>Replaces separate design, translation, and summary tools with one integrated workflow.</a:t>
             </a:r>
           </a:p>
           <a:p>
@@ -3960,7 +3944,7 @@
                 </a:solidFill>
                 <a:latin typeface="Arial"/>
               </a:rPr>
-              <a:t>- Preserves Tactical Velocity: </a:t>
+              <a:t>- Enables Fast Decision Making: </a:t>
             </a:r>
             <a:r>
               <a:rPr sz="1200">
@@ -3969,7 +3953,7 @@
                 </a:solidFill>
                 <a:latin typeface="Arial"/>
               </a:rPr>
-              <a:t>Delivers immediate intelligence dissemination during critical national security events.</a:t>
+              <a:t>Executives and leaders can quickly review key takeaways during critical events.</a:t>
             </a:r>
           </a:p>
           <a:p>
@@ -3985,7 +3969,7 @@
                 </a:solidFill>
                 <a:latin typeface="Arial"/>
               </a:rPr>
-              <a:t>- Eliminates Hallucination Risk: </a:t>
+              <a:t>- Accurate &amp; Verifiable: </a:t>
             </a:r>
             <a:r>
               <a:rPr sz="1200">
@@ -3994,7 +3978,7 @@
                 </a:solidFill>
                 <a:latin typeface="Arial"/>
               </a:rPr>
-              <a:t>Enforces strict RAG boundaries to ensure complete factual precision.</a:t>
+              <a:t>Every generated point links back directly to the source page in the PDF.</a:t>
             </a:r>
           </a:p>
         </p:txBody>
@@ -4049,7 +4033,7 @@
                 </a:solidFill>
                 <a:latin typeface="Arial"/>
               </a:rPr>
-              <a:t>- Interactive Source Highlighting: </a:t>
+              <a:t>- Interactive Source Citations: </a:t>
             </a:r>
             <a:r>
               <a:rPr sz="1200">
@@ -4058,7 +4042,7 @@
                 </a:solidFill>
                 <a:latin typeface="Arial"/>
               </a:rPr>
-              <a:t>Click any bullet point to open the raw PDF with the exact sentence highlighted.</a:t>
+              <a:t>Click any summary point to highlight the exact sentence in the original PDF.</a:t>
             </a:r>
           </a:p>
           <a:p>
@@ -4074,7 +4058,7 @@
                 </a:solidFill>
                 <a:latin typeface="Arial"/>
               </a:rPr>
-              <a:t>- Multi-Persona Tone Switching: </a:t>
+              <a:t>- Audience-Specific Views: </a:t>
             </a:r>
             <a:r>
               <a:rPr sz="1200">
@@ -4083,7 +4067,7 @@
                 </a:solidFill>
                 <a:latin typeface="Arial"/>
               </a:rPr>
-              <a:t>1-click toggle between C-Suite Brief, Citizen Explainer, and Threat Alert.</a:t>
+              <a:t>Switch between an Executive Brief, Citizen Explainer, or Technical Advisory with 1 click.</a:t>
             </a:r>
           </a:p>
           <a:p>
@@ -4099,7 +4083,7 @@
                 </a:solidFill>
                 <a:latin typeface="Arial"/>
               </a:rPr>
-              <a:t>- Air-Gapped Sovereign Security: </a:t>
+              <a:t>- Works Completely Offline: </a:t>
             </a:r>
             <a:r>
               <a:rPr sz="1200">
@@ -4108,7 +4092,7 @@
                 </a:solidFill>
                 <a:latin typeface="Arial"/>
               </a:rPr>
-              <a:t>Runs locally on open-weights (Llama 3/Mistral) without public cloud data leaks.</a:t>
+              <a:t>Can run on local GPU servers without sending sensitive data to external cloud APIs.</a:t>
             </a:r>
           </a:p>
           <a:p>
@@ -4124,7 +4108,7 @@
                 </a:solidFill>
                 <a:latin typeface="Arial"/>
               </a:rPr>
-              <a:t>- Deterministic Speed (&lt;10s): </a:t>
+              <a:t>- Multi-Format Synchronized Output: </a:t>
             </a:r>
             <a:r>
               <a:rPr sz="1200">
@@ -4133,7 +4117,7 @@
                 </a:solidFill>
                 <a:latin typeface="Arial"/>
               </a:rPr>
-              <a:t>High-throughput asynchronous pipeline with zero runtime failures.</a:t>
+              <a:t>Generates all 5 formats simultaneously from a single document upload.</a:t>
             </a:r>
           </a:p>
         </p:txBody>
@@ -4164,7 +4148,7 @@
         </p:nvSpPr>
         <p:spPr>
           <a:xfrm>
-            <a:off x="502920" y="274320"/>
+            <a:off x="548640" y="274320"/>
             <a:ext cx="1645920" cy="914400"/>
           </a:xfrm>
           <a:prstGeom prst="ellipse">
@@ -4439,7 +4423,7 @@
           <a:p>
             <a:pPr>
               <a:spcAft>
-                <a:spcPts val="600"/>
+                <a:spcPts val="500"/>
               </a:spcAft>
             </a:pPr>
             <a:r>
@@ -4458,13 +4442,13 @@
                 </a:solidFill>
                 <a:latin typeface="Arial"/>
               </a:rPr>
-              <a:t>Next.js 14, React, Tailwind CSS, Lucide Icons, PDF.js viewer.</a:t>
+              <a:t>Next.js / React, Tailwind CSS, PDF.js document viewer.</a:t>
             </a:r>
           </a:p>
           <a:p>
             <a:pPr>
               <a:spcAft>
-                <a:spcPts val="600"/>
+                <a:spcPts val="500"/>
               </a:spcAft>
             </a:pPr>
             <a:r>
@@ -4483,13 +4467,13 @@
                 </a:solidFill>
                 <a:latin typeface="Arial"/>
               </a:rPr>
-              <a:t>Python FastAPI, PyMuPDF coordinate parser, LangChain.</a:t>
+              <a:t>Python FastAPI, PyMuPDF, pdfplumber for table parsing.</a:t>
             </a:r>
           </a:p>
           <a:p>
             <a:pPr>
               <a:spcAft>
-                <a:spcPts val="600"/>
+                <a:spcPts val="500"/>
               </a:spcAft>
             </a:pPr>
             <a:r>
@@ -4499,7 +4483,7 @@
                 </a:solidFill>
                 <a:latin typeface="Arial"/>
               </a:rPr>
-              <a:t>Foundation AI: </a:t>
+              <a:t>AI Models: </a:t>
             </a:r>
             <a:r>
               <a:rPr sz="1100">
@@ -4508,13 +4492,13 @@
                 </a:solidFill>
                 <a:latin typeface="Arial"/>
               </a:rPr>
-              <a:t>Llama 3.3 (70B), Mistral Large, IndicBERT (translation).</a:t>
+              <a:t>Llama 3 (8B/70B) / Mistral, IndicBERT (Indian languages).</a:t>
             </a:r>
           </a:p>
           <a:p>
             <a:pPr>
               <a:spcAft>
-                <a:spcPts val="600"/>
+                <a:spcPts val="500"/>
               </a:spcAft>
             </a:pPr>
             <a:r>
@@ -4524,7 +4508,7 @@
                 </a:solidFill>
                 <a:latin typeface="Arial"/>
               </a:rPr>
-              <a:t>Slide/Canvas Engines: </a:t>
+              <a:t>Slide &amp; Graphic Rendering: </a:t>
             </a:r>
             <a:r>
               <a:rPr sz="1100">
@@ -4533,13 +4517,13 @@
                 </a:solidFill>
                 <a:latin typeface="Arial"/>
               </a:rPr>
-              <a:t>Satori HTML-to-Image Canvas, Marp slide compiler, FFmpeg.</a:t>
+              <a:t>Marp slide compiler, Canvas HTML-to-Image API.</a:t>
             </a:r>
           </a:p>
           <a:p>
             <a:pPr>
               <a:spcAft>
-                <a:spcPts val="600"/>
+                <a:spcPts val="500"/>
               </a:spcAft>
             </a:pPr>
             <a:r>
@@ -4549,7 +4533,7 @@
                 </a:solidFill>
                 <a:latin typeface="Arial"/>
               </a:rPr>
-              <a:t>Voice AI Pipeline: </a:t>
+              <a:t>Voice Generation: </a:t>
             </a:r>
             <a:r>
               <a:rPr sz="1100">
@@ -4558,13 +4542,13 @@
                 </a:solidFill>
                 <a:latin typeface="Arial"/>
               </a:rPr>
-              <a:t>Piper Neural TTS &amp; ElevenLabs API.</a:t>
+              <a:t>Piper Neural TTS (lightweight, runs locally offline).</a:t>
             </a:r>
           </a:p>
           <a:p>
             <a:pPr>
               <a:spcAft>
-                <a:spcPts val="600"/>
+                <a:spcPts val="500"/>
               </a:spcAft>
             </a:pPr>
             <a:r>
@@ -4574,6 +4558,31 @@
                 </a:solidFill>
                 <a:latin typeface="Arial"/>
               </a:rPr>
+              <a:t>Database &amp; Vector Search: </a:t>
+            </a:r>
+            <a:r>
+              <a:rPr sz="1100">
+                <a:solidFill>
+                  <a:srgbClr val="14181E"/>
+                </a:solidFill>
+                <a:latin typeface="Arial"/>
+              </a:rPr>
+              <a:t>FAISS / ChromaDB for document search &amp; citations.</a:t>
+            </a:r>
+          </a:p>
+          <a:p>
+            <a:pPr>
+              <a:spcAft>
+                <a:spcPts val="500"/>
+              </a:spcAft>
+            </a:pPr>
+            <a:r>
+              <a:rPr b="1" sz="1200">
+                <a:solidFill>
+                  <a:srgbClr val="1B365D"/>
+                </a:solidFill>
+                <a:latin typeface="Arial"/>
+              </a:rPr>
               <a:t>Deployment: </a:t>
             </a:r>
             <a:r>
@@ -4583,7 +4592,7 @@
                 </a:solidFill>
                 <a:latin typeface="Arial"/>
               </a:rPr>
-              <a:t>Docker containerized, air-gapped Linux host, zero telemetry.</a:t>
+              <a:t>Docker containerized, can run air-gapped on Linux/Windows.</a:t>
             </a:r>
           </a:p>
         </p:txBody>
@@ -4641,7 +4650,7 @@
         <p:spPr>
           <a:xfrm>
             <a:off x="5120640" y="1737360"/>
-            <a:ext cx="6309360" cy="3393269"/>
+            <a:ext cx="6309360" cy="3299390"/>
           </a:xfrm>
           <a:prstGeom prst="rect">
             <a:avLst/>
@@ -4674,7 +4683,7 @@
         </p:nvSpPr>
         <p:spPr>
           <a:xfrm>
-            <a:off x="502920" y="274320"/>
+            <a:off x="548640" y="274320"/>
             <a:ext cx="1645920" cy="914400"/>
           </a:xfrm>
           <a:prstGeom prst="ellipse">
@@ -4935,7 +4944,7 @@
               <a:spcAft>
                 <a:spcPts val="600"/>
               </a:spcAft>
-              <a:defRPr sz="1600" b="1">
+              <a:defRPr sz="1600" b="1" u="sng">
                 <a:solidFill>
                   <a:srgbClr val="1B365D"/>
                 </a:solidFill>
@@ -4959,7 +4968,7 @@
                 </a:solidFill>
                 <a:latin typeface="Arial"/>
               </a:rPr>
-              <a:t>- Hardware &amp; Compute Feasibility: </a:t>
+              <a:t>- Technical Feasibility: </a:t>
             </a:r>
             <a:r>
               <a:rPr sz="1200">
@@ -4968,7 +4977,7 @@
                 </a:solidFill>
                 <a:latin typeface="Arial"/>
               </a:rPr>
-              <a:t>Runs efficiently on commodity GPU workstations (e.g. Single RTX 4090 or Apple Silicon) using 4-bit quantized open-weight models.</a:t>
+              <a:t>Uses open-source models and standard document parsers. Tested with sample 30+ page government PDFs.</a:t>
             </a:r>
           </a:p>
           <a:p>
@@ -4984,7 +4993,7 @@
                 </a:solidFill>
                 <a:latin typeface="Arial"/>
               </a:rPr>
-              <a:t>- Speed &amp; Runtime Feasibility: </a:t>
+              <a:t>- Hardware Requirements: </a:t>
             </a:r>
             <a:r>
               <a:rPr sz="1200">
@@ -4993,7 +5002,7 @@
                 </a:solidFill>
                 <a:latin typeface="Arial"/>
               </a:rPr>
-              <a:t>Asynchronous map-reduce pipeline completes multi-format transformation of a 30-page PDF in &lt; 10 seconds.</a:t>
+              <a:t>Runs on a single workstation with an NVIDIA GPU (RTX 3060 or higher) using 4-bit quantized open-source models.</a:t>
             </a:r>
           </a:p>
           <a:p>
@@ -5009,7 +5018,7 @@
                 </a:solidFill>
                 <a:latin typeface="Arial"/>
               </a:rPr>
-              <a:t>- Operational Deployment Feasibility: </a:t>
+              <a:t>- Deployment Feasibility: </a:t>
             </a:r>
             <a:r>
               <a:rPr sz="1200">
@@ -5018,7 +5027,7 @@
                 </a:solidFill>
                 <a:latin typeface="Arial"/>
               </a:rPr>
-              <a:t>100% Dockerized container stack; operates fully air-gapped without external internet dependencies.</a:t>
+              <a:t>Packaged with Docker for simple 1-click deployment on internal government networks without cloud setup.</a:t>
             </a:r>
           </a:p>
         </p:txBody>
@@ -5049,7 +5058,7 @@
               <a:spcAft>
                 <a:spcPts val="800"/>
               </a:spcAft>
-              <a:defRPr sz="1600" b="1">
+              <a:defRPr sz="1600" b="1" u="sng">
                 <a:solidFill>
                   <a:srgbClr val="1B365D"/>
                 </a:solidFill>
@@ -5069,29 +5078,31 @@
             <a:r>
               <a:rPr b="1" sz="1200">
                 <a:solidFill>
+                  <a:srgbClr val="1B365D"/>
+                </a:solidFill>
+                <a:latin typeface="Arial"/>
+              </a:rPr>
+              <a:t>1. Risk of AI Hallucinations in Summary Briefs
+  </a:t>
+            </a:r>
+            <a:r>
+              <a:rPr sz="1150">
+                <a:solidFill>
+                  <a:srgbClr val="14181E"/>
+                </a:solidFill>
+                <a:latin typeface="Arial"/>
+              </a:rPr>
+              <a:t>Challenge: LLMs can sometimes generate inaccurate numbers or dates. </a:t>
+            </a:r>
+            <a:r>
+              <a:rPr b="1" sz="1150">
+                <a:solidFill>
                   <a:srgbClr val="F37021"/>
                 </a:solidFill>
                 <a:latin typeface="Arial"/>
               </a:rPr>
-              <a:t>1. Risk: AI Hallucinations in Intelligence Briefs | </a:t>
-            </a:r>
-            <a:r>
-              <a:rPr sz="1150">
-                <a:solidFill>
-                  <a:srgbClr val="14181E"/>
-                </a:solidFill>
-                <a:latin typeface="Arial"/>
-              </a:rPr>
-              <a:t>Challenge: Generative models inventing ungrounded facts. </a:t>
-            </a:r>
-            <a:r>
-              <a:rPr b="1" sz="1150">
-                <a:solidFill>
-                  <a:srgbClr val="1B365D"/>
-                </a:solidFill>
-                <a:latin typeface="Arial"/>
-              </a:rPr>
-              <a:t>--&gt; Strategy: Strict RAG constraint boundaries + reverse citation bounding-box coordinate verification for 100% grounded truth.</a:t>
+              <a:t>
+  Solution: Strategy: Use strict retrieval prompts and bind every output sentence to exact source page citations.</a:t>
             </a:r>
           </a:p>
           <a:p>
@@ -5103,29 +5114,31 @@
             <a:r>
               <a:rPr b="1" sz="1200">
                 <a:solidFill>
+                  <a:srgbClr val="1B365D"/>
+                </a:solidFill>
+                <a:latin typeface="Arial"/>
+              </a:rPr>
+              <a:t>2. Data Privacy &amp; Confidentiality
+  </a:t>
+            </a:r>
+            <a:r>
+              <a:rPr sz="1150">
+                <a:solidFill>
+                  <a:srgbClr val="14181E"/>
+                </a:solidFill>
+                <a:latin typeface="Arial"/>
+              </a:rPr>
+              <a:t>Challenge: Sensitive official documents cannot be sent to public AI APIs. </a:t>
+            </a:r>
+            <a:r>
+              <a:rPr b="1" sz="1150">
+                <a:solidFill>
                   <a:srgbClr val="F37021"/>
                 </a:solidFill>
                 <a:latin typeface="Arial"/>
               </a:rPr>
-              <a:t>2. Risk: Classified Data Confidentiality | </a:t>
-            </a:r>
-            <a:r>
-              <a:rPr sz="1150">
-                <a:solidFill>
-                  <a:srgbClr val="14181E"/>
-                </a:solidFill>
-                <a:latin typeface="Arial"/>
-              </a:rPr>
-              <a:t>Challenge: Sensitive intelligence leaked to public cloud APIs. </a:t>
-            </a:r>
-            <a:r>
-              <a:rPr b="1" sz="1150">
-                <a:solidFill>
-                  <a:srgbClr val="1B365D"/>
-                </a:solidFill>
-                <a:latin typeface="Arial"/>
-              </a:rPr>
-              <a:t>--&gt; Strategy: Sovereign on-premise air-gapped deployment with local open-weights (Llama 3/Mistral); zero telemetry.</a:t>
+              <a:t>
+  Solution: Strategy: Host open-source models (Llama 3 / Mistral) entirely on local private servers.</a:t>
             </a:r>
           </a:p>
           <a:p>
@@ -5137,29 +5150,31 @@
             <a:r>
               <a:rPr b="1" sz="1200">
                 <a:solidFill>
+                  <a:srgbClr val="1B365D"/>
+                </a:solidFill>
+                <a:latin typeface="Arial"/>
+              </a:rPr>
+              <a:t>3. Complex Multi-Column Layouts &amp; Tables
+  </a:t>
+            </a:r>
+            <a:r>
+              <a:rPr sz="1150">
+                <a:solidFill>
+                  <a:srgbClr val="14181E"/>
+                </a:solidFill>
+                <a:latin typeface="Arial"/>
+              </a:rPr>
+              <a:t>Challenge: Standard PDF text extractors scramble tables and multi-column text. </a:t>
+            </a:r>
+            <a:r>
+              <a:rPr b="1" sz="1150">
+                <a:solidFill>
                   <a:srgbClr val="F37021"/>
                 </a:solidFill>
                 <a:latin typeface="Arial"/>
               </a:rPr>
-              <a:t>3. Risk: Complex Multi-Column Tables &amp; Diagram Loss | </a:t>
-            </a:r>
-            <a:r>
-              <a:rPr sz="1150">
-                <a:solidFill>
-                  <a:srgbClr val="14181E"/>
-                </a:solidFill>
-                <a:latin typeface="Arial"/>
-              </a:rPr>
-              <a:t>Challenge: Loss of tabular structure during document parsing. </a:t>
-            </a:r>
-            <a:r>
-              <a:rPr b="1" sz="1150">
-                <a:solidFill>
-                  <a:srgbClr val="1B365D"/>
-                </a:solidFill>
-                <a:latin typeface="Arial"/>
-              </a:rPr>
-              <a:t>--&gt; Strategy: Multimodal vision-language parsing (VLM) + Markdown table structure extraction.</a:t>
+              <a:t>
+  Solution: Strategy: Use PyMuPDF spatial coordinate extraction and pdfplumber table bounding boxes.</a:t>
             </a:r>
           </a:p>
         </p:txBody>
@@ -5190,7 +5205,7 @@
         </p:nvSpPr>
         <p:spPr>
           <a:xfrm>
-            <a:off x="502920" y="274320"/>
+            <a:off x="548640" y="274320"/>
             <a:ext cx="1645920" cy="914400"/>
           </a:xfrm>
           <a:prstGeom prst="ellipse">
@@ -5451,7 +5466,7 @@
               <a:spcAft>
                 <a:spcPts val="1000"/>
               </a:spcAft>
-              <a:defRPr sz="1600" b="1">
+              <a:defRPr sz="1600" b="1" u="sng">
                 <a:solidFill>
                   <a:srgbClr val="1B365D"/>
                 </a:solidFill>
@@ -5475,7 +5490,7 @@
                 </a:solidFill>
                 <a:latin typeface="Arial"/>
               </a:rPr>
-              <a:t>- Government &amp; Defense Analysts (NTRO/MoD):
+              <a:t>- Defense &amp; Intelligence Analysts (NTRO / MoD):
   </a:t>
             </a:r>
             <a:r>
@@ -5485,7 +5500,7 @@
                 </a:solidFill>
                 <a:latin typeface="Arial"/>
               </a:rPr>
-              <a:t>Saves 4-6 hours daily per analyst by instantly synthesizing complex intelligence and security advisories into actionable briefs.</a:t>
+              <a:t>Saves 4 to 6 hours daily per analyst by instantly synthesizing long threat advisories and technical reports.</a:t>
             </a:r>
           </a:p>
           <a:p>
@@ -5501,7 +5516,7 @@
                 </a:solidFill>
                 <a:latin typeface="Arial"/>
               </a:rPr>
-              <a:t>- Senior Bureaucrats &amp; C-Suite Executives:
+              <a:t>- Senior Officials &amp; Executives:
   </a:t>
             </a:r>
             <a:r>
@@ -5511,7 +5526,7 @@
                 </a:solidFill>
                 <a:latin typeface="Arial"/>
               </a:rPr>
-              <a:t>Enables immediate decision-making via 1-page executive memos and interactive presentation decks.</a:t>
+              <a:t>Provides 1-page summaries and ready-to-present slide decks for urgent decision meetings.</a:t>
             </a:r>
           </a:p>
           <a:p>
@@ -5537,7 +5552,7 @@
                 </a:solidFill>
                 <a:latin typeface="Arial"/>
               </a:rPr>
-              <a:t>Instant generation of accurate, jargon-free press releases and infographics in multiple regional languages.</a:t>
+              <a:t>Quickly converts technical policy documents into public press releases and infographics in English and regional languages.</a:t>
             </a:r>
           </a:p>
           <a:p>
@@ -5553,7 +5568,7 @@
                 </a:solidFill>
                 <a:latin typeface="Arial"/>
               </a:rPr>
-              <a:t>- Field Personnel &amp; Traveling Officials:
+              <a:t>- Field Staff &amp; Mobile Teams:
   </a:t>
             </a:r>
             <a:r>
@@ -5563,7 +5578,7 @@
                 </a:solidFill>
                 <a:latin typeface="Arial"/>
               </a:rPr>
-              <a:t>Delivers 60-second audio podcast briefings directly to mobile devices.</a:t>
+              <a:t>Allows personnel to listen to 60-second audio podcast briefings on the go.</a:t>
             </a:r>
           </a:p>
         </p:txBody>
@@ -5594,7 +5609,7 @@
               <a:spcAft>
                 <a:spcPts val="1000"/>
               </a:spcAft>
-              <a:defRPr sz="1600" b="1">
+              <a:defRPr sz="1600" b="1" u="sng">
                 <a:solidFill>
                   <a:srgbClr val="1B365D"/>
                 </a:solidFill>
@@ -5602,7 +5617,7 @@
               </a:defRPr>
             </a:pPr>
             <a:r>
-              <a:t>• Benefits of the solution (social, economic, environmental, etc.)</a:t>
+              <a:t>• Benefits of the solution (social, economic, etc.)</a:t>
             </a:r>
           </a:p>
           <a:p>
@@ -5618,7 +5633,7 @@
                 </a:solidFill>
                 <a:latin typeface="Arial"/>
               </a:rPr>
-              <a:t>- Economic Benefits:
+              <a:t>- Time &amp; Cost Savings:
   </a:t>
             </a:r>
             <a:r>
@@ -5628,7 +5643,7 @@
                 </a:solidFill>
                 <a:latin typeface="Arial"/>
               </a:rPr>
-              <a:t>Reduces enterprise document processing costs by 75%; eliminates expensive third-party graphic and presentation outsourcing.</a:t>
+              <a:t>Reduces manual document formatting and translation time by over 80%, saving departmental resources.</a:t>
             </a:r>
           </a:p>
           <a:p>
@@ -5644,7 +5659,7 @@
                 </a:solidFill>
                 <a:latin typeface="Arial"/>
               </a:rPr>
-              <a:t>- Social &amp; Governance Impact:
+              <a:t>- Regional Language Accessibility:
   </a:t>
             </a:r>
             <a:r>
@@ -5654,7 +5669,7 @@
                 </a:solidFill>
                 <a:latin typeface="Arial"/>
               </a:rPr>
-              <a:t>Bridges the communication gap between technical policymakers and general citizens through regional Indic language summaries and visual posters.</a:t>
+              <a:t>Bridges language barriers by translating government policies into Hindi, Kannada, and other Indian languages.</a:t>
             </a:r>
           </a:p>
           <a:p>
@@ -5670,7 +5685,7 @@
                 </a:solidFill>
                 <a:latin typeface="Arial"/>
               </a:rPr>
-              <a:t>- National Security Advantage:
+              <a:t>- Enhanced Information Security:
   </a:t>
             </a:r>
             <a:r>
@@ -5680,7 +5695,7 @@
                 </a:solidFill>
                 <a:latin typeface="Arial"/>
               </a:rPr>
-              <a:t>Maintains tactical information advantage during national security events through instant, multi-format threat dissemination.</a:t>
+              <a:t>100% data remains on internal servers with zero risk of leaks to third-party APIs.</a:t>
             </a:r>
           </a:p>
           <a:p>
@@ -5696,7 +5711,7 @@
                 </a:solidFill>
                 <a:latin typeface="Arial"/>
               </a:rPr>
-              <a:t>- Environmental Sustainability:
+              <a:t>- Eco-Friendly &amp; Paperless:
   </a:t>
             </a:r>
             <a:r>
@@ -5706,7 +5721,7 @@
                 </a:solidFill>
                 <a:latin typeface="Arial"/>
               </a:rPr>
-              <a:t>Drastically cuts down unnecessary paper report printing through interactive digital briefs and mobile voice summaries.</a:t>
+              <a:t>Reduces printing of bulky multi-page reports by providing interactive digital memos and presentations.</a:t>
             </a:r>
           </a:p>
         </p:txBody>
@@ -5737,7 +5752,7 @@
         </p:nvSpPr>
         <p:spPr>
           <a:xfrm>
-            <a:off x="502920" y="274320"/>
+            <a:off x="548640" y="274320"/>
             <a:ext cx="1645920" cy="914400"/>
           </a:xfrm>
           <a:prstGeom prst="ellipse">
@@ -5998,7 +6013,7 @@
               <a:spcAft>
                 <a:spcPts val="1000"/>
               </a:spcAft>
-              <a:defRPr sz="1600" b="1">
+              <a:defRPr sz="1600" b="1" u="sng">
                 <a:solidFill>
                   <a:srgbClr val="1B365D"/>
                 </a:solidFill>
@@ -6022,7 +6037,7 @@
                 </a:solidFill>
                 <a:latin typeface="Arial"/>
               </a:rPr>
-              <a:t>- Lewis et al. (2020):
+              <a:t>- Retrieval-Augmented Generation (RAG):
   </a:t>
             </a:r>
             <a:r>
@@ -6032,7 +6047,7 @@
                 </a:solidFill>
                 <a:latin typeface="Arial"/>
               </a:rPr>
-              <a:t>Retrieval-Augmented Generation for Knowledge-Intensive NLP Tasks (NeurIPS).</a:t>
+              <a:t>Lewis et al. (NeurIPS 2020) — Foundation for verifiable knowledge retrieval.</a:t>
             </a:r>
           </a:p>
           <a:p>
@@ -6048,7 +6063,7 @@
                 </a:solidFill>
                 <a:latin typeface="Arial"/>
               </a:rPr>
-              <a:t>- Touvron et al. (2023/2024):
+              <a:t>- Open-Weight Foundation Models:
   </a:t>
             </a:r>
             <a:r>
@@ -6058,7 +6073,7 @@
                 </a:solidFill>
                 <a:latin typeface="Arial"/>
               </a:rPr>
-              <a:t>Llama 3 &amp; Open Foundation Models for Sovereign Enterprise Reasoning.</a:t>
+              <a:t>Meta Llama 3 &amp; Mistral AI Research Papers on Instruction Tuning (2024).</a:t>
             </a:r>
           </a:p>
           <a:p>
@@ -6074,7 +6089,7 @@
                 </a:solidFill>
                 <a:latin typeface="Arial"/>
               </a:rPr>
-              <a:t>- Vaswani et al. (2017):
+              <a:t>- Multilingual NLP for Indian Languages:
   </a:t>
             </a:r>
             <a:r>
@@ -6084,7 +6099,7 @@
                 </a:solidFill>
                 <a:latin typeface="Arial"/>
               </a:rPr>
-              <a:t>Attention Is All You Need — Transformer Architecture Fundamentals.</a:t>
+              <a:t>AI4Bharat &amp; Bhashini Project Research on IndicBERT (2023).</a:t>
             </a:r>
           </a:p>
           <a:p>
@@ -6100,7 +6115,7 @@
                 </a:solidFill>
                 <a:latin typeface="Arial"/>
               </a:rPr>
-              <a:t>- AI4Bharat / Bhashini (2023):
+              <a:t>- Document Layout Analysis:
   </a:t>
             </a:r>
             <a:r>
@@ -6110,33 +6125,7 @@
                 </a:solidFill>
                 <a:latin typeface="Arial"/>
               </a:rPr>
-              <a:t>IndicBERT &amp; Multilingual Natural Language Architectures for Indian Languages.</a:t>
-            </a:r>
-          </a:p>
-          <a:p>
-            <a:pPr>
-              <a:spcAft>
-                <a:spcPts val="600"/>
-              </a:spcAft>
-            </a:pPr>
-            <a:r>
-              <a:rPr b="1" sz="1200">
-                <a:solidFill>
-                  <a:srgbClr val="1B365D"/>
-                </a:solidFill>
-                <a:latin typeface="Arial"/>
-              </a:rPr>
-              <a:t>- ISO/IEC 27001 &amp; NIST Standards:
-  </a:t>
-            </a:r>
-            <a:r>
-              <a:rPr sz="1150">
-                <a:solidFill>
-                  <a:srgbClr val="14181E"/>
-                </a:solidFill>
-                <a:latin typeface="Arial"/>
-              </a:rPr>
-              <a:t>Cybersecurity &amp; Data Protection Frameworks for Air-Gapped Intelligence.</a:t>
+              <a:t>PyMuPDF spatial coordinate mapping and bounding box extraction standards.</a:t>
             </a:r>
           </a:p>
         </p:txBody>
@@ -6167,7 +6156,7 @@
               <a:spcAft>
                 <a:spcPts val="1000"/>
               </a:spcAft>
-              <a:defRPr sz="1600" b="1">
+              <a:defRPr sz="1600" b="1" u="sng">
                 <a:solidFill>
                   <a:srgbClr val="1B365D"/>
                 </a:solidFill>
@@ -6217,7 +6206,7 @@
                 </a:solidFill>
                 <a:latin typeface="Arial"/>
               </a:rPr>
-              <a:t>- NTRO Official Government Portal:
+              <a:t>- NTRO Official Government Website:
   </a:t>
             </a:r>
             <a:r>
@@ -6243,7 +6232,7 @@
                 </a:solidFill>
                 <a:latin typeface="Arial"/>
               </a:rPr>
-              <a:t>- Live Web Platform &amp; Design System:
+              <a:t>- Live Web Prototype &amp; Design:
   </a:t>
             </a:r>
             <a:r>
@@ -6295,7 +6284,7 @@
                 </a:solidFill>
                 <a:latin typeface="Arial"/>
               </a:rPr>
-              <a:t>- Winning Blueprint &amp; Documentation:
+              <a:t>- Winning Strategy &amp; Technical Documentation:
   </a:t>
             </a:r>
             <a:r>

</xml_diff>

<commit_message>
Update SIH 2026 deck with simple basic English, authentic winning template layout, user stories, and diamond references
</commit_message>
<xml_diff>
--- a/SIH2026_Idea_Presentation_PS26154.pptx
+++ b/SIH2026_Idea_Presentation_PS26154.pptx
@@ -3101,8 +3101,8 @@
         </p:nvSpPr>
         <p:spPr>
           <a:xfrm>
-            <a:off x="731520" y="365760"/>
-            <a:ext cx="10698480" cy="548640"/>
+            <a:off x="731520" y="548640"/>
+            <a:ext cx="10698480" cy="731520"/>
           </a:xfrm>
           <a:prstGeom prst="rect">
             <a:avLst/>
@@ -3115,8 +3115,8 @@
           </a:bodyPr>
           <a:lstStyle/>
           <a:p>
-            <a:pPr algn="ctr">
-              <a:defRPr sz="2800" b="1">
+            <a:pPr algn="l">
+              <a:defRPr sz="3200" b="1">
                 <a:solidFill>
                   <a:srgbClr val="1B365D"/>
                 </a:solidFill>
@@ -3137,8 +3137,8 @@
         </p:nvSpPr>
         <p:spPr>
           <a:xfrm>
-            <a:off x="731520" y="1005840"/>
-            <a:ext cx="10698480" cy="457200"/>
+            <a:off x="731520" y="1463040"/>
+            <a:ext cx="7498079" cy="4754880"/>
           </a:xfrm>
           <a:prstGeom prst="rect">
             <a:avLst/>
@@ -3146,42 +3146,6 @@
           <a:noFill/>
         </p:spPr>
         <p:txBody>
-          <a:bodyPr wrap="none">
-            <a:spAutoFit/>
-          </a:bodyPr>
-          <a:lstStyle/>
-          <a:p>
-            <a:pPr algn="ctr">
-              <a:defRPr sz="2200" b="1">
-                <a:solidFill>
-                  <a:srgbClr val="14181E"/>
-                </a:solidFill>
-                <a:latin typeface="Times New Roman"/>
-              </a:defRPr>
-            </a:pPr>
-            <a:r>
-              <a:t>TITLE PAGE</a:t>
-            </a:r>
-          </a:p>
-        </p:txBody>
-      </p:sp>
-      <p:sp>
-        <p:nvSpPr>
-          <p:cNvPr id="4" name="TextBox 3"/>
-          <p:cNvSpPr txBox="1"/>
-          <p:nvPr/>
-        </p:nvSpPr>
-        <p:spPr>
-          <a:xfrm>
-            <a:off x="731520" y="1645920"/>
-            <a:ext cx="7132320" cy="4663440"/>
-          </a:xfrm>
-          <a:prstGeom prst="rect">
-            <a:avLst/>
-          </a:prstGeom>
-          <a:noFill/>
-        </p:spPr>
-        <p:txBody>
           <a:bodyPr wrap="square">
             <a:spAutoFit/>
           </a:bodyPr>
@@ -3189,208 +3153,158 @@
           <a:p>
             <a:pPr>
               <a:spcAft>
-                <a:spcPts val="1000"/>
+                <a:spcPts val="1400"/>
               </a:spcAft>
             </a:pPr>
             <a:r>
-              <a:rPr b="1" sz="1400">
-                <a:solidFill>
-                  <a:srgbClr val="1B365D"/>
+              <a:rPr b="1" sz="1800">
+                <a:solidFill>
+                  <a:srgbClr val="141414"/>
                 </a:solidFill>
                 <a:latin typeface="Times New Roman"/>
               </a:rPr>
-              <a:t>• Problem Statement ID –</a:t>
-            </a:r>
-            <a:r>
-              <a:rPr sz="1400" b="1">
-                <a:solidFill>
-                  <a:srgbClr val="F37021"/>
-                </a:solidFill>
-                <a:latin typeface="Times New Roman"/>
-              </a:rPr>
-              <a:t> 26154</a:t>
+              <a:t>• Problem Statement ID – </a:t>
+            </a:r>
+            <a:r>
+              <a:rPr b="1" sz="1800">
+                <a:solidFill>
+                  <a:srgbClr val="141414"/>
+                </a:solidFill>
+                <a:latin typeface="Arial"/>
+              </a:rPr>
+              <a:t>26154</a:t>
             </a:r>
           </a:p>
           <a:p>
             <a:pPr>
               <a:spcAft>
-                <a:spcPts val="1000"/>
+                <a:spcPts val="1400"/>
               </a:spcAft>
             </a:pPr>
             <a:r>
-              <a:rPr b="1" sz="1400">
-                <a:solidFill>
-                  <a:srgbClr val="1B365D"/>
+              <a:rPr b="1" sz="1800">
+                <a:solidFill>
+                  <a:srgbClr val="141414"/>
                 </a:solidFill>
                 <a:latin typeface="Times New Roman"/>
               </a:rPr>
-              <a:t>• Problem Statement Title –</a:t>
-            </a:r>
-            <a:r>
-              <a:rPr sz="1400" b="1">
-                <a:solidFill>
-                  <a:srgbClr val="14181E"/>
-                </a:solidFill>
-                <a:latin typeface="Times New Roman"/>
-              </a:rPr>
-              <a:t> Gen AI Platform for Automated Content Transformation</a:t>
+              <a:t>• Problem Statement Title - </a:t>
+            </a:r>
+            <a:r>
+              <a:rPr b="1" sz="1800">
+                <a:solidFill>
+                  <a:srgbClr val="141414"/>
+                </a:solidFill>
+                <a:latin typeface="Arial"/>
+              </a:rPr>
+              <a:t>Gen AI Platform for Automated Content Transformation</a:t>
             </a:r>
           </a:p>
           <a:p>
             <a:pPr>
               <a:spcAft>
-                <a:spcPts val="1000"/>
+                <a:spcPts val="1400"/>
               </a:spcAft>
             </a:pPr>
             <a:r>
-              <a:rPr b="1" sz="1400">
-                <a:solidFill>
-                  <a:srgbClr val="1B365D"/>
+              <a:rPr b="1" sz="1800">
+                <a:solidFill>
+                  <a:srgbClr val="141414"/>
                 </a:solidFill>
                 <a:latin typeface="Times New Roman"/>
               </a:rPr>
-              <a:t>• Theme –</a:t>
-            </a:r>
-            <a:r>
-              <a:rPr sz="1400" b="0">
-                <a:solidFill>
-                  <a:srgbClr val="14181E"/>
-                </a:solidFill>
-                <a:latin typeface="Arial"/>
-              </a:rPr>
-              <a:t> Blockchain &amp; Cybersecurity / AI</a:t>
+              <a:t>• Theme - </a:t>
+            </a:r>
+            <a:r>
+              <a:rPr b="0" sz="1800">
+                <a:solidFill>
+                  <a:srgbClr val="141414"/>
+                </a:solidFill>
+                <a:latin typeface="Arial"/>
+              </a:rPr>
+              <a:t>Miscellaneous / AI</a:t>
             </a:r>
           </a:p>
           <a:p>
             <a:pPr>
               <a:spcAft>
-                <a:spcPts val="1000"/>
+                <a:spcPts val="1400"/>
               </a:spcAft>
             </a:pPr>
             <a:r>
-              <a:rPr b="1" sz="1400">
-                <a:solidFill>
-                  <a:srgbClr val="1B365D"/>
+              <a:rPr b="1" sz="1800">
+                <a:solidFill>
+                  <a:srgbClr val="141414"/>
                 </a:solidFill>
                 <a:latin typeface="Times New Roman"/>
               </a:rPr>
-              <a:t>• PS Category –</a:t>
-            </a:r>
-            <a:r>
-              <a:rPr sz="1400" b="0">
-                <a:solidFill>
-                  <a:srgbClr val="14181E"/>
-                </a:solidFill>
-                <a:latin typeface="Arial"/>
-              </a:rPr>
-              <a:t> Software</a:t>
+              <a:t>• PS Category - </a:t>
+            </a:r>
+            <a:r>
+              <a:rPr b="0" sz="1800">
+                <a:solidFill>
+                  <a:srgbClr val="141414"/>
+                </a:solidFill>
+                <a:latin typeface="Arial"/>
+              </a:rPr>
+              <a:t>Software</a:t>
             </a:r>
           </a:p>
           <a:p>
             <a:pPr>
               <a:spcAft>
-                <a:spcPts val="1000"/>
+                <a:spcPts val="1400"/>
               </a:spcAft>
             </a:pPr>
             <a:r>
-              <a:rPr b="1" sz="1400">
-                <a:solidFill>
-                  <a:srgbClr val="1B365D"/>
+              <a:rPr b="1" sz="1800">
+                <a:solidFill>
+                  <a:srgbClr val="141414"/>
                 </a:solidFill>
                 <a:latin typeface="Times New Roman"/>
               </a:rPr>
-              <a:t>• Organization –</a:t>
-            </a:r>
-            <a:r>
-              <a:rPr sz="1400" b="0">
-                <a:solidFill>
-                  <a:srgbClr val="14181E"/>
-                </a:solidFill>
-                <a:latin typeface="Arial"/>
-              </a:rPr>
-              <a:t> National Technical Research Organisation (NTRO)</a:t>
+              <a:t>• Team ID - </a:t>
+            </a:r>
+            <a:r>
+              <a:rPr b="0" sz="1800">
+                <a:solidFill>
+                  <a:srgbClr val="141414"/>
+                </a:solidFill>
+                <a:latin typeface="Arial"/>
+              </a:rPr>
+              <a:t>104580</a:t>
             </a:r>
           </a:p>
           <a:p>
             <a:pPr>
               <a:spcAft>
-                <a:spcPts val="1000"/>
+                <a:spcPts val="1400"/>
               </a:spcAft>
             </a:pPr>
             <a:r>
-              <a:rPr b="1" sz="1400">
-                <a:solidFill>
-                  <a:srgbClr val="1B365D"/>
+              <a:rPr b="1" sz="1800">
+                <a:solidFill>
+                  <a:srgbClr val="141414"/>
                 </a:solidFill>
                 <a:latin typeface="Times New Roman"/>
               </a:rPr>
-              <a:t>• Team ID –</a:t>
-            </a:r>
-            <a:r>
-              <a:rPr sz="1400" b="0">
-                <a:solidFill>
-                  <a:srgbClr val="14181E"/>
-                </a:solidFill>
-                <a:latin typeface="Arial"/>
-              </a:rPr>
-              <a:t> [Registered Team ID on Portal]</a:t>
-            </a:r>
-          </a:p>
-          <a:p>
-            <a:pPr>
-              <a:spcAft>
-                <a:spcPts val="1000"/>
-              </a:spcAft>
-            </a:pPr>
-            <a:r>
-              <a:rPr b="1" sz="1400">
-                <a:solidFill>
-                  <a:srgbClr val="1B365D"/>
-                </a:solidFill>
-                <a:latin typeface="Times New Roman"/>
-              </a:rPr>
-              <a:t>• Team Name (Registered on portal) –</a:t>
-            </a:r>
-            <a:r>
-              <a:rPr sz="1400" b="1">
-                <a:solidFill>
-                  <a:srgbClr val="14181E"/>
-                </a:solidFill>
-                <a:latin typeface="Times New Roman"/>
-              </a:rPr>
-              <a:t> OmniTransform</a:t>
-            </a:r>
-          </a:p>
-          <a:p>
-            <a:pPr>
-              <a:spcAft>
-                <a:spcPts val="1000"/>
-              </a:spcAft>
-            </a:pPr>
-            <a:r>
-              <a:rPr b="1" sz="1400">
-                <a:solidFill>
-                  <a:srgbClr val="1B365D"/>
-                </a:solidFill>
-                <a:latin typeface="Times New Roman"/>
-              </a:rPr>
-              <a:t>• Idea Title –</a:t>
-            </a:r>
-            <a:r>
-              <a:rPr sz="1400" b="1">
-                <a:solidFill>
-                  <a:srgbClr val="14181E"/>
-                </a:solidFill>
-                <a:latin typeface="Times New Roman"/>
-              </a:rPr>
-              <a:t> OmniTransform AI - Automated Multi-Format Content Platform</a:t>
+              <a:t>• Team Name - </a:t>
+            </a:r>
+            <a:r>
+              <a:rPr b="1" sz="1800">
+                <a:solidFill>
+                  <a:srgbClr val="141414"/>
+                </a:solidFill>
+                <a:latin typeface="Arial"/>
+              </a:rPr>
+              <a:t>OmniTransform</a:t>
             </a:r>
           </a:p>
         </p:txBody>
       </p:sp>
       <p:pic>
         <p:nvPicPr>
-          <p:cNvPr id="5" name="Picture 4" descr="sih_official_logo.png"/>
+          <p:cNvPr id="4" name="Picture 3" descr="sih_official_logo.png"/>
           <p:cNvPicPr>
             <a:picLocks noChangeAspect="1"/>
           </p:cNvPicPr>
@@ -3404,8 +3318,8 @@
         </p:blipFill>
         <p:spPr>
           <a:xfrm>
-            <a:off x="8046720" y="1828800"/>
-            <a:ext cx="3474720" cy="1789308"/>
+            <a:off x="8412480" y="1645920"/>
+            <a:ext cx="3291840" cy="1695134"/>
           </a:xfrm>
           <a:prstGeom prst="rect">
             <a:avLst/>
@@ -3438,8 +3352,8 @@
         </p:nvSpPr>
         <p:spPr>
           <a:xfrm>
-            <a:off x="548640" y="274320"/>
-            <a:ext cx="1645920" cy="914400"/>
+            <a:off x="365760" y="182880"/>
+            <a:ext cx="1645920" cy="868680"/>
           </a:xfrm>
           <a:prstGeom prst="ellipse">
             <a:avLst/>
@@ -3472,28 +3386,15 @@
           <a:lstStyle/>
           <a:p>
             <a:pPr algn="ctr">
-              <a:defRPr sz="1100">
-                <a:solidFill>
-                  <a:srgbClr val="14181E"/>
+              <a:defRPr sz="1200" b="1">
+                <a:solidFill>
+                  <a:srgbClr val="1B365D"/>
                 </a:solidFill>
                 <a:latin typeface="Arial"/>
               </a:defRPr>
             </a:pPr>
             <a:r>
-              <a:t>Your Team</a:t>
-            </a:r>
-          </a:p>
-          <a:p>
-            <a:pPr algn="ctr">
-              <a:defRPr sz="1100">
-                <a:solidFill>
-                  <a:srgbClr val="14181E"/>
-                </a:solidFill>
-                <a:latin typeface="Arial"/>
-              </a:defRPr>
-            </a:pPr>
-            <a:r>
-              <a:t>Name</a:t>
+              <a:t>OmniTransform</a:t>
             </a:r>
           </a:p>
         </p:txBody>
@@ -3506,8 +3407,8 @@
         </p:nvSpPr>
         <p:spPr>
           <a:xfrm>
-            <a:off x="2286000" y="320040"/>
-            <a:ext cx="6217920" cy="777240"/>
+            <a:off x="2103120" y="228600"/>
+            <a:ext cx="6766560" cy="777240"/>
           </a:xfrm>
           <a:prstGeom prst="rect">
             <a:avLst/>
@@ -3521,7 +3422,7 @@
           <a:lstStyle/>
           <a:p>
             <a:pPr algn="ctr">
-              <a:defRPr sz="2600" b="1">
+              <a:defRPr sz="2200" b="1">
                 <a:solidFill>
                   <a:srgbClr val="1B365D"/>
                 </a:solidFill>
@@ -3529,7 +3430,7 @@
               </a:defRPr>
             </a:pPr>
             <a:r>
-              <a:t>IDEA TITLE: OmniTransform AI</a:t>
+              <a:t>OMNITRANSFORM (ALL-IN-ONE) AI CONTENT PLATFORM</a:t>
             </a:r>
           </a:p>
         </p:txBody>
@@ -3550,8 +3451,8 @@
         </p:blipFill>
         <p:spPr>
           <a:xfrm>
-            <a:off x="8961120" y="228600"/>
-            <a:ext cx="2743200" cy="1412611"/>
+            <a:off x="9144000" y="164592"/>
+            <a:ext cx="2560320" cy="1318437"/>
           </a:xfrm>
           <a:prstGeom prst="rect">
             <a:avLst/>
@@ -3675,449 +3576,735 @@
       </p:sp>
       <p:sp>
         <p:nvSpPr>
-          <p:cNvPr id="8" name="TextBox 7"/>
-          <p:cNvSpPr txBox="1"/>
+          <p:cNvPr id="8" name="Rectangle 7"/>
+          <p:cNvSpPr/>
           <p:nvPr/>
         </p:nvSpPr>
         <p:spPr>
           <a:xfrm>
-            <a:off x="731520" y="1234440"/>
-            <a:ext cx="10698480" cy="457200"/>
+            <a:off x="548640" y="1188720"/>
+            <a:ext cx="3474720" cy="411480"/>
           </a:xfrm>
           <a:prstGeom prst="rect">
             <a:avLst/>
           </a:prstGeom>
-          <a:noFill/>
-        </p:spPr>
-        <p:txBody>
-          <a:bodyPr wrap="none">
-            <a:spAutoFit/>
-          </a:bodyPr>
-          <a:lstStyle/>
-          <a:p>
-            <a:pPr>
-              <a:defRPr sz="1800" b="1" u="sng">
-                <a:solidFill>
-                  <a:srgbClr val="1B365D"/>
-                </a:solidFill>
-                <a:latin typeface="Times New Roman"/>
+          <a:solidFill>
+            <a:srgbClr val="6AA84F"/>
+          </a:solidFill>
+          <a:ln>
+            <a:noFill/>
+          </a:ln>
+        </p:spPr>
+        <p:style>
+          <a:lnRef idx="1">
+            <a:schemeClr val="accent1"/>
+          </a:lnRef>
+          <a:fillRef idx="3">
+            <a:schemeClr val="accent1"/>
+          </a:fillRef>
+          <a:effectRef idx="2">
+            <a:schemeClr val="accent1"/>
+          </a:effectRef>
+          <a:fontRef idx="minor">
+            <a:schemeClr val="lt1"/>
+          </a:fontRef>
+        </p:style>
+        <p:txBody>
+          <a:bodyPr rtlCol="0" anchor="ctr"/>
+          <a:lstStyle/>
+          <a:p>
+            <a:pPr algn="ctr">
+              <a:defRPr sz="1300" b="1">
+                <a:solidFill>
+                  <a:srgbClr val="FFFFFF"/>
+                </a:solidFill>
+                <a:latin typeface="Arial"/>
               </a:defRPr>
             </a:pPr>
             <a:r>
-              <a:t>• Proposed Solution (Describe your Idea/Solution/Prototype)</a:t>
-            </a:r>
-          </a:p>
-        </p:txBody>
-      </p:sp>
-      <p:sp>
-        <p:nvSpPr>
-          <p:cNvPr id="9" name="TextBox 8"/>
-          <p:cNvSpPr txBox="1"/>
+              <a:t>Proposed Solution Overview</a:t>
+            </a:r>
+          </a:p>
+        </p:txBody>
+      </p:sp>
+      <p:sp>
+        <p:nvSpPr>
+          <p:cNvPr id="9" name="Rectangle 8"/>
+          <p:cNvSpPr/>
           <p:nvPr/>
         </p:nvSpPr>
         <p:spPr>
           <a:xfrm>
-            <a:off x="731520" y="1828800"/>
-            <a:ext cx="3383280" cy="4389120"/>
+            <a:off x="548640" y="1600200"/>
+            <a:ext cx="3474720" cy="4617720"/>
           </a:xfrm>
           <a:prstGeom prst="rect">
             <a:avLst/>
           </a:prstGeom>
-          <a:noFill/>
-        </p:spPr>
-        <p:txBody>
-          <a:bodyPr wrap="square">
-            <a:spAutoFit/>
-          </a:bodyPr>
-          <a:lstStyle/>
+          <a:solidFill>
+            <a:srgbClr val="F5F8FA"/>
+          </a:solidFill>
+          <a:ln w="12700">
+            <a:solidFill>
+              <a:srgbClr val="D2DCE6"/>
+            </a:solidFill>
+          </a:ln>
+        </p:spPr>
+        <p:style>
+          <a:lnRef idx="1">
+            <a:schemeClr val="accent1"/>
+          </a:lnRef>
+          <a:fillRef idx="3">
+            <a:schemeClr val="accent1"/>
+          </a:fillRef>
+          <a:effectRef idx="2">
+            <a:schemeClr val="accent1"/>
+          </a:effectRef>
+          <a:fontRef idx="minor">
+            <a:schemeClr val="lt1"/>
+          </a:fontRef>
+        </p:style>
+        <p:txBody>
+          <a:bodyPr rtlCol="0" anchor="ctr" wrap="square" lIns="164592" tIns="164592" rIns="164592"/>
+          <a:lstStyle/>
+          <a:p>
+            <a:pPr algn="ctr">
+              <a:spcAft>
+                <a:spcPts val="700"/>
+              </a:spcAft>
+            </a:pPr>
+            <a:r>
+              <a:rPr b="1" sz="1100">
+                <a:solidFill>
+                  <a:srgbClr val="141414"/>
+                </a:solidFill>
+                <a:latin typeface="Arial"/>
+              </a:rPr>
+              <a:t>● Simple Web Platform: </a:t>
+            </a:r>
+            <a:r>
+              <a:rPr sz="1050">
+                <a:solidFill>
+                  <a:srgbClr val="141414"/>
+                </a:solidFill>
+                <a:latin typeface="Arial"/>
+              </a:rPr>
+              <a:t>A clean and fast web application built for government officers, analysts, and students.</a:t>
+            </a:r>
+          </a:p>
           <a:p>
             <a:pPr>
               <a:spcAft>
-                <a:spcPts val="800"/>
+                <a:spcPts val="700"/>
               </a:spcAft>
-              <a:defRPr sz="1400" b="1">
-                <a:solidFill>
-                  <a:srgbClr val="1B365D"/>
-                </a:solidFill>
-                <a:latin typeface="Times New Roman"/>
-              </a:defRPr>
-            </a:pPr>
-            <a:r>
-              <a:t>• Detailed explanation of the proposed solution</a:t>
+            </a:pPr>
+            <a:r>
+              <a:rPr b="1" sz="1100">
+                <a:solidFill>
+                  <a:srgbClr val="141414"/>
+                </a:solidFill>
+                <a:latin typeface="Arial"/>
+              </a:rPr>
+              <a:t>● Upload Any Document: </a:t>
+            </a:r>
+            <a:r>
+              <a:rPr sz="1050">
+                <a:solidFill>
+                  <a:srgbClr val="141414"/>
+                </a:solidFill>
+                <a:latin typeface="Arial"/>
+              </a:rPr>
+              <a:t>Takes long PDFs, research whitepapers, and government reports up to 100+ pages.</a:t>
             </a:r>
           </a:p>
           <a:p>
             <a:pPr>
               <a:spcAft>
-                <a:spcPts val="800"/>
+                <a:spcPts val="700"/>
               </a:spcAft>
-              <a:defRPr sz="1200">
-                <a:solidFill>
-                  <a:srgbClr val="14181E"/>
-                </a:solidFill>
-                <a:latin typeface="Arial"/>
-              </a:defRPr>
-            </a:pPr>
-            <a:r>
-              <a:t>An automated system that ingests long PDFs, security advisories, and policy whitepapers, converting them into 5 ready-to-use formats in under 10 seconds:</a:t>
+            </a:pPr>
+            <a:r>
+              <a:rPr b="1" sz="1100">
+                <a:solidFill>
+                  <a:srgbClr val="141414"/>
+                </a:solidFill>
+                <a:latin typeface="Arial"/>
+              </a:rPr>
+              <a:t>● 5 Output Formats in Seconds: </a:t>
+            </a:r>
+            <a:r>
+              <a:rPr sz="1050">
+                <a:solidFill>
+                  <a:srgbClr val="141414"/>
+                </a:solidFill>
+                <a:latin typeface="Arial"/>
+              </a:rPr>
+              <a:t>Automatically creates 1-page memo, presentation slides, infographics, press release, and 60s voice audio.</a:t>
             </a:r>
           </a:p>
           <a:p>
             <a:pPr>
               <a:spcAft>
-                <a:spcPts val="400"/>
+                <a:spcPts val="700"/>
               </a:spcAft>
-              <a:defRPr sz="1150">
-                <a:solidFill>
-                  <a:srgbClr val="14181E"/>
-                </a:solidFill>
-                <a:latin typeface="Arial"/>
-              </a:defRPr>
-            </a:pPr>
-            <a:r>
-              <a:t>   1. 1-Page Executive Summary Memo</a:t>
+            </a:pPr>
+            <a:r>
+              <a:rPr b="1" sz="1100">
+                <a:solidFill>
+                  <a:srgbClr val="141414"/>
+                </a:solidFill>
+                <a:latin typeface="Arial"/>
+              </a:rPr>
+              <a:t>● Saves Hours of Manual Work: </a:t>
+            </a:r>
+            <a:r>
+              <a:rPr sz="1050">
+                <a:solidFill>
+                  <a:srgbClr val="141414"/>
+                </a:solidFill>
+                <a:latin typeface="Arial"/>
+              </a:rPr>
+              <a:t>Officers save 4 to 6 hours daily spent on manually typing summaries and designing PPTs.</a:t>
             </a:r>
           </a:p>
           <a:p>
             <a:pPr>
               <a:spcAft>
-                <a:spcPts val="400"/>
+                <a:spcPts val="700"/>
               </a:spcAft>
-              <a:defRPr sz="1150">
-                <a:solidFill>
-                  <a:srgbClr val="14181E"/>
-                </a:solidFill>
-                <a:latin typeface="Arial"/>
-              </a:defRPr>
-            </a:pPr>
-            <a:r>
-              <a:t>   2. Presentation Slide Deck</a:t>
+            </a:pPr>
+            <a:r>
+              <a:rPr b="1" sz="1100">
+                <a:solidFill>
+                  <a:srgbClr val="141414"/>
+                </a:solidFill>
+                <a:latin typeface="Arial"/>
+              </a:rPr>
+              <a:t>● Accurate Page References: </a:t>
+            </a:r>
+            <a:r>
+              <a:rPr sz="1050">
+                <a:solidFill>
+                  <a:srgbClr val="141414"/>
+                </a:solidFill>
+                <a:latin typeface="Arial"/>
+              </a:rPr>
+              <a:t>Every bullet point links directly to the exact page and line in the original PDF file.</a:t>
             </a:r>
           </a:p>
           <a:p>
             <a:pPr>
               <a:spcAft>
-                <a:spcPts val="400"/>
+                <a:spcPts val="700"/>
               </a:spcAft>
-              <a:defRPr sz="1150">
-                <a:solidFill>
-                  <a:srgbClr val="14181E"/>
-                </a:solidFill>
-                <a:latin typeface="Arial"/>
-              </a:defRPr>
-            </a:pPr>
-            <a:r>
-              <a:t>   3. Infographics &amp; Visual Data Cards</a:t>
-            </a:r>
-          </a:p>
-          <a:p>
-            <a:pPr>
-              <a:spcAft>
-                <a:spcPts val="400"/>
-              </a:spcAft>
-              <a:defRPr sz="1150">
-                <a:solidFill>
-                  <a:srgbClr val="14181E"/>
-                </a:solidFill>
-                <a:latin typeface="Arial"/>
-              </a:defRPr>
-            </a:pPr>
-            <a:r>
-              <a:t>   4. Multilingual Press Release (English &amp; Regional)</a:t>
-            </a:r>
-          </a:p>
-          <a:p>
-            <a:pPr>
-              <a:spcAft>
-                <a:spcPts val="400"/>
-              </a:spcAft>
-              <a:defRPr sz="1150">
-                <a:solidFill>
-                  <a:srgbClr val="14181E"/>
-                </a:solidFill>
-                <a:latin typeface="Arial"/>
-              </a:defRPr>
-            </a:pPr>
-            <a:r>
-              <a:t>   5. 60-Second Voice Audio Briefing</a:t>
-            </a:r>
-          </a:p>
-        </p:txBody>
-      </p:sp>
-      <p:sp>
-        <p:nvSpPr>
-          <p:cNvPr id="10" name="TextBox 9"/>
-          <p:cNvSpPr txBox="1"/>
+            </a:pPr>
+            <a:r>
+              <a:rPr b="1" sz="1100">
+                <a:solidFill>
+                  <a:srgbClr val="141414"/>
+                </a:solidFill>
+                <a:latin typeface="Arial"/>
+              </a:rPr>
+              <a:t>● Works 100% Offline: </a:t>
+            </a:r>
+            <a:r>
+              <a:rPr sz="1050">
+                <a:solidFill>
+                  <a:srgbClr val="141414"/>
+                </a:solidFill>
+                <a:latin typeface="Arial"/>
+              </a:rPr>
+              <a:t>Can be installed on local office servers without sending sensitive data to the internet.</a:t>
+            </a:r>
+          </a:p>
+        </p:txBody>
+      </p:sp>
+      <p:sp>
+        <p:nvSpPr>
+          <p:cNvPr id="10" name="Rectangle 9"/>
+          <p:cNvSpPr/>
           <p:nvPr/>
         </p:nvSpPr>
         <p:spPr>
           <a:xfrm>
-            <a:off x="4434840" y="1828800"/>
-            <a:ext cx="3383280" cy="4389120"/>
+            <a:off x="4297680" y="1188720"/>
+            <a:ext cx="3474720" cy="411480"/>
           </a:xfrm>
           <a:prstGeom prst="rect">
             <a:avLst/>
           </a:prstGeom>
-          <a:noFill/>
-        </p:spPr>
-        <p:txBody>
-          <a:bodyPr wrap="square">
-            <a:spAutoFit/>
-          </a:bodyPr>
-          <a:lstStyle/>
-          <a:p>
-            <a:pPr>
-              <a:spcAft>
-                <a:spcPts val="800"/>
-              </a:spcAft>
-              <a:defRPr sz="1400" b="1">
-                <a:solidFill>
-                  <a:srgbClr val="1B365D"/>
-                </a:solidFill>
-                <a:latin typeface="Times New Roman"/>
+          <a:solidFill>
+            <a:srgbClr val="3C788C"/>
+          </a:solidFill>
+          <a:ln>
+            <a:noFill/>
+          </a:ln>
+        </p:spPr>
+        <p:style>
+          <a:lnRef idx="1">
+            <a:schemeClr val="accent1"/>
+          </a:lnRef>
+          <a:fillRef idx="3">
+            <a:schemeClr val="accent1"/>
+          </a:fillRef>
+          <a:effectRef idx="2">
+            <a:schemeClr val="accent1"/>
+          </a:effectRef>
+          <a:fontRef idx="minor">
+            <a:schemeClr val="lt1"/>
+          </a:fontRef>
+        </p:style>
+        <p:txBody>
+          <a:bodyPr rtlCol="0" anchor="ctr"/>
+          <a:lstStyle/>
+          <a:p>
+            <a:pPr algn="ctr">
+              <a:defRPr sz="1300" b="1">
+                <a:solidFill>
+                  <a:srgbClr val="FFFFFF"/>
+                </a:solidFill>
+                <a:latin typeface="Arial"/>
               </a:defRPr>
             </a:pPr>
             <a:r>
-              <a:t>• How it addresses the problem</a:t>
-            </a:r>
-          </a:p>
-          <a:p>
-            <a:pPr>
-              <a:spcAft>
-                <a:spcPts val="800"/>
-              </a:spcAft>
-            </a:pPr>
-            <a:r>
-              <a:rPr b="1" sz="1200">
-                <a:solidFill>
-                  <a:srgbClr val="1B365D"/>
-                </a:solidFill>
-                <a:latin typeface="Arial"/>
-              </a:rPr>
-              <a:t>- Saves Analyst Time: </a:t>
-            </a:r>
-            <a:r>
-              <a:rPr sz="1200">
-                <a:solidFill>
-                  <a:srgbClr val="14181E"/>
-                </a:solidFill>
-                <a:latin typeface="Arial"/>
-              </a:rPr>
-              <a:t>Officers spend 4–6 hours daily converting reports into slides and briefs. OmniTransform automates this in seconds.</a:t>
-            </a:r>
-          </a:p>
-          <a:p>
-            <a:pPr>
-              <a:spcAft>
-                <a:spcPts val="800"/>
-              </a:spcAft>
-            </a:pPr>
-            <a:r>
-              <a:rPr b="1" sz="1200">
-                <a:solidFill>
-                  <a:srgbClr val="1B365D"/>
-                </a:solidFill>
-                <a:latin typeface="Arial"/>
-              </a:rPr>
-              <a:t>- Eliminates Multiple Tools: </a:t>
-            </a:r>
-            <a:r>
-              <a:rPr sz="1200">
-                <a:solidFill>
-                  <a:srgbClr val="14181E"/>
-                </a:solidFill>
-                <a:latin typeface="Arial"/>
-              </a:rPr>
-              <a:t>Replaces separate design, translation, and summary tools with one integrated workflow.</a:t>
-            </a:r>
-          </a:p>
-          <a:p>
-            <a:pPr>
-              <a:spcAft>
-                <a:spcPts val="800"/>
-              </a:spcAft>
-            </a:pPr>
-            <a:r>
-              <a:rPr b="1" sz="1200">
-                <a:solidFill>
-                  <a:srgbClr val="1B365D"/>
-                </a:solidFill>
-                <a:latin typeface="Arial"/>
-              </a:rPr>
-              <a:t>- Enables Fast Decision Making: </a:t>
-            </a:r>
-            <a:r>
-              <a:rPr sz="1200">
-                <a:solidFill>
-                  <a:srgbClr val="14181E"/>
-                </a:solidFill>
-                <a:latin typeface="Arial"/>
-              </a:rPr>
-              <a:t>Executives and leaders can quickly review key takeaways during critical events.</a:t>
-            </a:r>
-          </a:p>
-          <a:p>
-            <a:pPr>
-              <a:spcAft>
-                <a:spcPts val="800"/>
-              </a:spcAft>
-            </a:pPr>
-            <a:r>
-              <a:rPr b="1" sz="1200">
-                <a:solidFill>
-                  <a:srgbClr val="1B365D"/>
-                </a:solidFill>
-                <a:latin typeface="Arial"/>
-              </a:rPr>
-              <a:t>- Accurate &amp; Verifiable: </a:t>
-            </a:r>
-            <a:r>
-              <a:rPr sz="1200">
-                <a:solidFill>
-                  <a:srgbClr val="14181E"/>
-                </a:solidFill>
-                <a:latin typeface="Arial"/>
-              </a:rPr>
-              <a:t>Every generated point links back directly to the source page in the PDF.</a:t>
-            </a:r>
-          </a:p>
-        </p:txBody>
-      </p:sp>
-      <p:sp>
-        <p:nvSpPr>
-          <p:cNvPr id="11" name="TextBox 10"/>
-          <p:cNvSpPr txBox="1"/>
+              <a:t>Key Feature &amp; Technology</a:t>
+            </a:r>
+          </a:p>
+        </p:txBody>
+      </p:sp>
+      <p:sp>
+        <p:nvSpPr>
+          <p:cNvPr id="11" name="Rectangle 10"/>
+          <p:cNvSpPr/>
           <p:nvPr/>
         </p:nvSpPr>
         <p:spPr>
           <a:xfrm>
-            <a:off x="8138160" y="1828800"/>
-            <a:ext cx="3383280" cy="4389120"/>
+            <a:off x="4297680" y="1600200"/>
+            <a:ext cx="3474720" cy="4617720"/>
           </a:xfrm>
           <a:prstGeom prst="rect">
             <a:avLst/>
           </a:prstGeom>
-          <a:noFill/>
-        </p:spPr>
-        <p:txBody>
-          <a:bodyPr wrap="square">
-            <a:spAutoFit/>
-          </a:bodyPr>
-          <a:lstStyle/>
+          <a:solidFill>
+            <a:srgbClr val="F5F8FA"/>
+          </a:solidFill>
+          <a:ln w="12700">
+            <a:solidFill>
+              <a:srgbClr val="D2DCE6"/>
+            </a:solidFill>
+          </a:ln>
+        </p:spPr>
+        <p:style>
+          <a:lnRef idx="1">
+            <a:schemeClr val="accent1"/>
+          </a:lnRef>
+          <a:fillRef idx="3">
+            <a:schemeClr val="accent1"/>
+          </a:fillRef>
+          <a:effectRef idx="2">
+            <a:schemeClr val="accent1"/>
+          </a:effectRef>
+          <a:fontRef idx="minor">
+            <a:schemeClr val="lt1"/>
+          </a:fontRef>
+        </p:style>
+        <p:txBody>
+          <a:bodyPr rtlCol="0" anchor="ctr" wrap="square" lIns="164592" tIns="164592" rIns="164592"/>
+          <a:lstStyle/>
+          <a:p>
+            <a:pPr algn="ctr">
+              <a:spcAft>
+                <a:spcPts val="700"/>
+              </a:spcAft>
+            </a:pPr>
+            <a:r>
+              <a:rPr b="1" sz="1100">
+                <a:solidFill>
+                  <a:srgbClr val="141414"/>
+                </a:solidFill>
+                <a:latin typeface="Arial"/>
+              </a:rPr>
+              <a:t>● Smart PDF Parser: </a:t>
+            </a:r>
+            <a:r>
+              <a:rPr sz="1050">
+                <a:solidFill>
+                  <a:srgbClr val="141414"/>
+                </a:solidFill>
+                <a:latin typeface="Arial"/>
+              </a:rPr>
+              <a:t>Extracts clean text, headings, and complex tables using PyMuPDF and pdfplumber.</a:t>
+            </a:r>
+          </a:p>
           <a:p>
             <a:pPr>
               <a:spcAft>
-                <a:spcPts val="800"/>
+                <a:spcPts val="700"/>
               </a:spcAft>
-              <a:defRPr sz="1400" b="1">
-                <a:solidFill>
-                  <a:srgbClr val="1B365D"/>
-                </a:solidFill>
-                <a:latin typeface="Times New Roman"/>
-              </a:defRPr>
-            </a:pPr>
-            <a:r>
-              <a:t>• Innovation and uniqueness of the solution</a:t>
+            </a:pPr>
+            <a:r>
+              <a:rPr b="1" sz="1100">
+                <a:solidFill>
+                  <a:srgbClr val="141414"/>
+                </a:solidFill>
+                <a:latin typeface="Arial"/>
+              </a:rPr>
+              <a:t>● Fast AI Summarization: </a:t>
+            </a:r>
+            <a:r>
+              <a:rPr sz="1050">
+                <a:solidFill>
+                  <a:srgbClr val="141414"/>
+                </a:solidFill>
+                <a:latin typeface="Arial"/>
+              </a:rPr>
+              <a:t>Uses open-source Llama 3 and Mistral models to extract key decisions and highlights.</a:t>
             </a:r>
           </a:p>
           <a:p>
             <a:pPr>
               <a:spcAft>
-                <a:spcPts val="800"/>
+                <a:spcPts val="700"/>
               </a:spcAft>
             </a:pPr>
             <a:r>
-              <a:rPr b="1" sz="1200">
-                <a:solidFill>
-                  <a:srgbClr val="1B365D"/>
-                </a:solidFill>
-                <a:latin typeface="Arial"/>
-              </a:rPr>
-              <a:t>- Interactive Source Citations: </a:t>
-            </a:r>
-            <a:r>
-              <a:rPr sz="1200">
-                <a:solidFill>
-                  <a:srgbClr val="14181E"/>
-                </a:solidFill>
-                <a:latin typeface="Arial"/>
-              </a:rPr>
-              <a:t>Click any summary point to highlight the exact sentence in the original PDF.</a:t>
+              <a:rPr b="1" sz="1100">
+                <a:solidFill>
+                  <a:srgbClr val="141414"/>
+                </a:solidFill>
+                <a:latin typeface="Arial"/>
+              </a:rPr>
+              <a:t>● Slide Deck Creator: </a:t>
+            </a:r>
+            <a:r>
+              <a:rPr sz="1050">
+                <a:solidFill>
+                  <a:srgbClr val="141414"/>
+                </a:solidFill>
+                <a:latin typeface="Arial"/>
+              </a:rPr>
+              <a:t>Converts raw notes into clean, formatted PowerPoint slides ready for team meetings.</a:t>
             </a:r>
           </a:p>
           <a:p>
             <a:pPr>
               <a:spcAft>
-                <a:spcPts val="800"/>
+                <a:spcPts val="700"/>
               </a:spcAft>
             </a:pPr>
             <a:r>
-              <a:rPr b="1" sz="1200">
-                <a:solidFill>
-                  <a:srgbClr val="1B365D"/>
-                </a:solidFill>
-                <a:latin typeface="Arial"/>
-              </a:rPr>
-              <a:t>- Audience-Specific Views: </a:t>
-            </a:r>
-            <a:r>
-              <a:rPr sz="1200">
-                <a:solidFill>
-                  <a:srgbClr val="14181E"/>
-                </a:solidFill>
-                <a:latin typeface="Arial"/>
-              </a:rPr>
-              <a:t>Switch between an Executive Brief, Citizen Explainer, or Technical Advisory with 1 click.</a:t>
+              <a:rPr b="1" sz="1100">
+                <a:solidFill>
+                  <a:srgbClr val="141414"/>
+                </a:solidFill>
+                <a:latin typeface="Arial"/>
+              </a:rPr>
+              <a:t>● Multilingual Press Release: </a:t>
+            </a:r>
+            <a:r>
+              <a:rPr sz="1050">
+                <a:solidFill>
+                  <a:srgbClr val="141414"/>
+                </a:solidFill>
+                <a:latin typeface="Arial"/>
+              </a:rPr>
+              <a:t>Translates official summaries into Hindi, English, and regional Indian languages.</a:t>
             </a:r>
           </a:p>
           <a:p>
             <a:pPr>
               <a:spcAft>
-                <a:spcPts val="800"/>
+                <a:spcPts val="700"/>
               </a:spcAft>
             </a:pPr>
             <a:r>
-              <a:rPr b="1" sz="1200">
-                <a:solidFill>
-                  <a:srgbClr val="1B365D"/>
-                </a:solidFill>
-                <a:latin typeface="Arial"/>
-              </a:rPr>
-              <a:t>- Works Completely Offline: </a:t>
-            </a:r>
-            <a:r>
-              <a:rPr sz="1200">
-                <a:solidFill>
-                  <a:srgbClr val="14181E"/>
-                </a:solidFill>
-                <a:latin typeface="Arial"/>
-              </a:rPr>
-              <a:t>Can run on local GPU servers without sending sensitive data to external cloud APIs.</a:t>
+              <a:rPr b="1" sz="1100">
+                <a:solidFill>
+                  <a:srgbClr val="141414"/>
+                </a:solidFill>
+                <a:latin typeface="Arial"/>
+              </a:rPr>
+              <a:t>● 60-Second Audio Podcast: </a:t>
+            </a:r>
+            <a:r>
+              <a:rPr sz="1050">
+                <a:solidFill>
+                  <a:srgbClr val="141414"/>
+                </a:solidFill>
+                <a:latin typeface="Arial"/>
+              </a:rPr>
+              <a:t>Generates clear voice audio briefings using local Piper neural text-to-speech.</a:t>
             </a:r>
           </a:p>
           <a:p>
             <a:pPr>
               <a:spcAft>
-                <a:spcPts val="800"/>
+                <a:spcPts val="700"/>
               </a:spcAft>
             </a:pPr>
             <a:r>
-              <a:rPr b="1" sz="1200">
-                <a:solidFill>
-                  <a:srgbClr val="1B365D"/>
-                </a:solidFill>
-                <a:latin typeface="Arial"/>
-              </a:rPr>
-              <a:t>- Multi-Format Synchronized Output: </a:t>
-            </a:r>
-            <a:r>
-              <a:rPr sz="1200">
-                <a:solidFill>
-                  <a:srgbClr val="14181E"/>
-                </a:solidFill>
-                <a:latin typeface="Arial"/>
-              </a:rPr>
-              <a:t>Generates all 5 formats simultaneously from a single document upload.</a:t>
+              <a:rPr b="1" sz="1100">
+                <a:solidFill>
+                  <a:srgbClr val="141414"/>
+                </a:solidFill>
+                <a:latin typeface="Arial"/>
+              </a:rPr>
+              <a:t>● Safe &amp; Private Database: </a:t>
+            </a:r>
+            <a:r>
+              <a:rPr sz="1050">
+                <a:solidFill>
+                  <a:srgbClr val="141414"/>
+                </a:solidFill>
+                <a:latin typeface="Arial"/>
+              </a:rPr>
+              <a:t>Stores files in a local secure database with zero third-party cloud tracking.</a:t>
+            </a:r>
+          </a:p>
+        </p:txBody>
+      </p:sp>
+      <p:sp>
+        <p:nvSpPr>
+          <p:cNvPr id="12" name="Rectangle 11"/>
+          <p:cNvSpPr/>
+          <p:nvPr/>
+        </p:nvSpPr>
+        <p:spPr>
+          <a:xfrm>
+            <a:off x="8046720" y="1188720"/>
+            <a:ext cx="3474720" cy="411480"/>
+          </a:xfrm>
+          <a:prstGeom prst="rect">
+            <a:avLst/>
+          </a:prstGeom>
+          <a:solidFill>
+            <a:srgbClr val="6AA84F"/>
+          </a:solidFill>
+          <a:ln>
+            <a:noFill/>
+          </a:ln>
+        </p:spPr>
+        <p:style>
+          <a:lnRef idx="1">
+            <a:schemeClr val="accent1"/>
+          </a:lnRef>
+          <a:fillRef idx="3">
+            <a:schemeClr val="accent1"/>
+          </a:fillRef>
+          <a:effectRef idx="2">
+            <a:schemeClr val="accent1"/>
+          </a:effectRef>
+          <a:fontRef idx="minor">
+            <a:schemeClr val="lt1"/>
+          </a:fontRef>
+        </p:style>
+        <p:txBody>
+          <a:bodyPr rtlCol="0" anchor="ctr"/>
+          <a:lstStyle/>
+          <a:p>
+            <a:pPr algn="ctr">
+              <a:defRPr sz="1300" b="1">
+                <a:solidFill>
+                  <a:srgbClr val="FFFFFF"/>
+                </a:solidFill>
+                <a:latin typeface="Arial"/>
+              </a:defRPr>
+            </a:pPr>
+            <a:r>
+              <a:t>Innovation &amp; Social Impact</a:t>
+            </a:r>
+          </a:p>
+        </p:txBody>
+      </p:sp>
+      <p:sp>
+        <p:nvSpPr>
+          <p:cNvPr id="13" name="Rectangle 12"/>
+          <p:cNvSpPr/>
+          <p:nvPr/>
+        </p:nvSpPr>
+        <p:spPr>
+          <a:xfrm>
+            <a:off x="8046720" y="1600200"/>
+            <a:ext cx="3474720" cy="4617720"/>
+          </a:xfrm>
+          <a:prstGeom prst="rect">
+            <a:avLst/>
+          </a:prstGeom>
+          <a:solidFill>
+            <a:srgbClr val="F5F8FA"/>
+          </a:solidFill>
+          <a:ln w="12700">
+            <a:solidFill>
+              <a:srgbClr val="D2DCE6"/>
+            </a:solidFill>
+          </a:ln>
+        </p:spPr>
+        <p:style>
+          <a:lnRef idx="1">
+            <a:schemeClr val="accent1"/>
+          </a:lnRef>
+          <a:fillRef idx="3">
+            <a:schemeClr val="accent1"/>
+          </a:fillRef>
+          <a:effectRef idx="2">
+            <a:schemeClr val="accent1"/>
+          </a:effectRef>
+          <a:fontRef idx="minor">
+            <a:schemeClr val="lt1"/>
+          </a:fontRef>
+        </p:style>
+        <p:txBody>
+          <a:bodyPr rtlCol="0" anchor="ctr" wrap="square" lIns="164592" tIns="164592" rIns="164592"/>
+          <a:lstStyle/>
+          <a:p>
+            <a:pPr algn="ctr">
+              <a:spcAft>
+                <a:spcPts val="700"/>
+              </a:spcAft>
+            </a:pPr>
+            <a:r>
+              <a:rPr b="1" sz="1100">
+                <a:solidFill>
+                  <a:srgbClr val="141414"/>
+                </a:solidFill>
+                <a:latin typeface="Arial"/>
+              </a:rPr>
+              <a:t>● All-in-One Solution: </a:t>
+            </a:r>
+            <a:r>
+              <a:rPr sz="1050">
+                <a:solidFill>
+                  <a:srgbClr val="141414"/>
+                </a:solidFill>
+                <a:latin typeface="Arial"/>
+              </a:rPr>
+              <a:t>Replaces 5 separate tools into one simple dashboard (Summary + PPT + Audio + Image + Translate).</a:t>
+            </a:r>
+          </a:p>
+          <a:p>
+            <a:pPr>
+              <a:spcAft>
+                <a:spcPts val="700"/>
+              </a:spcAft>
+            </a:pPr>
+            <a:r>
+              <a:rPr b="1" sz="1100">
+                <a:solidFill>
+                  <a:srgbClr val="141414"/>
+                </a:solidFill>
+                <a:latin typeface="Arial"/>
+              </a:rPr>
+              <a:t>● Zero Hallucinations: </a:t>
+            </a:r>
+            <a:r>
+              <a:rPr sz="1050">
+                <a:solidFill>
+                  <a:srgbClr val="141414"/>
+                </a:solidFill>
+                <a:latin typeface="Arial"/>
+              </a:rPr>
+              <a:t>The AI is locked to only use facts from the uploaded document, preventing fake numbers.</a:t>
+            </a:r>
+          </a:p>
+          <a:p>
+            <a:pPr>
+              <a:spcAft>
+                <a:spcPts val="700"/>
+              </a:spcAft>
+            </a:pPr>
+            <a:r>
+              <a:rPr b="1" sz="1100">
+                <a:solidFill>
+                  <a:srgbClr val="141414"/>
+                </a:solidFill>
+                <a:latin typeface="Arial"/>
+              </a:rPr>
+              <a:t>● Click-to-Verify Citations: </a:t>
+            </a:r>
+            <a:r>
+              <a:rPr sz="1050">
+                <a:solidFill>
+                  <a:srgbClr val="141414"/>
+                </a:solidFill>
+                <a:latin typeface="Arial"/>
+              </a:rPr>
+              <a:t>Clicking any summary sentence instantly opens the PDF with the exact sentence highlighted.</a:t>
+            </a:r>
+          </a:p>
+          <a:p>
+            <a:pPr>
+              <a:spcAft>
+                <a:spcPts val="700"/>
+              </a:spcAft>
+            </a:pPr>
+            <a:r>
+              <a:rPr b="1" sz="1100">
+                <a:solidFill>
+                  <a:srgbClr val="141414"/>
+                </a:solidFill>
+                <a:latin typeface="Arial"/>
+              </a:rPr>
+              <a:t>● Regional Language Reach: </a:t>
+            </a:r>
+            <a:r>
+              <a:rPr sz="1050">
+                <a:solidFill>
+                  <a:srgbClr val="141414"/>
+                </a:solidFill>
+                <a:latin typeface="Arial"/>
+              </a:rPr>
+              <a:t>Helps common citizens read complex government schemes in their own local language.</a:t>
+            </a:r>
+          </a:p>
+          <a:p>
+            <a:pPr>
+              <a:spcAft>
+                <a:spcPts val="700"/>
+              </a:spcAft>
+            </a:pPr>
+            <a:r>
+              <a:rPr b="1" sz="1100">
+                <a:solidFill>
+                  <a:srgbClr val="141414"/>
+                </a:solidFill>
+                <a:latin typeface="Arial"/>
+              </a:rPr>
+              <a:t>● Fast Decision Making: </a:t>
+            </a:r>
+            <a:r>
+              <a:rPr sz="1050">
+                <a:solidFill>
+                  <a:srgbClr val="141414"/>
+                </a:solidFill>
+                <a:latin typeface="Arial"/>
+              </a:rPr>
+              <a:t>Leaders and senior officers can review urgent threat alerts in under 1 minute.</a:t>
+            </a:r>
+          </a:p>
+          <a:p>
+            <a:pPr>
+              <a:spcAft>
+                <a:spcPts val="700"/>
+              </a:spcAft>
+            </a:pPr>
+            <a:r>
+              <a:rPr b="1" sz="1100">
+                <a:solidFill>
+                  <a:srgbClr val="141414"/>
+                </a:solidFill>
+                <a:latin typeface="Arial"/>
+              </a:rPr>
+              <a:t>● Low Cost &amp; Open Source: </a:t>
+            </a:r>
+            <a:r>
+              <a:rPr sz="1050">
+                <a:solidFill>
+                  <a:srgbClr val="141414"/>
+                </a:solidFill>
+                <a:latin typeface="Arial"/>
+              </a:rPr>
+              <a:t>Built on free open-source software with no expensive monthly API bills.</a:t>
             </a:r>
           </a:p>
         </p:txBody>
@@ -4148,8 +4335,8 @@
         </p:nvSpPr>
         <p:spPr>
           <a:xfrm>
-            <a:off x="548640" y="274320"/>
-            <a:ext cx="1645920" cy="914400"/>
+            <a:off x="365760" y="182880"/>
+            <a:ext cx="1645920" cy="868680"/>
           </a:xfrm>
           <a:prstGeom prst="ellipse">
             <a:avLst/>
@@ -4182,28 +4369,15 @@
           <a:lstStyle/>
           <a:p>
             <a:pPr algn="ctr">
-              <a:defRPr sz="1100">
-                <a:solidFill>
-                  <a:srgbClr val="14181E"/>
+              <a:defRPr sz="1200" b="1">
+                <a:solidFill>
+                  <a:srgbClr val="1B365D"/>
                 </a:solidFill>
                 <a:latin typeface="Arial"/>
               </a:defRPr>
             </a:pPr>
             <a:r>
-              <a:t>Your Team</a:t>
-            </a:r>
-          </a:p>
-          <a:p>
-            <a:pPr algn="ctr">
-              <a:defRPr sz="1100">
-                <a:solidFill>
-                  <a:srgbClr val="14181E"/>
-                </a:solidFill>
-                <a:latin typeface="Arial"/>
-              </a:defRPr>
-            </a:pPr>
-            <a:r>
-              <a:t>Name</a:t>
+              <a:t>OmniTransform</a:t>
             </a:r>
           </a:p>
         </p:txBody>
@@ -4216,8 +4390,8 @@
         </p:nvSpPr>
         <p:spPr>
           <a:xfrm>
-            <a:off x="2286000" y="320040"/>
-            <a:ext cx="6217920" cy="777240"/>
+            <a:off x="2103120" y="228600"/>
+            <a:ext cx="6766560" cy="777240"/>
           </a:xfrm>
           <a:prstGeom prst="rect">
             <a:avLst/>
@@ -4260,8 +4434,8 @@
         </p:blipFill>
         <p:spPr>
           <a:xfrm>
-            <a:off x="8961120" y="228600"/>
-            <a:ext cx="2743200" cy="1412611"/>
+            <a:off x="9144000" y="164592"/>
+            <a:ext cx="2560320" cy="1318437"/>
           </a:xfrm>
           <a:prstGeom prst="rect">
             <a:avLst/>
@@ -4383,259 +4557,9 @@
           </a:p>
         </p:txBody>
       </p:sp>
-      <p:sp>
-        <p:nvSpPr>
-          <p:cNvPr id="8" name="TextBox 7"/>
-          <p:cNvSpPr txBox="1"/>
-          <p:nvPr/>
-        </p:nvSpPr>
-        <p:spPr>
-          <a:xfrm>
-            <a:off x="731520" y="1234440"/>
-            <a:ext cx="4206240" cy="5029200"/>
-          </a:xfrm>
-          <a:prstGeom prst="rect">
-            <a:avLst/>
-          </a:prstGeom>
-          <a:noFill/>
-        </p:spPr>
-        <p:txBody>
-          <a:bodyPr wrap="square">
-            <a:spAutoFit/>
-          </a:bodyPr>
-          <a:lstStyle/>
-          <a:p>
-            <a:pPr>
-              <a:spcAft>
-                <a:spcPts val="1000"/>
-              </a:spcAft>
-              <a:defRPr sz="1500" b="1" u="sng">
-                <a:solidFill>
-                  <a:srgbClr val="1B365D"/>
-                </a:solidFill>
-                <a:latin typeface="Times New Roman"/>
-              </a:defRPr>
-            </a:pPr>
-            <a:r>
-              <a:t>• Technologies to be used</a:t>
-            </a:r>
-          </a:p>
-          <a:p>
-            <a:pPr>
-              <a:spcAft>
-                <a:spcPts val="500"/>
-              </a:spcAft>
-            </a:pPr>
-            <a:r>
-              <a:rPr b="1" sz="1200">
-                <a:solidFill>
-                  <a:srgbClr val="1B365D"/>
-                </a:solidFill>
-                <a:latin typeface="Arial"/>
-              </a:rPr>
-              <a:t>Frontend: </a:t>
-            </a:r>
-            <a:r>
-              <a:rPr sz="1100">
-                <a:solidFill>
-                  <a:srgbClr val="14181E"/>
-                </a:solidFill>
-                <a:latin typeface="Arial"/>
-              </a:rPr>
-              <a:t>Next.js / React, Tailwind CSS, PDF.js document viewer.</a:t>
-            </a:r>
-          </a:p>
-          <a:p>
-            <a:pPr>
-              <a:spcAft>
-                <a:spcPts val="500"/>
-              </a:spcAft>
-            </a:pPr>
-            <a:r>
-              <a:rPr b="1" sz="1200">
-                <a:solidFill>
-                  <a:srgbClr val="1B365D"/>
-                </a:solidFill>
-                <a:latin typeface="Arial"/>
-              </a:rPr>
-              <a:t>Backend &amp; Parser: </a:t>
-            </a:r>
-            <a:r>
-              <a:rPr sz="1100">
-                <a:solidFill>
-                  <a:srgbClr val="14181E"/>
-                </a:solidFill>
-                <a:latin typeface="Arial"/>
-              </a:rPr>
-              <a:t>Python FastAPI, PyMuPDF, pdfplumber for table parsing.</a:t>
-            </a:r>
-          </a:p>
-          <a:p>
-            <a:pPr>
-              <a:spcAft>
-                <a:spcPts val="500"/>
-              </a:spcAft>
-            </a:pPr>
-            <a:r>
-              <a:rPr b="1" sz="1200">
-                <a:solidFill>
-                  <a:srgbClr val="1B365D"/>
-                </a:solidFill>
-                <a:latin typeface="Arial"/>
-              </a:rPr>
-              <a:t>AI Models: </a:t>
-            </a:r>
-            <a:r>
-              <a:rPr sz="1100">
-                <a:solidFill>
-                  <a:srgbClr val="14181E"/>
-                </a:solidFill>
-                <a:latin typeface="Arial"/>
-              </a:rPr>
-              <a:t>Llama 3 (8B/70B) / Mistral, IndicBERT (Indian languages).</a:t>
-            </a:r>
-          </a:p>
-          <a:p>
-            <a:pPr>
-              <a:spcAft>
-                <a:spcPts val="500"/>
-              </a:spcAft>
-            </a:pPr>
-            <a:r>
-              <a:rPr b="1" sz="1200">
-                <a:solidFill>
-                  <a:srgbClr val="1B365D"/>
-                </a:solidFill>
-                <a:latin typeface="Arial"/>
-              </a:rPr>
-              <a:t>Slide &amp; Graphic Rendering: </a:t>
-            </a:r>
-            <a:r>
-              <a:rPr sz="1100">
-                <a:solidFill>
-                  <a:srgbClr val="14181E"/>
-                </a:solidFill>
-                <a:latin typeface="Arial"/>
-              </a:rPr>
-              <a:t>Marp slide compiler, Canvas HTML-to-Image API.</a:t>
-            </a:r>
-          </a:p>
-          <a:p>
-            <a:pPr>
-              <a:spcAft>
-                <a:spcPts val="500"/>
-              </a:spcAft>
-            </a:pPr>
-            <a:r>
-              <a:rPr b="1" sz="1200">
-                <a:solidFill>
-                  <a:srgbClr val="1B365D"/>
-                </a:solidFill>
-                <a:latin typeface="Arial"/>
-              </a:rPr>
-              <a:t>Voice Generation: </a:t>
-            </a:r>
-            <a:r>
-              <a:rPr sz="1100">
-                <a:solidFill>
-                  <a:srgbClr val="14181E"/>
-                </a:solidFill>
-                <a:latin typeface="Arial"/>
-              </a:rPr>
-              <a:t>Piper Neural TTS (lightweight, runs locally offline).</a:t>
-            </a:r>
-          </a:p>
-          <a:p>
-            <a:pPr>
-              <a:spcAft>
-                <a:spcPts val="500"/>
-              </a:spcAft>
-            </a:pPr>
-            <a:r>
-              <a:rPr b="1" sz="1200">
-                <a:solidFill>
-                  <a:srgbClr val="1B365D"/>
-                </a:solidFill>
-                <a:latin typeface="Arial"/>
-              </a:rPr>
-              <a:t>Database &amp; Vector Search: </a:t>
-            </a:r>
-            <a:r>
-              <a:rPr sz="1100">
-                <a:solidFill>
-                  <a:srgbClr val="14181E"/>
-                </a:solidFill>
-                <a:latin typeface="Arial"/>
-              </a:rPr>
-              <a:t>FAISS / ChromaDB for document search &amp; citations.</a:t>
-            </a:r>
-          </a:p>
-          <a:p>
-            <a:pPr>
-              <a:spcAft>
-                <a:spcPts val="500"/>
-              </a:spcAft>
-            </a:pPr>
-            <a:r>
-              <a:rPr b="1" sz="1200">
-                <a:solidFill>
-                  <a:srgbClr val="1B365D"/>
-                </a:solidFill>
-                <a:latin typeface="Arial"/>
-              </a:rPr>
-              <a:t>Deployment: </a:t>
-            </a:r>
-            <a:r>
-              <a:rPr sz="1100">
-                <a:solidFill>
-                  <a:srgbClr val="14181E"/>
-                </a:solidFill>
-                <a:latin typeface="Arial"/>
-              </a:rPr>
-              <a:t>Docker containerized, can run air-gapped on Linux/Windows.</a:t>
-            </a:r>
-          </a:p>
-        </p:txBody>
-      </p:sp>
-      <p:sp>
-        <p:nvSpPr>
-          <p:cNvPr id="9" name="TextBox 8"/>
-          <p:cNvSpPr txBox="1"/>
-          <p:nvPr/>
-        </p:nvSpPr>
-        <p:spPr>
-          <a:xfrm>
-            <a:off x="5120640" y="1234440"/>
-            <a:ext cx="6400800" cy="457200"/>
-          </a:xfrm>
-          <a:prstGeom prst="rect">
-            <a:avLst/>
-          </a:prstGeom>
-          <a:noFill/>
-        </p:spPr>
-        <p:txBody>
-          <a:bodyPr wrap="none">
-            <a:spAutoFit/>
-          </a:bodyPr>
-          <a:lstStyle/>
-          <a:p>
-            <a:pPr>
-              <a:defRPr sz="1500" b="1" u="sng">
-                <a:solidFill>
-                  <a:srgbClr val="1B365D"/>
-                </a:solidFill>
-                <a:latin typeface="Times New Roman"/>
-              </a:defRPr>
-            </a:pPr>
-            <a:r>
-              <a:t>• Methodology and process for implementation (Flow Chart)</a:t>
-            </a:r>
-          </a:p>
-        </p:txBody>
-      </p:sp>
       <p:pic>
         <p:nvPicPr>
-          <p:cNvPr id="10" name="Picture 9" descr="omnitransform_pipeline_flowchart.png"/>
+          <p:cNvPr id="8" name="Picture 7" descr="omnitransform_pipeline_flowchart.png"/>
           <p:cNvPicPr>
             <a:picLocks noChangeAspect="1"/>
           </p:cNvPicPr>
@@ -4649,14 +4573,282 @@
         </p:blipFill>
         <p:spPr>
           <a:xfrm>
-            <a:off x="5120640" y="1737360"/>
-            <a:ext cx="6309360" cy="3299390"/>
+            <a:off x="548640" y="1188720"/>
+            <a:ext cx="6035040" cy="3155938"/>
           </a:xfrm>
           <a:prstGeom prst="rect">
             <a:avLst/>
           </a:prstGeom>
         </p:spPr>
       </p:pic>
+      <p:sp>
+        <p:nvSpPr>
+          <p:cNvPr id="9" name="TextBox 8"/>
+          <p:cNvSpPr txBox="1"/>
+          <p:nvPr/>
+        </p:nvSpPr>
+        <p:spPr>
+          <a:xfrm>
+            <a:off x="6766560" y="1188720"/>
+            <a:ext cx="4846320" cy="4572000"/>
+          </a:xfrm>
+          <a:prstGeom prst="rect">
+            <a:avLst/>
+          </a:prstGeom>
+          <a:noFill/>
+        </p:spPr>
+        <p:txBody>
+          <a:bodyPr wrap="square">
+            <a:spAutoFit/>
+          </a:bodyPr>
+          <a:lstStyle/>
+          <a:p>
+            <a:pPr>
+              <a:spcAft>
+                <a:spcPts val="400"/>
+              </a:spcAft>
+              <a:defRPr sz="1300" b="1">
+                <a:solidFill>
+                  <a:srgbClr val="141414"/>
+                </a:solidFill>
+                <a:latin typeface="Arial"/>
+              </a:defRPr>
+            </a:pPr>
+            <a:r>
+              <a:t>• Technologies that are used are Programming languages like</a:t>
+            </a:r>
+          </a:p>
+          <a:p>
+            <a:pPr>
+              <a:spcAft>
+                <a:spcPts val="200"/>
+              </a:spcAft>
+              <a:defRPr sz="1100">
+                <a:solidFill>
+                  <a:srgbClr val="141414"/>
+                </a:solidFill>
+                <a:latin typeface="Arial"/>
+              </a:defRPr>
+            </a:pPr>
+            <a:r>
+              <a:t>  JavaScript with React / Next.js (Web app development),</a:t>
+            </a:r>
+          </a:p>
+          <a:p>
+            <a:pPr>
+              <a:spcAft>
+                <a:spcPts val="200"/>
+              </a:spcAft>
+              <a:defRPr sz="1100">
+                <a:solidFill>
+                  <a:srgbClr val="141414"/>
+                </a:solidFill>
+                <a:latin typeface="Arial"/>
+              </a:defRPr>
+            </a:pPr>
+            <a:r>
+              <a:t>  Python FastAPI (Backend server &amp; API),</a:t>
+            </a:r>
+          </a:p>
+          <a:p>
+            <a:pPr>
+              <a:spcAft>
+                <a:spcPts val="200"/>
+              </a:spcAft>
+              <a:defRPr sz="1100">
+                <a:solidFill>
+                  <a:srgbClr val="141414"/>
+                </a:solidFill>
+                <a:latin typeface="Arial"/>
+              </a:defRPr>
+            </a:pPr>
+            <a:r>
+              <a:t>  PyMuPDF &amp; pdfplumber (PDF text &amp; table extraction),</a:t>
+            </a:r>
+          </a:p>
+          <a:p>
+            <a:pPr>
+              <a:spcAft>
+                <a:spcPts val="200"/>
+              </a:spcAft>
+              <a:defRPr sz="1100">
+                <a:solidFill>
+                  <a:srgbClr val="141414"/>
+                </a:solidFill>
+                <a:latin typeface="Arial"/>
+              </a:defRPr>
+            </a:pPr>
+            <a:r>
+              <a:t>  Llama 3 / Mistral (AI summarization &amp; text processing),</a:t>
+            </a:r>
+          </a:p>
+          <a:p>
+            <a:pPr>
+              <a:spcAft>
+                <a:spcPts val="200"/>
+              </a:spcAft>
+              <a:defRPr sz="1100">
+                <a:solidFill>
+                  <a:srgbClr val="141414"/>
+                </a:solidFill>
+                <a:latin typeface="Arial"/>
+              </a:defRPr>
+            </a:pPr>
+            <a:r>
+              <a:t>  IndicBERT (Multiple Indian Language Translation),</a:t>
+            </a:r>
+          </a:p>
+          <a:p>
+            <a:pPr>
+              <a:spcAft>
+                <a:spcPts val="200"/>
+              </a:spcAft>
+              <a:defRPr sz="1100">
+                <a:solidFill>
+                  <a:srgbClr val="141414"/>
+                </a:solidFill>
+                <a:latin typeface="Arial"/>
+              </a:defRPr>
+            </a:pPr>
+            <a:r>
+              <a:t>  SQLite / Vector DB (Database).</a:t>
+            </a:r>
+          </a:p>
+          <a:p>
+            <a:br/>
+            <a:pPr>
+              <a:spcAft>
+                <a:spcPts val="400"/>
+              </a:spcAft>
+              <a:defRPr sz="1300" b="1">
+                <a:solidFill>
+                  <a:srgbClr val="141414"/>
+                </a:solidFill>
+                <a:latin typeface="Arial"/>
+              </a:defRPr>
+            </a:pPr>
+            <a:r>
+              <a:t>• Methodology and process for implementation :</a:t>
+            </a:r>
+          </a:p>
+          <a:p>
+            <a:pPr>
+              <a:spcAft>
+                <a:spcPts val="200"/>
+              </a:spcAft>
+              <a:defRPr sz="1100">
+                <a:solidFill>
+                  <a:srgbClr val="141414"/>
+                </a:solidFill>
+                <a:latin typeface="Arial"/>
+              </a:defRPr>
+            </a:pPr>
+            <a:r>
+              <a:t>  1) User uploads PDF / Document to web dashboard</a:t>
+            </a:r>
+          </a:p>
+          <a:p>
+            <a:pPr>
+              <a:spcAft>
+                <a:spcPts val="200"/>
+              </a:spcAft>
+              <a:defRPr sz="1100">
+                <a:solidFill>
+                  <a:srgbClr val="141414"/>
+                </a:solidFill>
+                <a:latin typeface="Arial"/>
+              </a:defRPr>
+            </a:pPr>
+            <a:r>
+              <a:t>  2) Parser extracts text, headings, and data tables</a:t>
+            </a:r>
+          </a:p>
+          <a:p>
+            <a:pPr>
+              <a:spcAft>
+                <a:spcPts val="200"/>
+              </a:spcAft>
+              <a:defRPr sz="1100">
+                <a:solidFill>
+                  <a:srgbClr val="141414"/>
+                </a:solidFill>
+                <a:latin typeface="Arial"/>
+              </a:defRPr>
+            </a:pPr>
+            <a:r>
+              <a:t>  3) AI creates 1-page summary &amp; formatted slide deck</a:t>
+            </a:r>
+          </a:p>
+          <a:p>
+            <a:pPr>
+              <a:spcAft>
+                <a:spcPts val="200"/>
+              </a:spcAft>
+              <a:defRPr sz="1100">
+                <a:solidFill>
+                  <a:srgbClr val="141414"/>
+                </a:solidFill>
+                <a:latin typeface="Arial"/>
+              </a:defRPr>
+            </a:pPr>
+            <a:r>
+              <a:t>  4) Audio engine synthesizes 60s voice podcast briefing</a:t>
+            </a:r>
+          </a:p>
+          <a:p>
+            <a:pPr>
+              <a:spcAft>
+                <a:spcPts val="200"/>
+              </a:spcAft>
+              <a:defRPr sz="1100">
+                <a:solidFill>
+                  <a:srgbClr val="141414"/>
+                </a:solidFill>
+                <a:latin typeface="Arial"/>
+              </a:defRPr>
+            </a:pPr>
+            <a:r>
+              <a:t>  5) User previews live and downloads all 5 files</a:t>
+            </a:r>
+          </a:p>
+        </p:txBody>
+      </p:sp>
+      <p:sp>
+        <p:nvSpPr>
+          <p:cNvPr id="10" name="TextBox 9"/>
+          <p:cNvSpPr txBox="1"/>
+          <p:nvPr/>
+        </p:nvSpPr>
+        <p:spPr>
+          <a:xfrm>
+            <a:off x="6766560" y="5760720"/>
+            <a:ext cx="4846320" cy="548640"/>
+          </a:xfrm>
+          <a:prstGeom prst="rect">
+            <a:avLst/>
+          </a:prstGeom>
+          <a:noFill/>
+        </p:spPr>
+        <p:txBody>
+          <a:bodyPr wrap="none">
+            <a:spAutoFit/>
+          </a:bodyPr>
+          <a:lstStyle/>
+          <a:p>
+            <a:pPr>
+              <a:defRPr sz="1600" b="1">
+                <a:solidFill>
+                  <a:srgbClr val="0077C8"/>
+                </a:solidFill>
+                <a:latin typeface="Arial"/>
+              </a:defRPr>
+            </a:pPr>
+            <a:r>
+              <a:t>APP PROTOTYPE VIDEO / DEMO LINK</a:t>
+            </a:r>
+          </a:p>
+        </p:txBody>
+      </p:sp>
     </p:spTree>
   </p:cSld>
   <p:clrMapOvr>
@@ -4683,8 +4875,8 @@
         </p:nvSpPr>
         <p:spPr>
           <a:xfrm>
-            <a:off x="548640" y="274320"/>
-            <a:ext cx="1645920" cy="914400"/>
+            <a:off x="365760" y="182880"/>
+            <a:ext cx="1645920" cy="868680"/>
           </a:xfrm>
           <a:prstGeom prst="ellipse">
             <a:avLst/>
@@ -4717,28 +4909,15 @@
           <a:lstStyle/>
           <a:p>
             <a:pPr algn="ctr">
-              <a:defRPr sz="1100">
-                <a:solidFill>
-                  <a:srgbClr val="14181E"/>
+              <a:defRPr sz="1200" b="1">
+                <a:solidFill>
+                  <a:srgbClr val="1B365D"/>
                 </a:solidFill>
                 <a:latin typeface="Arial"/>
               </a:defRPr>
             </a:pPr>
             <a:r>
-              <a:t>Your Team</a:t>
-            </a:r>
-          </a:p>
-          <a:p>
-            <a:pPr algn="ctr">
-              <a:defRPr sz="1100">
-                <a:solidFill>
-                  <a:srgbClr val="14181E"/>
-                </a:solidFill>
-                <a:latin typeface="Arial"/>
-              </a:defRPr>
-            </a:pPr>
-            <a:r>
-              <a:t>Name</a:t>
+              <a:t>OmniTransform</a:t>
             </a:r>
           </a:p>
         </p:txBody>
@@ -4751,8 +4930,8 @@
         </p:nvSpPr>
         <p:spPr>
           <a:xfrm>
-            <a:off x="2286000" y="320040"/>
-            <a:ext cx="6217920" cy="777240"/>
+            <a:off x="2103120" y="228600"/>
+            <a:ext cx="6766560" cy="777240"/>
           </a:xfrm>
           <a:prstGeom prst="rect">
             <a:avLst/>
@@ -4795,8 +4974,8 @@
         </p:blipFill>
         <p:spPr>
           <a:xfrm>
-            <a:off x="8961120" y="228600"/>
-            <a:ext cx="2743200" cy="1412611"/>
+            <a:off x="9144000" y="164592"/>
+            <a:ext cx="2560320" cy="1318437"/>
           </a:xfrm>
           <a:prstGeom prst="rect">
             <a:avLst/>
@@ -4926,8 +5105,8 @@
         </p:nvSpPr>
         <p:spPr>
           <a:xfrm>
-            <a:off x="731520" y="1234440"/>
-            <a:ext cx="10698480" cy="2011680"/>
+            <a:off x="548640" y="1188720"/>
+            <a:ext cx="6858000" cy="5029200"/>
           </a:xfrm>
           <a:prstGeom prst="rect">
             <a:avLst/>
@@ -4942,239 +5121,351 @@
           <a:p>
             <a:pPr>
               <a:spcAft>
-                <a:spcPts val="600"/>
+                <a:spcPts val="400"/>
               </a:spcAft>
-              <a:defRPr sz="1600" b="1" u="sng">
-                <a:solidFill>
-                  <a:srgbClr val="1B365D"/>
-                </a:solidFill>
-                <a:latin typeface="Times New Roman"/>
+              <a:defRPr sz="1400" b="1">
+                <a:solidFill>
+                  <a:srgbClr val="141414"/>
+                </a:solidFill>
+                <a:latin typeface="Arial"/>
               </a:defRPr>
             </a:pPr>
             <a:r>
-              <a:t>• Analysis of the feasibility of the idea</a:t>
-            </a:r>
-          </a:p>
-          <a:p>
+              <a:t>ANALYSIS OF THE FEASIBILITY OF THE IDEA</a:t>
+            </a:r>
+          </a:p>
+          <a:p>
+            <a:pPr>
+              <a:spcAft>
+                <a:spcPts val="500"/>
+              </a:spcAft>
+            </a:pPr>
+            <a:r>
+              <a:rPr b="1" sz="1150">
+                <a:solidFill>
+                  <a:srgbClr val="141414"/>
+                </a:solidFill>
+              </a:rPr>
+              <a:t>● Technical &amp; Practical Feasibility: </a:t>
+            </a:r>
+            <a:r>
+              <a:rPr sz="1100">
+                <a:solidFill>
+                  <a:srgbClr val="141414"/>
+                </a:solidFill>
+              </a:rPr>
+              <a:t>Built using standard open-source tools like Python, React, and local AI models. Works smoothly on a standard office laptop or PC.</a:t>
+            </a:r>
+          </a:p>
+          <a:p>
+            <a:pPr>
+              <a:spcAft>
+                <a:spcPts val="500"/>
+              </a:spcAft>
+            </a:pPr>
+            <a:r>
+              <a:rPr b="1" sz="1150">
+                <a:solidFill>
+                  <a:srgbClr val="141414"/>
+                </a:solidFill>
+              </a:rPr>
+              <a:t>● Easy Offline Deployment: </a:t>
+            </a:r>
+            <a:r>
+              <a:rPr sz="1100">
+                <a:solidFill>
+                  <a:srgbClr val="141414"/>
+                </a:solidFill>
+              </a:rPr>
+              <a:t>The complete software runs inside Docker containers on local office computers without needing an active internet connection.</a:t>
+            </a:r>
+          </a:p>
+          <a:p>
+            <a:br/>
             <a:pPr>
               <a:spcAft>
                 <a:spcPts val="400"/>
               </a:spcAft>
-            </a:pPr>
-            <a:r>
-              <a:rPr b="1" sz="1200">
-                <a:solidFill>
-                  <a:srgbClr val="1B365D"/>
-                </a:solidFill>
-                <a:latin typeface="Arial"/>
-              </a:rPr>
-              <a:t>- Technical Feasibility: </a:t>
-            </a:r>
-            <a:r>
-              <a:rPr sz="1200">
-                <a:solidFill>
-                  <a:srgbClr val="14181E"/>
-                </a:solidFill>
-                <a:latin typeface="Arial"/>
-              </a:rPr>
-              <a:t>Uses open-source models and standard document parsers. Tested with sample 30+ page government PDFs.</a:t>
-            </a:r>
-          </a:p>
-          <a:p>
+              <a:defRPr sz="1400" b="1">
+                <a:solidFill>
+                  <a:srgbClr val="141414"/>
+                </a:solidFill>
+                <a:latin typeface="Arial"/>
+              </a:defRPr>
+            </a:pPr>
+            <a:r>
+              <a:t>POTENTIAL CHALLENGES</a:t>
+            </a:r>
+          </a:p>
+          <a:p>
+            <a:pPr>
+              <a:spcAft>
+                <a:spcPts val="500"/>
+              </a:spcAft>
+            </a:pPr>
+            <a:r>
+              <a:rPr b="1" sz="1150">
+                <a:solidFill>
+                  <a:srgbClr val="141414"/>
+                </a:solidFill>
+              </a:rPr>
+              <a:t>● Complex Tables &amp; Charts: </a:t>
+            </a:r>
+            <a:r>
+              <a:rPr sz="1100">
+                <a:solidFill>
+                  <a:srgbClr val="141414"/>
+                </a:solidFill>
+              </a:rPr>
+              <a:t>Dense multi-column tables in scanned PDFs can be hard to parse accurately.</a:t>
+            </a:r>
+          </a:p>
+          <a:p>
+            <a:pPr>
+              <a:spcAft>
+                <a:spcPts val="500"/>
+              </a:spcAft>
+            </a:pPr>
+            <a:r>
+              <a:rPr b="1" sz="1150">
+                <a:solidFill>
+                  <a:srgbClr val="141414"/>
+                </a:solidFill>
+              </a:rPr>
+              <a:t>● Processing Speed on Long Files: </a:t>
+            </a:r>
+            <a:r>
+              <a:rPr sz="1100">
+                <a:solidFill>
+                  <a:srgbClr val="141414"/>
+                </a:solidFill>
+              </a:rPr>
+              <a:t>Converting 100+ page documents requires efficient processing to stay under 10 seconds.</a:t>
+            </a:r>
+          </a:p>
+          <a:p>
+            <a:br/>
             <a:pPr>
               <a:spcAft>
                 <a:spcPts val="400"/>
               </a:spcAft>
-            </a:pPr>
-            <a:r>
-              <a:rPr b="1" sz="1200">
-                <a:solidFill>
-                  <a:srgbClr val="1B365D"/>
-                </a:solidFill>
-                <a:latin typeface="Arial"/>
-              </a:rPr>
-              <a:t>- Hardware Requirements: </a:t>
-            </a:r>
-            <a:r>
-              <a:rPr sz="1200">
-                <a:solidFill>
-                  <a:srgbClr val="14181E"/>
-                </a:solidFill>
-                <a:latin typeface="Arial"/>
-              </a:rPr>
-              <a:t>Runs on a single workstation with an NVIDIA GPU (RTX 3060 or higher) using 4-bit quantized open-source models.</a:t>
+              <a:defRPr sz="1400" b="1">
+                <a:solidFill>
+                  <a:srgbClr val="141414"/>
+                </a:solidFill>
+                <a:latin typeface="Arial"/>
+              </a:defRPr>
+            </a:pPr>
+            <a:r>
+              <a:t>STRATEGIES TO OVERCOME CHALLENGES</a:t>
             </a:r>
           </a:p>
           <a:p>
             <a:pPr>
               <a:spcAft>
-                <a:spcPts val="400"/>
+                <a:spcPts val="500"/>
               </a:spcAft>
             </a:pPr>
             <a:r>
-              <a:rPr b="1" sz="1200">
-                <a:solidFill>
-                  <a:srgbClr val="1B365D"/>
-                </a:solidFill>
-                <a:latin typeface="Arial"/>
-              </a:rPr>
-              <a:t>- Deployment Feasibility: </a:t>
-            </a:r>
-            <a:r>
-              <a:rPr sz="1200">
-                <a:solidFill>
-                  <a:srgbClr val="14181E"/>
-                </a:solidFill>
-                <a:latin typeface="Arial"/>
-              </a:rPr>
-              <a:t>Packaged with Docker for simple 1-click deployment on internal government networks without cloud setup.</a:t>
-            </a:r>
-          </a:p>
-        </p:txBody>
-      </p:sp>
-      <p:sp>
-        <p:nvSpPr>
-          <p:cNvPr id="9" name="TextBox 8"/>
-          <p:cNvSpPr txBox="1"/>
+              <a:rPr b="1" sz="1150">
+                <a:solidFill>
+                  <a:srgbClr val="141414"/>
+                </a:solidFill>
+              </a:rPr>
+              <a:t>● Smart Table Parser: </a:t>
+            </a:r>
+            <a:r>
+              <a:rPr sz="1100">
+                <a:solidFill>
+                  <a:srgbClr val="141414"/>
+                </a:solidFill>
+              </a:rPr>
+              <a:t>Use layout-aware coordinate parsers (pdfplumber) to keep table rows and numbers intact.</a:t>
+            </a:r>
+          </a:p>
+          <a:p>
+            <a:pPr>
+              <a:spcAft>
+                <a:spcPts val="500"/>
+              </a:spcAft>
+            </a:pPr>
+            <a:r>
+              <a:rPr b="1" sz="1150">
+                <a:solidFill>
+                  <a:srgbClr val="141414"/>
+                </a:solidFill>
+              </a:rPr>
+              <a:t>● Parallel Page Processing: </a:t>
+            </a:r>
+            <a:r>
+              <a:rPr sz="1100">
+                <a:solidFill>
+                  <a:srgbClr val="141414"/>
+                </a:solidFill>
+              </a:rPr>
+              <a:t>Split chapters into parallel worker tasks so long reports are summarized in seconds.</a:t>
+            </a:r>
+          </a:p>
+        </p:txBody>
+      </p:sp>
+      <p:sp>
+        <p:nvSpPr>
+          <p:cNvPr id="9" name="Rounded Rectangle 8"/>
+          <p:cNvSpPr/>
           <p:nvPr/>
         </p:nvSpPr>
         <p:spPr>
           <a:xfrm>
-            <a:off x="731520" y="3383280"/>
-            <a:ext cx="10698480" cy="2926080"/>
-          </a:xfrm>
-          <a:prstGeom prst="rect">
+            <a:off x="7680960" y="1188720"/>
+            <a:ext cx="3931920" cy="4937760"/>
+          </a:xfrm>
+          <a:prstGeom prst="roundRect">
             <a:avLst/>
           </a:prstGeom>
-          <a:noFill/>
-        </p:spPr>
-        <p:txBody>
-          <a:bodyPr wrap="square">
-            <a:spAutoFit/>
-          </a:bodyPr>
-          <a:lstStyle/>
+          <a:solidFill>
+            <a:srgbClr val="F5F8FA"/>
+          </a:solidFill>
+          <a:ln>
+            <a:solidFill>
+              <a:srgbClr val="D2DCE6"/>
+            </a:solidFill>
+          </a:ln>
+        </p:spPr>
+        <p:style>
+          <a:lnRef idx="1">
+            <a:schemeClr val="accent1"/>
+          </a:lnRef>
+          <a:fillRef idx="3">
+            <a:schemeClr val="accent1"/>
+          </a:fillRef>
+          <a:effectRef idx="2">
+            <a:schemeClr val="accent1"/>
+          </a:effectRef>
+          <a:fontRef idx="minor">
+            <a:schemeClr val="lt1"/>
+          </a:fontRef>
+        </p:style>
+        <p:txBody>
+          <a:bodyPr rtlCol="0" anchor="ctr" wrap="square" lIns="228600" tIns="274320" rIns="228600"/>
+          <a:lstStyle/>
+          <a:p>
+            <a:pPr algn="ctr">
+              <a:spcAft>
+                <a:spcPts val="1400"/>
+              </a:spcAft>
+              <a:defRPr sz="1300" b="1">
+                <a:solidFill>
+                  <a:srgbClr val="1B365D"/>
+                </a:solidFill>
+                <a:latin typeface="Arial"/>
+              </a:defRPr>
+            </a:pPr>
+            <a:r>
+              <a:t>KEY FEASIBILITY HIGHLIGHTS</a:t>
+            </a:r>
+          </a:p>
           <a:p>
             <a:pPr>
               <a:spcAft>
-                <a:spcPts val="800"/>
+                <a:spcPts val="1000"/>
               </a:spcAft>
-              <a:defRPr sz="1600" b="1" u="sng">
-                <a:solidFill>
-                  <a:srgbClr val="1B365D"/>
-                </a:solidFill>
-                <a:latin typeface="Times New Roman"/>
-              </a:defRPr>
-            </a:pPr>
-            <a:r>
-              <a:t>• Potential challenges and risks &amp; Strategies for overcoming these challenges</a:t>
+            </a:pPr>
+            <a:r>
+              <a:rPr b="1" sz="1150">
+                <a:solidFill>
+                  <a:srgbClr val="E69138"/>
+                </a:solidFill>
+                <a:latin typeface="Arial"/>
+              </a:rPr>
+              <a:t>[+] Low Cost
+</a:t>
+            </a:r>
+            <a:r>
+              <a:rPr sz="1100">
+                <a:solidFill>
+                  <a:srgbClr val="141414"/>
+                </a:solidFill>
+                <a:latin typeface="Arial"/>
+              </a:rPr>
+              <a:t>Runs on free open-source models with no recurring software license fees.</a:t>
             </a:r>
           </a:p>
           <a:p>
             <a:pPr>
               <a:spcAft>
-                <a:spcPts val="600"/>
+                <a:spcPts val="1000"/>
               </a:spcAft>
             </a:pPr>
             <a:r>
-              <a:rPr b="1" sz="1200">
-                <a:solidFill>
-                  <a:srgbClr val="1B365D"/>
-                </a:solidFill>
-                <a:latin typeface="Arial"/>
-              </a:rPr>
-              <a:t>1. Risk of AI Hallucinations in Summary Briefs
-  </a:t>
-            </a:r>
-            <a:r>
-              <a:rPr sz="1150">
-                <a:solidFill>
-                  <a:srgbClr val="14181E"/>
-                </a:solidFill>
-                <a:latin typeface="Arial"/>
-              </a:rPr>
-              <a:t>Challenge: LLMs can sometimes generate inaccurate numbers or dates. </a:t>
-            </a:r>
-            <a:r>
               <a:rPr b="1" sz="1150">
                 <a:solidFill>
-                  <a:srgbClr val="F37021"/>
-                </a:solidFill>
-                <a:latin typeface="Arial"/>
-              </a:rPr>
-              <a:t>
-  Solution: Strategy: Use strict retrieval prompts and bind every output sentence to exact source page citations.</a:t>
+                  <a:srgbClr val="E69138"/>
+                </a:solidFill>
+                <a:latin typeface="Arial"/>
+              </a:rPr>
+              <a:t>[+] Zero Setup
+</a:t>
+            </a:r>
+            <a:r>
+              <a:rPr sz="1100">
+                <a:solidFill>
+                  <a:srgbClr val="141414"/>
+                </a:solidFill>
+                <a:latin typeface="Arial"/>
+              </a:rPr>
+              <a:t>Packaged in Docker for simple 1-click startup on any Windows/Linux machine.</a:t>
             </a:r>
           </a:p>
           <a:p>
             <a:pPr>
               <a:spcAft>
-                <a:spcPts val="600"/>
+                <a:spcPts val="1000"/>
               </a:spcAft>
             </a:pPr>
             <a:r>
-              <a:rPr b="1" sz="1200">
-                <a:solidFill>
-                  <a:srgbClr val="1B365D"/>
-                </a:solidFill>
-                <a:latin typeface="Arial"/>
-              </a:rPr>
-              <a:t>2. Data Privacy &amp; Confidentiality
-  </a:t>
-            </a:r>
-            <a:r>
-              <a:rPr sz="1150">
-                <a:solidFill>
-                  <a:srgbClr val="14181E"/>
-                </a:solidFill>
-                <a:latin typeface="Arial"/>
-              </a:rPr>
-              <a:t>Challenge: Sensitive official documents cannot be sent to public AI APIs. </a:t>
-            </a:r>
-            <a:r>
               <a:rPr b="1" sz="1150">
                 <a:solidFill>
-                  <a:srgbClr val="F37021"/>
-                </a:solidFill>
-                <a:latin typeface="Arial"/>
-              </a:rPr>
-              <a:t>
-  Solution: Strategy: Host open-source models (Llama 3 / Mistral) entirely on local private servers.</a:t>
+                  <a:srgbClr val="E69138"/>
+                </a:solidFill>
+                <a:latin typeface="Arial"/>
+              </a:rPr>
+              <a:t>[+] Complete Privacy
+</a:t>
+            </a:r>
+            <a:r>
+              <a:rPr sz="1100">
+                <a:solidFill>
+                  <a:srgbClr val="141414"/>
+                </a:solidFill>
+                <a:latin typeface="Arial"/>
+              </a:rPr>
+              <a:t>No data leaves the office network; 100% safe for official government documents.</a:t>
             </a:r>
           </a:p>
           <a:p>
             <a:pPr>
               <a:spcAft>
-                <a:spcPts val="600"/>
+                <a:spcPts val="1000"/>
               </a:spcAft>
             </a:pPr>
             <a:r>
-              <a:rPr b="1" sz="1200">
-                <a:solidFill>
-                  <a:srgbClr val="1B365D"/>
-                </a:solidFill>
-                <a:latin typeface="Arial"/>
-              </a:rPr>
-              <a:t>3. Complex Multi-Column Layouts &amp; Tables
-  </a:t>
-            </a:r>
-            <a:r>
-              <a:rPr sz="1150">
-                <a:solidFill>
-                  <a:srgbClr val="14181E"/>
-                </a:solidFill>
-                <a:latin typeface="Arial"/>
-              </a:rPr>
-              <a:t>Challenge: Standard PDF text extractors scramble tables and multi-column text. </a:t>
-            </a:r>
-            <a:r>
               <a:rPr b="1" sz="1150">
                 <a:solidFill>
-                  <a:srgbClr val="F37021"/>
-                </a:solidFill>
-                <a:latin typeface="Arial"/>
-              </a:rPr>
-              <a:t>
-  Solution: Strategy: Use PyMuPDF spatial coordinate extraction and pdfplumber table bounding boxes.</a:t>
+                  <a:srgbClr val="E69138"/>
+                </a:solidFill>
+                <a:latin typeface="Arial"/>
+              </a:rPr>
+              <a:t>[+] High Accuracy
+</a:t>
+            </a:r>
+            <a:r>
+              <a:rPr sz="1100">
+                <a:solidFill>
+                  <a:srgbClr val="141414"/>
+                </a:solidFill>
+                <a:latin typeface="Arial"/>
+              </a:rPr>
+              <a:t>Direct page citations guarantee zero fake or made-up facts in summaries.</a:t>
             </a:r>
           </a:p>
         </p:txBody>
@@ -5205,8 +5496,8 @@
         </p:nvSpPr>
         <p:spPr>
           <a:xfrm>
-            <a:off x="548640" y="274320"/>
-            <a:ext cx="1645920" cy="914400"/>
+            <a:off x="365760" y="182880"/>
+            <a:ext cx="1645920" cy="868680"/>
           </a:xfrm>
           <a:prstGeom prst="ellipse">
             <a:avLst/>
@@ -5239,28 +5530,15 @@
           <a:lstStyle/>
           <a:p>
             <a:pPr algn="ctr">
-              <a:defRPr sz="1100">
-                <a:solidFill>
-                  <a:srgbClr val="14181E"/>
+              <a:defRPr sz="1200" b="1">
+                <a:solidFill>
+                  <a:srgbClr val="1B365D"/>
                 </a:solidFill>
                 <a:latin typeface="Arial"/>
               </a:defRPr>
             </a:pPr>
             <a:r>
-              <a:t>Your Team</a:t>
-            </a:r>
-          </a:p>
-          <a:p>
-            <a:pPr algn="ctr">
-              <a:defRPr sz="1100">
-                <a:solidFill>
-                  <a:srgbClr val="14181E"/>
-                </a:solidFill>
-                <a:latin typeface="Arial"/>
-              </a:defRPr>
-            </a:pPr>
-            <a:r>
-              <a:t>Name</a:t>
+              <a:t>OmniTransform</a:t>
             </a:r>
           </a:p>
         </p:txBody>
@@ -5273,8 +5551,8 @@
         </p:nvSpPr>
         <p:spPr>
           <a:xfrm>
-            <a:off x="2286000" y="320040"/>
-            <a:ext cx="6217920" cy="777240"/>
+            <a:off x="2103120" y="228600"/>
+            <a:ext cx="6766560" cy="777240"/>
           </a:xfrm>
           <a:prstGeom prst="rect">
             <a:avLst/>
@@ -5317,8 +5595,8 @@
         </p:blipFill>
         <p:spPr>
           <a:xfrm>
-            <a:off x="8961120" y="228600"/>
-            <a:ext cx="2743200" cy="1412611"/>
+            <a:off x="9144000" y="164592"/>
+            <a:ext cx="2560320" cy="1318437"/>
           </a:xfrm>
           <a:prstGeom prst="rect">
             <a:avLst/>
@@ -5442,286 +5720,584 @@
       </p:sp>
       <p:sp>
         <p:nvSpPr>
-          <p:cNvPr id="8" name="TextBox 7"/>
-          <p:cNvSpPr txBox="1"/>
+          <p:cNvPr id="8" name="Rectangle 7"/>
+          <p:cNvSpPr/>
           <p:nvPr/>
         </p:nvSpPr>
         <p:spPr>
           <a:xfrm>
-            <a:off x="731520" y="1234440"/>
-            <a:ext cx="5212080" cy="4937760"/>
+            <a:off x="548640" y="1188720"/>
+            <a:ext cx="5486400" cy="365760"/>
           </a:xfrm>
           <a:prstGeom prst="rect">
             <a:avLst/>
           </a:prstGeom>
-          <a:noFill/>
-        </p:spPr>
-        <p:txBody>
-          <a:bodyPr wrap="square">
-            <a:spAutoFit/>
-          </a:bodyPr>
-          <a:lstStyle/>
-          <a:p>
-            <a:pPr>
-              <a:spcAft>
-                <a:spcPts val="1000"/>
-              </a:spcAft>
-              <a:defRPr sz="1600" b="1" u="sng">
-                <a:solidFill>
-                  <a:srgbClr val="1B365D"/>
-                </a:solidFill>
-                <a:latin typeface="Times New Roman"/>
+          <a:solidFill>
+            <a:srgbClr val="E69138"/>
+          </a:solidFill>
+          <a:ln>
+            <a:noFill/>
+          </a:ln>
+        </p:spPr>
+        <p:style>
+          <a:lnRef idx="1">
+            <a:schemeClr val="accent1"/>
+          </a:lnRef>
+          <a:fillRef idx="3">
+            <a:schemeClr val="accent1"/>
+          </a:fillRef>
+          <a:effectRef idx="2">
+            <a:schemeClr val="accent1"/>
+          </a:effectRef>
+          <a:fontRef idx="minor">
+            <a:schemeClr val="lt1"/>
+          </a:fontRef>
+        </p:style>
+        <p:txBody>
+          <a:bodyPr rtlCol="0" anchor="ctr"/>
+          <a:lstStyle/>
+          <a:p>
+            <a:pPr algn="ctr">
+              <a:defRPr sz="1300" b="1">
+                <a:solidFill>
+                  <a:srgbClr val="FFFFFF"/>
+                </a:solidFill>
+                <a:latin typeface="Arial"/>
               </a:defRPr>
             </a:pPr>
             <a:r>
-              <a:t>• Potential impact on the target audience</a:t>
-            </a:r>
-          </a:p>
-          <a:p>
-            <a:pPr>
-              <a:spcAft>
-                <a:spcPts val="600"/>
-              </a:spcAft>
-            </a:pPr>
-            <a:r>
-              <a:rPr b="1" sz="1200">
-                <a:solidFill>
-                  <a:srgbClr val="1B365D"/>
-                </a:solidFill>
-                <a:latin typeface="Arial"/>
-              </a:rPr>
-              <a:t>- Defense &amp; Intelligence Analysts (NTRO / MoD):
-  </a:t>
-            </a:r>
-            <a:r>
-              <a:rPr sz="1150">
-                <a:solidFill>
-                  <a:srgbClr val="14181E"/>
-                </a:solidFill>
-                <a:latin typeface="Arial"/>
-              </a:rPr>
-              <a:t>Saves 4 to 6 hours daily per analyst by instantly synthesizing long threat advisories and technical reports.</a:t>
-            </a:r>
-          </a:p>
-          <a:p>
-            <a:pPr>
-              <a:spcAft>
-                <a:spcPts val="600"/>
-              </a:spcAft>
-            </a:pPr>
-            <a:r>
-              <a:rPr b="1" sz="1200">
-                <a:solidFill>
-                  <a:srgbClr val="1B365D"/>
-                </a:solidFill>
-                <a:latin typeface="Arial"/>
-              </a:rPr>
-              <a:t>- Senior Officials &amp; Executives:
-  </a:t>
-            </a:r>
-            <a:r>
-              <a:rPr sz="1150">
-                <a:solidFill>
-                  <a:srgbClr val="14181E"/>
-                </a:solidFill>
-                <a:latin typeface="Arial"/>
-              </a:rPr>
-              <a:t>Provides 1-page summaries and ready-to-present slide decks for urgent decision meetings.</a:t>
-            </a:r>
-          </a:p>
-          <a:p>
-            <a:pPr>
-              <a:spcAft>
-                <a:spcPts val="600"/>
-              </a:spcAft>
-            </a:pPr>
-            <a:r>
-              <a:rPr b="1" sz="1200">
-                <a:solidFill>
-                  <a:srgbClr val="1B365D"/>
-                </a:solidFill>
-                <a:latin typeface="Arial"/>
-              </a:rPr>
-              <a:t>- Public Relations &amp; Media Officers:
-  </a:t>
-            </a:r>
-            <a:r>
-              <a:rPr sz="1150">
-                <a:solidFill>
-                  <a:srgbClr val="14181E"/>
-                </a:solidFill>
-                <a:latin typeface="Arial"/>
-              </a:rPr>
-              <a:t>Quickly converts technical policy documents into public press releases and infographics in English and regional languages.</a:t>
-            </a:r>
-          </a:p>
-          <a:p>
-            <a:pPr>
-              <a:spcAft>
-                <a:spcPts val="600"/>
-              </a:spcAft>
-            </a:pPr>
-            <a:r>
-              <a:rPr b="1" sz="1200">
-                <a:solidFill>
-                  <a:srgbClr val="1B365D"/>
-                </a:solidFill>
-                <a:latin typeface="Arial"/>
-              </a:rPr>
-              <a:t>- Field Staff &amp; Mobile Teams:
-  </a:t>
-            </a:r>
-            <a:r>
-              <a:rPr sz="1150">
-                <a:solidFill>
-                  <a:srgbClr val="14181E"/>
-                </a:solidFill>
-                <a:latin typeface="Arial"/>
-              </a:rPr>
-              <a:t>Allows personnel to listen to 60-second audio podcast briefings on the go.</a:t>
-            </a:r>
-          </a:p>
-        </p:txBody>
-      </p:sp>
-      <p:sp>
-        <p:nvSpPr>
-          <p:cNvPr id="9" name="TextBox 8"/>
-          <p:cNvSpPr txBox="1"/>
+              <a:t>Impact</a:t>
+            </a:r>
+          </a:p>
+        </p:txBody>
+      </p:sp>
+      <p:sp>
+        <p:nvSpPr>
+          <p:cNvPr id="9" name="Rectangle 8"/>
+          <p:cNvSpPr/>
           <p:nvPr/>
         </p:nvSpPr>
         <p:spPr>
           <a:xfrm>
-            <a:off x="6217920" y="1234440"/>
-            <a:ext cx="5212080" cy="4937760"/>
+            <a:off x="548640" y="1554480"/>
+            <a:ext cx="5486400" cy="2194560"/>
           </a:xfrm>
           <a:prstGeom prst="rect">
             <a:avLst/>
           </a:prstGeom>
-          <a:noFill/>
-        </p:spPr>
-        <p:txBody>
-          <a:bodyPr wrap="square">
-            <a:spAutoFit/>
-          </a:bodyPr>
-          <a:lstStyle/>
+          <a:solidFill>
+            <a:srgbClr val="F5F8FA"/>
+          </a:solidFill>
+          <a:ln>
+            <a:solidFill>
+              <a:srgbClr val="D2DCE6"/>
+            </a:solidFill>
+          </a:ln>
+        </p:spPr>
+        <p:style>
+          <a:lnRef idx="1">
+            <a:schemeClr val="accent1"/>
+          </a:lnRef>
+          <a:fillRef idx="3">
+            <a:schemeClr val="accent1"/>
+          </a:fillRef>
+          <a:effectRef idx="2">
+            <a:schemeClr val="accent1"/>
+          </a:effectRef>
+          <a:fontRef idx="minor">
+            <a:schemeClr val="lt1"/>
+          </a:fontRef>
+        </p:style>
+        <p:txBody>
+          <a:bodyPr rtlCol="0" anchor="ctr" wrap="square" lIns="137160" tIns="109728" rIns="137160"/>
+          <a:lstStyle/>
+          <a:p>
+            <a:pPr algn="ctr">
+              <a:spcAft>
+                <a:spcPts val="400"/>
+              </a:spcAft>
+            </a:pPr>
+            <a:r>
+              <a:rPr b="1" sz="1050">
+                <a:solidFill>
+                  <a:srgbClr val="141414"/>
+                </a:solidFill>
+              </a:rPr>
+              <a:t>● Saves Analyst Time: </a:t>
+            </a:r>
+            <a:r>
+              <a:rPr sz="1050">
+                <a:solidFill>
+                  <a:srgbClr val="141414"/>
+                </a:solidFill>
+              </a:rPr>
+              <a:t>Reduces 4 to 6 hours of manual report writing to under 10 seconds.</a:t>
+            </a:r>
+          </a:p>
           <a:p>
             <a:pPr>
               <a:spcAft>
-                <a:spcPts val="1000"/>
+                <a:spcPts val="400"/>
               </a:spcAft>
-              <a:defRPr sz="1600" b="1" u="sng">
-                <a:solidFill>
-                  <a:srgbClr val="1B365D"/>
-                </a:solidFill>
-                <a:latin typeface="Times New Roman"/>
-              </a:defRPr>
-            </a:pPr>
-            <a:r>
-              <a:t>• Benefits of the solution (social, economic, etc.)</a:t>
+            </a:pPr>
+            <a:r>
+              <a:rPr b="1" sz="1050">
+                <a:solidFill>
+                  <a:srgbClr val="141414"/>
+                </a:solidFill>
+              </a:rPr>
+              <a:t>● Faster Decision Making: </a:t>
+            </a:r>
+            <a:r>
+              <a:rPr sz="1050">
+                <a:solidFill>
+                  <a:srgbClr val="141414"/>
+                </a:solidFill>
+              </a:rPr>
+              <a:t>Officers can quickly read 1-page executive memos during urgent meetings.</a:t>
             </a:r>
           </a:p>
           <a:p>
             <a:pPr>
               <a:spcAft>
-                <a:spcPts val="600"/>
+                <a:spcPts val="400"/>
               </a:spcAft>
             </a:pPr>
             <a:r>
-              <a:rPr b="1" sz="1200">
-                <a:solidFill>
-                  <a:srgbClr val="1B365D"/>
-                </a:solidFill>
-                <a:latin typeface="Arial"/>
-              </a:rPr>
-              <a:t>- Time &amp; Cost Savings:
-  </a:t>
-            </a:r>
-            <a:r>
-              <a:rPr sz="1150">
-                <a:solidFill>
-                  <a:srgbClr val="14181E"/>
-                </a:solidFill>
-                <a:latin typeface="Arial"/>
-              </a:rPr>
-              <a:t>Reduces manual document formatting and translation time by over 80%, saving departmental resources.</a:t>
+              <a:rPr b="1" sz="1050">
+                <a:solidFill>
+                  <a:srgbClr val="141414"/>
+                </a:solidFill>
+              </a:rPr>
+              <a:t>● Regional Language Reach: </a:t>
+            </a:r>
+            <a:r>
+              <a:rPr sz="1050">
+                <a:solidFill>
+                  <a:srgbClr val="141414"/>
+                </a:solidFill>
+              </a:rPr>
+              <a:t>Converts central government policies into Hindi, Kannada, and local Indian languages.</a:t>
+            </a:r>
+          </a:p>
+        </p:txBody>
+      </p:sp>
+      <p:sp>
+        <p:nvSpPr>
+          <p:cNvPr id="10" name="Rectangle 9"/>
+          <p:cNvSpPr/>
+          <p:nvPr/>
+        </p:nvSpPr>
+        <p:spPr>
+          <a:xfrm>
+            <a:off x="548640" y="3931920"/>
+            <a:ext cx="5486400" cy="365760"/>
+          </a:xfrm>
+          <a:prstGeom prst="rect">
+            <a:avLst/>
+          </a:prstGeom>
+          <a:solidFill>
+            <a:srgbClr val="E69138"/>
+          </a:solidFill>
+          <a:ln>
+            <a:noFill/>
+          </a:ln>
+        </p:spPr>
+        <p:style>
+          <a:lnRef idx="1">
+            <a:schemeClr val="accent1"/>
+          </a:lnRef>
+          <a:fillRef idx="3">
+            <a:schemeClr val="accent1"/>
+          </a:fillRef>
+          <a:effectRef idx="2">
+            <a:schemeClr val="accent1"/>
+          </a:effectRef>
+          <a:fontRef idx="minor">
+            <a:schemeClr val="lt1"/>
+          </a:fontRef>
+        </p:style>
+        <p:txBody>
+          <a:bodyPr rtlCol="0" anchor="ctr"/>
+          <a:lstStyle/>
+          <a:p>
+            <a:pPr algn="ctr">
+              <a:defRPr sz="1300" b="1">
+                <a:solidFill>
+                  <a:srgbClr val="FFFFFF"/>
+                </a:solidFill>
+                <a:latin typeface="Arial"/>
+              </a:defRPr>
+            </a:pPr>
+            <a:r>
+              <a:t>Benefits</a:t>
+            </a:r>
+          </a:p>
+        </p:txBody>
+      </p:sp>
+      <p:sp>
+        <p:nvSpPr>
+          <p:cNvPr id="11" name="Rectangle 10"/>
+          <p:cNvSpPr/>
+          <p:nvPr/>
+        </p:nvSpPr>
+        <p:spPr>
+          <a:xfrm>
+            <a:off x="548640" y="4297680"/>
+            <a:ext cx="5486400" cy="1920240"/>
+          </a:xfrm>
+          <a:prstGeom prst="rect">
+            <a:avLst/>
+          </a:prstGeom>
+          <a:solidFill>
+            <a:srgbClr val="F5F8FA"/>
+          </a:solidFill>
+          <a:ln>
+            <a:solidFill>
+              <a:srgbClr val="D2DCE6"/>
+            </a:solidFill>
+          </a:ln>
+        </p:spPr>
+        <p:style>
+          <a:lnRef idx="1">
+            <a:schemeClr val="accent1"/>
+          </a:lnRef>
+          <a:fillRef idx="3">
+            <a:schemeClr val="accent1"/>
+          </a:fillRef>
+          <a:effectRef idx="2">
+            <a:schemeClr val="accent1"/>
+          </a:effectRef>
+          <a:fontRef idx="minor">
+            <a:schemeClr val="lt1"/>
+          </a:fontRef>
+        </p:style>
+        <p:txBody>
+          <a:bodyPr rtlCol="0" anchor="ctr" wrap="square" lIns="137160" tIns="109728" rIns="137160"/>
+          <a:lstStyle/>
+          <a:p>
+            <a:pPr algn="ctr">
+              <a:spcAft>
+                <a:spcPts val="400"/>
+              </a:spcAft>
+            </a:pPr>
+            <a:r>
+              <a:rPr b="1" sz="1050">
+                <a:solidFill>
+                  <a:srgbClr val="141414"/>
+                </a:solidFill>
+              </a:rPr>
+              <a:t>● Cost Effective: </a:t>
+            </a:r>
+            <a:r>
+              <a:rPr sz="1050">
+                <a:solidFill>
+                  <a:srgbClr val="141414"/>
+                </a:solidFill>
+              </a:rPr>
+              <a:t>Eliminates high costs of outsourcing presentation design and document translation.</a:t>
             </a:r>
           </a:p>
           <a:p>
             <a:pPr>
               <a:spcAft>
-                <a:spcPts val="600"/>
+                <a:spcPts val="400"/>
               </a:spcAft>
             </a:pPr>
             <a:r>
-              <a:rPr b="1" sz="1200">
-                <a:solidFill>
-                  <a:srgbClr val="1B365D"/>
-                </a:solidFill>
-                <a:latin typeface="Arial"/>
-              </a:rPr>
-              <a:t>- Regional Language Accessibility:
-  </a:t>
-            </a:r>
-            <a:r>
-              <a:rPr sz="1150">
-                <a:solidFill>
-                  <a:srgbClr val="14181E"/>
-                </a:solidFill>
-                <a:latin typeface="Arial"/>
-              </a:rPr>
-              <a:t>Bridges language barriers by translating government policies into Hindi, Kannada, and other Indian languages.</a:t>
+              <a:rPr b="1" sz="1050">
+                <a:solidFill>
+                  <a:srgbClr val="141414"/>
+                </a:solidFill>
+              </a:rPr>
+              <a:t>● 100% Data Privacy: </a:t>
+            </a:r>
+            <a:r>
+              <a:rPr sz="1050">
+                <a:solidFill>
+                  <a:srgbClr val="141414"/>
+                </a:solidFill>
+              </a:rPr>
+              <a:t>Sensitive government intelligence remains inside local servers without leaks.</a:t>
             </a:r>
           </a:p>
           <a:p>
             <a:pPr>
               <a:spcAft>
-                <a:spcPts val="600"/>
+                <a:spcPts val="400"/>
               </a:spcAft>
             </a:pPr>
             <a:r>
-              <a:rPr b="1" sz="1200">
+              <a:rPr b="1" sz="1050">
+                <a:solidFill>
+                  <a:srgbClr val="141414"/>
+                </a:solidFill>
+              </a:rPr>
+              <a:t>● Easy Mobile Access: </a:t>
+            </a:r>
+            <a:r>
+              <a:rPr sz="1050">
+                <a:solidFill>
+                  <a:srgbClr val="141414"/>
+                </a:solidFill>
+              </a:rPr>
+              <a:t>Field staff can listen to 60-second audio summaries on their mobile phones.</a:t>
+            </a:r>
+          </a:p>
+        </p:txBody>
+      </p:sp>
+      <p:sp>
+        <p:nvSpPr>
+          <p:cNvPr id="12" name="Rectangle 11"/>
+          <p:cNvSpPr/>
+          <p:nvPr/>
+        </p:nvSpPr>
+        <p:spPr>
+          <a:xfrm>
+            <a:off x="6309360" y="1188720"/>
+            <a:ext cx="5303520" cy="365760"/>
+          </a:xfrm>
+          <a:prstGeom prst="rect">
+            <a:avLst/>
+          </a:prstGeom>
+          <a:solidFill>
+            <a:srgbClr val="E69138"/>
+          </a:solidFill>
+          <a:ln>
+            <a:noFill/>
+          </a:ln>
+        </p:spPr>
+        <p:style>
+          <a:lnRef idx="1">
+            <a:schemeClr val="accent1"/>
+          </a:lnRef>
+          <a:fillRef idx="3">
+            <a:schemeClr val="accent1"/>
+          </a:fillRef>
+          <a:effectRef idx="2">
+            <a:schemeClr val="accent1"/>
+          </a:effectRef>
+          <a:fontRef idx="minor">
+            <a:schemeClr val="lt1"/>
+          </a:fontRef>
+        </p:style>
+        <p:txBody>
+          <a:bodyPr rtlCol="0" anchor="ctr"/>
+          <a:lstStyle/>
+          <a:p>
+            <a:pPr algn="ctr">
+              <a:defRPr sz="1300" b="1">
+                <a:solidFill>
+                  <a:srgbClr val="FFFFFF"/>
+                </a:solidFill>
+                <a:latin typeface="Arial"/>
+              </a:defRPr>
+            </a:pPr>
+            <a:r>
+              <a:t>For Instance: User Story</a:t>
+            </a:r>
+          </a:p>
+        </p:txBody>
+      </p:sp>
+      <p:sp>
+        <p:nvSpPr>
+          <p:cNvPr id="13" name="Rectangle 12"/>
+          <p:cNvSpPr/>
+          <p:nvPr/>
+        </p:nvSpPr>
+        <p:spPr>
+          <a:xfrm>
+            <a:off x="6309360" y="1554480"/>
+            <a:ext cx="5303520" cy="4663440"/>
+          </a:xfrm>
+          <a:prstGeom prst="rect">
+            <a:avLst/>
+          </a:prstGeom>
+          <a:solidFill>
+            <a:srgbClr val="F5F8FA"/>
+          </a:solidFill>
+          <a:ln>
+            <a:solidFill>
+              <a:srgbClr val="D2DCE6"/>
+            </a:solidFill>
+          </a:ln>
+        </p:spPr>
+        <p:style>
+          <a:lnRef idx="1">
+            <a:schemeClr val="accent1"/>
+          </a:lnRef>
+          <a:fillRef idx="3">
+            <a:schemeClr val="accent1"/>
+          </a:fillRef>
+          <a:effectRef idx="2">
+            <a:schemeClr val="accent1"/>
+          </a:effectRef>
+          <a:fontRef idx="minor">
+            <a:schemeClr val="lt1"/>
+          </a:fontRef>
+        </p:style>
+        <p:txBody>
+          <a:bodyPr rtlCol="0" anchor="ctr" wrap="square" lIns="182880" tIns="137160" rIns="182880"/>
+          <a:lstStyle/>
+          <a:p>
+            <a:pPr algn="ctr">
+              <a:spcAft>
+                <a:spcPts val="400"/>
+              </a:spcAft>
+            </a:pPr>
+            <a:r>
+              <a:rPr b="1" sz="1050">
                 <a:solidFill>
                   <a:srgbClr val="1B365D"/>
                 </a:solidFill>
-                <a:latin typeface="Arial"/>
-              </a:rPr>
-              <a:t>- Enhanced Information Security:
-  </a:t>
-            </a:r>
-            <a:r>
-              <a:rPr sz="1150">
-                <a:solidFill>
-                  <a:srgbClr val="14181E"/>
-                </a:solidFill>
-                <a:latin typeface="Arial"/>
-              </a:rPr>
-              <a:t>100% data remains on internal servers with zero risk of leaks to third-party APIs.</a:t>
+              </a:rPr>
+              <a:t>Scenario: </a:t>
+            </a:r>
+            <a:r>
+              <a:rPr sz="1050">
+                <a:solidFill>
+                  <a:srgbClr val="141414"/>
+                </a:solidFill>
+              </a:rPr>
+              <a:t>Rahul, an intelligence analyst at a government agency, receives a 50-page technical threat report at 9:00 AM. He has to present the key findings to senior officers in a 9:30 AM meeting.</a:t>
             </a:r>
           </a:p>
           <a:p>
             <a:pPr>
               <a:spcAft>
-                <a:spcPts val="600"/>
+                <a:spcPts val="400"/>
               </a:spcAft>
             </a:pPr>
             <a:r>
-              <a:rPr b="1" sz="1200">
+              <a:rPr b="1" sz="1050">
                 <a:solidFill>
                   <a:srgbClr val="1B365D"/>
                 </a:solidFill>
-                <a:latin typeface="Arial"/>
-              </a:rPr>
-              <a:t>- Eco-Friendly &amp; Paperless:
-  </a:t>
-            </a:r>
-            <a:r>
-              <a:rPr sz="1150">
-                <a:solidFill>
-                  <a:srgbClr val="14181E"/>
-                </a:solidFill>
-                <a:latin typeface="Arial"/>
-              </a:rPr>
-              <a:t>Reduces printing of bulky multi-page reports by providing interactive digital memos and presentations.</a:t>
+              </a:rPr>
+              <a:t>Problem: </a:t>
+            </a:r>
+            <a:r>
+              <a:rPr sz="1050">
+                <a:solidFill>
+                  <a:srgbClr val="141414"/>
+                </a:solidFill>
+              </a:rPr>
+              <a:t>Reading the full 50 pages and manually typing summary slides takes at least 3 hours. Finding the most critical points in a hurry can lead to missing important details.</a:t>
+            </a:r>
+          </a:p>
+          <a:p>
+            <a:pPr>
+              <a:spcAft>
+                <a:spcPts val="400"/>
+              </a:spcAft>
+            </a:pPr>
+            <a:r>
+              <a:rPr b="1" sz="1050">
+                <a:solidFill>
+                  <a:srgbClr val="1B365D"/>
+                </a:solidFill>
+              </a:rPr>
+              <a:t>Impact with OmniTransform: </a:t>
+            </a:r>
+            <a:r>
+              <a:rPr sz="1050">
+                <a:solidFill>
+                  <a:srgbClr val="141414"/>
+                </a:solidFill>
+              </a:rPr>
+              <a:t>Rahul uploads the PDF to OmniTransform. In 10 seconds, the platform gives him:</a:t>
+            </a:r>
+          </a:p>
+          <a:p>
+            <a:pPr>
+              <a:spcAft>
+                <a:spcPts val="400"/>
+              </a:spcAft>
+            </a:pPr>
+            <a:r>
+              <a:rPr b="1" sz="1050">
+                <a:solidFill>
+                  <a:srgbClr val="141414"/>
+                </a:solidFill>
+              </a:rPr>
+              <a:t>● 1-Page Summary Memo </a:t>
+            </a:r>
+            <a:r>
+              <a:rPr sz="1050">
+                <a:solidFill>
+                  <a:srgbClr val="141414"/>
+                </a:solidFill>
+              </a:rPr>
+              <a:t>Clear bullet points with key highlights and numbers.</a:t>
+            </a:r>
+          </a:p>
+          <a:p>
+            <a:pPr>
+              <a:spcAft>
+                <a:spcPts val="400"/>
+              </a:spcAft>
+            </a:pPr>
+            <a:r>
+              <a:rPr b="1" sz="1050">
+                <a:solidFill>
+                  <a:srgbClr val="141414"/>
+                </a:solidFill>
+              </a:rPr>
+              <a:t>● 5 Presentation Slides </a:t>
+            </a:r>
+            <a:r>
+              <a:rPr sz="1050">
+                <a:solidFill>
+                  <a:srgbClr val="141414"/>
+                </a:solidFill>
+              </a:rPr>
+              <a:t>Formatted and ready to project in the meeting room.</a:t>
+            </a:r>
+          </a:p>
+          <a:p>
+            <a:pPr>
+              <a:spcAft>
+                <a:spcPts val="400"/>
+              </a:spcAft>
+            </a:pPr>
+            <a:r>
+              <a:rPr b="1" sz="1050">
+                <a:solidFill>
+                  <a:srgbClr val="141414"/>
+                </a:solidFill>
+              </a:rPr>
+              <a:t>● Clickable Citations </a:t>
+            </a:r>
+            <a:r>
+              <a:rPr sz="1050">
+                <a:solidFill>
+                  <a:srgbClr val="141414"/>
+                </a:solidFill>
+              </a:rPr>
+              <a:t>Rahul clicks any bullet point to show the exact page in the raw PDF.</a:t>
+            </a:r>
+          </a:p>
+          <a:p>
+            <a:pPr>
+              <a:spcAft>
+                <a:spcPts val="400"/>
+              </a:spcAft>
+            </a:pPr>
+            <a:r>
+              <a:rPr b="1" sz="1050">
+                <a:solidFill>
+                  <a:srgbClr val="1B365D"/>
+                </a:solidFill>
+              </a:rPr>
+              <a:t>Benefits: </a:t>
+            </a:r>
+            <a:r>
+              <a:rPr sz="1050">
+                <a:solidFill>
+                  <a:srgbClr val="141414"/>
+                </a:solidFill>
+              </a:rPr>
+              <a:t>Rahul walks into the 9:30 AM meeting fully prepared with accurate, verified facts. What used to take 3 hours was finished in under 10 seconds.</a:t>
             </a:r>
           </a:p>
         </p:txBody>
@@ -5752,8 +6328,8 @@
         </p:nvSpPr>
         <p:spPr>
           <a:xfrm>
-            <a:off x="548640" y="274320"/>
-            <a:ext cx="1645920" cy="914400"/>
+            <a:off x="365760" y="182880"/>
+            <a:ext cx="1645920" cy="868680"/>
           </a:xfrm>
           <a:prstGeom prst="ellipse">
             <a:avLst/>
@@ -5786,28 +6362,15 @@
           <a:lstStyle/>
           <a:p>
             <a:pPr algn="ctr">
-              <a:defRPr sz="1100">
-                <a:solidFill>
-                  <a:srgbClr val="14181E"/>
+              <a:defRPr sz="1200" b="1">
+                <a:solidFill>
+                  <a:srgbClr val="1B365D"/>
                 </a:solidFill>
                 <a:latin typeface="Arial"/>
               </a:defRPr>
             </a:pPr>
             <a:r>
-              <a:t>Your Team</a:t>
-            </a:r>
-          </a:p>
-          <a:p>
-            <a:pPr algn="ctr">
-              <a:defRPr sz="1100">
-                <a:solidFill>
-                  <a:srgbClr val="14181E"/>
-                </a:solidFill>
-                <a:latin typeface="Arial"/>
-              </a:defRPr>
-            </a:pPr>
-            <a:r>
-              <a:t>Name</a:t>
+              <a:t>OmniTransform</a:t>
             </a:r>
           </a:p>
         </p:txBody>
@@ -5820,8 +6383,8 @@
         </p:nvSpPr>
         <p:spPr>
           <a:xfrm>
-            <a:off x="2286000" y="320040"/>
-            <a:ext cx="6217920" cy="777240"/>
+            <a:off x="2103120" y="228600"/>
+            <a:ext cx="6766560" cy="777240"/>
           </a:xfrm>
           <a:prstGeom prst="rect">
             <a:avLst/>
@@ -5864,8 +6427,8 @@
         </p:blipFill>
         <p:spPr>
           <a:xfrm>
-            <a:off x="8961120" y="228600"/>
-            <a:ext cx="2743200" cy="1412611"/>
+            <a:off x="9144000" y="164592"/>
+            <a:ext cx="2560320" cy="1318437"/>
           </a:xfrm>
           <a:prstGeom prst="rect">
             <a:avLst/>
@@ -5995,8 +6558,8 @@
         </p:nvSpPr>
         <p:spPr>
           <a:xfrm>
-            <a:off x="731520" y="1234440"/>
-            <a:ext cx="5212080" cy="4937760"/>
+            <a:off x="1371600" y="1463040"/>
+            <a:ext cx="9418320" cy="4754880"/>
           </a:xfrm>
           <a:prstGeom prst="rect">
             <a:avLst/>
@@ -6011,290 +6574,145 @@
           <a:p>
             <a:pPr>
               <a:spcAft>
-                <a:spcPts val="1000"/>
+                <a:spcPts val="1800"/>
               </a:spcAft>
-              <a:defRPr sz="1600" b="1" u="sng">
-                <a:solidFill>
-                  <a:srgbClr val="1B365D"/>
+            </a:pPr>
+            <a:r>
+              <a:rPr b="1" sz="2000">
+                <a:solidFill>
+                  <a:srgbClr val="141414"/>
+                </a:solidFill>
+              </a:rPr>
+              <a:t>❖  </a:t>
+            </a:r>
+            <a:r>
+              <a:rPr b="1" u="sng" sz="2000">
+                <a:solidFill>
+                  <a:srgbClr val="0077C8"/>
                 </a:solidFill>
                 <a:latin typeface="Times New Roman"/>
-              </a:defRPr>
-            </a:pPr>
-            <a:r>
-              <a:t>• Details / Links of the reference and research work</a:t>
+              </a:rPr>
+              <a:t>APP PROTOTYPE LIVE DEMO LINK</a:t>
             </a:r>
           </a:p>
           <a:p>
             <a:pPr>
               <a:spcAft>
-                <a:spcPts val="600"/>
+                <a:spcPts val="1800"/>
               </a:spcAft>
             </a:pPr>
             <a:r>
-              <a:rPr b="1" sz="1200">
-                <a:solidFill>
-                  <a:srgbClr val="1B365D"/>
-                </a:solidFill>
-                <a:latin typeface="Arial"/>
-              </a:rPr>
-              <a:t>- Retrieval-Augmented Generation (RAG):
-  </a:t>
-            </a:r>
-            <a:r>
-              <a:rPr sz="1150">
-                <a:solidFill>
-                  <a:srgbClr val="14181E"/>
-                </a:solidFill>
-                <a:latin typeface="Arial"/>
-              </a:rPr>
-              <a:t>Lewis et al. (NeurIPS 2020) — Foundation for verifiable knowledge retrieval.</a:t>
+              <a:rPr b="1" sz="2000">
+                <a:solidFill>
+                  <a:srgbClr val="141414"/>
+                </a:solidFill>
+              </a:rPr>
+              <a:t>❖  </a:t>
+            </a:r>
+            <a:r>
+              <a:rPr b="1" u="sng" sz="2000">
+                <a:solidFill>
+                  <a:srgbClr val="0077C8"/>
+                </a:solidFill>
+                <a:latin typeface="Times New Roman"/>
+              </a:rPr>
+              <a:t>GITHUB PROJECT SOURCE CODE REPOSITORY</a:t>
             </a:r>
           </a:p>
           <a:p>
             <a:pPr>
               <a:spcAft>
-                <a:spcPts val="600"/>
+                <a:spcPts val="1800"/>
               </a:spcAft>
             </a:pPr>
             <a:r>
-              <a:rPr b="1" sz="1200">
-                <a:solidFill>
-                  <a:srgbClr val="1B365D"/>
-                </a:solidFill>
-                <a:latin typeface="Arial"/>
-              </a:rPr>
-              <a:t>- Open-Weight Foundation Models:
-  </a:t>
-            </a:r>
-            <a:r>
-              <a:rPr sz="1150">
-                <a:solidFill>
-                  <a:srgbClr val="14181E"/>
-                </a:solidFill>
-                <a:latin typeface="Arial"/>
-              </a:rPr>
-              <a:t>Meta Llama 3 &amp; Mistral AI Research Papers on Instruction Tuning (2024).</a:t>
+              <a:rPr b="1" sz="2000">
+                <a:solidFill>
+                  <a:srgbClr val="141414"/>
+                </a:solidFill>
+              </a:rPr>
+              <a:t>❖  </a:t>
+            </a:r>
+            <a:r>
+              <a:rPr b="1" u="sng" sz="2000">
+                <a:solidFill>
+                  <a:srgbClr val="0077C8"/>
+                </a:solidFill>
+                <a:latin typeface="Times New Roman"/>
+              </a:rPr>
+              <a:t>SMART INDIA HACKATHON 2026 OFFICIAL PROBLEM STATEMENT (PS 26154)</a:t>
             </a:r>
           </a:p>
           <a:p>
             <a:pPr>
               <a:spcAft>
-                <a:spcPts val="600"/>
+                <a:spcPts val="1800"/>
               </a:spcAft>
             </a:pPr>
             <a:r>
-              <a:rPr b="1" sz="1200">
-                <a:solidFill>
-                  <a:srgbClr val="1B365D"/>
-                </a:solidFill>
-                <a:latin typeface="Arial"/>
-              </a:rPr>
-              <a:t>- Multilingual NLP for Indian Languages:
-  </a:t>
-            </a:r>
-            <a:r>
-              <a:rPr sz="1150">
-                <a:solidFill>
-                  <a:srgbClr val="14181E"/>
-                </a:solidFill>
-                <a:latin typeface="Arial"/>
-              </a:rPr>
-              <a:t>AI4Bharat &amp; Bhashini Project Research on IndicBERT (2023).</a:t>
+              <a:rPr b="1" sz="2000">
+                <a:solidFill>
+                  <a:srgbClr val="141414"/>
+                </a:solidFill>
+              </a:rPr>
+              <a:t>❖  </a:t>
+            </a:r>
+            <a:r>
+              <a:rPr b="1" u="sng" sz="2000">
+                <a:solidFill>
+                  <a:srgbClr val="0077C8"/>
+                </a:solidFill>
+                <a:latin typeface="Times New Roman"/>
+              </a:rPr>
+              <a:t>NATIONAL TECHNICAL RESEARCH ORGANISATION (NTRO) PORTAL</a:t>
             </a:r>
           </a:p>
           <a:p>
             <a:pPr>
               <a:spcAft>
-                <a:spcPts val="600"/>
+                <a:spcPts val="1800"/>
               </a:spcAft>
             </a:pPr>
             <a:r>
-              <a:rPr b="1" sz="1200">
-                <a:solidFill>
-                  <a:srgbClr val="1B365D"/>
-                </a:solidFill>
-                <a:latin typeface="Arial"/>
-              </a:rPr>
-              <a:t>- Document Layout Analysis:
-  </a:t>
-            </a:r>
-            <a:r>
-              <a:rPr sz="1150">
-                <a:solidFill>
-                  <a:srgbClr val="14181E"/>
-                </a:solidFill>
-                <a:latin typeface="Arial"/>
-              </a:rPr>
-              <a:t>PyMuPDF spatial coordinate mapping and bounding box extraction standards.</a:t>
-            </a:r>
-          </a:p>
-        </p:txBody>
-      </p:sp>
-      <p:sp>
-        <p:nvSpPr>
-          <p:cNvPr id="9" name="TextBox 8"/>
-          <p:cNvSpPr txBox="1"/>
-          <p:nvPr/>
-        </p:nvSpPr>
-        <p:spPr>
-          <a:xfrm>
-            <a:off x="6217920" y="1234440"/>
-            <a:ext cx="5212080" cy="4937760"/>
-          </a:xfrm>
-          <a:prstGeom prst="rect">
-            <a:avLst/>
-          </a:prstGeom>
-          <a:noFill/>
-        </p:spPr>
-        <p:txBody>
-          <a:bodyPr wrap="square">
-            <a:spAutoFit/>
-          </a:bodyPr>
-          <a:lstStyle/>
+              <a:rPr b="1" sz="2000">
+                <a:solidFill>
+                  <a:srgbClr val="141414"/>
+                </a:solidFill>
+              </a:rPr>
+              <a:t>❖  </a:t>
+            </a:r>
+            <a:r>
+              <a:rPr b="1" u="sng" sz="2000">
+                <a:solidFill>
+                  <a:srgbClr val="0077C8"/>
+                </a:solidFill>
+                <a:latin typeface="Times New Roman"/>
+              </a:rPr>
+              <a:t>RESEARCH PAPER ON AI SUMMARIZATION &amp; RAG (LEWIS ET AL.)</a:t>
+            </a:r>
+          </a:p>
           <a:p>
             <a:pPr>
               <a:spcAft>
-                <a:spcPts val="1000"/>
+                <a:spcPts val="1800"/>
               </a:spcAft>
-              <a:defRPr sz="1600" b="1" u="sng">
-                <a:solidFill>
-                  <a:srgbClr val="1B365D"/>
+            </a:pPr>
+            <a:r>
+              <a:rPr b="1" sz="2000">
+                <a:solidFill>
+                  <a:srgbClr val="141414"/>
+                </a:solidFill>
+              </a:rPr>
+              <a:t>❖  </a:t>
+            </a:r>
+            <a:r>
+              <a:rPr b="1" u="sng" sz="2000">
+                <a:solidFill>
+                  <a:srgbClr val="0077C8"/>
                 </a:solidFill>
                 <a:latin typeface="Times New Roman"/>
-              </a:defRPr>
-            </a:pPr>
-            <a:r>
-              <a:t>• Official Portals &amp; Project Verification Links</a:t>
-            </a:r>
-          </a:p>
-          <a:p>
-            <a:pPr>
-              <a:spcAft>
-                <a:spcPts val="600"/>
-              </a:spcAft>
-            </a:pPr>
-            <a:r>
-              <a:rPr b="1" sz="1200">
-                <a:solidFill>
-                  <a:srgbClr val="1B365D"/>
-                </a:solidFill>
-                <a:latin typeface="Arial"/>
-              </a:rPr>
-              <a:t>- SIH 2026 Problem Statement 26154:
-  </a:t>
-            </a:r>
-            <a:r>
-              <a:rPr sz="1100">
-                <a:solidFill>
-                  <a:srgbClr val="0077C8"/>
-                </a:solidFill>
-                <a:latin typeface="Arial"/>
-              </a:rPr>
-              <a:t>https://www.sih.gov.in/sih2026PS</a:t>
-            </a:r>
-          </a:p>
-          <a:p>
-            <a:pPr>
-              <a:spcAft>
-                <a:spcPts val="600"/>
-              </a:spcAft>
-            </a:pPr>
-            <a:r>
-              <a:rPr b="1" sz="1200">
-                <a:solidFill>
-                  <a:srgbClr val="1B365D"/>
-                </a:solidFill>
-                <a:latin typeface="Arial"/>
-              </a:rPr>
-              <a:t>- NTRO Official Government Website:
-  </a:t>
-            </a:r>
-            <a:r>
-              <a:rPr sz="1100">
-                <a:solidFill>
-                  <a:srgbClr val="0077C8"/>
-                </a:solidFill>
-                <a:latin typeface="Arial"/>
-              </a:rPr>
-              <a:t>https://ntro.gov.in</a:t>
-            </a:r>
-          </a:p>
-          <a:p>
-            <a:pPr>
-              <a:spcAft>
-                <a:spcPts val="600"/>
-              </a:spcAft>
-            </a:pPr>
-            <a:r>
-              <a:rPr b="1" sz="1200">
-                <a:solidFill>
-                  <a:srgbClr val="1B365D"/>
-                </a:solidFill>
-                <a:latin typeface="Arial"/>
-              </a:rPr>
-              <a:t>- Live Web Prototype &amp; Design:
-  </a:t>
-            </a:r>
-            <a:r>
-              <a:rPr sz="1100">
-                <a:solidFill>
-                  <a:srgbClr val="0077C8"/>
-                </a:solidFill>
-                <a:latin typeface="Arial"/>
-              </a:rPr>
-              <a:t>https://hrl-brand-seo.vercel.app</a:t>
-            </a:r>
-          </a:p>
-          <a:p>
-            <a:pPr>
-              <a:spcAft>
-                <a:spcPts val="600"/>
-              </a:spcAft>
-            </a:pPr>
-            <a:r>
-              <a:rPr b="1" sz="1200">
-                <a:solidFill>
-                  <a:srgbClr val="1B365D"/>
-                </a:solidFill>
-                <a:latin typeface="Arial"/>
-              </a:rPr>
-              <a:t>- GitHub Project Repository:
-  </a:t>
-            </a:r>
-            <a:r>
-              <a:rPr sz="1100">
-                <a:solidFill>
-                  <a:srgbClr val="0077C8"/>
-                </a:solidFill>
-                <a:latin typeface="Arial"/>
-              </a:rPr>
-              <a:t>https://github.com/hrlpavan/sih-2026-media-problem-statements</a:t>
-            </a:r>
-          </a:p>
-          <a:p>
-            <a:pPr>
-              <a:spcAft>
-                <a:spcPts val="600"/>
-              </a:spcAft>
-            </a:pPr>
-            <a:r>
-              <a:rPr b="1" sz="1200">
-                <a:solidFill>
-                  <a:srgbClr val="1B365D"/>
-                </a:solidFill>
-                <a:latin typeface="Arial"/>
-              </a:rPr>
-              <a:t>- Winning Strategy &amp; Technical Documentation:
-  </a:t>
-            </a:r>
-            <a:r>
-              <a:rPr sz="1100">
-                <a:solidFill>
-                  <a:srgbClr val="0077C8"/>
-                </a:solidFill>
-                <a:latin typeface="Arial"/>
-              </a:rPr>
-              <a:t>https://github.com/hrlpavan/sih-2026-media-problem-statements/blob/main/WINNING_STRATEGY_PS26154.md</a:t>
+              </a:rPr>
+              <a:t>BHASHINI &amp; AI4BHARAT MULTILINGUAL INDIAN LANGUAGE RESEARCH</a:t>
             </a:r>
           </a:p>
         </p:txBody>

</xml_diff>

<commit_message>
Update README and PPTX with live interactive App Prototype Demo links and video walkthrough
</commit_message>
<xml_diff>
--- a/SIH2026_Idea_Presentation_PS26154.pptx
+++ b/SIH2026_Idea_Presentation_PS26154.pptx
@@ -4590,7 +4590,7 @@
         <p:spPr>
           <a:xfrm>
             <a:off x="6766560" y="1188720"/>
-            <a:ext cx="4846320" cy="4572000"/>
+            <a:ext cx="4846320" cy="4389120"/>
           </a:xfrm>
           <a:prstGeom prst="rect">
             <a:avLst/>
@@ -4821,8 +4821,8 @@
         </p:nvSpPr>
         <p:spPr>
           <a:xfrm>
-            <a:off x="6766560" y="5760720"/>
-            <a:ext cx="4846320" cy="548640"/>
+            <a:off x="6766560" y="5623560"/>
+            <a:ext cx="4846320" cy="731520"/>
           </a:xfrm>
           <a:prstGeom prst="rect">
             <a:avLst/>
@@ -4836,7 +4836,7 @@
           <a:lstStyle/>
           <a:p>
             <a:pPr>
-              <a:defRPr sz="1600" b="1">
+              <a:defRPr sz="1500" b="1">
                 <a:solidFill>
                   <a:srgbClr val="0077C8"/>
                 </a:solidFill>
@@ -4844,7 +4844,20 @@
               </a:defRPr>
             </a:pPr>
             <a:r>
-              <a:t>APP PROTOTYPE VIDEO / DEMO LINK</a:t>
+              <a:t>APP PROTOTYPE LIVE DEMO LINK</a:t>
+            </a:r>
+          </a:p>
+          <a:p>
+            <a:pPr>
+              <a:defRPr sz="1300" b="1" u="sng">
+                <a:solidFill>
+                  <a:srgbClr val="0077C8"/>
+                </a:solidFill>
+                <a:latin typeface="Arial"/>
+              </a:defRPr>
+            </a:pPr>
+            <a:r>
+              <a:t>https://hrl-brand-seo.vercel.app</a:t>
             </a:r>
           </a:p>
         </p:txBody>
@@ -6558,8 +6571,8 @@
         </p:nvSpPr>
         <p:spPr>
           <a:xfrm>
-            <a:off x="1371600" y="1463040"/>
-            <a:ext cx="9418320" cy="4754880"/>
+            <a:off x="914400" y="1280160"/>
+            <a:ext cx="10332720" cy="4937760"/>
           </a:xfrm>
           <a:prstGeom prst="rect">
             <a:avLst/>
@@ -6574,11 +6587,11 @@
           <a:p>
             <a:pPr>
               <a:spcAft>
-                <a:spcPts val="1800"/>
+                <a:spcPts val="1200"/>
               </a:spcAft>
             </a:pPr>
             <a:r>
-              <a:rPr b="1" sz="2000">
+              <a:rPr b="1" sz="1500">
                 <a:solidFill>
                   <a:srgbClr val="141414"/>
                 </a:solidFill>
@@ -6586,23 +6599,32 @@
               <a:t>❖  </a:t>
             </a:r>
             <a:r>
-              <a:rPr b="1" u="sng" sz="2000">
+              <a:rPr b="1" sz="1400">
+                <a:solidFill>
+                  <a:srgbClr val="1B365D"/>
+                </a:solidFill>
+                <a:latin typeface="Times New Roman"/>
+              </a:rPr>
+              <a:t>APP PROTOTYPE LIVE DEMO LINK:  </a:t>
+            </a:r>
+            <a:r>
+              <a:rPr u="sng" sz="1300">
                 <a:solidFill>
                   <a:srgbClr val="0077C8"/>
                 </a:solidFill>
-                <a:latin typeface="Times New Roman"/>
-              </a:rPr>
-              <a:t>APP PROTOTYPE LIVE DEMO LINK</a:t>
+                <a:latin typeface="Arial"/>
+              </a:rPr>
+              <a:t>https://hrl-brand-seo.vercel.app</a:t>
             </a:r>
           </a:p>
           <a:p>
             <a:pPr>
               <a:spcAft>
-                <a:spcPts val="1800"/>
+                <a:spcPts val="1200"/>
               </a:spcAft>
             </a:pPr>
             <a:r>
-              <a:rPr b="1" sz="2000">
+              <a:rPr b="1" sz="1500">
                 <a:solidFill>
                   <a:srgbClr val="141414"/>
                 </a:solidFill>
@@ -6610,23 +6632,32 @@
               <a:t>❖  </a:t>
             </a:r>
             <a:r>
-              <a:rPr b="1" u="sng" sz="2000">
+              <a:rPr b="1" sz="1400">
+                <a:solidFill>
+                  <a:srgbClr val="1B365D"/>
+                </a:solidFill>
+                <a:latin typeface="Times New Roman"/>
+              </a:rPr>
+              <a:t>GITHUB PROJECT REPOSITORY LINK:  </a:t>
+            </a:r>
+            <a:r>
+              <a:rPr u="sng" sz="1300">
                 <a:solidFill>
                   <a:srgbClr val="0077C8"/>
                 </a:solidFill>
-                <a:latin typeface="Times New Roman"/>
-              </a:rPr>
-              <a:t>GITHUB PROJECT SOURCE CODE REPOSITORY</a:t>
+                <a:latin typeface="Arial"/>
+              </a:rPr>
+              <a:t>https://github.com/hrlpavan/sih-2026-media-problem-statements</a:t>
             </a:r>
           </a:p>
           <a:p>
             <a:pPr>
               <a:spcAft>
-                <a:spcPts val="1800"/>
+                <a:spcPts val="1200"/>
               </a:spcAft>
             </a:pPr>
             <a:r>
-              <a:rPr b="1" sz="2000">
+              <a:rPr b="1" sz="1500">
                 <a:solidFill>
                   <a:srgbClr val="141414"/>
                 </a:solidFill>
@@ -6634,23 +6665,32 @@
               <a:t>❖  </a:t>
             </a:r>
             <a:r>
-              <a:rPr b="1" u="sng" sz="2000">
+              <a:rPr b="1" sz="1400">
+                <a:solidFill>
+                  <a:srgbClr val="1B365D"/>
+                </a:solidFill>
+                <a:latin typeface="Times New Roman"/>
+              </a:rPr>
+              <a:t>SMART INDIA HACKATHON 2026 OFFICIAL PORTAL (PS ID 26154):  </a:t>
+            </a:r>
+            <a:r>
+              <a:rPr u="sng" sz="1300">
                 <a:solidFill>
                   <a:srgbClr val="0077C8"/>
                 </a:solidFill>
-                <a:latin typeface="Times New Roman"/>
-              </a:rPr>
-              <a:t>SMART INDIA HACKATHON 2026 OFFICIAL PROBLEM STATEMENT (PS 26154)</a:t>
+                <a:latin typeface="Arial"/>
+              </a:rPr>
+              <a:t>https://www.sih.gov.in/sih2026PS</a:t>
             </a:r>
           </a:p>
           <a:p>
             <a:pPr>
               <a:spcAft>
-                <a:spcPts val="1800"/>
+                <a:spcPts val="1200"/>
               </a:spcAft>
             </a:pPr>
             <a:r>
-              <a:rPr b="1" sz="2000">
+              <a:rPr b="1" sz="1500">
                 <a:solidFill>
                   <a:srgbClr val="141414"/>
                 </a:solidFill>
@@ -6658,23 +6698,32 @@
               <a:t>❖  </a:t>
             </a:r>
             <a:r>
-              <a:rPr b="1" u="sng" sz="2000">
+              <a:rPr b="1" sz="1400">
+                <a:solidFill>
+                  <a:srgbClr val="1B365D"/>
+                </a:solidFill>
+                <a:latin typeface="Times New Roman"/>
+              </a:rPr>
+              <a:t>NATIONAL TECHNICAL RESEARCH ORGANISATION (NTRO) PORTAL:  </a:t>
+            </a:r>
+            <a:r>
+              <a:rPr u="sng" sz="1300">
                 <a:solidFill>
                   <a:srgbClr val="0077C8"/>
                 </a:solidFill>
-                <a:latin typeface="Times New Roman"/>
-              </a:rPr>
-              <a:t>NATIONAL TECHNICAL RESEARCH ORGANISATION (NTRO) PORTAL</a:t>
+                <a:latin typeface="Arial"/>
+              </a:rPr>
+              <a:t>https://ntro.gov.in</a:t>
             </a:r>
           </a:p>
           <a:p>
             <a:pPr>
               <a:spcAft>
-                <a:spcPts val="1800"/>
+                <a:spcPts val="1200"/>
               </a:spcAft>
             </a:pPr>
             <a:r>
-              <a:rPr b="1" sz="2000">
+              <a:rPr b="1" sz="1500">
                 <a:solidFill>
                   <a:srgbClr val="141414"/>
                 </a:solidFill>
@@ -6682,23 +6731,32 @@
               <a:t>❖  </a:t>
             </a:r>
             <a:r>
-              <a:rPr b="1" u="sng" sz="2000">
+              <a:rPr b="1" sz="1400">
+                <a:solidFill>
+                  <a:srgbClr val="1B365D"/>
+                </a:solidFill>
+                <a:latin typeface="Times New Roman"/>
+              </a:rPr>
+              <a:t>RESEARCH ON RAG &amp; SOURCE CITATIONS (LEWIS ET AL.):  </a:t>
+            </a:r>
+            <a:r>
+              <a:rPr u="sng" sz="1300">
                 <a:solidFill>
                   <a:srgbClr val="0077C8"/>
                 </a:solidFill>
-                <a:latin typeface="Times New Roman"/>
-              </a:rPr>
-              <a:t>RESEARCH PAPER ON AI SUMMARIZATION &amp; RAG (LEWIS ET AL.)</a:t>
+                <a:latin typeface="Arial"/>
+              </a:rPr>
+              <a:t>https://arxiv.org/abs/2005.11401</a:t>
             </a:r>
           </a:p>
           <a:p>
             <a:pPr>
               <a:spcAft>
-                <a:spcPts val="1800"/>
+                <a:spcPts val="1200"/>
               </a:spcAft>
             </a:pPr>
             <a:r>
-              <a:rPr b="1" sz="2000">
+              <a:rPr b="1" sz="1500">
                 <a:solidFill>
                   <a:srgbClr val="141414"/>
                 </a:solidFill>
@@ -6706,13 +6764,22 @@
               <a:t>❖  </a:t>
             </a:r>
             <a:r>
-              <a:rPr b="1" u="sng" sz="2000">
+              <a:rPr b="1" sz="1400">
+                <a:solidFill>
+                  <a:srgbClr val="1B365D"/>
+                </a:solidFill>
+                <a:latin typeface="Times New Roman"/>
+              </a:rPr>
+              <a:t>BHASHINI &amp; AI4BHARAT MULTILINGUAL RESEARCH:  </a:t>
+            </a:r>
+            <a:r>
+              <a:rPr u="sng" sz="1300">
                 <a:solidFill>
                   <a:srgbClr val="0077C8"/>
                 </a:solidFill>
-                <a:latin typeface="Times New Roman"/>
-              </a:rPr>
-              <a:t>BHASHINI &amp; AI4BHARAT MULTILINGUAL INDIAN LANGUAGE RESEARCH</a:t>
+                <a:latin typeface="Arial"/>
+              </a:rPr>
+              <a:t>https://bhashini.gov.in</a:t>
             </a:r>
           </a:p>
         </p:txBody>

</xml_diff>

<commit_message>
Completely remove main company website link across all presentation and documentation files
</commit_message>
<xml_diff>
--- a/SIH2026_Idea_Presentation_PS26154.pptx
+++ b/SIH2026_Idea_Presentation_PS26154.pptx
@@ -4857,7 +4857,7 @@
               </a:defRPr>
             </a:pPr>
             <a:r>
-              <a:t>https://hrl-brand-seo.vercel.app</a:t>
+              <a:t>https://github.com/hrlpavan/sih-2026-media-problem-statements</a:t>
             </a:r>
           </a:p>
         </p:txBody>
@@ -6614,7 +6614,7 @@
                 </a:solidFill>
                 <a:latin typeface="Arial"/>
               </a:rPr>
-              <a:t>https://hrl-brand-seo.vercel.app</a:t>
+              <a:t>https://github.com/hrlpavan/sih-2026-media-problem-statements</a:t>
             </a:r>
           </a:p>
           <a:p>

</xml_diff>

<commit_message>
Update PPTX with dedicated resource repository https://github.com/hrlpavan/omnitransform-ai-resources
</commit_message>
<xml_diff>
--- a/SIH2026_Idea_Presentation_PS26154.pptx
+++ b/SIH2026_Idea_Presentation_PS26154.pptx
@@ -3101,8 +3101,8 @@
         </p:nvSpPr>
         <p:spPr>
           <a:xfrm>
-            <a:off x="731520" y="548640"/>
-            <a:ext cx="10698480" cy="731520"/>
+            <a:off x="731520" y="457200"/>
+            <a:ext cx="10698480" cy="640080"/>
           </a:xfrm>
           <a:prstGeom prst="rect">
             <a:avLst/>
@@ -3137,8 +3137,8 @@
         </p:nvSpPr>
         <p:spPr>
           <a:xfrm>
-            <a:off x="731520" y="1463040"/>
-            <a:ext cx="7498079" cy="4754880"/>
+            <a:off x="731520" y="1280160"/>
+            <a:ext cx="7680960" cy="4937760"/>
           </a:xfrm>
           <a:prstGeom prst="rect">
             <a:avLst/>
@@ -3153,11 +3153,11 @@
           <a:p>
             <a:pPr>
               <a:spcAft>
-                <a:spcPts val="1400"/>
+                <a:spcPts val="1000"/>
               </a:spcAft>
             </a:pPr>
             <a:r>
-              <a:rPr b="1" sz="1800">
+              <a:rPr b="1" sz="1750">
                 <a:solidFill>
                   <a:srgbClr val="141414"/>
                 </a:solidFill>
@@ -3166,7 +3166,7 @@
               <a:t>• Problem Statement ID – </a:t>
             </a:r>
             <a:r>
-              <a:rPr b="1" sz="1800">
+              <a:rPr b="1" sz="1750" u="none">
                 <a:solidFill>
                   <a:srgbClr val="141414"/>
                 </a:solidFill>
@@ -3178,11 +3178,11 @@
           <a:p>
             <a:pPr>
               <a:spcAft>
-                <a:spcPts val="1400"/>
+                <a:spcPts val="1000"/>
               </a:spcAft>
             </a:pPr>
             <a:r>
-              <a:rPr b="1" sz="1800">
+              <a:rPr b="1" sz="1750">
                 <a:solidFill>
                   <a:srgbClr val="141414"/>
                 </a:solidFill>
@@ -3191,7 +3191,7 @@
               <a:t>• Problem Statement Title - </a:t>
             </a:r>
             <a:r>
-              <a:rPr b="1" sz="1800">
+              <a:rPr b="1" sz="1750" u="none">
                 <a:solidFill>
                   <a:srgbClr val="141414"/>
                 </a:solidFill>
@@ -3203,11 +3203,11 @@
           <a:p>
             <a:pPr>
               <a:spcAft>
-                <a:spcPts val="1400"/>
+                <a:spcPts val="1000"/>
               </a:spcAft>
             </a:pPr>
             <a:r>
-              <a:rPr b="1" sz="1800">
+              <a:rPr b="1" sz="1750">
                 <a:solidFill>
                   <a:srgbClr val="141414"/>
                 </a:solidFill>
@@ -3216,7 +3216,7 @@
               <a:t>• Theme - </a:t>
             </a:r>
             <a:r>
-              <a:rPr b="0" sz="1800">
+              <a:rPr b="0" sz="1750" u="none">
                 <a:solidFill>
                   <a:srgbClr val="141414"/>
                 </a:solidFill>
@@ -3228,11 +3228,11 @@
           <a:p>
             <a:pPr>
               <a:spcAft>
-                <a:spcPts val="1400"/>
+                <a:spcPts val="1000"/>
               </a:spcAft>
             </a:pPr>
             <a:r>
-              <a:rPr b="1" sz="1800">
+              <a:rPr b="1" sz="1750">
                 <a:solidFill>
                   <a:srgbClr val="141414"/>
                 </a:solidFill>
@@ -3241,7 +3241,7 @@
               <a:t>• PS Category - </a:t>
             </a:r>
             <a:r>
-              <a:rPr b="0" sz="1800">
+              <a:rPr b="0" sz="1750" u="none">
                 <a:solidFill>
                   <a:srgbClr val="141414"/>
                 </a:solidFill>
@@ -3253,11 +3253,11 @@
           <a:p>
             <a:pPr>
               <a:spcAft>
-                <a:spcPts val="1400"/>
+                <a:spcPts val="1000"/>
               </a:spcAft>
             </a:pPr>
             <a:r>
-              <a:rPr b="1" sz="1800">
+              <a:rPr b="1" sz="1750">
                 <a:solidFill>
                   <a:srgbClr val="141414"/>
                 </a:solidFill>
@@ -3266,7 +3266,7 @@
               <a:t>• Team ID - </a:t>
             </a:r>
             <a:r>
-              <a:rPr b="0" sz="1800">
+              <a:rPr b="0" sz="1750" u="none">
                 <a:solidFill>
                   <a:srgbClr val="141414"/>
                 </a:solidFill>
@@ -3278,11 +3278,11 @@
           <a:p>
             <a:pPr>
               <a:spcAft>
-                <a:spcPts val="1400"/>
+                <a:spcPts val="1000"/>
               </a:spcAft>
             </a:pPr>
             <a:r>
-              <a:rPr b="1" sz="1800">
+              <a:rPr b="1" sz="1750">
                 <a:solidFill>
                   <a:srgbClr val="141414"/>
                 </a:solidFill>
@@ -3291,13 +3291,38 @@
               <a:t>• Team Name - </a:t>
             </a:r>
             <a:r>
-              <a:rPr b="1" sz="1800">
+              <a:rPr b="1" sz="1750" u="none">
                 <a:solidFill>
                   <a:srgbClr val="141414"/>
                 </a:solidFill>
                 <a:latin typeface="Arial"/>
               </a:rPr>
               <a:t>OmniTransform</a:t>
+            </a:r>
+          </a:p>
+          <a:p>
+            <a:pPr>
+              <a:spcAft>
+                <a:spcPts val="1000"/>
+              </a:spcAft>
+            </a:pPr>
+            <a:r>
+              <a:rPr b="1" sz="1600">
+                <a:solidFill>
+                  <a:srgbClr val="1B365D"/>
+                </a:solidFill>
+                <a:latin typeface="Times New Roman"/>
+              </a:rPr>
+              <a:t>• Project Resources - </a:t>
+            </a:r>
+            <a:r>
+              <a:rPr b="1" sz="1400" u="sng">
+                <a:solidFill>
+                  <a:srgbClr val="0077C8"/>
+                </a:solidFill>
+                <a:latin typeface="Arial"/>
+              </a:rPr>
+              <a:t>https://github.com/hrlpavan/omnitransform-ai-resources</a:t>
             </a:r>
           </a:p>
         </p:txBody>
@@ -4590,7 +4615,7 @@
         <p:spPr>
           <a:xfrm>
             <a:off x="6766560" y="1188720"/>
-            <a:ext cx="4846320" cy="4389120"/>
+            <a:ext cx="4846320" cy="4297680"/>
           </a:xfrm>
           <a:prstGeom prst="rect">
             <a:avLst/>
@@ -4821,8 +4846,8 @@
         </p:nvSpPr>
         <p:spPr>
           <a:xfrm>
-            <a:off x="6766560" y="5623560"/>
-            <a:ext cx="4846320" cy="731520"/>
+            <a:off x="6766560" y="5577840"/>
+            <a:ext cx="4846320" cy="777240"/>
           </a:xfrm>
           <a:prstGeom prst="rect">
             <a:avLst/>
@@ -4836,7 +4861,7 @@
           <a:lstStyle/>
           <a:p>
             <a:pPr>
-              <a:defRPr sz="1500" b="1">
+              <a:defRPr sz="1350" b="1">
                 <a:solidFill>
                   <a:srgbClr val="0077C8"/>
                 </a:solidFill>
@@ -4844,12 +4869,12 @@
               </a:defRPr>
             </a:pPr>
             <a:r>
-              <a:t>APP PROTOTYPE LIVE DEMO LINK</a:t>
+              <a:t>APP PROTOTYPE &amp; RESOURCE REPOSITORY LINK</a:t>
             </a:r>
           </a:p>
           <a:p>
             <a:pPr>
-              <a:defRPr sz="1300" b="1" u="sng">
+              <a:defRPr sz="1200" b="1" u="sng">
                 <a:solidFill>
                   <a:srgbClr val="0077C8"/>
                 </a:solidFill>
@@ -4857,7 +4882,7 @@
               </a:defRPr>
             </a:pPr>
             <a:r>
-              <a:t>https://github.com/hrlpavan/sih-2026-media-problem-statements</a:t>
+              <a:t>https://github.com/hrlpavan/omnitransform-ai-resources</a:t>
             </a:r>
           </a:p>
         </p:txBody>
@@ -6571,8 +6596,8 @@
         </p:nvSpPr>
         <p:spPr>
           <a:xfrm>
-            <a:off x="914400" y="1280160"/>
-            <a:ext cx="10332720" cy="4937760"/>
+            <a:off x="731520" y="1234440"/>
+            <a:ext cx="10698480" cy="5029200"/>
           </a:xfrm>
           <a:prstGeom prst="rect">
             <a:avLst/>
@@ -6587,11 +6612,11 @@
           <a:p>
             <a:pPr>
               <a:spcAft>
-                <a:spcPts val="1200"/>
+                <a:spcPts val="1000"/>
               </a:spcAft>
             </a:pPr>
             <a:r>
-              <a:rPr b="1" sz="1500">
+              <a:rPr b="1" sz="1400">
                 <a:solidFill>
                   <a:srgbClr val="141414"/>
                 </a:solidFill>
@@ -6599,32 +6624,32 @@
               <a:t>❖  </a:t>
             </a:r>
             <a:r>
-              <a:rPr b="1" sz="1400">
+              <a:rPr b="1" sz="1300">
                 <a:solidFill>
                   <a:srgbClr val="1B365D"/>
                 </a:solidFill>
                 <a:latin typeface="Times New Roman"/>
               </a:rPr>
-              <a:t>APP PROTOTYPE LIVE DEMO LINK:  </a:t>
-            </a:r>
-            <a:r>
-              <a:rPr u="sng" sz="1300">
+              <a:t>MASTER RESOURCE REPOSITORY &amp; CODE:  </a:t>
+            </a:r>
+            <a:r>
+              <a:rPr u="sng" sz="1200">
                 <a:solidFill>
                   <a:srgbClr val="0077C8"/>
                 </a:solidFill>
                 <a:latin typeface="Arial"/>
               </a:rPr>
-              <a:t>https://github.com/hrlpavan/sih-2026-media-problem-statements</a:t>
+              <a:t>https://github.com/hrlpavan/omnitransform-ai-resources</a:t>
             </a:r>
           </a:p>
           <a:p>
             <a:pPr>
               <a:spcAft>
-                <a:spcPts val="1200"/>
+                <a:spcPts val="1000"/>
               </a:spcAft>
             </a:pPr>
             <a:r>
-              <a:rPr b="1" sz="1500">
+              <a:rPr b="1" sz="1400">
                 <a:solidFill>
                   <a:srgbClr val="141414"/>
                 </a:solidFill>
@@ -6632,32 +6657,32 @@
               <a:t>❖  </a:t>
             </a:r>
             <a:r>
-              <a:rPr b="1" sz="1400">
+              <a:rPr b="1" sz="1300">
                 <a:solidFill>
                   <a:srgbClr val="1B365D"/>
                 </a:solidFill>
                 <a:latin typeface="Times New Roman"/>
               </a:rPr>
-              <a:t>GITHUB PROJECT REPOSITORY LINK:  </a:t>
-            </a:r>
-            <a:r>
-              <a:rPr u="sng" sz="1300">
+              <a:t>OPEN-SOURCE DATASETS &amp; MODELS GUIDE:  </a:t>
+            </a:r>
+            <a:r>
+              <a:rPr u="sng" sz="1200">
                 <a:solidFill>
                   <a:srgbClr val="0077C8"/>
                 </a:solidFill>
                 <a:latin typeface="Arial"/>
               </a:rPr>
-              <a:t>https://github.com/hrlpavan/sih-2026-media-problem-statements</a:t>
+              <a:t>https://github.com/hrlpavan/omnitransform-ai-resources/blob/main/OPEN_SOURCE_RESOURCES_AND_DATASETS.md</a:t>
             </a:r>
           </a:p>
           <a:p>
             <a:pPr>
               <a:spcAft>
-                <a:spcPts val="1200"/>
+                <a:spcPts val="1000"/>
               </a:spcAft>
             </a:pPr>
             <a:r>
-              <a:rPr b="1" sz="1500">
+              <a:rPr b="1" sz="1400">
                 <a:solidFill>
                   <a:srgbClr val="141414"/>
                 </a:solidFill>
@@ -6665,32 +6690,32 @@
               <a:t>❖  </a:t>
             </a:r>
             <a:r>
-              <a:rPr b="1" sz="1400">
+              <a:rPr b="1" sz="1300">
                 <a:solidFill>
                   <a:srgbClr val="1B365D"/>
                 </a:solidFill>
                 <a:latin typeface="Times New Roman"/>
               </a:rPr>
-              <a:t>SMART INDIA HACKATHON 2026 OFFICIAL PORTAL (PS ID 26154):  </a:t>
-            </a:r>
-            <a:r>
-              <a:rPr u="sng" sz="1300">
+              <a:t>TECHNICAL DEVELOPMENT SPECIFICATION:  </a:t>
+            </a:r>
+            <a:r>
+              <a:rPr u="sng" sz="1200">
                 <a:solidFill>
                   <a:srgbClr val="0077C8"/>
                 </a:solidFill>
                 <a:latin typeface="Arial"/>
               </a:rPr>
-              <a:t>https://www.sih.gov.in/sih2026PS</a:t>
+              <a:t>https://github.com/hrlpavan/omnitransform-ai-resources/blob/main/PROJECT_DEVELOPMENT_SPECIFICATION.md</a:t>
             </a:r>
           </a:p>
           <a:p>
             <a:pPr>
               <a:spcAft>
-                <a:spcPts val="1200"/>
+                <a:spcPts val="1000"/>
               </a:spcAft>
             </a:pPr>
             <a:r>
-              <a:rPr b="1" sz="1500">
+              <a:rPr b="1" sz="1400">
                 <a:solidFill>
                   <a:srgbClr val="141414"/>
                 </a:solidFill>
@@ -6698,32 +6723,32 @@
               <a:t>❖  </a:t>
             </a:r>
             <a:r>
-              <a:rPr b="1" sz="1400">
+              <a:rPr b="1" sz="1300">
                 <a:solidFill>
                   <a:srgbClr val="1B365D"/>
                 </a:solidFill>
                 <a:latin typeface="Times New Roman"/>
               </a:rPr>
-              <a:t>NATIONAL TECHNICAL RESEARCH ORGANISATION (NTRO) PORTAL:  </a:t>
-            </a:r>
-            <a:r>
-              <a:rPr u="sng" sz="1300">
+              <a:t>SMART INDIA HACKATHON 2026 OFFICIAL PORTAL (PS ID 26154):  </a:t>
+            </a:r>
+            <a:r>
+              <a:rPr u="sng" sz="1200">
                 <a:solidFill>
                   <a:srgbClr val="0077C8"/>
                 </a:solidFill>
                 <a:latin typeface="Arial"/>
               </a:rPr>
-              <a:t>https://ntro.gov.in</a:t>
+              <a:t>https://www.sih.gov.in/sih2026PS</a:t>
             </a:r>
           </a:p>
           <a:p>
             <a:pPr>
               <a:spcAft>
-                <a:spcPts val="1200"/>
+                <a:spcPts val="1000"/>
               </a:spcAft>
             </a:pPr>
             <a:r>
-              <a:rPr b="1" sz="1500">
+              <a:rPr b="1" sz="1400">
                 <a:solidFill>
                   <a:srgbClr val="141414"/>
                 </a:solidFill>
@@ -6731,32 +6756,32 @@
               <a:t>❖  </a:t>
             </a:r>
             <a:r>
-              <a:rPr b="1" sz="1400">
+              <a:rPr b="1" sz="1300">
                 <a:solidFill>
                   <a:srgbClr val="1B365D"/>
                 </a:solidFill>
                 <a:latin typeface="Times New Roman"/>
               </a:rPr>
-              <a:t>RESEARCH ON RAG &amp; SOURCE CITATIONS (LEWIS ET AL.):  </a:t>
-            </a:r>
-            <a:r>
-              <a:rPr u="sng" sz="1300">
+              <a:t>NATIONAL TECHNICAL RESEARCH ORGANISATION (NTRO) PORTAL:  </a:t>
+            </a:r>
+            <a:r>
+              <a:rPr u="sng" sz="1200">
                 <a:solidFill>
                   <a:srgbClr val="0077C8"/>
                 </a:solidFill>
                 <a:latin typeface="Arial"/>
               </a:rPr>
-              <a:t>https://arxiv.org/abs/2005.11401</a:t>
+              <a:t>https://ntro.gov.in</a:t>
             </a:r>
           </a:p>
           <a:p>
             <a:pPr>
               <a:spcAft>
-                <a:spcPts val="1200"/>
+                <a:spcPts val="1000"/>
               </a:spcAft>
             </a:pPr>
             <a:r>
-              <a:rPr b="1" sz="1500">
+              <a:rPr b="1" sz="1400">
                 <a:solidFill>
                   <a:srgbClr val="141414"/>
                 </a:solidFill>
@@ -6764,22 +6789,22 @@
               <a:t>❖  </a:t>
             </a:r>
             <a:r>
-              <a:rPr b="1" sz="1400">
+              <a:rPr b="1" sz="1300">
                 <a:solidFill>
                   <a:srgbClr val="1B365D"/>
                 </a:solidFill>
                 <a:latin typeface="Times New Roman"/>
               </a:rPr>
-              <a:t>BHASHINI &amp; AI4BHARAT MULTILINGUAL RESEARCH:  </a:t>
-            </a:r>
-            <a:r>
-              <a:rPr u="sng" sz="1300">
+              <a:t>RESEARCH ON RAG &amp; CITATIONS (LEWIS ET AL. 2020):  </a:t>
+            </a:r>
+            <a:r>
+              <a:rPr u="sng" sz="1200">
                 <a:solidFill>
                   <a:srgbClr val="0077C8"/>
                 </a:solidFill>
                 <a:latin typeface="Arial"/>
               </a:rPr>
-              <a:t>https://bhashini.gov.in</a:t>
+              <a:t>https://arxiv.org/abs/2005.11401</a:t>
             </a:r>
           </a:p>
         </p:txBody>

</xml_diff>

<commit_message>
Integrate official HRL brand logo across webpage and PowerPoint deck
</commit_message>
<xml_diff>
--- a/SIH2026_Idea_Presentation_PS26154.pptx
+++ b/SIH2026_Idea_Presentation_PS26154.pptx
@@ -3329,7 +3329,7 @@
       </p:sp>
       <p:pic>
         <p:nvPicPr>
-          <p:cNvPr id="4" name="Picture 3" descr="sih_official_logo.png"/>
+          <p:cNvPr id="4" name="Picture 3" descr="hrl_brand_logo.png"/>
           <p:cNvPicPr>
             <a:picLocks noChangeAspect="1"/>
           </p:cNvPicPr>
@@ -3343,8 +3343,8 @@
         </p:blipFill>
         <p:spPr>
           <a:xfrm>
-            <a:off x="8412480" y="1645920"/>
-            <a:ext cx="3291840" cy="1695134"/>
+            <a:off x="8595360" y="2011680"/>
+            <a:ext cx="3017520" cy="1090602"/>
           </a:xfrm>
           <a:prstGeom prst="rect">
             <a:avLst/>
@@ -3411,15 +3411,15 @@
           <a:lstStyle/>
           <a:p>
             <a:pPr algn="ctr">
-              <a:defRPr sz="1200" b="1">
+              <a:defRPr b="1" sz="1300">
                 <a:solidFill>
                   <a:srgbClr val="1B365D"/>
                 </a:solidFill>
-                <a:latin typeface="Arial"/>
+                <a:latin typeface="Times New Roman"/>
               </a:defRPr>
             </a:pPr>
             <a:r>
-              <a:t>OmniTransform</a:t>
+              <a:t>TEAM: HRL</a:t>
             </a:r>
           </a:p>
         </p:txBody>
@@ -4394,15 +4394,15 @@
           <a:lstStyle/>
           <a:p>
             <a:pPr algn="ctr">
-              <a:defRPr sz="1200" b="1">
+              <a:defRPr b="1" sz="1300">
                 <a:solidFill>
                   <a:srgbClr val="1B365D"/>
                 </a:solidFill>
-                <a:latin typeface="Arial"/>
+                <a:latin typeface="Times New Roman"/>
               </a:defRPr>
             </a:pPr>
             <a:r>
-              <a:t>OmniTransform</a:t>
+              <a:t>TEAM: HRL</a:t>
             </a:r>
           </a:p>
         </p:txBody>
@@ -4947,15 +4947,15 @@
           <a:lstStyle/>
           <a:p>
             <a:pPr algn="ctr">
-              <a:defRPr sz="1200" b="1">
+              <a:defRPr b="1" sz="1300">
                 <a:solidFill>
                   <a:srgbClr val="1B365D"/>
                 </a:solidFill>
-                <a:latin typeface="Arial"/>
+                <a:latin typeface="Times New Roman"/>
               </a:defRPr>
             </a:pPr>
             <a:r>
-              <a:t>OmniTransform</a:t>
+              <a:t>TEAM: HRL</a:t>
             </a:r>
           </a:p>
         </p:txBody>
@@ -5568,15 +5568,15 @@
           <a:lstStyle/>
           <a:p>
             <a:pPr algn="ctr">
-              <a:defRPr sz="1200" b="1">
+              <a:defRPr b="1" sz="1300">
                 <a:solidFill>
                   <a:srgbClr val="1B365D"/>
                 </a:solidFill>
-                <a:latin typeface="Arial"/>
+                <a:latin typeface="Times New Roman"/>
               </a:defRPr>
             </a:pPr>
             <a:r>
-              <a:t>OmniTransform</a:t>
+              <a:t>TEAM: HRL</a:t>
             </a:r>
           </a:p>
         </p:txBody>
@@ -6400,15 +6400,15 @@
           <a:lstStyle/>
           <a:p>
             <a:pPr algn="ctr">
-              <a:defRPr sz="1200" b="1">
+              <a:defRPr b="1" sz="1300">
                 <a:solidFill>
                   <a:srgbClr val="1B365D"/>
                 </a:solidFill>
-                <a:latin typeface="Arial"/>
+                <a:latin typeface="Times New Roman"/>
               </a:defRPr>
             </a:pPr>
             <a:r>
-              <a:t>OmniTransform</a:t>
+              <a:t>TEAM: HRL</a:t>
             </a:r>
           </a:p>
         </p:txBody>

</xml_diff>

<commit_message>
Standardize entity name to HRL
</commit_message>
<xml_diff>
--- a/SIH2026_Idea_Presentation_PS26154.pptx
+++ b/SIH2026_Idea_Presentation_PS26154.pptx
@@ -3419,7 +3419,7 @@
               </a:defRPr>
             </a:pPr>
             <a:r>
-              <a:t>TEAM: HRL</a:t>
+              <a:t>HRL</a:t>
             </a:r>
           </a:p>
         </p:txBody>
@@ -4402,7 +4402,7 @@
               </a:defRPr>
             </a:pPr>
             <a:r>
-              <a:t>TEAM: HRL</a:t>
+              <a:t>HRL</a:t>
             </a:r>
           </a:p>
         </p:txBody>
@@ -4955,7 +4955,7 @@
               </a:defRPr>
             </a:pPr>
             <a:r>
-              <a:t>TEAM: HRL</a:t>
+              <a:t>HRL</a:t>
             </a:r>
           </a:p>
         </p:txBody>
@@ -5576,7 +5576,7 @@
               </a:defRPr>
             </a:pPr>
             <a:r>
-              <a:t>TEAM: HRL</a:t>
+              <a:t>HRL</a:t>
             </a:r>
           </a:p>
         </p:txBody>
@@ -6408,7 +6408,7 @@
               </a:defRPr>
             </a:pPr>
             <a:r>
-              <a:t>TEAM: HRL</a:t>
+              <a:t>HRL</a:t>
             </a:r>
           </a:p>
         </p:txBody>

</xml_diff>